<commit_message>
Refine Chapter 7 figure mark placement
</commit_message>
<xml_diff>
--- a/chapter-07/FIN1209-Chapter-07.pptx
+++ b/chapter-07/FIN1209-Chapter-07.pptx
@@ -17016,16 +17016,16 @@
       </p:pic>
       <p:sp>
         <p:nvSpPr>
-          <p:cNvPr id="13" name="Oval 12"/>
-          <p:cNvSpPr/>
-          <p:nvPr/>
-        </p:nvSpPr>
-        <p:spPr>
-          <a:xfrm>
-            <a:off x="10448446" y="2393374"/>
-            <a:ext cx="220717" cy="103109"/>
-          </a:xfrm>
-          <a:prstGeom prst="ellipse">
+          <p:cNvPr id="13" name="Rectangle 12"/>
+          <p:cNvSpPr/>
+          <p:nvPr/>
+        </p:nvSpPr>
+        <p:spPr>
+          <a:xfrm>
+            <a:off x="10742736" y="2290265"/>
+            <a:ext cx="147145" cy="206218"/>
+          </a:xfrm>
+          <a:prstGeom prst="rect">
             <a:avLst/>
           </a:prstGeom>
           <a:noFill/>
@@ -17051,8 +17051,8 @@
         </p:nvSpPr>
         <p:spPr>
           <a:xfrm>
-            <a:off x="10448446" y="2651147"/>
-            <a:ext cx="220717" cy="103109"/>
+            <a:off x="10742736" y="2204341"/>
+            <a:ext cx="294290" cy="103109"/>
           </a:xfrm>
           <a:prstGeom prst="ellipse">
             <a:avLst/>
@@ -17072,35 +17072,27 @@
           </a:p>
         </p:txBody>
       </p:sp>
-      <p:sp>
-        <p:nvSpPr>
-          <p:cNvPr id="15" name="Oval 14"/>
-          <p:cNvSpPr/>
-          <p:nvPr/>
-        </p:nvSpPr>
-        <p:spPr>
-          <a:xfrm>
-            <a:off x="10448446" y="2101232"/>
-            <a:ext cx="220717" cy="103109"/>
-          </a:xfrm>
-          <a:prstGeom prst="ellipse">
-            <a:avLst/>
-          </a:prstGeom>
-          <a:noFill/>
+      <p:cxnSp>
+        <p:nvCxnSpPr>
+          <p:cNvPr id="15" name="Connector 14"/>
+          <p:cNvCxnSpPr/>
+          <p:nvPr/>
+        </p:nvCxnSpPr>
+        <p:spPr>
+          <a:xfrm>
+            <a:off x="10926668" y="2359005"/>
+            <a:ext cx="0" cy="309327"/>
+          </a:xfrm>
+          <a:prstGeom prst="line">
+            <a:avLst/>
+          </a:prstGeom>
           <a:ln w="44450">
             <a:solidFill>
               <a:srgbClr val="1F5FAD"/>
             </a:solidFill>
           </a:ln>
         </p:spPr>
-        <p:txBody>
-          <a:bodyPr rtlCol="0" anchor="ctr"/>
-          <a:lstStyle/>
-          <a:p>
-            <a:pPr algn="ctr"/>
-          </a:p>
-        </p:txBody>
-      </p:sp>
+      </p:cxnSp>
       <p:sp>
         <p:nvSpPr>
           <p:cNvPr id="16" name="Oval 15"/>
@@ -17109,7 +17101,7 @@
         </p:nvSpPr>
         <p:spPr>
           <a:xfrm>
-            <a:off x="10127354" y="2307769"/>
+            <a:off x="10458431" y="2445248"/>
             <a:ext cx="274320" cy="274320"/>
           </a:xfrm>
           <a:prstGeom prst="ellipse">
@@ -17160,7 +17152,7 @@
         </p:nvSpPr>
         <p:spPr>
           <a:xfrm>
-            <a:off x="10752722" y="2599911"/>
+            <a:off x="11010226" y="2032811"/>
             <a:ext cx="274320" cy="274320"/>
           </a:xfrm>
           <a:prstGeom prst="ellipse">
@@ -17211,7 +17203,7 @@
         </p:nvSpPr>
         <p:spPr>
           <a:xfrm>
-            <a:off x="10752722" y="1998442"/>
+            <a:off x="11010226" y="2617096"/>
             <a:ext cx="274320" cy="274320"/>
           </a:xfrm>
           <a:prstGeom prst="ellipse">
@@ -19420,35 +19412,27 @@
           </a:p>
         </p:txBody>
       </p:sp>
-      <p:sp>
-        <p:nvSpPr>
-          <p:cNvPr id="17" name="Rectangle 16"/>
-          <p:cNvSpPr/>
-          <p:nvPr/>
-        </p:nvSpPr>
-        <p:spPr>
-          <a:xfrm>
-            <a:off x="10278861" y="2725314"/>
-            <a:ext cx="708294" cy="795930"/>
-          </a:xfrm>
-          <a:prstGeom prst="rect">
-            <a:avLst/>
-          </a:prstGeom>
-          <a:noFill/>
+      <p:cxnSp>
+        <p:nvCxnSpPr>
+          <p:cNvPr id="17" name="Connector 16"/>
+          <p:cNvCxnSpPr/>
+          <p:nvPr/>
+        </p:nvCxnSpPr>
+        <p:spPr>
+          <a:xfrm>
+            <a:off x="9924714" y="3153892"/>
+            <a:ext cx="0" cy="448987"/>
+          </a:xfrm>
+          <a:prstGeom prst="line">
+            <a:avLst/>
+          </a:prstGeom>
           <a:ln w="44450">
             <a:solidFill>
               <a:srgbClr val="1F5FAD"/>
             </a:solidFill>
           </a:ln>
         </p:spPr>
-        <p:txBody>
-          <a:bodyPr rtlCol="0" anchor="ctr"/>
-          <a:lstStyle/>
-          <a:p>
-            <a:pPr algn="ctr"/>
-          </a:p>
-        </p:txBody>
-      </p:sp>
+      </p:cxnSp>
       <p:sp>
         <p:nvSpPr>
           <p:cNvPr id="18" name="Oval 17"/>
@@ -25858,8 +25842,8 @@
         </p:nvSpPr>
         <p:spPr>
           <a:xfrm>
-            <a:off x="8589014" y="2672258"/>
-            <a:ext cx="645694" cy="961367"/>
+            <a:off x="8589014" y="1973082"/>
+            <a:ext cx="645694" cy="1442050"/>
           </a:xfrm>
           <a:prstGeom prst="rect">
             <a:avLst/>
@@ -25887,8 +25871,8 @@
         </p:nvSpPr>
         <p:spPr>
           <a:xfrm>
-            <a:off x="9414067" y="2672258"/>
-            <a:ext cx="645694" cy="961367"/>
+            <a:off x="9414067" y="1973082"/>
+            <a:ext cx="645694" cy="1442050"/>
           </a:xfrm>
           <a:prstGeom prst="rect">
             <a:avLst/>
@@ -25945,7 +25929,7 @@
         </p:nvSpPr>
         <p:spPr>
           <a:xfrm>
-            <a:off x="8380110" y="2447701"/>
+            <a:off x="8272494" y="2535098"/>
             <a:ext cx="274320" cy="274320"/>
           </a:xfrm>
           <a:prstGeom prst="ellipse">
@@ -25996,7 +25980,7 @@
         </p:nvSpPr>
         <p:spPr>
           <a:xfrm>
-            <a:off x="9205164" y="2447701"/>
+            <a:off x="9097548" y="2535098"/>
             <a:ext cx="274320" cy="274320"/>
           </a:xfrm>
           <a:prstGeom prst="ellipse">
@@ -26047,7 +26031,7 @@
         </p:nvSpPr>
         <p:spPr>
           <a:xfrm>
-            <a:off x="8380110" y="2709892"/>
+            <a:off x="8236622" y="3059480"/>
             <a:ext cx="274320" cy="274320"/>
           </a:xfrm>
           <a:prstGeom prst="ellipse">

</xml_diff>

<commit_message>
Resolve fourth-read Chapter 7 findings
</commit_message>
<xml_diff>
--- a/chapter-07/FIN1209-Chapter-07.pptx
+++ b/chapter-07/FIN1209-Chapter-07.pptx
@@ -12214,35 +12214,28 @@
           </a:prstGeom>
         </p:spPr>
       </p:pic>
-      <p:sp>
-        <p:nvSpPr>
-          <p:cNvPr id="13" name="Oval 12"/>
-          <p:cNvSpPr/>
-          <p:nvPr/>
-        </p:nvSpPr>
-        <p:spPr>
-          <a:xfrm>
-            <a:off x="9901150" y="2401721"/>
-            <a:ext cx="242663" cy="113361"/>
-          </a:xfrm>
-          <a:prstGeom prst="ellipse">
-            <a:avLst/>
-          </a:prstGeom>
-          <a:noFill/>
+      <p:cxnSp>
+        <p:nvCxnSpPr>
+          <p:cNvPr id="13" name="Connector 12"/>
+          <p:cNvCxnSpPr/>
+          <p:nvPr/>
+        </p:nvCxnSpPr>
+        <p:spPr>
+          <a:xfrm flipV="1">
+            <a:off x="10143813" y="2628443"/>
+            <a:ext cx="0" cy="245616"/>
+          </a:xfrm>
+          <a:prstGeom prst="line">
+            <a:avLst/>
+          </a:prstGeom>
           <a:ln w="44450">
             <a:solidFill>
               <a:srgbClr val="E09B00"/>
             </a:solidFill>
-          </a:ln>
-        </p:spPr>
-        <p:txBody>
-          <a:bodyPr rtlCol="0" anchor="ctr"/>
-          <a:lstStyle/>
-          <a:p>
-            <a:pPr algn="ctr"/>
-          </a:p>
-        </p:txBody>
-      </p:sp>
+            <a:tailEnd type="triangle" w="med" len="med"/>
+          </a:ln>
+        </p:spPr>
+      </p:cxnSp>
       <p:sp>
         <p:nvSpPr>
           <p:cNvPr id="14" name="Oval 13"/>
@@ -12309,7 +12302,7 @@
         </p:nvSpPr>
         <p:spPr>
           <a:xfrm>
-            <a:off x="9399995" y="2340135"/>
+            <a:off x="10330205" y="2604644"/>
             <a:ext cx="274320" cy="274320"/>
           </a:xfrm>
           <a:prstGeom prst="ellipse">
@@ -17986,7 +17979,7 @@
         </p:nvSpPr>
         <p:spPr>
           <a:xfrm>
-            <a:off x="9814986" y="3710239"/>
+            <a:off x="9743242" y="3710239"/>
             <a:ext cx="274320" cy="274320"/>
           </a:xfrm>
           <a:prstGeom prst="ellipse">
@@ -18037,7 +18030,7 @@
         </p:nvSpPr>
         <p:spPr>
           <a:xfrm>
-            <a:off x="9958474" y="3624994"/>
+            <a:off x="10173705" y="3710239"/>
             <a:ext cx="274320" cy="274320"/>
           </a:xfrm>
           <a:prstGeom prst="ellipse">
@@ -22283,7 +22276,7 @@
         </p:nvSpPr>
         <p:spPr>
           <a:xfrm>
-            <a:off x="9284634" y="3693434"/>
+            <a:off x="9190945" y="3693434"/>
             <a:ext cx="274320" cy="274320"/>
           </a:xfrm>
           <a:prstGeom prst="ellipse">
@@ -22334,7 +22327,7 @@
         </p:nvSpPr>
         <p:spPr>
           <a:xfrm>
-            <a:off x="9472013" y="3582113"/>
+            <a:off x="9753081" y="3693434"/>
             <a:ext cx="274320" cy="274320"/>
           </a:xfrm>
           <a:prstGeom prst="ellipse">
@@ -23286,7 +23279,7 @@
         </p:nvSpPr>
         <p:spPr>
           <a:xfrm>
-            <a:off x="9284634" y="3642834"/>
+            <a:off x="9190945" y="3642834"/>
             <a:ext cx="274320" cy="274320"/>
           </a:xfrm>
           <a:prstGeom prst="ellipse">
@@ -23337,7 +23330,7 @@
         </p:nvSpPr>
         <p:spPr>
           <a:xfrm>
-            <a:off x="9472013" y="3533762"/>
+            <a:off x="9753081" y="3642834"/>
             <a:ext cx="274320" cy="274320"/>
           </a:xfrm>
           <a:prstGeom prst="ellipse">
@@ -26577,7 +26570,7 @@
               </a:spcAft>
             </a:pPr>
             <a:r>
-              <a:rPr sz="1600" b="0" i="0">
+              <a:rPr sz="1700" b="0" i="0">
                 <a:solidFill>
                   <a:srgbClr val="1A1A1A"/>
                 </a:solidFill>
@@ -26599,13 +26592,13 @@
               </a:spcAft>
             </a:pPr>
             <a:r>
-              <a:rPr sz="1600" b="0" i="0">
+              <a:rPr sz="1700" b="0" i="0">
                 <a:solidFill>
                   <a:srgbClr val="1A1A1A"/>
                 </a:solidFill>
                 <a:latin typeface="Arial"/>
               </a:rPr>
-              <a:t>Ideal: first bar wide on high volume; second narrow on very low volume. Barrier and trend context strengthen the potential reading.</a:t>
+              <a:t>Ideal: wide/high-volume first bar; narrow/very-low-volume second bar. Barrier and trend context add weight.</a:t>
             </a:r>
           </a:p>
           <a:p>
@@ -26621,7 +26614,7 @@
               </a:spcAft>
             </a:pPr>
             <a:r>
-              <a:rPr sz="1600" b="0" i="0">
+              <a:rPr sz="1700" b="0" i="0">
                 <a:solidFill>
                   <a:srgbClr val="1A1A1A"/>
                 </a:solidFill>
@@ -26630,7 +26623,7 @@
               <a:t>Figure 7.25 marks wide </a:t>
             </a:r>
             <a:r>
-              <a:rPr sz="1600" b="1" i="0">
+              <a:rPr sz="1700" b="1" i="0">
                 <a:solidFill>
                   <a:srgbClr val="E09B00"/>
                 </a:solidFill>
@@ -26639,7 +26632,7 @@
               <a:t>(1)</a:t>
             </a:r>
             <a:r>
-              <a:rPr sz="1600" b="0" i="0">
+              <a:rPr sz="1700" b="0" i="0">
                 <a:solidFill>
                   <a:srgbClr val="1A1A1A"/>
                 </a:solidFill>
@@ -26648,7 +26641,7 @@
               <a:t>, narrow inside </a:t>
             </a:r>
             <a:r>
-              <a:rPr sz="1600" b="1" i="0">
+              <a:rPr sz="1700" b="1" i="0">
                 <a:solidFill>
                   <a:srgbClr val="C62828"/>
                 </a:solidFill>
@@ -26657,7 +26650,7 @@
               <a:t>(2)</a:t>
             </a:r>
             <a:r>
-              <a:rPr sz="1600" b="0" i="0">
+              <a:rPr sz="1700" b="0" i="0">
                 <a:solidFill>
                   <a:srgbClr val="1A1A1A"/>
                 </a:solidFill>
@@ -26666,7 +26659,7 @@
               <a:t>, and oscillator region </a:t>
             </a:r>
             <a:r>
-              <a:rPr sz="1600" b="1" i="0">
+              <a:rPr sz="1700" b="1" i="0">
                 <a:solidFill>
                   <a:srgbClr val="1F5FAD"/>
                 </a:solidFill>
@@ -26675,7 +26668,7 @@
               <a:t>(3)</a:t>
             </a:r>
             <a:r>
-              <a:rPr sz="1600" b="0" i="0">
+              <a:rPr sz="1700" b="0" i="0">
                 <a:solidFill>
                   <a:srgbClr val="1A1A1A"/>
                 </a:solidFill>
@@ -26697,7 +26690,7 @@
               </a:spcAft>
             </a:pPr>
             <a:r>
-              <a:rPr sz="1600" b="0" i="0">
+              <a:rPr sz="1700" b="0" i="0">
                 <a:solidFill>
                   <a:srgbClr val="1A1A1A"/>
                 </a:solidFill>
@@ -26716,8 +26709,8 @@
         </p:nvSpPr>
         <p:spPr>
           <a:xfrm>
-            <a:off x="777240" y="4873752"/>
-            <a:ext cx="82296" cy="664464"/>
+            <a:off x="777240" y="5001768"/>
+            <a:ext cx="82296" cy="694944"/>
           </a:xfrm>
           <a:prstGeom prst="rect">
             <a:avLst/>
@@ -26746,8 +26739,8 @@
         </p:nvSpPr>
         <p:spPr>
           <a:xfrm>
-            <a:off x="1069848" y="4910328"/>
-            <a:ext cx="6656832" cy="664464"/>
+            <a:off x="1069848" y="5038344"/>
+            <a:ext cx="6656832" cy="694944"/>
           </a:xfrm>
           <a:prstGeom prst="rect">
             <a:avLst/>
@@ -26772,7 +26765,7 @@
               </a:spcAft>
             </a:pPr>
             <a:r>
-              <a:rPr sz="1700" b="1" i="0">
+              <a:rPr sz="1800" b="1" i="0">
                 <a:solidFill>
                   <a:srgbClr val="1A1A1A"/>
                 </a:solidFill>

</xml_diff>

<commit_message>
Resolve third-read Chapter 7 mark findings
</commit_message>
<xml_diff>
--- a/chapter-07/FIN1209-Chapter-07.pptx
+++ b/chapter-07/FIN1209-Chapter-07.pptx
@@ -1769,13 +1769,13 @@
           <a:p>
             <a:r>
               <a:rPr sz="1400"/>
-              <a:t>- Mark 1 is the narrowest bar and mark 2 is its inside condition.</a:t>
+              <a:t>- Mark 1 is the narrowest final bar and mark 2 boxes its inside relationship with the prior bar.</a:t>
             </a:r>
           </a:p>
           <a:p>
             <a:r>
               <a:rPr sz="1400"/>
-              <a:t>- The blue line crosses both printed trigger levels; either direction is possible before the break.</a:t>
+              <a:t>- Mark 3's top and bottom edges sit on the printed long and short trigger levels; either direction is possible before the break.</a:t>
             </a:r>
           </a:p>
         </p:txBody>
@@ -1846,19 +1846,13 @@
           <a:p>
             <a:r>
               <a:rPr sz="1400"/>
-              <a:t>- This is the monthly extension, not an ordinary daily ID/NR example.</a:t>
+              <a:t>- The five counted monthly ranges are 12, 10, 9, 7, and 5 PHP; the fifth bar is inside the fourth.</a:t>
             </a:r>
           </a:p>
           <a:p>
             <a:r>
               <a:rPr sz="1400"/>
-              <a:t>- Mark 1 identifies the inside month, mark 2 spans the five-month range count, and mark 3 is on the first upside breakout bar.</a:t>
-            </a:r>
-          </a:p>
-          <a:p>
-            <a:r>
-              <a:rPr sz="1400"/>
-              <a:t>- The count and neutral direction rule remain the same before breakout.</a:t>
+              <a:t>- The sixth bar breaks above PHP 31.00. The example is invented to show the extension.</a:t>
             </a:r>
           </a:p>
         </p:txBody>
@@ -13172,35 +13166,27 @@
           </a:p>
         </p:txBody>
       </p:sp>
-      <p:sp>
-        <p:nvSpPr>
-          <p:cNvPr id="15" name="Oval 14"/>
-          <p:cNvSpPr/>
-          <p:nvPr/>
-        </p:nvSpPr>
-        <p:spPr>
-          <a:xfrm>
-            <a:off x="8145603" y="3166829"/>
-            <a:ext cx="395295" cy="135345"/>
-          </a:xfrm>
-          <a:prstGeom prst="ellipse">
-            <a:avLst/>
-          </a:prstGeom>
-          <a:noFill/>
+      <p:cxnSp>
+        <p:nvCxnSpPr>
+          <p:cNvPr id="15" name="Connector 14"/>
+          <p:cNvCxnSpPr/>
+          <p:nvPr/>
+        </p:nvCxnSpPr>
+        <p:spPr>
+          <a:xfrm>
+            <a:off x="8066544" y="3205499"/>
+            <a:ext cx="513883" cy="0"/>
+          </a:xfrm>
+          <a:prstGeom prst="line">
+            <a:avLst/>
+          </a:prstGeom>
           <a:ln w="44450">
             <a:solidFill>
               <a:srgbClr val="E09B00"/>
             </a:solidFill>
           </a:ln>
         </p:spPr>
-        <p:txBody>
-          <a:bodyPr rtlCol="0" anchor="ctr"/>
-          <a:lstStyle/>
-          <a:p>
-            <a:pPr algn="ctr"/>
-          </a:p>
-        </p:txBody>
-      </p:sp>
+      </p:cxnSp>
       <p:cxnSp>
         <p:nvCxnSpPr>
           <p:cNvPr id="16" name="Connector 15"/>
@@ -13251,7 +13237,7 @@
         </p:nvSpPr>
         <p:spPr>
           <a:xfrm>
-            <a:off x="7850325" y="3087674"/>
+            <a:off x="7771266" y="2855653"/>
             <a:ext cx="274320" cy="274320"/>
           </a:xfrm>
           <a:prstGeom prst="ellipse">
@@ -14003,93 +13989,70 @@
           </a:prstGeom>
         </p:spPr>
       </p:pic>
-      <p:sp>
-        <p:nvSpPr>
-          <p:cNvPr id="13" name="Oval 12"/>
-          <p:cNvSpPr/>
-          <p:nvPr/>
-        </p:nvSpPr>
-        <p:spPr>
-          <a:xfrm>
-            <a:off x="9873261" y="2564501"/>
-            <a:ext cx="239920" cy="112079"/>
-          </a:xfrm>
-          <a:prstGeom prst="ellipse">
-            <a:avLst/>
-          </a:prstGeom>
-          <a:noFill/>
+      <p:cxnSp>
+        <p:nvCxnSpPr>
+          <p:cNvPr id="13" name="Connector 12"/>
+          <p:cNvCxnSpPr/>
+          <p:nvPr/>
+        </p:nvCxnSpPr>
+        <p:spPr>
+          <a:xfrm>
+            <a:off x="10113181" y="2956779"/>
+            <a:ext cx="0" cy="186799"/>
+          </a:xfrm>
+          <a:prstGeom prst="line">
+            <a:avLst/>
+          </a:prstGeom>
           <a:ln w="44450">
             <a:solidFill>
               <a:srgbClr val="E09B00"/>
             </a:solidFill>
-          </a:ln>
-        </p:spPr>
-        <p:txBody>
-          <a:bodyPr rtlCol="0" anchor="ctr"/>
-          <a:lstStyle/>
-          <a:p>
-            <a:pPr algn="ctr"/>
-          </a:p>
-        </p:txBody>
-      </p:sp>
-      <p:sp>
-        <p:nvSpPr>
-          <p:cNvPr id="14" name="Oval 13"/>
-          <p:cNvSpPr/>
-          <p:nvPr/>
-        </p:nvSpPr>
-        <p:spPr>
-          <a:xfrm>
-            <a:off x="9873261" y="2844700"/>
-            <a:ext cx="239920" cy="112079"/>
-          </a:xfrm>
-          <a:prstGeom prst="ellipse">
-            <a:avLst/>
-          </a:prstGeom>
-          <a:noFill/>
+            <a:tailEnd type="triangle" w="med" len="med"/>
+          </a:ln>
+        </p:spPr>
+      </p:cxnSp>
+      <p:cxnSp>
+        <p:nvCxnSpPr>
+          <p:cNvPr id="14" name="Connector 13"/>
+          <p:cNvCxnSpPr/>
+          <p:nvPr/>
+        </p:nvCxnSpPr>
+        <p:spPr>
+          <a:xfrm>
+            <a:off x="8993553" y="2938099"/>
+            <a:ext cx="959681" cy="0"/>
+          </a:xfrm>
+          <a:prstGeom prst="line">
+            <a:avLst/>
+          </a:prstGeom>
           <a:ln w="44450">
             <a:solidFill>
               <a:srgbClr val="C62828"/>
             </a:solidFill>
           </a:ln>
         </p:spPr>
-        <p:txBody>
-          <a:bodyPr rtlCol="0" anchor="ctr"/>
-          <a:lstStyle/>
-          <a:p>
-            <a:pPr algn="ctr"/>
-          </a:p>
-        </p:txBody>
-      </p:sp>
-      <p:sp>
-        <p:nvSpPr>
-          <p:cNvPr id="15" name="Oval 14"/>
-          <p:cNvSpPr/>
-          <p:nvPr/>
-        </p:nvSpPr>
-        <p:spPr>
-          <a:xfrm>
-            <a:off x="9873261" y="3236978"/>
-            <a:ext cx="239920" cy="112079"/>
-          </a:xfrm>
-          <a:prstGeom prst="ellipse">
-            <a:avLst/>
-          </a:prstGeom>
-          <a:noFill/>
+      </p:cxnSp>
+      <p:cxnSp>
+        <p:nvCxnSpPr>
+          <p:cNvPr id="15" name="Connector 14"/>
+          <p:cNvCxnSpPr/>
+          <p:nvPr/>
+        </p:nvCxnSpPr>
+        <p:spPr>
+          <a:xfrm>
+            <a:off x="8993553" y="3498497"/>
+            <a:ext cx="959681" cy="0"/>
+          </a:xfrm>
+          <a:prstGeom prst="line">
+            <a:avLst/>
+          </a:prstGeom>
           <a:ln w="44450">
             <a:solidFill>
               <a:srgbClr val="1F5FAD"/>
             </a:solidFill>
           </a:ln>
         </p:spPr>
-        <p:txBody>
-          <a:bodyPr rtlCol="0" anchor="ctr"/>
-          <a:lstStyle/>
-          <a:p>
-            <a:pPr algn="ctr"/>
-          </a:p>
-        </p:txBody>
-      </p:sp>
+      </p:cxnSp>
       <p:sp>
         <p:nvSpPr>
           <p:cNvPr id="16" name="Oval 15"/>
@@ -14098,7 +14061,7 @@
         </p:nvSpPr>
         <p:spPr>
           <a:xfrm>
-            <a:off x="9376220" y="2576780"/>
+            <a:off x="10335901" y="2875659"/>
             <a:ext cx="274320" cy="274320"/>
           </a:xfrm>
           <a:prstGeom prst="ellipse">
@@ -14149,7 +14112,7 @@
         </p:nvSpPr>
         <p:spPr>
           <a:xfrm>
-            <a:off x="10335901" y="2744900"/>
+            <a:off x="10415875" y="2670180"/>
             <a:ext cx="274320" cy="274320"/>
           </a:xfrm>
           <a:prstGeom prst="ellipse">
@@ -14200,7 +14163,7 @@
         </p:nvSpPr>
         <p:spPr>
           <a:xfrm>
-            <a:off x="10335901" y="3323977"/>
+            <a:off x="10495848" y="3417377"/>
             <a:ext cx="274320" cy="274320"/>
           </a:xfrm>
           <a:prstGeom prst="ellipse">
@@ -16692,7 +16655,7 @@
                 </a:solidFill>
                 <a:latin typeface="Arial"/>
               </a:rPr>
-              <a:t>Ours: six ranges are 4.0, 3.2, 2.8, 2.1, 1.6, and 1.2 PHP. Bar 6 is inside bar 5 and has the narrowest range </a:t>
+              <a:t>Ours: six ranges are 4.0, 3.2, 2.8, 2.1, 1.6, and 1.2 PHP. Bar 6 is inside bar 5 </a:t>
             </a:r>
             <a:r>
               <a:rPr sz="1700" b="1" i="0">
@@ -16710,7 +16673,7 @@
                 </a:solidFill>
                 <a:latin typeface="Arial"/>
               </a:rPr>
-              <a:t> </a:t>
+              <a:t> and has the narrowest range </a:t>
             </a:r>
             <a:r>
               <a:rPr sz="1700" b="1" i="0">
@@ -16957,8 +16920,8 @@
         </p:nvSpPr>
         <p:spPr>
           <a:xfrm>
-            <a:off x="10742736" y="2290265"/>
-            <a:ext cx="147145" cy="206218"/>
+            <a:off x="10301301" y="2359005"/>
+            <a:ext cx="588580" cy="309327"/>
           </a:xfrm>
           <a:prstGeom prst="rect">
             <a:avLst/>
@@ -16978,35 +16941,27 @@
           </a:p>
         </p:txBody>
       </p:sp>
-      <p:sp>
-        <p:nvSpPr>
-          <p:cNvPr id="14" name="Oval 13"/>
-          <p:cNvSpPr/>
-          <p:nvPr/>
-        </p:nvSpPr>
-        <p:spPr>
-          <a:xfrm>
-            <a:off x="10742736" y="2204341"/>
-            <a:ext cx="294290" cy="103109"/>
-          </a:xfrm>
-          <a:prstGeom prst="ellipse">
-            <a:avLst/>
-          </a:prstGeom>
-          <a:noFill/>
+      <p:cxnSp>
+        <p:nvCxnSpPr>
+          <p:cNvPr id="14" name="Connector 13"/>
+          <p:cNvCxnSpPr/>
+          <p:nvPr/>
+        </p:nvCxnSpPr>
+        <p:spPr>
+          <a:xfrm>
+            <a:off x="10742736" y="2307450"/>
+            <a:ext cx="0" cy="360882"/>
+          </a:xfrm>
+          <a:prstGeom prst="line">
+            <a:avLst/>
+          </a:prstGeom>
           <a:ln w="44450">
             <a:solidFill>
               <a:srgbClr val="C62828"/>
             </a:solidFill>
           </a:ln>
         </p:spPr>
-        <p:txBody>
-          <a:bodyPr rtlCol="0" anchor="ctr"/>
-          <a:lstStyle/>
-          <a:p>
-            <a:pPr algn="ctr"/>
-          </a:p>
-        </p:txBody>
-      </p:sp>
+      </p:cxnSp>
       <p:cxnSp>
         <p:nvCxnSpPr>
           <p:cNvPr id="15" name="Connector 14"/>
@@ -17015,8 +16970,8 @@
         </p:nvCxnSpPr>
         <p:spPr>
           <a:xfrm>
-            <a:off x="10926668" y="2359005"/>
-            <a:ext cx="0" cy="309327"/>
+            <a:off x="10485232" y="2290265"/>
+            <a:ext cx="0" cy="326512"/>
           </a:xfrm>
           <a:prstGeom prst="line">
             <a:avLst/>
@@ -17036,7 +16991,7 @@
         </p:nvSpPr>
         <p:spPr>
           <a:xfrm>
-            <a:off x="10458431" y="2445248"/>
+            <a:off x="9980209" y="2617096"/>
             <a:ext cx="274320" cy="274320"/>
           </a:xfrm>
           <a:prstGeom prst="ellipse">
@@ -17087,7 +17042,7 @@
         </p:nvSpPr>
         <p:spPr>
           <a:xfrm>
-            <a:off x="11010226" y="2032811"/>
+            <a:off x="10899867" y="2599911"/>
             <a:ext cx="274320" cy="274320"/>
           </a:xfrm>
           <a:prstGeom prst="ellipse">
@@ -17138,7 +17093,7 @@
         </p:nvSpPr>
         <p:spPr>
           <a:xfrm>
-            <a:off x="11010226" y="2617096"/>
+            <a:off x="10164141" y="2737390"/>
             <a:ext cx="274320" cy="274320"/>
           </a:xfrm>
           <a:prstGeom prst="ellipse">
@@ -17893,28 +17848,35 @@
           </a:p>
         </p:txBody>
       </p:sp>
-      <p:cxnSp>
-        <p:nvCxnSpPr>
-          <p:cNvPr id="15" name="Connector 14"/>
-          <p:cNvCxnSpPr/>
-          <p:nvPr/>
-        </p:nvCxnSpPr>
-        <p:spPr>
-          <a:xfrm>
-            <a:off x="8875989" y="3911333"/>
-            <a:ext cx="932669" cy="0"/>
-          </a:xfrm>
-          <a:prstGeom prst="line">
-            <a:avLst/>
-          </a:prstGeom>
+      <p:sp>
+        <p:nvSpPr>
+          <p:cNvPr id="15" name="Rectangle 14"/>
+          <p:cNvSpPr/>
+          <p:nvPr/>
+        </p:nvSpPr>
+        <p:spPr>
+          <a:xfrm>
+            <a:off x="8768373" y="2675279"/>
+            <a:ext cx="1004413" cy="1278677"/>
+          </a:xfrm>
+          <a:prstGeom prst="rect">
+            <a:avLst/>
+          </a:prstGeom>
+          <a:noFill/>
           <a:ln w="44450">
             <a:solidFill>
               <a:srgbClr val="E09B00"/>
             </a:solidFill>
-            <a:tailEnd type="triangle" w="med" len="med"/>
-          </a:ln>
-        </p:spPr>
-      </p:cxnSp>
+          </a:ln>
+        </p:spPr>
+        <p:txBody>
+          <a:bodyPr rtlCol="0" anchor="ctr"/>
+          <a:lstStyle/>
+          <a:p>
+            <a:pPr algn="ctr"/>
+          </a:p>
+        </p:txBody>
+      </p:sp>
       <p:sp>
         <p:nvSpPr>
           <p:cNvPr id="16" name="Rectangle 15"/>
@@ -17923,8 +17885,8 @@
         </p:nvSpPr>
         <p:spPr>
           <a:xfrm>
-            <a:off x="9557555" y="3250683"/>
-            <a:ext cx="322847" cy="767206"/>
+            <a:off x="9593427" y="3122816"/>
+            <a:ext cx="179359" cy="831140"/>
           </a:xfrm>
           <a:prstGeom prst="rect">
             <a:avLst/>
@@ -17952,8 +17914,8 @@
         </p:nvCxnSpPr>
         <p:spPr>
           <a:xfrm>
-            <a:off x="9736915" y="3314617"/>
-            <a:ext cx="0" cy="703273"/>
+            <a:off x="9701043" y="3144127"/>
+            <a:ext cx="0" cy="809829"/>
           </a:xfrm>
           <a:prstGeom prst="line">
             <a:avLst/>
@@ -17973,7 +17935,7 @@
         </p:nvSpPr>
         <p:spPr>
           <a:xfrm>
-            <a:off x="8631213" y="3646305"/>
+            <a:off x="8380110" y="2857788"/>
             <a:ext cx="274320" cy="274320"/>
           </a:xfrm>
           <a:prstGeom prst="ellipse">
@@ -18024,7 +17986,7 @@
         </p:nvSpPr>
         <p:spPr>
           <a:xfrm>
-            <a:off x="9922602" y="2985656"/>
+            <a:off x="9814986" y="3710239"/>
             <a:ext cx="274320" cy="274320"/>
           </a:xfrm>
           <a:prstGeom prst="ellipse">
@@ -18075,7 +18037,7 @@
         </p:nvSpPr>
         <p:spPr>
           <a:xfrm>
-            <a:off x="9958474" y="3667617"/>
+            <a:off x="9958474" y="3624994"/>
             <a:ext cx="274320" cy="274320"/>
           </a:xfrm>
           <a:prstGeom prst="ellipse">
@@ -19290,8 +19252,8 @@
         </p:nvCxnSpPr>
         <p:spPr>
           <a:xfrm>
-            <a:off x="9712226" y="3255935"/>
-            <a:ext cx="0" cy="673479"/>
+            <a:off x="9676811" y="3092667"/>
+            <a:ext cx="0" cy="775522"/>
           </a:xfrm>
           <a:prstGeom prst="line">
             <a:avLst/>
@@ -19311,8 +19273,8 @@
         </p:nvSpPr>
         <p:spPr>
           <a:xfrm>
-            <a:off x="9535152" y="3194709"/>
-            <a:ext cx="318732" cy="734705"/>
+            <a:off x="9570567" y="3072258"/>
+            <a:ext cx="177073" cy="795930"/>
           </a:xfrm>
           <a:prstGeom prst="rect">
             <a:avLst/>
@@ -19332,27 +19294,35 @@
           </a:p>
         </p:txBody>
       </p:sp>
-      <p:cxnSp>
-        <p:nvCxnSpPr>
-          <p:cNvPr id="17" name="Connector 16"/>
-          <p:cNvCxnSpPr/>
-          <p:nvPr/>
-        </p:nvCxnSpPr>
-        <p:spPr>
-          <a:xfrm>
-            <a:off x="9924714" y="3153892"/>
-            <a:ext cx="0" cy="448987"/>
-          </a:xfrm>
-          <a:prstGeom prst="line">
-            <a:avLst/>
-          </a:prstGeom>
+      <p:sp>
+        <p:nvSpPr>
+          <p:cNvPr id="17" name="Rectangle 16"/>
+          <p:cNvSpPr/>
+          <p:nvPr/>
+        </p:nvSpPr>
+        <p:spPr>
+          <a:xfrm>
+            <a:off x="9853885" y="3174301"/>
+            <a:ext cx="247902" cy="346944"/>
+          </a:xfrm>
+          <a:prstGeom prst="rect">
+            <a:avLst/>
+          </a:prstGeom>
+          <a:noFill/>
           <a:ln w="44450">
             <a:solidFill>
               <a:srgbClr val="1F5FAD"/>
             </a:solidFill>
           </a:ln>
         </p:spPr>
-      </p:cxnSp>
+        <p:txBody>
+          <a:bodyPr rtlCol="0" anchor="ctr"/>
+          <a:lstStyle/>
+          <a:p>
+            <a:pPr algn="ctr"/>
+          </a:p>
+        </p:txBody>
+      </p:sp>
       <p:sp>
         <p:nvSpPr>
           <p:cNvPr id="18" name="Oval 17"/>
@@ -19361,7 +19331,7 @@
         </p:nvSpPr>
         <p:spPr>
           <a:xfrm>
-            <a:off x="9929213" y="3588169"/>
+            <a:off x="9752139" y="3628986"/>
             <a:ext cx="274320" cy="274320"/>
           </a:xfrm>
           <a:prstGeom prst="ellipse">
@@ -19412,7 +19382,7 @@
         </p:nvSpPr>
         <p:spPr>
           <a:xfrm>
-            <a:off x="9893798" y="2935098"/>
+            <a:off x="9716725" y="2608563"/>
             <a:ext cx="274320" cy="274320"/>
           </a:xfrm>
           <a:prstGeom prst="ellipse">
@@ -19463,7 +19433,7 @@
         </p:nvSpPr>
         <p:spPr>
           <a:xfrm>
-            <a:off x="10920825" y="3506536"/>
+            <a:off x="10849995" y="3547353"/>
             <a:ext cx="274320" cy="274320"/>
           </a:xfrm>
           <a:prstGeom prst="ellipse">
@@ -19834,7 +19804,43 @@
                 </a:solidFill>
                 <a:latin typeface="Arial"/>
               </a:rPr>
-              <a:t>Inside month applies the idea to monthly bars. Ours: ranges 12, 10, 9, 7, 5 PHP; the fifth is inside the fourth and narrowest. Invented, not the book figure.</a:t>
+              <a:t>Inside month applies the idea to monthly bars. Ours: ranges 12, 10, 9, 7, 5 PHP; the fifth is inside the fourth and narrowest </a:t>
+            </a:r>
+            <a:r>
+              <a:rPr sz="1700" b="1" i="0">
+                <a:solidFill>
+                  <a:srgbClr val="E09B00"/>
+                </a:solidFill>
+                <a:latin typeface="Arial"/>
+              </a:rPr>
+              <a:t>(1)</a:t>
+            </a:r>
+            <a:r>
+              <a:rPr sz="1700" b="0" i="0">
+                <a:solidFill>
+                  <a:srgbClr val="1A1A1A"/>
+                </a:solidFill>
+                <a:latin typeface="Arial"/>
+              </a:rPr>
+              <a:t> </a:t>
+            </a:r>
+            <a:r>
+              <a:rPr sz="1700" b="1" i="0">
+                <a:solidFill>
+                  <a:srgbClr val="C62828"/>
+                </a:solidFill>
+                <a:latin typeface="Arial"/>
+              </a:rPr>
+              <a:t>(2)</a:t>
+            </a:r>
+            <a:r>
+              <a:rPr sz="1700" b="0" i="0">
+                <a:solidFill>
+                  <a:srgbClr val="1A1A1A"/>
+                </a:solidFill>
+                <a:latin typeface="Arial"/>
+              </a:rPr>
+              <a:t>. Invented, not the book figure.</a:t>
             </a:r>
           </a:p>
           <a:p>
@@ -19856,7 +19862,25 @@
                 </a:solidFill>
                 <a:latin typeface="Arial"/>
               </a:rPr>
-              <a:t>The invented bar breaks upward at PHP 8.00. Before the break, the pattern is neutral.</a:t>
+              <a:t>The sixth invented bar breaks upward through PHP 31.00 </a:t>
+            </a:r>
+            <a:r>
+              <a:rPr sz="1700" b="1" i="0">
+                <a:solidFill>
+                  <a:srgbClr val="1F5FAD"/>
+                </a:solidFill>
+                <a:latin typeface="Arial"/>
+              </a:rPr>
+              <a:t>(3)</a:t>
+            </a:r>
+            <a:r>
+              <a:rPr sz="1700" b="0" i="0">
+                <a:solidFill>
+                  <a:srgbClr val="1A1A1A"/>
+                </a:solidFill>
+                <a:latin typeface="Arial"/>
+              </a:rPr>
+              <a:t>. Before the break, the pattern is neutral.</a:t>
             </a:r>
           </a:p>
           <a:p>
@@ -20012,7 +20036,7 @@
         <p:spPr>
           <a:xfrm>
             <a:off x="7680960" y="1810512"/>
-            <a:ext cx="3916374" cy="1682920"/>
+            <a:ext cx="3916374" cy="1956228"/>
           </a:xfrm>
           <a:prstGeom prst="rect">
             <a:avLst/>
@@ -20035,38 +20059,30 @@
           </a:p>
         </p:txBody>
       </p:sp>
-      <p:sp>
-        <p:nvSpPr>
-          <p:cNvPr id="12" name="Rectangle 11"/>
-          <p:cNvSpPr/>
-          <p:nvPr/>
-        </p:nvSpPr>
+      <p:pic>
+        <p:nvPicPr>
+          <p:cNvPr id="12" name="Picture 11" descr="chart-w.png"/>
+          <p:cNvPicPr>
+            <a:picLocks noChangeAspect="1"/>
+          </p:cNvPicPr>
+          <p:nvPr/>
+        </p:nvPicPr>
+        <p:blipFill>
+          <a:blip r:embed="rId2"/>
+          <a:stretch>
+            <a:fillRect/>
+          </a:stretch>
+        </p:blipFill>
         <p:spPr>
           <a:xfrm>
             <a:off x="7799832" y="1929384"/>
-            <a:ext cx="3678631" cy="1445176"/>
-          </a:xfrm>
-          <a:prstGeom prst="rect">
-            <a:avLst/>
-          </a:prstGeom>
-          <a:solidFill>
-            <a:srgbClr val="FFFFFF"/>
-          </a:solidFill>
-          <a:ln w="12700">
-            <a:solidFill>
-              <a:srgbClr val="D7E0D9"/>
-            </a:solidFill>
-          </a:ln>
-          <a:effectLst/>
-        </p:spPr>
-        <p:txBody>
-          <a:bodyPr rtlCol="0" anchor="ctr"/>
-          <a:lstStyle/>
-          <a:p>
-            <a:pPr algn="ctr"/>
-          </a:p>
-        </p:txBody>
-      </p:sp>
+            <a:ext cx="3678631" cy="1718484"/>
+          </a:xfrm>
+          <a:prstGeom prst="rect">
+            <a:avLst/>
+          </a:prstGeom>
+        </p:spPr>
+      </p:pic>
       <p:sp>
         <p:nvSpPr>
           <p:cNvPr id="13" name="Rectangle 12"/>
@@ -20075,107 +20091,10 @@
         </p:nvSpPr>
         <p:spPr>
           <a:xfrm>
-            <a:off x="7799832" y="1929384"/>
-            <a:ext cx="3678631" cy="50800"/>
-          </a:xfrm>
-          <a:prstGeom prst="rect">
-            <a:avLst/>
-          </a:prstGeom>
-          <a:solidFill>
-            <a:srgbClr val="F2A900"/>
-          </a:solidFill>
-          <a:ln>
-            <a:noFill/>
-          </a:ln>
-          <a:effectLst/>
-        </p:spPr>
-        <p:txBody>
-          <a:bodyPr rtlCol="0" anchor="ctr"/>
-          <a:lstStyle/>
-          <a:p>
-            <a:pPr algn="ctr"/>
-          </a:p>
-        </p:txBody>
-      </p:sp>
-      <p:sp>
-        <p:nvSpPr>
-          <p:cNvPr id="14" name="TextBox 13"/>
-          <p:cNvSpPr txBox="1"/>
-          <p:nvPr/>
-        </p:nvSpPr>
-        <p:spPr>
-          <a:xfrm>
-            <a:off x="8074152" y="2203703"/>
-            <a:ext cx="3129990" cy="987976"/>
-          </a:xfrm>
-          <a:prstGeom prst="rect">
-            <a:avLst/>
-          </a:prstGeom>
-          <a:noFill/>
-        </p:spPr>
-        <p:txBody>
-          <a:bodyPr wrap="square" anchor="t" lIns="0" rIns="0" tIns="0" bIns="0">
-            <a:spAutoFit/>
-          </a:bodyPr>
-          <a:lstStyle/>
-          <a:p>
-            <a:pPr algn="l">
-              <a:lnSpc>
-                <a:spcPct val="100000"/>
-              </a:lnSpc>
-              <a:spcBef>
-                <a:spcPts val="0"/>
-              </a:spcBef>
-              <a:spcAft>
-                <a:spcPts val="400"/>
-              </a:spcAft>
-            </a:pPr>
-            <a:r>
-              <a:rPr sz="1100" b="1" i="0">
-                <a:solidFill>
-                  <a:srgbClr val="818181"/>
-                </a:solidFill>
-                <a:latin typeface="Arial"/>
-              </a:rPr>
-              <a:t>FIGURE 7.39</a:t>
-            </a:r>
-          </a:p>
-          <a:p>
-            <a:pPr algn="l">
-              <a:lnSpc>
-                <a:spcPct val="115000"/>
-              </a:lnSpc>
-              <a:spcBef>
-                <a:spcPts val="0"/>
-              </a:spcBef>
-              <a:spcAft>
-                <a:spcPts val="0"/>
-              </a:spcAft>
-            </a:pPr>
-            <a:r>
-              <a:rPr sz="1100" b="0" i="0">
-                <a:solidFill>
-                  <a:srgbClr val="1A1A1A"/>
-                </a:solidFill>
-                <a:latin typeface="Palatino"/>
-              </a:rPr>
-              <a:t>The book's monthly Dynegy chart: an inside month after five monthly ranges, followed by an upside breakout.</a:t>
-            </a:r>
-          </a:p>
-        </p:txBody>
-      </p:sp>
-      <p:sp>
-        <p:nvSpPr>
-          <p:cNvPr id="15" name="Oval 14"/>
-          <p:cNvSpPr/>
-          <p:nvPr/>
-        </p:nvSpPr>
-        <p:spPr>
-          <a:xfrm>
-            <a:off x="9528788" y="2825393"/>
-            <a:ext cx="220717" cy="260131"/>
-          </a:xfrm>
-          <a:prstGeom prst="ellipse">
+            <a:off x="9749506" y="2582408"/>
+            <a:ext cx="625367" cy="360881"/>
+          </a:xfrm>
+          <a:prstGeom prst="rect">
             <a:avLst/>
           </a:prstGeom>
           <a:noFill/>
@@ -20195,14 +20114,14 @@
       </p:sp>
       <p:cxnSp>
         <p:nvCxnSpPr>
-          <p:cNvPr id="16" name="Connector 15"/>
+          <p:cNvPr id="14" name="Connector 13"/>
           <p:cNvCxnSpPr/>
           <p:nvPr/>
         </p:nvCxnSpPr>
         <p:spPr>
           <a:xfrm>
-            <a:off x="8609130" y="3201139"/>
-            <a:ext cx="1177162" cy="0"/>
+            <a:off x="10264514" y="2599592"/>
+            <a:ext cx="0" cy="274958"/>
           </a:xfrm>
           <a:prstGeom prst="line">
             <a:avLst/>
@@ -20211,20 +20130,19 @@
             <a:solidFill>
               <a:srgbClr val="C62828"/>
             </a:solidFill>
-            <a:tailEnd type="triangle" w="med" len="med"/>
           </a:ln>
         </p:spPr>
       </p:cxnSp>
       <p:sp>
         <p:nvSpPr>
-          <p:cNvPr id="17" name="Oval 16"/>
+          <p:cNvPr id="15" name="Oval 14"/>
           <p:cNvSpPr/>
           <p:nvPr/>
         </p:nvSpPr>
         <p:spPr>
           <a:xfrm>
-            <a:off x="9749506" y="2175063"/>
-            <a:ext cx="220717" cy="361294"/>
+            <a:off x="10669164" y="2238711"/>
+            <a:ext cx="220717" cy="532730"/>
           </a:xfrm>
           <a:prstGeom prst="ellipse">
             <a:avLst/>
@@ -20246,13 +20164,13 @@
       </p:sp>
       <p:sp>
         <p:nvSpPr>
-          <p:cNvPr id="18" name="Oval 17"/>
+          <p:cNvPr id="16" name="Oval 15"/>
           <p:cNvSpPr/>
           <p:nvPr/>
         </p:nvSpPr>
         <p:spPr>
           <a:xfrm>
-            <a:off x="9207697" y="3006172"/>
+            <a:off x="9465201" y="2874869"/>
             <a:ext cx="274320" cy="274320"/>
           </a:xfrm>
           <a:prstGeom prst="ellipse">
@@ -20297,13 +20215,13 @@
       </p:sp>
       <p:sp>
         <p:nvSpPr>
-          <p:cNvPr id="19" name="Oval 18"/>
+          <p:cNvPr id="17" name="Oval 16"/>
           <p:cNvSpPr/>
           <p:nvPr/>
         </p:nvSpPr>
         <p:spPr>
           <a:xfrm>
-            <a:off x="8324825" y="3136238"/>
+            <a:off x="10384858" y="2874869"/>
             <a:ext cx="274320" cy="274320"/>
           </a:xfrm>
           <a:prstGeom prst="ellipse">
@@ -20348,13 +20266,13 @@
       </p:sp>
       <p:sp>
         <p:nvSpPr>
-          <p:cNvPr id="20" name="Oval 19"/>
+          <p:cNvPr id="18" name="Oval 17"/>
           <p:cNvSpPr/>
           <p:nvPr/>
         </p:nvSpPr>
         <p:spPr>
           <a:xfrm>
-            <a:off x="9980209" y="1965645"/>
+            <a:off x="11010226" y="2737390"/>
             <a:ext cx="274320" cy="274320"/>
           </a:xfrm>
           <a:prstGeom prst="ellipse">
@@ -20399,13 +20317,13 @@
       </p:sp>
       <p:sp>
         <p:nvSpPr>
-          <p:cNvPr id="21" name="TextBox 20"/>
+          <p:cNvPr id="19" name="TextBox 18"/>
           <p:cNvSpPr txBox="1"/>
           <p:nvPr/>
         </p:nvSpPr>
         <p:spPr>
           <a:xfrm>
-            <a:off x="7680960" y="3584872"/>
+            <a:off x="7680960" y="3858180"/>
             <a:ext cx="3916374" cy="274320"/>
           </a:xfrm>
           <a:prstGeom prst="rect">
@@ -20437,14 +20355,14 @@
                 </a:solidFill>
                 <a:latin typeface="Arial"/>
               </a:rPr>
-              <a:t>Figure 7.39 - Lim, The Handbook of Technical Analysis (Wiley, 2016)</a:t>
-            </a:r>
-          </a:p>
-        </p:txBody>
-      </p:sp>
-      <p:sp>
-        <p:nvSpPr>
-          <p:cNvPr id="22" name="TextBox 21"/>
+              <a:t>Chart W - FIN1209 teaching chart, drawn for this course. Illustrative data, not a real instrument.</a:t>
+            </a:r>
+          </a:p>
+        </p:txBody>
+      </p:sp>
+      <p:sp>
+        <p:nvSpPr>
+          <p:cNvPr id="20" name="TextBox 19"/>
           <p:cNvSpPr txBox="1"/>
           <p:nvPr/>
         </p:nvSpPr>
@@ -20482,7 +20400,7 @@
                 </a:solidFill>
                 <a:latin typeface="Arial"/>
               </a:rPr>
-              <a:t>Lim (2016), p. 232, Figure 7.39. The numbered marks are for teaching.</a:t>
+              <a:t>Chart W is ours, with invented monthly PHP values to show Lim (2016), p. 232.</a:t>
             </a:r>
           </a:p>
         </p:txBody>
@@ -22227,28 +22145,35 @@
           </a:p>
         </p:txBody>
       </p:sp>
-      <p:cxnSp>
-        <p:nvCxnSpPr>
-          <p:cNvPr id="18" name="Connector 17"/>
-          <p:cNvCxnSpPr/>
-          <p:nvPr/>
-        </p:nvCxnSpPr>
-        <p:spPr>
-          <a:xfrm>
-            <a:off x="8016453" y="3914085"/>
-            <a:ext cx="1217962" cy="0"/>
-          </a:xfrm>
-          <a:prstGeom prst="line">
-            <a:avLst/>
-          </a:prstGeom>
+      <p:sp>
+        <p:nvSpPr>
+          <p:cNvPr id="18" name="Rectangle 17"/>
+          <p:cNvSpPr/>
+          <p:nvPr/>
+        </p:nvSpPr>
+        <p:spPr>
+          <a:xfrm>
+            <a:off x="7875919" y="2299935"/>
+            <a:ext cx="1311651" cy="1669809"/>
+          </a:xfrm>
+          <a:prstGeom prst="rect">
+            <a:avLst/>
+          </a:prstGeom>
+          <a:noFill/>
           <a:ln w="44450">
             <a:solidFill>
               <a:srgbClr val="E09B00"/>
             </a:solidFill>
-            <a:tailEnd type="triangle" w="med" len="med"/>
-          </a:ln>
-        </p:spPr>
-      </p:cxnSp>
+          </a:ln>
+        </p:spPr>
+        <p:txBody>
+          <a:bodyPr rtlCol="0" anchor="ctr"/>
+          <a:lstStyle/>
+          <a:p>
+            <a:pPr algn="ctr"/>
+          </a:p>
+        </p:txBody>
+      </p:sp>
       <p:sp>
         <p:nvSpPr>
           <p:cNvPr id="19" name="Rectangle 18"/>
@@ -22257,8 +22182,8 @@
         </p:nvSpPr>
         <p:spPr>
           <a:xfrm>
-            <a:off x="8906502" y="3051350"/>
-            <a:ext cx="421602" cy="1001885"/>
+            <a:off x="8953347" y="2884369"/>
+            <a:ext cx="234223" cy="1085376"/>
           </a:xfrm>
           <a:prstGeom prst="rect">
             <a:avLst/>
@@ -22286,8 +22211,8 @@
         </p:nvCxnSpPr>
         <p:spPr>
           <a:xfrm>
-            <a:off x="9140726" y="3134840"/>
-            <a:ext cx="0" cy="918395"/>
+            <a:off x="9093881" y="2912199"/>
+            <a:ext cx="0" cy="1057546"/>
           </a:xfrm>
           <a:prstGeom prst="line">
             <a:avLst/>
@@ -22307,7 +22232,7 @@
         </p:nvSpPr>
         <p:spPr>
           <a:xfrm>
-            <a:off x="7738759" y="3609944"/>
+            <a:off x="7410846" y="2580228"/>
             <a:ext cx="274320" cy="274320"/>
           </a:xfrm>
           <a:prstGeom prst="ellipse">
@@ -22358,7 +22283,7 @@
         </p:nvSpPr>
         <p:spPr>
           <a:xfrm>
-            <a:off x="9425168" y="2747209"/>
+            <a:off x="9284634" y="3693434"/>
             <a:ext cx="274320" cy="274320"/>
           </a:xfrm>
           <a:prstGeom prst="ellipse">
@@ -22409,7 +22334,7 @@
         </p:nvSpPr>
         <p:spPr>
           <a:xfrm>
-            <a:off x="9472013" y="3637774"/>
+            <a:off x="9472013" y="3582113"/>
             <a:ext cx="274320" cy="274320"/>
           </a:xfrm>
           <a:prstGeom prst="ellipse">
@@ -23223,28 +23148,35 @@
           </a:p>
         </p:txBody>
       </p:sp>
-      <p:cxnSp>
-        <p:nvCxnSpPr>
-          <p:cNvPr id="18" name="Connector 17"/>
-          <p:cNvCxnSpPr/>
-          <p:nvPr/>
-        </p:nvCxnSpPr>
-        <p:spPr>
-          <a:xfrm>
-            <a:off x="8016453" y="3861798"/>
-            <a:ext cx="1217962" cy="0"/>
-          </a:xfrm>
-          <a:prstGeom prst="line">
-            <a:avLst/>
-          </a:prstGeom>
+      <p:sp>
+        <p:nvSpPr>
+          <p:cNvPr id="18" name="Rectangle 17"/>
+          <p:cNvSpPr/>
+          <p:nvPr/>
+        </p:nvSpPr>
+        <p:spPr>
+          <a:xfrm>
+            <a:off x="7875919" y="2280257"/>
+            <a:ext cx="1311651" cy="1636076"/>
+          </a:xfrm>
+          <a:prstGeom prst="rect">
+            <a:avLst/>
+          </a:prstGeom>
+          <a:noFill/>
           <a:ln w="44450">
             <a:solidFill>
               <a:srgbClr val="E09B00"/>
             </a:solidFill>
-            <a:tailEnd type="triangle" w="med" len="med"/>
-          </a:ln>
-        </p:spPr>
-      </p:cxnSp>
+          </a:ln>
+        </p:spPr>
+        <p:txBody>
+          <a:bodyPr rtlCol="0" anchor="ctr"/>
+          <a:lstStyle/>
+          <a:p>
+            <a:pPr algn="ctr"/>
+          </a:p>
+        </p:txBody>
+      </p:sp>
       <p:sp>
         <p:nvSpPr>
           <p:cNvPr id="19" name="Rectangle 18"/>
@@ -23253,8 +23185,8 @@
         </p:nvSpPr>
         <p:spPr>
           <a:xfrm>
-            <a:off x="8906502" y="3016492"/>
-            <a:ext cx="421602" cy="981645"/>
+            <a:off x="8953347" y="2852884"/>
+            <a:ext cx="234223" cy="1063449"/>
           </a:xfrm>
           <a:prstGeom prst="rect">
             <a:avLst/>
@@ -23282,8 +23214,8 @@
         </p:nvCxnSpPr>
         <p:spPr>
           <a:xfrm>
-            <a:off x="9140726" y="3098295"/>
-            <a:ext cx="0" cy="899842"/>
+            <a:off x="9093881" y="2880152"/>
+            <a:ext cx="0" cy="1036181"/>
           </a:xfrm>
           <a:prstGeom prst="line">
             <a:avLst/>
@@ -23303,7 +23235,7 @@
         </p:nvSpPr>
         <p:spPr>
           <a:xfrm>
-            <a:off x="7738759" y="3561030"/>
+            <a:off x="7410846" y="2552116"/>
             <a:ext cx="274320" cy="274320"/>
           </a:xfrm>
           <a:prstGeom prst="ellipse">
@@ -23354,7 +23286,7 @@
         </p:nvSpPr>
         <p:spPr>
           <a:xfrm>
-            <a:off x="9425168" y="2715724"/>
+            <a:off x="9284634" y="3642834"/>
             <a:ext cx="274320" cy="274320"/>
           </a:xfrm>
           <a:prstGeom prst="ellipse">
@@ -23405,7 +23337,7 @@
         </p:nvSpPr>
         <p:spPr>
           <a:xfrm>
-            <a:off x="9472013" y="3588298"/>
+            <a:off x="9472013" y="3533762"/>
             <a:ext cx="274320" cy="274320"/>
           </a:xfrm>
           <a:prstGeom prst="ellipse">

</xml_diff>

<commit_message>
Expand Figure 7.38 counted-bar mark
</commit_message>
<xml_diff>
--- a/chapter-07/FIN1209-Chapter-07.pptx
+++ b/chapter-07/FIN1209-Chapter-07.pptx
@@ -29240,7 +29240,7 @@
         <p:spPr>
           <a:xfrm>
             <a:off x="777240" y="1965960"/>
-            <a:ext cx="6583680" cy="3108960"/>
+            <a:ext cx="5943600" cy="3108960"/>
           </a:xfrm>
           <a:prstGeom prst="rect">
             <a:avLst/>
@@ -29265,7 +29265,7 @@
               </a:spcAft>
             </a:pPr>
             <a:r>
-              <a:rPr sz="1900" b="0" i="0">
+              <a:rPr sz="1700" b="0" i="0">
                 <a:solidFill>
                   <a:srgbClr val="1A1A1A"/>
                 </a:solidFill>
@@ -29274,7 +29274,7 @@
               <a:t>The book's schematic shows the last six bars counted for ID/NR6 </a:t>
             </a:r>
             <a:r>
-              <a:rPr sz="1900" b="1" i="0">
+              <a:rPr sz="1700" b="1" i="0">
                 <a:solidFill>
                   <a:srgbClr val="E09B00"/>
                 </a:solidFill>
@@ -29283,7 +29283,7 @@
               <a:t>(1)</a:t>
             </a:r>
             <a:r>
-              <a:rPr sz="1900" b="0" i="0">
+              <a:rPr sz="1700" b="0" i="0">
                 <a:solidFill>
                   <a:srgbClr val="1A1A1A"/>
                 </a:solidFill>
@@ -29292,7 +29292,7 @@
               <a:t>. The final bar is inside the prior range </a:t>
             </a:r>
             <a:r>
-              <a:rPr sz="1900" b="1" i="0">
+              <a:rPr sz="1700" b="1" i="0">
                 <a:solidFill>
                   <a:srgbClr val="C62828"/>
                 </a:solidFill>
@@ -29301,7 +29301,7 @@
               <a:t>(2)</a:t>
             </a:r>
             <a:r>
-              <a:rPr sz="1900" b="0" i="0">
+              <a:rPr sz="1700" b="0" i="0">
                 <a:solidFill>
                   <a:srgbClr val="1A1A1A"/>
                 </a:solidFill>
@@ -29310,7 +29310,7 @@
               <a:t> and is the narrowest of those six </a:t>
             </a:r>
             <a:r>
-              <a:rPr sz="1900" b="1" i="0">
+              <a:rPr sz="1700" b="1" i="0">
                 <a:solidFill>
                   <a:srgbClr val="1F5FAD"/>
                 </a:solidFill>
@@ -29319,7 +29319,7 @@
               <a:t>(3)</a:t>
             </a:r>
             <a:r>
-              <a:rPr sz="1900" b="0" i="0">
+              <a:rPr sz="1700" b="0" i="0">
                 <a:solidFill>
                   <a:srgbClr val="1A1A1A"/>
                 </a:solidFill>
@@ -29341,7 +29341,7 @@
               </a:spcAft>
             </a:pPr>
             <a:r>
-              <a:rPr sz="1900" b="0" i="0">
+              <a:rPr sz="1700" b="0" i="0">
                 <a:solidFill>
                   <a:srgbClr val="1A1A1A"/>
                 </a:solidFill>
@@ -29363,7 +29363,7 @@
               </a:spcAft>
             </a:pPr>
             <a:r>
-              <a:rPr sz="1900" b="0" i="0">
+              <a:rPr sz="1700" b="0" i="0">
                 <a:solidFill>
                   <a:srgbClr val="1A1A1A"/>
                 </a:solidFill>
@@ -29382,8 +29382,8 @@
         </p:nvSpPr>
         <p:spPr>
           <a:xfrm>
-            <a:off x="777240" y="5093208"/>
-            <a:ext cx="82296" cy="451103"/>
+            <a:off x="777240" y="4837176"/>
+            <a:ext cx="82296" cy="420623"/>
           </a:xfrm>
           <a:prstGeom prst="rect">
             <a:avLst/>
@@ -29412,8 +29412,8 @@
         </p:nvSpPr>
         <p:spPr>
           <a:xfrm>
-            <a:off x="1069848" y="5129784"/>
-            <a:ext cx="6291072" cy="451103"/>
+            <a:off x="1069848" y="4873752"/>
+            <a:ext cx="5650992" cy="420623"/>
           </a:xfrm>
           <a:prstGeom prst="rect">
             <a:avLst/>
@@ -29438,7 +29438,7 @@
               </a:spcAft>
             </a:pPr>
             <a:r>
-              <a:rPr sz="2000" b="1" i="0">
+              <a:rPr sz="1800" b="1" i="0">
                 <a:solidFill>
                   <a:srgbClr val="1A1A1A"/>
                 </a:solidFill>
@@ -29457,8 +29457,8 @@
         </p:nvSpPr>
         <p:spPr>
           <a:xfrm>
-            <a:off x="777240" y="5745480"/>
-            <a:ext cx="6583680" cy="731520"/>
+            <a:off x="777240" y="5458968"/>
+            <a:ext cx="5943600" cy="731520"/>
           </a:xfrm>
           <a:prstGeom prst="rect">
             <a:avLst/>
@@ -29502,8 +29502,8 @@
         </p:nvSpPr>
         <p:spPr>
           <a:xfrm>
-            <a:off x="7680960" y="1810512"/>
-            <a:ext cx="3824934" cy="2368872"/>
+            <a:off x="7040879" y="1810512"/>
+            <a:ext cx="4510735" cy="2776302"/>
           </a:xfrm>
           <a:prstGeom prst="rect">
             <a:avLst/>
@@ -29534,8 +29534,8 @@
         </p:nvSpPr>
         <p:spPr>
           <a:xfrm>
-            <a:off x="7799832" y="1929384"/>
-            <a:ext cx="3587190" cy="2131128"/>
+            <a:off x="7159751" y="1929384"/>
+            <a:ext cx="4272991" cy="2538558"/>
           </a:xfrm>
           <a:prstGeom prst="rect">
             <a:avLst/>
@@ -29566,8 +29566,8 @@
         </p:nvSpPr>
         <p:spPr>
           <a:xfrm>
-            <a:off x="7799832" y="1929384"/>
-            <a:ext cx="3587190" cy="50800"/>
+            <a:off x="7159751" y="1929384"/>
+            <a:ext cx="4272991" cy="50800"/>
           </a:xfrm>
           <a:prstGeom prst="rect">
             <a:avLst/>
@@ -29596,8 +29596,8 @@
         </p:nvSpPr>
         <p:spPr>
           <a:xfrm>
-            <a:off x="8074152" y="2203703"/>
-            <a:ext cx="3038550" cy="1673928"/>
+            <a:off x="7434071" y="2203703"/>
+            <a:ext cx="3724351" cy="2081358"/>
           </a:xfrm>
           <a:prstGeom prst="rect">
             <a:avLst/>
@@ -29644,7 +29644,7 @@
               </a:spcAft>
             </a:pPr>
             <a:r>
-              <a:rPr sz="1300" b="0" i="0">
+              <a:rPr sz="1500" b="0" i="0">
                 <a:solidFill>
                   <a:srgbClr val="1A1A1A"/>
                 </a:solidFill>
@@ -29663,8 +29663,8 @@
         </p:nvSpPr>
         <p:spPr>
           <a:xfrm>
-            <a:off x="8768373" y="2675279"/>
-            <a:ext cx="1004413" cy="1278677"/>
+            <a:off x="8313459" y="2081697"/>
+            <a:ext cx="1196437" cy="2335473"/>
           </a:xfrm>
           <a:prstGeom prst="rect">
             <a:avLst/>
@@ -29692,8 +29692,8 @@
         </p:nvSpPr>
         <p:spPr>
           <a:xfrm>
-            <a:off x="9593427" y="3122816"/>
-            <a:ext cx="179359" cy="831140"/>
+            <a:off x="9296247" y="3350976"/>
+            <a:ext cx="213649" cy="990037"/>
           </a:xfrm>
           <a:prstGeom prst="rect">
             <a:avLst/>
@@ -29721,8 +29721,8 @@
         </p:nvCxnSpPr>
         <p:spPr>
           <a:xfrm>
-            <a:off x="9701043" y="3144127"/>
-            <a:ext cx="0" cy="809829"/>
+            <a:off x="9424437" y="3376362"/>
+            <a:ext cx="0" cy="964652"/>
           </a:xfrm>
           <a:prstGeom prst="line">
             <a:avLst/>
@@ -29742,7 +29742,7 @@
         </p:nvSpPr>
         <p:spPr>
           <a:xfrm>
-            <a:off x="8200750" y="3539749"/>
+            <a:off x="7663540" y="3873841"/>
             <a:ext cx="274320" cy="274320"/>
           </a:xfrm>
           <a:prstGeom prst="ellipse">
@@ -29793,7 +29793,7 @@
         </p:nvSpPr>
         <p:spPr>
           <a:xfrm>
-            <a:off x="9743242" y="3710239"/>
+            <a:off x="9500926" y="4076926"/>
             <a:ext cx="274320" cy="274320"/>
           </a:xfrm>
           <a:prstGeom prst="ellipse">
@@ -29844,7 +29844,7 @@
         </p:nvSpPr>
         <p:spPr>
           <a:xfrm>
-            <a:off x="10173705" y="3710239"/>
+            <a:off x="10013685" y="4076926"/>
             <a:ext cx="274320" cy="274320"/>
           </a:xfrm>
           <a:prstGeom prst="ellipse">
@@ -29895,8 +29895,8 @@
         </p:nvSpPr>
         <p:spPr>
           <a:xfrm>
-            <a:off x="7680960" y="4270824"/>
-            <a:ext cx="3824934" cy="274320"/>
+            <a:off x="7040879" y="4678254"/>
+            <a:ext cx="4510735" cy="274320"/>
           </a:xfrm>
           <a:prstGeom prst="rect">
             <a:avLst/>
@@ -29921,7 +29921,7 @@
               </a:spcAft>
             </a:pPr>
             <a:r>
-              <a:rPr sz="900" b="0" i="0">
+              <a:rPr sz="1000" b="0" i="0">
                 <a:solidFill>
                   <a:srgbClr val="818181"/>
                 </a:solidFill>
@@ -33960,8 +33960,8 @@
         </p:nvSpPr>
         <p:spPr>
           <a:xfrm>
-            <a:off x="7875919" y="2299935"/>
-            <a:ext cx="1311651" cy="1669809"/>
+            <a:off x="7875919" y="1492860"/>
+            <a:ext cx="1311651" cy="2560374"/>
           </a:xfrm>
           <a:prstGeom prst="rect">
             <a:avLst/>
@@ -35896,8 +35896,8 @@
         </p:nvSpPr>
         <p:spPr>
           <a:xfrm>
-            <a:off x="7875919" y="2280257"/>
-            <a:ext cx="1311651" cy="1636076"/>
+            <a:off x="7875919" y="1489487"/>
+            <a:ext cx="1311651" cy="2508650"/>
           </a:xfrm>
           <a:prstGeom prst="rect">
             <a:avLst/>

</xml_diff>

<commit_message>
Clear Figure 7.38 teaching badge
</commit_message>
<xml_diff>
--- a/chapter-07/FIN1209-Chapter-07.pptx
+++ b/chapter-07/FIN1209-Chapter-07.pptx
@@ -17928,7 +17928,7 @@
         </p:nvSpPr>
         <p:spPr>
           <a:xfrm>
-            <a:off x="8380110" y="2857788"/>
+            <a:off x="8200750" y="3539749"/>
             <a:ext cx="274320" cy="274320"/>
           </a:xfrm>
           <a:prstGeom prst="ellipse">
@@ -22225,7 +22225,7 @@
         </p:nvSpPr>
         <p:spPr>
           <a:xfrm>
-            <a:off x="7410846" y="2580228"/>
+            <a:off x="7176622" y="3470793"/>
             <a:ext cx="274320" cy="274320"/>
           </a:xfrm>
           <a:prstGeom prst="ellipse">
@@ -23228,7 +23228,7 @@
         </p:nvSpPr>
         <p:spPr>
           <a:xfrm>
-            <a:off x="7410846" y="2552116"/>
+            <a:off x="7176622" y="3424690"/>
             <a:ext cx="274320" cy="274320"/>
           </a:xfrm>
           <a:prstGeom prst="ellipse">

</xml_diff>

<commit_message>
Fix Chapter 7 volatility breakout teaching marks
</commit_message>
<xml_diff>
--- a/chapter-07/FIN1209-Chapter-07.pptx
+++ b/chapter-07/FIN1209-Chapter-07.pptx
@@ -39,6 +39,7 @@
     <p:sldId id="287" r:id="rId39"/>
     <p:sldId id="288" r:id="rId40"/>
     <p:sldId id="289" r:id="rId41"/>
+    <p:sldId id="290" r:id="rId42"/>
   </p:sldIdLst>
   <p:sldSz cx="12191695" cy="6858000" type="screen4x3"/>
   <p:notesSz cx="6858000" cy="9144000"/>
@@ -1217,19 +1218,13 @@
           <a:p>
             <a:r>
               <a:rPr sz="1400"/>
-              <a:t>- The crop enlarges the Oops annotations and leaves the price sequence visible.</a:t>
+              <a:t>- The previous bar's low is PHP 48.00. The next bar opens at PHP 47.00, below that low.</a:t>
             </a:r>
           </a:p>
           <a:p>
             <a:r>
               <a:rPr sz="1400"/>
-              <a:t>- The book gives a bearish example; the exact order rule was defined on the previous slide.</a:t>
-            </a:r>
-          </a:p>
-          <a:p>
-            <a:r>
-              <a:rPr sz="1400"/>
-              <a:t>- Keep this as a potential setup. The book does not give a complete trade plan here.</a:t>
+              <a:t>- The buy-stop is PHP 48.00 and the new low and stoploss are PHP 46.00.</a:t>
             </a:r>
           </a:p>
         </p:txBody>
@@ -1780,7 +1775,7 @@
           <a:p>
             <a:r>
               <a:rPr sz="1400"/>
-              <a:t>- The blue box contains both printed trigger arrows; either direction is possible before the break.</a:t>
+              <a:t>- The blue line crosses both printed trigger levels; either direction is possible before the break.</a:t>
             </a:r>
           </a:p>
         </p:txBody>
@@ -2402,13 +2397,13 @@
           <a:p>
             <a:r>
               <a:rPr sz="1400"/>
-              <a:t>- Point back to the earlier Chapter 5 terms for the definitions the book says to recall.</a:t>
+              <a:t>- Point back to the earlier Chapter 5 terms for the first eight characteristics.</a:t>
             </a:r>
           </a:p>
           <a:p>
             <a:r>
               <a:rPr sz="1400"/>
-              <a:t>- Read barrier proximity as the strongest reliability emphasis in this chapter.</a:t>
+              <a:t>- Read every name as evidence, not certainty.</a:t>
             </a:r>
           </a:p>
         </p:txBody>
@@ -2479,13 +2474,13 @@
           <a:p>
             <a:r>
               <a:rPr sz="1400"/>
-              <a:t>- Gold mark 1 brackets pattern 1 and red mark 2 brackets pattern 2.</a:t>
+              <a:t>- Point back to the earlier Chapter 5 terms for the remaining definitions the book says to recall.</a:t>
             </a:r>
           </a:p>
           <a:p>
             <a:r>
               <a:rPr sz="1400"/>
-              <a:t>- Blue mark 3 sits beside the source's uptrend context. Read the source conditions rather than inventing a trade rule.</a:t>
+              <a:t>- Read barrier proximity as the strongest reliability emphasis in this chapter.</a:t>
             </a:r>
           </a:p>
         </p:txBody>
@@ -2556,13 +2551,13 @@
           <a:p>
             <a:r>
               <a:rPr sz="1400"/>
-              <a:t>- Gold mark 1 identifies the wide first bar near resistance; red mark 2 identifies the narrow inside bar.</a:t>
+              <a:t>- Gold mark 1 brackets pattern 1 and red mark 2 brackets pattern 2.</a:t>
             </a:r>
           </a:p>
           <a:p>
             <a:r>
               <a:rPr sz="1400"/>
-              <a:t>- Blue mark 3 identifies the lower oscillator region shown in the source. Chapter 7 does not teach its calculation.</a:t>
+              <a:t>- Blue mark 3 sits beside the source's uptrend context. Read the source conditions rather than inventing a trade rule.</a:t>
             </a:r>
           </a:p>
         </p:txBody>
@@ -2588,6 +2583,83 @@
 </file>
 
 <file path=ppt/notesSlides/notesSlide34.xml><?xml version="1.0" encoding="utf-8"?>
+<p:notes xmlns:a="http://schemas.openxmlformats.org/drawingml/2006/main" xmlns:p="http://schemas.openxmlformats.org/presentationml/2006/main" xmlns:r="http://schemas.openxmlformats.org/officeDocument/2006/relationships">
+  <p:cSld>
+    <p:spTree>
+      <p:nvGrpSpPr>
+        <p:cNvPr id="1" name=""/>
+        <p:cNvGrpSpPr/>
+        <p:nvPr/>
+      </p:nvGrpSpPr>
+      <p:grpSpPr>
+        <a:xfrm>
+          <a:off x="0" y="0"/>
+          <a:ext cx="0" cy="0"/>
+          <a:chOff x="0" y="0"/>
+          <a:chExt cx="0" cy="0"/>
+        </a:xfrm>
+      </p:grpSpPr>
+      <p:sp>
+        <p:nvSpPr>
+          <p:cNvPr id="2" name="Slide Image Placeholder 1"/>
+          <p:cNvSpPr>
+            <a:spLocks noGrp="1"/>
+          </p:cNvSpPr>
+          <p:nvPr>
+            <p:ph type="sldImg" idx="2"/>
+          </p:nvPr>
+        </p:nvSpPr>
+        <p:spPr/>
+      </p:sp>
+      <p:sp>
+        <p:nvSpPr>
+          <p:cNvPr id="3" name="Notes Placeholder 2"/>
+          <p:cNvSpPr>
+            <a:spLocks noGrp="1"/>
+          </p:cNvSpPr>
+          <p:nvPr>
+            <p:ph type="body" idx="3" sz="quarter"/>
+          </p:nvPr>
+        </p:nvSpPr>
+        <p:spPr/>
+        <p:txBody>
+          <a:bodyPr/>
+          <a:lstStyle/>
+          <a:p>
+            <a:r>
+              <a:rPr sz="1400"/>
+              <a:t>- Gold mark 1 identifies the wide first bar near resistance; red mark 2 identifies the narrow inside bar.</a:t>
+            </a:r>
+          </a:p>
+          <a:p>
+            <a:r>
+              <a:rPr sz="1400"/>
+              <a:t>- Blue mark 3 identifies the lower oscillator region shown in the source. Chapter 7 does not teach its calculation.</a:t>
+            </a:r>
+          </a:p>
+        </p:txBody>
+      </p:sp>
+      <p:sp>
+        <p:nvSpPr>
+          <p:cNvPr id="4" name="Slide Number Placeholder 3"/>
+          <p:cNvSpPr>
+            <a:spLocks noGrp="1"/>
+          </p:cNvSpPr>
+          <p:nvPr>
+            <p:ph type="sldNum" idx="5" sz="quarter"/>
+          </p:nvPr>
+        </p:nvSpPr>
+        <p:spPr/>
+      </p:sp>
+    </p:spTree>
+  </p:cSld>
+  <p:clrMapOvr>
+    <a:masterClrMapping/>
+  </p:clrMapOvr>
+</p:notes>
+</file>
+
+<file path=ppt/notesSlides/notesSlide35.xml><?xml version="1.0" encoding="utf-8"?>
 <p:notes xmlns:a="http://schemas.openxmlformats.org/drawingml/2006/main" xmlns:p="http://schemas.openxmlformats.org/presentationml/2006/main" xmlns:r="http://schemas.openxmlformats.org/officeDocument/2006/relationships">
   <p:cSld>
     <p:spTree>
@@ -12792,7 +12864,7 @@
                 </a:solidFill>
                 <a:latin typeface="Arial"/>
               </a:rPr>
-              <a:t>Right is the converse: gap up, sell-stop at previous high, stoploss at new high.</a:t>
+              <a:t>Right is the unmarked converse: gap up, sell-stop at previous high, stoploss at new high.</a:t>
             </a:r>
           </a:p>
           <a:p>
@@ -13108,8 +13180,8 @@
         </p:nvSpPr>
         <p:spPr>
           <a:xfrm>
-            <a:off x="8422309" y="2760792"/>
-            <a:ext cx="316236" cy="232021"/>
+            <a:off x="8145603" y="3166829"/>
+            <a:ext cx="395295" cy="135345"/>
           </a:xfrm>
           <a:prstGeom prst="ellipse">
             <a:avLst/>
@@ -13129,64 +13201,48 @@
           </a:p>
         </p:txBody>
       </p:sp>
-      <p:sp>
-        <p:nvSpPr>
-          <p:cNvPr id="16" name="Oval 15"/>
-          <p:cNvSpPr/>
-          <p:nvPr/>
-        </p:nvSpPr>
-        <p:spPr>
-          <a:xfrm>
-            <a:off x="8540898" y="2973478"/>
-            <a:ext cx="395295" cy="193350"/>
-          </a:xfrm>
-          <a:prstGeom prst="ellipse">
-            <a:avLst/>
-          </a:prstGeom>
-          <a:noFill/>
+      <p:cxnSp>
+        <p:nvCxnSpPr>
+          <p:cNvPr id="16" name="Connector 15"/>
+          <p:cNvCxnSpPr/>
+          <p:nvPr/>
+        </p:nvCxnSpPr>
+        <p:spPr>
+          <a:xfrm>
+            <a:off x="8619957" y="3031483"/>
+            <a:ext cx="632472" cy="0"/>
+          </a:xfrm>
+          <a:prstGeom prst="line">
+            <a:avLst/>
+          </a:prstGeom>
           <a:ln w="44450">
             <a:solidFill>
               <a:srgbClr val="C62828"/>
             </a:solidFill>
           </a:ln>
         </p:spPr>
-        <p:txBody>
-          <a:bodyPr rtlCol="0" anchor="ctr"/>
-          <a:lstStyle/>
-          <a:p>
-            <a:pPr algn="ctr"/>
-          </a:p>
-        </p:txBody>
-      </p:sp>
-      <p:sp>
-        <p:nvSpPr>
-          <p:cNvPr id="17" name="Oval 16"/>
-          <p:cNvSpPr/>
-          <p:nvPr/>
-        </p:nvSpPr>
-        <p:spPr>
-          <a:xfrm>
-            <a:off x="8540898" y="3321510"/>
-            <a:ext cx="395295" cy="232021"/>
-          </a:xfrm>
-          <a:prstGeom prst="ellipse">
-            <a:avLst/>
-          </a:prstGeom>
-          <a:noFill/>
+      </p:cxnSp>
+      <p:cxnSp>
+        <p:nvCxnSpPr>
+          <p:cNvPr id="17" name="Connector 16"/>
+          <p:cNvCxnSpPr/>
+          <p:nvPr/>
+        </p:nvCxnSpPr>
+        <p:spPr>
+          <a:xfrm>
+            <a:off x="8619957" y="3379515"/>
+            <a:ext cx="711531" cy="0"/>
+          </a:xfrm>
+          <a:prstGeom prst="line">
+            <a:avLst/>
+          </a:prstGeom>
           <a:ln w="44450">
             <a:solidFill>
               <a:srgbClr val="1F5FAD"/>
             </a:solidFill>
           </a:ln>
         </p:spPr>
-        <p:txBody>
-          <a:bodyPr rtlCol="0" anchor="ctr"/>
-          <a:lstStyle/>
-          <a:p>
-            <a:pPr algn="ctr"/>
-          </a:p>
-        </p:txBody>
-      </p:sp>
+      </p:cxnSp>
       <p:sp>
         <p:nvSpPr>
           <p:cNvPr id="18" name="Oval 17"/>
@@ -13195,7 +13251,7 @@
         </p:nvSpPr>
         <p:spPr>
           <a:xfrm>
-            <a:off x="8087502" y="2526957"/>
+            <a:off x="7850325" y="3087674"/>
             <a:ext cx="274320" cy="274320"/>
           </a:xfrm>
           <a:prstGeom prst="ellipse">
@@ -13246,7 +13302,7 @@
         </p:nvSpPr>
         <p:spPr>
           <a:xfrm>
-            <a:off x="8957151" y="2816983"/>
+            <a:off x="9312917" y="2797648"/>
             <a:ext cx="274320" cy="274320"/>
           </a:xfrm>
           <a:prstGeom prst="ellipse">
@@ -13297,7 +13353,7 @@
         </p:nvSpPr>
         <p:spPr>
           <a:xfrm>
-            <a:off x="8957151" y="3455041"/>
+            <a:off x="9391976" y="3358365"/>
             <a:ext cx="274320" cy="274320"/>
           </a:xfrm>
           <a:prstGeom prst="ellipse">
@@ -13900,7 +13956,7 @@
         <p:spPr>
           <a:xfrm>
             <a:off x="7315199" y="1810512"/>
-            <a:ext cx="4236415" cy="1844352"/>
+            <a:ext cx="4236415" cy="2105736"/>
           </a:xfrm>
           <a:prstGeom prst="rect">
             <a:avLst/>
@@ -13923,145 +13979,40 @@
           </a:p>
         </p:txBody>
       </p:sp>
-      <p:sp>
-        <p:nvSpPr>
-          <p:cNvPr id="12" name="Rectangle 11"/>
+      <p:pic>
+        <p:nvPicPr>
+          <p:cNvPr id="12" name="Picture 11" descr="chart-v.png"/>
+          <p:cNvPicPr>
+            <a:picLocks noChangeAspect="1"/>
+          </p:cNvPicPr>
+          <p:nvPr/>
+        </p:nvPicPr>
+        <p:blipFill>
+          <a:blip r:embed="rId2"/>
+          <a:stretch>
+            <a:fillRect/>
+          </a:stretch>
+        </p:blipFill>
+        <p:spPr>
+          <a:xfrm>
+            <a:off x="7434071" y="1929384"/>
+            <a:ext cx="3998671" cy="1867992"/>
+          </a:xfrm>
+          <a:prstGeom prst="rect">
+            <a:avLst/>
+          </a:prstGeom>
+        </p:spPr>
+      </p:pic>
+      <p:sp>
+        <p:nvSpPr>
+          <p:cNvPr id="13" name="Oval 12"/>
           <p:cNvSpPr/>
           <p:nvPr/>
         </p:nvSpPr>
         <p:spPr>
           <a:xfrm>
-            <a:off x="7434071" y="1929384"/>
-            <a:ext cx="3998671" cy="1606608"/>
-          </a:xfrm>
-          <a:prstGeom prst="rect">
-            <a:avLst/>
-          </a:prstGeom>
-          <a:solidFill>
-            <a:srgbClr val="FFFFFF"/>
-          </a:solidFill>
-          <a:ln w="12700">
-            <a:solidFill>
-              <a:srgbClr val="D7E0D9"/>
-            </a:solidFill>
-          </a:ln>
-          <a:effectLst/>
-        </p:spPr>
-        <p:txBody>
-          <a:bodyPr rtlCol="0" anchor="ctr"/>
-          <a:lstStyle/>
-          <a:p>
-            <a:pPr algn="ctr"/>
-          </a:p>
-        </p:txBody>
-      </p:sp>
-      <p:sp>
-        <p:nvSpPr>
-          <p:cNvPr id="13" name="Rectangle 12"/>
-          <p:cNvSpPr/>
-          <p:nvPr/>
-        </p:nvSpPr>
-        <p:spPr>
-          <a:xfrm>
-            <a:off x="7434071" y="1929384"/>
-            <a:ext cx="3998671" cy="50800"/>
-          </a:xfrm>
-          <a:prstGeom prst="rect">
-            <a:avLst/>
-          </a:prstGeom>
-          <a:solidFill>
-            <a:srgbClr val="F2A900"/>
-          </a:solidFill>
-          <a:ln>
-            <a:noFill/>
-          </a:ln>
-          <a:effectLst/>
-        </p:spPr>
-        <p:txBody>
-          <a:bodyPr rtlCol="0" anchor="ctr"/>
-          <a:lstStyle/>
-          <a:p>
-            <a:pPr algn="ctr"/>
-          </a:p>
-        </p:txBody>
-      </p:sp>
-      <p:sp>
-        <p:nvSpPr>
-          <p:cNvPr id="14" name="TextBox 13"/>
-          <p:cNvSpPr txBox="1"/>
-          <p:nvPr/>
-        </p:nvSpPr>
-        <p:spPr>
-          <a:xfrm>
-            <a:off x="7708392" y="2203703"/>
-            <a:ext cx="3450031" cy="1149408"/>
-          </a:xfrm>
-          <a:prstGeom prst="rect">
-            <a:avLst/>
-          </a:prstGeom>
-          <a:noFill/>
-        </p:spPr>
-        <p:txBody>
-          <a:bodyPr wrap="square" anchor="t" lIns="0" rIns="0" tIns="0" bIns="0">
-            <a:spAutoFit/>
-          </a:bodyPr>
-          <a:lstStyle/>
-          <a:p>
-            <a:pPr algn="l">
-              <a:lnSpc>
-                <a:spcPct val="100000"/>
-              </a:lnSpc>
-              <a:spcBef>
-                <a:spcPts val="0"/>
-              </a:spcBef>
-              <a:spcAft>
-                <a:spcPts val="400"/>
-              </a:spcAft>
-            </a:pPr>
-            <a:r>
-              <a:rPr sz="1100" b="1" i="0">
-                <a:solidFill>
-                  <a:srgbClr val="818181"/>
-                </a:solidFill>
-                <a:latin typeface="Arial"/>
-              </a:rPr>
-              <a:t>FIGURE 7.37</a:t>
-            </a:r>
-          </a:p>
-          <a:p>
-            <a:pPr algn="l">
-              <a:lnSpc>
-                <a:spcPct val="115000"/>
-              </a:lnSpc>
-              <a:spcBef>
-                <a:spcPts val="0"/>
-              </a:spcBef>
-              <a:spcAft>
-                <a:spcPts val="0"/>
-              </a:spcAft>
-            </a:pPr>
-            <a:r>
-              <a:rPr sz="1100" b="0" i="0">
-                <a:solidFill>
-                  <a:srgbClr val="1A1A1A"/>
-                </a:solidFill>
-                <a:latin typeface="Palatino"/>
-              </a:rPr>
-              <a:t>The book's daily Dynegy chart marked at the bearish Oops opening gap, sell-stop at the prior high, stop-and-reverse buy level, and expected downside move.</a:t>
-            </a:r>
-          </a:p>
-        </p:txBody>
-      </p:sp>
-      <p:sp>
-        <p:nvSpPr>
-          <p:cNvPr id="15" name="Oval 14"/>
-          <p:cNvSpPr/>
-          <p:nvPr/>
-        </p:nvSpPr>
-        <p:spPr>
-          <a:xfrm>
-            <a:off x="10353101" y="2829084"/>
-            <a:ext cx="279906" cy="160660"/>
+            <a:off x="9873261" y="2564501"/>
+            <a:ext cx="239920" cy="112079"/>
           </a:xfrm>
           <a:prstGeom prst="ellipse">
             <a:avLst/>
@@ -14083,14 +14034,14 @@
       </p:sp>
       <p:sp>
         <p:nvSpPr>
-          <p:cNvPr id="16" name="Oval 15"/>
+          <p:cNvPr id="14" name="Oval 13"/>
           <p:cNvSpPr/>
           <p:nvPr/>
         </p:nvSpPr>
         <p:spPr>
           <a:xfrm>
-            <a:off x="10473061" y="2925481"/>
-            <a:ext cx="279906" cy="160660"/>
+            <a:off x="9873261" y="2844700"/>
+            <a:ext cx="239920" cy="112079"/>
           </a:xfrm>
           <a:prstGeom prst="ellipse">
             <a:avLst/>
@@ -14112,14 +14063,14 @@
       </p:sp>
       <p:sp>
         <p:nvSpPr>
-          <p:cNvPr id="17" name="Oval 16"/>
+          <p:cNvPr id="15" name="Oval 14"/>
           <p:cNvSpPr/>
           <p:nvPr/>
         </p:nvSpPr>
         <p:spPr>
           <a:xfrm>
-            <a:off x="10473061" y="2716622"/>
-            <a:ext cx="279906" cy="160660"/>
+            <a:off x="9873261" y="3236978"/>
+            <a:ext cx="239920" cy="112079"/>
           </a:xfrm>
           <a:prstGeom prst="ellipse">
             <a:avLst/>
@@ -14141,13 +14092,13 @@
       </p:sp>
       <p:sp>
         <p:nvSpPr>
-          <p:cNvPr id="18" name="Oval 17"/>
+          <p:cNvPr id="16" name="Oval 15"/>
           <p:cNvSpPr/>
           <p:nvPr/>
         </p:nvSpPr>
         <p:spPr>
           <a:xfrm>
-            <a:off x="10055994" y="2900784"/>
+            <a:off x="9376220" y="2576780"/>
             <a:ext cx="274320" cy="274320"/>
           </a:xfrm>
           <a:prstGeom prst="ellipse">
@@ -14192,13 +14143,13 @@
       </p:sp>
       <p:sp>
         <p:nvSpPr>
-          <p:cNvPr id="19" name="Oval 18"/>
+          <p:cNvPr id="17" name="Oval 16"/>
           <p:cNvSpPr/>
           <p:nvPr/>
         </p:nvSpPr>
         <p:spPr>
           <a:xfrm>
-            <a:off x="10775755" y="2997180"/>
+            <a:off x="10335901" y="2744900"/>
             <a:ext cx="274320" cy="274320"/>
           </a:xfrm>
           <a:prstGeom prst="ellipse">
@@ -14243,13 +14194,13 @@
       </p:sp>
       <p:sp>
         <p:nvSpPr>
-          <p:cNvPr id="20" name="Oval 19"/>
+          <p:cNvPr id="18" name="Oval 17"/>
           <p:cNvSpPr/>
           <p:nvPr/>
         </p:nvSpPr>
         <p:spPr>
           <a:xfrm>
-            <a:off x="10815742" y="2483065"/>
+            <a:off x="10335901" y="3323977"/>
             <a:ext cx="274320" cy="274320"/>
           </a:xfrm>
           <a:prstGeom prst="ellipse">
@@ -14294,13 +14245,13 @@
       </p:sp>
       <p:sp>
         <p:nvSpPr>
-          <p:cNvPr id="21" name="TextBox 20"/>
+          <p:cNvPr id="19" name="TextBox 18"/>
           <p:cNvSpPr txBox="1"/>
           <p:nvPr/>
         </p:nvSpPr>
         <p:spPr>
           <a:xfrm>
-            <a:off x="7315199" y="3746304"/>
+            <a:off x="7315199" y="4007688"/>
             <a:ext cx="4236415" cy="274320"/>
           </a:xfrm>
           <a:prstGeom prst="rect">
@@ -14332,14 +14283,14 @@
                 </a:solidFill>
                 <a:latin typeface="Arial"/>
               </a:rPr>
-              <a:t>Figure 7.37 - Lim, The Handbook of Technical Analysis (Wiley, 2016)</a:t>
-            </a:r>
-          </a:p>
-        </p:txBody>
-      </p:sp>
-      <p:sp>
-        <p:nvSpPr>
-          <p:cNvPr id="22" name="TextBox 21"/>
+              <a:t>Chart V - FIN1209 teaching chart, drawn for this course. Illustrative data, not a real instrument.</a:t>
+            </a:r>
+          </a:p>
+        </p:txBody>
+      </p:sp>
+      <p:sp>
+        <p:nvSpPr>
+          <p:cNvPr id="20" name="TextBox 19"/>
           <p:cNvSpPr txBox="1"/>
           <p:nvPr/>
         </p:nvSpPr>
@@ -14377,7 +14328,7 @@
                 </a:solidFill>
                 <a:latin typeface="Arial"/>
               </a:rPr>
-              <a:t>Lim (2016), p. 231, Figure 7.37. The crop and marks are for teaching.</a:t>
+              <a:t>Chart V is ours, with invented PHP values to show Lim (2016), p. 231.</a:t>
             </a:r>
           </a:p>
         </p:txBody>
@@ -15012,8 +14963,8 @@
         </p:nvSpPr>
         <p:spPr>
           <a:xfrm>
-            <a:off x="10319726" y="2818797"/>
-            <a:ext cx="276706" cy="158823"/>
+            <a:off x="10359255" y="2882327"/>
+            <a:ext cx="237177" cy="127059"/>
           </a:xfrm>
           <a:prstGeom prst="ellipse">
             <a:avLst/>
@@ -15033,64 +14984,48 @@
           </a:p>
         </p:txBody>
       </p:sp>
-      <p:sp>
-        <p:nvSpPr>
-          <p:cNvPr id="16" name="Oval 15"/>
-          <p:cNvSpPr/>
-          <p:nvPr/>
-        </p:nvSpPr>
-        <p:spPr>
-          <a:xfrm>
-            <a:off x="10438314" y="2914092"/>
-            <a:ext cx="276706" cy="158823"/>
-          </a:xfrm>
-          <a:prstGeom prst="ellipse">
-            <a:avLst/>
-          </a:prstGeom>
-          <a:noFill/>
+      <p:cxnSp>
+        <p:nvCxnSpPr>
+          <p:cNvPr id="16" name="Connector 15"/>
+          <p:cNvCxnSpPr/>
+          <p:nvPr/>
+        </p:nvCxnSpPr>
+        <p:spPr>
+          <a:xfrm>
+            <a:off x="10517373" y="2977621"/>
+            <a:ext cx="513884" cy="0"/>
+          </a:xfrm>
+          <a:prstGeom prst="line">
+            <a:avLst/>
+          </a:prstGeom>
           <a:ln w="44450">
             <a:solidFill>
               <a:srgbClr val="C62828"/>
             </a:solidFill>
           </a:ln>
         </p:spPr>
-        <p:txBody>
-          <a:bodyPr rtlCol="0" anchor="ctr"/>
-          <a:lstStyle/>
-          <a:p>
-            <a:pPr algn="ctr"/>
-          </a:p>
-        </p:txBody>
-      </p:sp>
-      <p:sp>
-        <p:nvSpPr>
-          <p:cNvPr id="17" name="Oval 16"/>
-          <p:cNvSpPr/>
-          <p:nvPr/>
-        </p:nvSpPr>
-        <p:spPr>
-          <a:xfrm>
-            <a:off x="10438314" y="2707621"/>
-            <a:ext cx="276706" cy="158823"/>
-          </a:xfrm>
-          <a:prstGeom prst="ellipse">
-            <a:avLst/>
-          </a:prstGeom>
-          <a:noFill/>
+      </p:cxnSp>
+      <p:cxnSp>
+        <p:nvCxnSpPr>
+          <p:cNvPr id="17" name="Connector 16"/>
+          <p:cNvCxnSpPr/>
+          <p:nvPr/>
+        </p:nvCxnSpPr>
+        <p:spPr>
+          <a:xfrm>
+            <a:off x="10517373" y="2898209"/>
+            <a:ext cx="513884" cy="0"/>
+          </a:xfrm>
+          <a:prstGeom prst="line">
+            <a:avLst/>
+          </a:prstGeom>
           <a:ln w="44450">
             <a:solidFill>
               <a:srgbClr val="1F5FAD"/>
             </a:solidFill>
           </a:ln>
         </p:spPr>
-        <p:txBody>
-          <a:bodyPr rtlCol="0" anchor="ctr"/>
-          <a:lstStyle/>
-          <a:p>
-            <a:pPr algn="ctr"/>
-          </a:p>
-        </p:txBody>
-      </p:sp>
+      </p:cxnSp>
       <p:sp>
         <p:nvSpPr>
           <p:cNvPr id="18" name="Oval 17"/>
@@ -15099,7 +15034,7 @@
         </p:nvSpPr>
         <p:spPr>
           <a:xfrm>
-            <a:off x="10024448" y="2888109"/>
+            <a:off x="10024448" y="2935756"/>
             <a:ext cx="274320" cy="274320"/>
           </a:xfrm>
           <a:prstGeom prst="ellipse">
@@ -15150,7 +15085,7 @@
         </p:nvSpPr>
         <p:spPr>
           <a:xfrm>
-            <a:off x="10735979" y="2983403"/>
+            <a:off x="10063977" y="2951638"/>
             <a:ext cx="274320" cy="274320"/>
           </a:xfrm>
           <a:prstGeom prst="ellipse">
@@ -15201,7 +15136,7 @@
         </p:nvSpPr>
         <p:spPr>
           <a:xfrm>
-            <a:off x="10775508" y="2475166"/>
+            <a:off x="11012685" y="2586343"/>
             <a:ext cx="274320" cy="274320"/>
           </a:xfrm>
           <a:prstGeom prst="ellipse">
@@ -17966,7 +17901,7 @@
         </p:nvCxnSpPr>
         <p:spPr>
           <a:xfrm>
-            <a:off x="8875989" y="3826088"/>
+            <a:off x="8875989" y="3911333"/>
             <a:ext cx="932669" cy="0"/>
           </a:xfrm>
           <a:prstGeom prst="line">
@@ -17976,6 +17911,7 @@
             <a:solidFill>
               <a:srgbClr val="E09B00"/>
             </a:solidFill>
+            <a:tailEnd type="triangle" w="med" len="med"/>
           </a:ln>
         </p:spPr>
       </p:cxnSp>
@@ -17987,8 +17923,8 @@
         </p:nvSpPr>
         <p:spPr>
           <a:xfrm>
-            <a:off x="9665171" y="2845769"/>
-            <a:ext cx="215231" cy="831140"/>
+            <a:off x="9557555" y="3250683"/>
+            <a:ext cx="322847" cy="767206"/>
           </a:xfrm>
           <a:prstGeom prst="rect">
             <a:avLst/>
@@ -18008,35 +17944,27 @@
           </a:p>
         </p:txBody>
       </p:sp>
-      <p:sp>
-        <p:nvSpPr>
-          <p:cNvPr id="17" name="Oval 16"/>
-          <p:cNvSpPr/>
-          <p:nvPr/>
-        </p:nvSpPr>
-        <p:spPr>
-          <a:xfrm>
-            <a:off x="9665171" y="3122816"/>
-            <a:ext cx="251103" cy="298358"/>
-          </a:xfrm>
-          <a:prstGeom prst="ellipse">
-            <a:avLst/>
-          </a:prstGeom>
-          <a:noFill/>
+      <p:cxnSp>
+        <p:nvCxnSpPr>
+          <p:cNvPr id="17" name="Connector 16"/>
+          <p:cNvCxnSpPr/>
+          <p:nvPr/>
+        </p:nvCxnSpPr>
+        <p:spPr>
+          <a:xfrm>
+            <a:off x="9736915" y="3314617"/>
+            <a:ext cx="0" cy="703273"/>
+          </a:xfrm>
+          <a:prstGeom prst="line">
+            <a:avLst/>
+          </a:prstGeom>
           <a:ln w="44450">
             <a:solidFill>
               <a:srgbClr val="1F5FAD"/>
             </a:solidFill>
           </a:ln>
         </p:spPr>
-        <p:txBody>
-          <a:bodyPr rtlCol="0" anchor="ctr"/>
-          <a:lstStyle/>
-          <a:p>
-            <a:pPr algn="ctr"/>
-          </a:p>
-        </p:txBody>
-      </p:sp>
+      </p:cxnSp>
       <p:sp>
         <p:nvSpPr>
           <p:cNvPr id="18" name="Oval 17"/>
@@ -18045,7 +17973,7 @@
         </p:nvSpPr>
         <p:spPr>
           <a:xfrm>
-            <a:off x="8667085" y="3774173"/>
+            <a:off x="8631213" y="3646305"/>
             <a:ext cx="274320" cy="274320"/>
           </a:xfrm>
           <a:prstGeom prst="ellipse">
@@ -18096,7 +18024,7 @@
         </p:nvSpPr>
         <p:spPr>
           <a:xfrm>
-            <a:off x="9850858" y="2644675"/>
+            <a:off x="9922602" y="2985656"/>
             <a:ext cx="274320" cy="274320"/>
           </a:xfrm>
           <a:prstGeom prst="ellipse">
@@ -18147,7 +18075,7 @@
         </p:nvSpPr>
         <p:spPr>
           <a:xfrm>
-            <a:off x="9958474" y="3347947"/>
+            <a:off x="9958474" y="3667617"/>
             <a:ext cx="274320" cy="274320"/>
           </a:xfrm>
           <a:prstGeom prst="ellipse">
@@ -19354,35 +19282,27 @@
           </a:p>
         </p:txBody>
       </p:sp>
-      <p:sp>
-        <p:nvSpPr>
-          <p:cNvPr id="15" name="Oval 14"/>
-          <p:cNvSpPr/>
-          <p:nvPr/>
-        </p:nvSpPr>
-        <p:spPr>
-          <a:xfrm>
-            <a:off x="9641396" y="3072258"/>
-            <a:ext cx="247902" cy="285718"/>
-          </a:xfrm>
-          <a:prstGeom prst="ellipse">
-            <a:avLst/>
-          </a:prstGeom>
-          <a:noFill/>
+      <p:cxnSp>
+        <p:nvCxnSpPr>
+          <p:cNvPr id="15" name="Connector 14"/>
+          <p:cNvCxnSpPr/>
+          <p:nvPr/>
+        </p:nvCxnSpPr>
+        <p:spPr>
+          <a:xfrm>
+            <a:off x="9712226" y="3255935"/>
+            <a:ext cx="0" cy="673479"/>
+          </a:xfrm>
+          <a:prstGeom prst="line">
+            <a:avLst/>
+          </a:prstGeom>
           <a:ln w="44450">
             <a:solidFill>
               <a:srgbClr val="E09B00"/>
             </a:solidFill>
           </a:ln>
         </p:spPr>
-        <p:txBody>
-          <a:bodyPr rtlCol="0" anchor="ctr"/>
-          <a:lstStyle/>
-          <a:p>
-            <a:pPr algn="ctr"/>
-          </a:p>
-        </p:txBody>
-      </p:sp>
+      </p:cxnSp>
       <p:sp>
         <p:nvSpPr>
           <p:cNvPr id="16" name="Rectangle 15"/>
@@ -19391,8 +19311,8 @@
         </p:nvSpPr>
         <p:spPr>
           <a:xfrm>
-            <a:off x="9641396" y="2806948"/>
-            <a:ext cx="212488" cy="795930"/>
+            <a:off x="9535152" y="3194709"/>
+            <a:ext cx="318732" cy="734705"/>
           </a:xfrm>
           <a:prstGeom prst="rect">
             <a:avLst/>
@@ -19441,7 +19361,7 @@
         </p:nvSpPr>
         <p:spPr>
           <a:xfrm>
-            <a:off x="9964628" y="3282042"/>
+            <a:off x="9929213" y="3588169"/>
             <a:ext cx="274320" cy="274320"/>
           </a:xfrm>
           <a:prstGeom prst="ellipse">
@@ -19492,7 +19412,7 @@
         </p:nvSpPr>
         <p:spPr>
           <a:xfrm>
-            <a:off x="9822969" y="2608563"/>
+            <a:off x="9893798" y="2935098"/>
             <a:ext cx="274320" cy="274320"/>
           </a:xfrm>
           <a:prstGeom prst="ellipse">
@@ -20252,7 +20172,7 @@
         </p:nvSpPr>
         <p:spPr>
           <a:xfrm>
-            <a:off x="9418429" y="2753134"/>
+            <a:off x="9528788" y="2825393"/>
             <a:ext cx="220717" cy="260131"/>
           </a:xfrm>
           <a:prstGeom prst="ellipse">
@@ -20281,8 +20201,8 @@
         </p:nvCxnSpPr>
         <p:spPr>
           <a:xfrm>
-            <a:off x="8609130" y="3143332"/>
-            <a:ext cx="919658" cy="0"/>
+            <a:off x="8609130" y="3201139"/>
+            <a:ext cx="1177162" cy="0"/>
           </a:xfrm>
           <a:prstGeom prst="line">
             <a:avLst/>
@@ -20291,6 +20211,7 @@
             <a:solidFill>
               <a:srgbClr val="C62828"/>
             </a:solidFill>
+            <a:tailEnd type="triangle" w="med" len="med"/>
           </a:ln>
         </p:spPr>
       </p:cxnSp>
@@ -20302,8 +20223,8 @@
         </p:nvSpPr>
         <p:spPr>
           <a:xfrm>
-            <a:off x="9675933" y="2175063"/>
-            <a:ext cx="220717" cy="592522"/>
+            <a:off x="9749506" y="2175063"/>
+            <a:ext cx="220717" cy="361294"/>
           </a:xfrm>
           <a:prstGeom prst="ellipse">
             <a:avLst/>
@@ -20331,7 +20252,7 @@
         </p:nvSpPr>
         <p:spPr>
           <a:xfrm>
-            <a:off x="9134124" y="2933913"/>
+            <a:off x="9207697" y="3006172"/>
             <a:ext cx="274320" cy="274320"/>
           </a:xfrm>
           <a:prstGeom prst="ellipse">
@@ -20382,7 +20303,7 @@
         </p:nvSpPr>
         <p:spPr>
           <a:xfrm>
-            <a:off x="8361611" y="3078431"/>
+            <a:off x="8324825" y="3136238"/>
             <a:ext cx="274320" cy="274320"/>
           </a:xfrm>
           <a:prstGeom prst="ellipse">
@@ -20433,7 +20354,7 @@
         </p:nvSpPr>
         <p:spPr>
           <a:xfrm>
-            <a:off x="9906636" y="1965645"/>
+            <a:off x="9980209" y="1965645"/>
             <a:ext cx="274320" cy="274320"/>
           </a:xfrm>
           <a:prstGeom prst="ellipse">
@@ -21196,7 +21117,7 @@
         </p:nvSpPr>
         <p:spPr>
           <a:xfrm>
-            <a:off x="9358079" y="2722420"/>
+            <a:off x="9464323" y="2791985"/>
             <a:ext cx="212488" cy="250432"/>
           </a:xfrm>
           <a:prstGeom prst="ellipse">
@@ -21225,8 +21146,8 @@
         </p:nvCxnSpPr>
         <p:spPr>
           <a:xfrm>
-            <a:off x="8578955" y="3098069"/>
-            <a:ext cx="885368" cy="0"/>
+            <a:off x="8578955" y="3153721"/>
+            <a:ext cx="1133271" cy="0"/>
           </a:xfrm>
           <a:prstGeom prst="line">
             <a:avLst/>
@@ -21235,6 +21156,7 @@
             <a:solidFill>
               <a:srgbClr val="C62828"/>
             </a:solidFill>
+            <a:tailEnd type="triangle" w="med" len="med"/>
           </a:ln>
         </p:spPr>
       </p:cxnSp>
@@ -21246,8 +21168,8 @@
         </p:nvSpPr>
         <p:spPr>
           <a:xfrm>
-            <a:off x="9605982" y="2165903"/>
-            <a:ext cx="212488" cy="570429"/>
+            <a:off x="9676811" y="2165903"/>
+            <a:ext cx="212488" cy="347823"/>
           </a:xfrm>
           <a:prstGeom prst="ellipse">
             <a:avLst/>
@@ -21275,7 +21197,7 @@
         </p:nvSpPr>
         <p:spPr>
           <a:xfrm>
-            <a:off x="9079260" y="2891344"/>
+            <a:off x="9150089" y="2960909"/>
             <a:ext cx="274320" cy="274320"/>
           </a:xfrm>
           <a:prstGeom prst="ellipse">
@@ -21326,7 +21248,7 @@
         </p:nvSpPr>
         <p:spPr>
           <a:xfrm>
-            <a:off x="8335551" y="3030474"/>
+            <a:off x="8300136" y="3086125"/>
             <a:ext cx="274320" cy="274320"/>
           </a:xfrm>
           <a:prstGeom prst="ellipse">
@@ -21377,7 +21299,7 @@
         </p:nvSpPr>
         <p:spPr>
           <a:xfrm>
-            <a:off x="9822969" y="1959179"/>
+            <a:off x="9893798" y="1959179"/>
             <a:ext cx="274320" cy="274320"/>
           </a:xfrm>
           <a:prstGeom prst="ellipse">
@@ -22313,7 +22235,7 @@
         </p:nvCxnSpPr>
         <p:spPr>
           <a:xfrm>
-            <a:off x="8016453" y="3802764"/>
+            <a:off x="8016453" y="3914085"/>
             <a:ext cx="1217962" cy="0"/>
           </a:xfrm>
           <a:prstGeom prst="line">
@@ -22323,6 +22245,7 @@
             <a:solidFill>
               <a:srgbClr val="E09B00"/>
             </a:solidFill>
+            <a:tailEnd type="triangle" w="med" len="med"/>
           </a:ln>
         </p:spPr>
       </p:cxnSp>
@@ -22334,8 +22257,8 @@
         </p:nvSpPr>
         <p:spPr>
           <a:xfrm>
-            <a:off x="9047036" y="2522576"/>
-            <a:ext cx="281068" cy="1085376"/>
+            <a:off x="8906502" y="3051350"/>
+            <a:ext cx="421602" cy="1001885"/>
           </a:xfrm>
           <a:prstGeom prst="rect">
             <a:avLst/>
@@ -22355,35 +22278,27 @@
           </a:p>
         </p:txBody>
       </p:sp>
-      <p:sp>
-        <p:nvSpPr>
-          <p:cNvPr id="20" name="Oval 19"/>
-          <p:cNvSpPr/>
-          <p:nvPr/>
-        </p:nvSpPr>
-        <p:spPr>
-          <a:xfrm>
-            <a:off x="9047036" y="2884369"/>
-            <a:ext cx="327912" cy="389622"/>
-          </a:xfrm>
-          <a:prstGeom prst="ellipse">
-            <a:avLst/>
-          </a:prstGeom>
-          <a:noFill/>
+      <p:cxnSp>
+        <p:nvCxnSpPr>
+          <p:cNvPr id="20" name="Connector 19"/>
+          <p:cNvCxnSpPr/>
+          <p:nvPr/>
+        </p:nvCxnSpPr>
+        <p:spPr>
+          <a:xfrm>
+            <a:off x="9140726" y="3134840"/>
+            <a:ext cx="0" cy="918395"/>
+          </a:xfrm>
+          <a:prstGeom prst="line">
+            <a:avLst/>
+          </a:prstGeom>
           <a:ln w="44450">
             <a:solidFill>
               <a:srgbClr val="1F5FAD"/>
             </a:solidFill>
           </a:ln>
         </p:spPr>
-        <p:txBody>
-          <a:bodyPr rtlCol="0" anchor="ctr"/>
-          <a:lstStyle/>
-          <a:p>
-            <a:pPr algn="ctr"/>
-          </a:p>
-        </p:txBody>
-      </p:sp>
+      </p:cxnSp>
       <p:sp>
         <p:nvSpPr>
           <p:cNvPr id="21" name="Oval 20"/>
@@ -22392,7 +22307,7 @@
         </p:nvSpPr>
         <p:spPr>
           <a:xfrm>
-            <a:off x="7785603" y="3776925"/>
+            <a:off x="7738759" y="3609944"/>
             <a:ext cx="274320" cy="274320"/>
           </a:xfrm>
           <a:prstGeom prst="ellipse">
@@ -22443,7 +22358,7 @@
         </p:nvSpPr>
         <p:spPr>
           <a:xfrm>
-            <a:off x="9331479" y="2301926"/>
+            <a:off x="9425168" y="2747209"/>
             <a:ext cx="274320" cy="274320"/>
           </a:xfrm>
           <a:prstGeom prst="ellipse">
@@ -22494,7 +22409,7 @@
         </p:nvSpPr>
         <p:spPr>
           <a:xfrm>
-            <a:off x="9472013" y="3220321"/>
+            <a:off x="9472013" y="3637774"/>
             <a:ext cx="274320" cy="274320"/>
           </a:xfrm>
           <a:prstGeom prst="ellipse">
@@ -23316,7 +23231,7 @@
         </p:nvCxnSpPr>
         <p:spPr>
           <a:xfrm>
-            <a:off x="8016453" y="3752726"/>
+            <a:off x="8016453" y="3861798"/>
             <a:ext cx="1217962" cy="0"/>
           </a:xfrm>
           <a:prstGeom prst="line">
@@ -23326,6 +23241,7 @@
             <a:solidFill>
               <a:srgbClr val="E09B00"/>
             </a:solidFill>
+            <a:tailEnd type="triangle" w="med" len="med"/>
           </a:ln>
         </p:spPr>
       </p:cxnSp>
@@ -23337,8 +23253,8 @@
         </p:nvSpPr>
         <p:spPr>
           <a:xfrm>
-            <a:off x="9047036" y="2498401"/>
-            <a:ext cx="281068" cy="1063449"/>
+            <a:off x="8906502" y="3016492"/>
+            <a:ext cx="421602" cy="981645"/>
           </a:xfrm>
           <a:prstGeom prst="rect">
             <a:avLst/>
@@ -23358,35 +23274,27 @@
           </a:p>
         </p:txBody>
       </p:sp>
-      <p:sp>
-        <p:nvSpPr>
-          <p:cNvPr id="20" name="Oval 19"/>
-          <p:cNvSpPr/>
-          <p:nvPr/>
-        </p:nvSpPr>
-        <p:spPr>
-          <a:xfrm>
-            <a:off x="9047036" y="2852884"/>
-            <a:ext cx="327912" cy="381751"/>
-          </a:xfrm>
-          <a:prstGeom prst="ellipse">
-            <a:avLst/>
-          </a:prstGeom>
-          <a:noFill/>
+      <p:cxnSp>
+        <p:nvCxnSpPr>
+          <p:cNvPr id="20" name="Connector 19"/>
+          <p:cNvCxnSpPr/>
+          <p:nvPr/>
+        </p:nvCxnSpPr>
+        <p:spPr>
+          <a:xfrm>
+            <a:off x="9140726" y="3098295"/>
+            <a:ext cx="0" cy="899842"/>
+          </a:xfrm>
+          <a:prstGeom prst="line">
+            <a:avLst/>
+          </a:prstGeom>
           <a:ln w="44450">
             <a:solidFill>
               <a:srgbClr val="1F5FAD"/>
             </a:solidFill>
           </a:ln>
         </p:spPr>
-        <p:txBody>
-          <a:bodyPr rtlCol="0" anchor="ctr"/>
-          <a:lstStyle/>
-          <a:p>
-            <a:pPr algn="ctr"/>
-          </a:p>
-        </p:txBody>
-      </p:sp>
+      </p:cxnSp>
       <p:sp>
         <p:nvSpPr>
           <p:cNvPr id="21" name="Oval 20"/>
@@ -23395,7 +23303,7 @@
         </p:nvSpPr>
         <p:spPr>
           <a:xfrm>
-            <a:off x="7785603" y="3724638"/>
+            <a:off x="7738759" y="3561030"/>
             <a:ext cx="274320" cy="274320"/>
           </a:xfrm>
           <a:prstGeom prst="ellipse">
@@ -23446,7 +23354,7 @@
         </p:nvSpPr>
         <p:spPr>
           <a:xfrm>
-            <a:off x="9331479" y="2279437"/>
+            <a:off x="9425168" y="2715724"/>
             <a:ext cx="274320" cy="274320"/>
           </a:xfrm>
           <a:prstGeom prst="ellipse">
@@ -23497,7 +23405,7 @@
         </p:nvSpPr>
         <p:spPr>
           <a:xfrm>
-            <a:off x="9472013" y="3179279"/>
+            <a:off x="9472013" y="3588298"/>
             <a:ext cx="274320" cy="274320"/>
           </a:xfrm>
           <a:prstGeom prst="ellipse">
@@ -24946,7 +24854,7 @@
                 </a:solidFill>
                 <a:latin typeface="Palatino"/>
               </a:rPr>
-              <a:t>Review answer 4: the 16 characteristics</a:t>
+              <a:t>Review answer 4: the 16 characteristics (1 of 2)</a:t>
             </a:r>
           </a:p>
         </p:txBody>
@@ -25091,50 +24999,6 @@
               <a:t>5 to 8: lack of the quality of price persistence; decrease in average bar stochastic ratio; decrease in average candlestick real body to range ratio; changes in angular symmetry and momentum.</a:t>
             </a:r>
           </a:p>
-          <a:p>
-            <a:pPr algn="l">
-              <a:lnSpc>
-                <a:spcPct val="118000"/>
-              </a:lnSpc>
-              <a:spcBef>
-                <a:spcPts val="0"/>
-              </a:spcBef>
-              <a:spcAft>
-                <a:spcPts val="1300"/>
-              </a:spcAft>
-            </a:pPr>
-            <a:r>
-              <a:rPr sz="2100" b="0" i="0">
-                <a:solidFill>
-                  <a:srgbClr val="1A1A1A"/>
-                </a:solidFill>
-                <a:latin typeface="Arial"/>
-              </a:rPr>
-              <a:t>9 to 12: proximity to a price barrier; reduction in frequency and decrease in depth of trend-based oscillations; appearance of relatively larger and longer lasting consolidations; appearance of an exhaustion gap.</a:t>
-            </a:r>
-          </a:p>
-          <a:p>
-            <a:pPr algn="l">
-              <a:lnSpc>
-                <a:spcPct val="118000"/>
-              </a:lnSpc>
-              <a:spcBef>
-                <a:spcPts val="0"/>
-              </a:spcBef>
-              <a:spcAft>
-                <a:spcPts val="1300"/>
-              </a:spcAft>
-            </a:pPr>
-            <a:r>
-              <a:rPr sz="2100" b="0" i="0">
-                <a:solidFill>
-                  <a:srgbClr val="1A1A1A"/>
-                </a:solidFill>
-                <a:latin typeface="Arial"/>
-              </a:rPr>
-              <a:t>13 to 16: completion of the average range for the period under observation; overextended price action with respect to a price barrier; price accompanied by extremely high or low volume; standard divergences between price, volume, and oscillators.</a:t>
-            </a:r>
-          </a:p>
         </p:txBody>
       </p:sp>
       <p:sp>
@@ -25145,7 +25009,7 @@
         </p:nvSpPr>
         <p:spPr>
           <a:xfrm>
-            <a:off x="777240" y="6784847"/>
+            <a:off x="777240" y="4216145"/>
             <a:ext cx="82296" cy="788924"/>
           </a:xfrm>
           <a:prstGeom prst="rect">
@@ -25175,7 +25039,7 @@
         </p:nvSpPr>
         <p:spPr>
           <a:xfrm>
-            <a:off x="1069848" y="6821423"/>
+            <a:off x="1069848" y="4252721"/>
             <a:ext cx="10344607" cy="788924"/>
           </a:xfrm>
           <a:prstGeom prst="rect">
@@ -25207,7 +25071,7 @@
                 </a:solidFill>
                 <a:latin typeface="Arial"/>
               </a:rPr>
-              <a:t>These are potential reversal clues, not guarantees. Chapter 5 gives the detailed discussion.</a:t>
+              <a:t>These first eight are potential reversal clues, not guarantees. Chapter 5 gives the detailed discussion.</a:t>
             </a:r>
           </a:p>
         </p:txBody>
@@ -25375,7 +25239,7 @@
                 </a:solidFill>
                 <a:latin typeface="Palatino"/>
               </a:rPr>
-              <a:t>Review answers 5 and 6</a:t>
+              <a:t>Review answer 4: the 16 characteristics (2 of 2)</a:t>
             </a:r>
           </a:p>
         </p:txBody>
@@ -25464,7 +25328,7 @@
         <p:spPr>
           <a:xfrm>
             <a:off x="777240" y="1965960"/>
-            <a:ext cx="6583680" cy="3108960"/>
+            <a:ext cx="10637215" cy="3108960"/>
           </a:xfrm>
           <a:prstGeom prst="rect">
             <a:avLst/>
@@ -25479,121 +25343,45 @@
           <a:p>
             <a:pPr algn="l">
               <a:lnSpc>
-                <a:spcPct val="105000"/>
-              </a:lnSpc>
-              <a:spcBef>
-                <a:spcPts val="0"/>
-              </a:spcBef>
-              <a:spcAft>
-                <a:spcPts val="1100"/>
-              </a:spcAft>
-            </a:pPr>
-            <a:r>
-              <a:rPr sz="1700" b="0" i="0">
+                <a:spcPct val="118000"/>
+              </a:lnSpc>
+              <a:spcBef>
+                <a:spcPts val="0"/>
+              </a:spcBef>
+              <a:spcAft>
+                <a:spcPts val="1300"/>
+              </a:spcAft>
+            </a:pPr>
+            <a:r>
+              <a:rPr sz="2100" b="0" i="0">
                 <a:solidFill>
                   <a:srgbClr val="1A1A1A"/>
                 </a:solidFill>
                 <a:latin typeface="Arial"/>
               </a:rPr>
-              <a:t>5. Volume: high volume can strengthen a wide final reversal bar; low volume can signal uncertainty. Pattern 1 allows larger middle volume to be more bearish.</a:t>
+              <a:t>9 to 12: proximity to a price barrier; reduction in frequency and decrease in depth of trend-based oscillations; appearance of relatively larger and longer lasting consolidations; appearance of an exhaustion gap.</a:t>
             </a:r>
           </a:p>
           <a:p>
             <a:pPr algn="l">
               <a:lnSpc>
-                <a:spcPct val="105000"/>
-              </a:lnSpc>
-              <a:spcBef>
-                <a:spcPts val="0"/>
-              </a:spcBef>
-              <a:spcAft>
-                <a:spcPts val="1100"/>
-              </a:spcAft>
-            </a:pPr>
-            <a:r>
-              <a:rPr sz="1700" b="0" i="0">
+                <a:spcPct val="118000"/>
+              </a:lnSpc>
+              <a:spcBef>
+                <a:spcPts val="0"/>
+              </a:spcBef>
+              <a:spcAft>
+                <a:spcPts val="1300"/>
+              </a:spcAft>
+            </a:pPr>
+            <a:r>
+              <a:rPr sz="2100" b="0" i="0">
                 <a:solidFill>
                   <a:srgbClr val="1A1A1A"/>
                 </a:solidFill>
                 <a:latin typeface="Arial"/>
               </a:rPr>
-              <a:t>6. Figure 7.6: pattern 1 </a:t>
-            </a:r>
-            <a:r>
-              <a:rPr sz="1700" b="1" i="0">
-                <a:solidFill>
-                  <a:srgbClr val="E09B00"/>
-                </a:solidFill>
-                <a:latin typeface="Arial"/>
-              </a:rPr>
-              <a:t>(1)</a:t>
-            </a:r>
-            <a:r>
-              <a:rPr sz="1700" b="0" i="0">
-                <a:solidFill>
-                  <a:srgbClr val="1A1A1A"/>
-                </a:solidFill>
-                <a:latin typeface="Arial"/>
-              </a:rPr>
-              <a:t> has first and third closes near low with a large middle bar; pattern 2 </a:t>
-            </a:r>
-            <a:r>
-              <a:rPr sz="1700" b="1" i="0">
-                <a:solidFill>
-                  <a:srgbClr val="C62828"/>
-                </a:solidFill>
-                <a:latin typeface="Arial"/>
-              </a:rPr>
-              <a:t>(2)</a:t>
-            </a:r>
-            <a:r>
-              <a:rPr sz="1700" b="0" i="0">
-                <a:solidFill>
-                  <a:srgbClr val="1A1A1A"/>
-                </a:solidFill>
-                <a:latin typeface="Arial"/>
-              </a:rPr>
-              <a:t> has a narrow, low-volume middle bar. Blue </a:t>
-            </a:r>
-            <a:r>
-              <a:rPr sz="1700" b="1" i="0">
-                <a:solidFill>
-                  <a:srgbClr val="1F5FAD"/>
-                </a:solidFill>
-                <a:latin typeface="Arial"/>
-              </a:rPr>
-              <a:t>(3)</a:t>
-            </a:r>
-            <a:r>
-              <a:rPr sz="1700" b="0" i="0">
-                <a:solidFill>
-                  <a:srgbClr val="1A1A1A"/>
-                </a:solidFill>
-                <a:latin typeface="Arial"/>
-              </a:rPr>
-              <a:t> marks shared uptrend.</a:t>
-            </a:r>
-          </a:p>
-          <a:p>
-            <a:pPr algn="l">
-              <a:lnSpc>
-                <a:spcPct val="105000"/>
-              </a:lnSpc>
-              <a:spcBef>
-                <a:spcPts val="0"/>
-              </a:spcBef>
-              <a:spcAft>
-                <a:spcPts val="1100"/>
-              </a:spcAft>
-            </a:pPr>
-            <a:r>
-              <a:rPr sz="1700" b="0" i="0">
-                <a:solidFill>
-                  <a:srgbClr val="1A1A1A"/>
-                </a:solidFill>
-                <a:latin typeface="Arial"/>
-              </a:rPr>
-              <a:t>Wider outer ranges and gaps add potential reliability. Chapter 7 supplies evidence, not a complete trade plan.</a:t>
+              <a:t>13 to 16: completion of the average range for the period under observation; overextended price action with respect to a price barrier; price accompanied by extremely high or low volume; standard divergences between price, volume, and oscillators.</a:t>
             </a:r>
           </a:p>
         </p:txBody>
@@ -25606,8 +25394,8 @@
         </p:nvSpPr>
         <p:spPr>
           <a:xfrm>
-            <a:off x="777240" y="4837176"/>
-            <a:ext cx="82296" cy="694944"/>
+            <a:off x="777240" y="4845558"/>
+            <a:ext cx="82296" cy="788924"/>
           </a:xfrm>
           <a:prstGeom prst="rect">
             <a:avLst/>
@@ -25636,8 +25424,8 @@
         </p:nvSpPr>
         <p:spPr>
           <a:xfrm>
-            <a:off x="1069848" y="4873752"/>
-            <a:ext cx="6291072" cy="694944"/>
+            <a:off x="1069848" y="4882134"/>
+            <a:ext cx="10344607" cy="788924"/>
           </a:xfrm>
           <a:prstGeom prst="rect">
             <a:avLst/>
@@ -25652,131 +25440,37 @@
           <a:p>
             <a:pPr algn="l">
               <a:lnSpc>
-                <a:spcPct val="100000"/>
-              </a:lnSpc>
-              <a:spcBef>
-                <a:spcPts val="0"/>
-              </a:spcBef>
-              <a:spcAft>
-                <a:spcPts val="0"/>
-              </a:spcAft>
-            </a:pPr>
-            <a:r>
-              <a:rPr sz="1800" b="1" i="0">
+                <a:spcPct val="115000"/>
+              </a:lnSpc>
+              <a:spcBef>
+                <a:spcPts val="0"/>
+              </a:spcBef>
+              <a:spcAft>
+                <a:spcPts val="0"/>
+              </a:spcAft>
+            </a:pPr>
+            <a:r>
+              <a:rPr sz="2200" b="1" i="0">
                 <a:solidFill>
                   <a:srgbClr val="1A1A1A"/>
                 </a:solidFill>
                 <a:latin typeface="Arial"/>
               </a:rPr>
-              <a:t>Pattern evidence does not make a complete trade plan.</a:t>
-            </a:r>
-          </a:p>
-        </p:txBody>
-      </p:sp>
-      <p:sp>
-        <p:nvSpPr>
-          <p:cNvPr id="10" name="Rectangle 9"/>
-          <p:cNvSpPr/>
-          <p:nvPr/>
-        </p:nvSpPr>
-        <p:spPr>
-          <a:xfrm>
-            <a:off x="7680960" y="1810512"/>
-            <a:ext cx="3824934" cy="2422669"/>
-          </a:xfrm>
-          <a:prstGeom prst="rect">
-            <a:avLst/>
-          </a:prstGeom>
-          <a:solidFill>
-            <a:srgbClr val="FFFFFF"/>
-          </a:solidFill>
-          <a:ln w="12700">
-            <a:solidFill>
-              <a:srgbClr val="D7E0D9"/>
-            </a:solidFill>
-          </a:ln>
-          <a:effectLst/>
-        </p:spPr>
-        <p:txBody>
-          <a:bodyPr rtlCol="0" anchor="ctr"/>
-          <a:lstStyle/>
-          <a:p>
-            <a:pPr algn="ctr"/>
-          </a:p>
-        </p:txBody>
-      </p:sp>
-      <p:sp>
-        <p:nvSpPr>
-          <p:cNvPr id="11" name="Rectangle 10"/>
-          <p:cNvSpPr/>
-          <p:nvPr/>
-        </p:nvSpPr>
-        <p:spPr>
-          <a:xfrm>
-            <a:off x="7799832" y="1929384"/>
-            <a:ext cx="3587190" cy="2184925"/>
-          </a:xfrm>
-          <a:prstGeom prst="rect">
-            <a:avLst/>
-          </a:prstGeom>
-          <a:solidFill>
-            <a:srgbClr val="FFFFFF"/>
-          </a:solidFill>
-          <a:ln w="12700">
-            <a:solidFill>
-              <a:srgbClr val="D7E0D9"/>
-            </a:solidFill>
-          </a:ln>
-          <a:effectLst/>
-        </p:spPr>
-        <p:txBody>
-          <a:bodyPr rtlCol="0" anchor="ctr"/>
-          <a:lstStyle/>
-          <a:p>
-            <a:pPr algn="ctr"/>
-          </a:p>
-        </p:txBody>
-      </p:sp>
-      <p:sp>
-        <p:nvSpPr>
-          <p:cNvPr id="12" name="Rectangle 11"/>
-          <p:cNvSpPr/>
-          <p:nvPr/>
-        </p:nvSpPr>
-        <p:spPr>
-          <a:xfrm>
-            <a:off x="7799832" y="1929384"/>
-            <a:ext cx="3587190" cy="50800"/>
-          </a:xfrm>
-          <a:prstGeom prst="rect">
-            <a:avLst/>
-          </a:prstGeom>
-          <a:solidFill>
-            <a:srgbClr val="F2A900"/>
-          </a:solidFill>
-          <a:ln>
-            <a:noFill/>
-          </a:ln>
-          <a:effectLst/>
-        </p:spPr>
-        <p:txBody>
-          <a:bodyPr rtlCol="0" anchor="ctr"/>
-          <a:lstStyle/>
-          <a:p>
-            <a:pPr algn="ctr"/>
-          </a:p>
-        </p:txBody>
-      </p:sp>
-      <p:sp>
-        <p:nvSpPr>
-          <p:cNvPr id="13" name="TextBox 12"/>
+              <a:t>Barrier proximity is the especially important context; these clues still do not guarantee reversal.</a:t>
+            </a:r>
+          </a:p>
+        </p:txBody>
+      </p:sp>
+      <p:sp>
+        <p:nvSpPr>
+          <p:cNvPr id="10" name="TextBox 9"/>
           <p:cNvSpPr txBox="1"/>
           <p:nvPr/>
         </p:nvSpPr>
         <p:spPr>
           <a:xfrm>
-            <a:off x="8074152" y="2203703"/>
-            <a:ext cx="3038550" cy="1727725"/>
+            <a:off x="5074920" y="6199632"/>
+            <a:ext cx="6339535" cy="457200"/>
           </a:xfrm>
           <a:prstGeom prst="rect">
             <a:avLst/>
@@ -25789,7 +25483,7 @@
           </a:bodyPr>
           <a:lstStyle/>
           <a:p>
-            <a:pPr algn="l">
+            <a:pPr algn="r">
               <a:lnSpc>
                 <a:spcPct val="100000"/>
               </a:lnSpc>
@@ -25797,369 +25491,17 @@
                 <a:spcPts val="0"/>
               </a:spcBef>
               <a:spcAft>
-                <a:spcPts val="400"/>
-              </a:spcAft>
-            </a:pPr>
-            <a:r>
-              <a:rPr sz="1100" b="1" i="0">
+                <a:spcPts val="0"/>
+              </a:spcAft>
+            </a:pPr>
+            <a:r>
+              <a:rPr sz="1100" b="0" i="1">
                 <a:solidFill>
                   <a:srgbClr val="818181"/>
                 </a:solidFill>
                 <a:latin typeface="Arial"/>
               </a:rPr>
-              <a:t>FIGURE 7.06</a:t>
-            </a:r>
-          </a:p>
-          <a:p>
-            <a:pPr algn="l">
-              <a:lnSpc>
-                <a:spcPct val="115000"/>
-              </a:lnSpc>
-              <a:spcBef>
-                <a:spcPts val="0"/>
-              </a:spcBef>
-              <a:spcAft>
-                <a:spcPts val="0"/>
-              </a:spcAft>
-            </a:pPr>
-            <a:r>
-              <a:rPr sz="1500" b="0" i="0">
-                <a:solidFill>
-                  <a:srgbClr val="1A1A1A"/>
-                </a:solidFill>
-                <a:latin typeface="Palatino"/>
-              </a:rPr>
-              <a:t>Figure 7.6's three bearish triple-bar schematics, with the first two structures marked for the review answer.</a:t>
-            </a:r>
-          </a:p>
-        </p:txBody>
-      </p:sp>
-      <p:sp>
-        <p:nvSpPr>
-          <p:cNvPr id="14" name="Rectangle 13"/>
-          <p:cNvSpPr/>
-          <p:nvPr/>
-        </p:nvSpPr>
-        <p:spPr>
-          <a:xfrm>
-            <a:off x="8589014" y="1973082"/>
-            <a:ext cx="645694" cy="1442050"/>
-          </a:xfrm>
-          <a:prstGeom prst="rect">
-            <a:avLst/>
-          </a:prstGeom>
-          <a:noFill/>
-          <a:ln w="44450">
-            <a:solidFill>
-              <a:srgbClr val="E09B00"/>
-            </a:solidFill>
-          </a:ln>
-        </p:spPr>
-        <p:txBody>
-          <a:bodyPr rtlCol="0" anchor="ctr"/>
-          <a:lstStyle/>
-          <a:p>
-            <a:pPr algn="ctr"/>
-          </a:p>
-        </p:txBody>
-      </p:sp>
-      <p:sp>
-        <p:nvSpPr>
-          <p:cNvPr id="15" name="Rectangle 14"/>
-          <p:cNvSpPr/>
-          <p:nvPr/>
-        </p:nvSpPr>
-        <p:spPr>
-          <a:xfrm>
-            <a:off x="9414067" y="1973082"/>
-            <a:ext cx="645694" cy="1442050"/>
-          </a:xfrm>
-          <a:prstGeom prst="rect">
-            <a:avLst/>
-          </a:prstGeom>
-          <a:noFill/>
-          <a:ln w="44450">
-            <a:solidFill>
-              <a:srgbClr val="C62828"/>
-            </a:solidFill>
-          </a:ln>
-        </p:spPr>
-        <p:txBody>
-          <a:bodyPr rtlCol="0" anchor="ctr"/>
-          <a:lstStyle/>
-          <a:p>
-            <a:pPr algn="ctr"/>
-          </a:p>
-        </p:txBody>
-      </p:sp>
-      <p:sp>
-        <p:nvSpPr>
-          <p:cNvPr id="16" name="Oval 15"/>
-          <p:cNvSpPr/>
-          <p:nvPr/>
-        </p:nvSpPr>
-        <p:spPr>
-          <a:xfrm>
-            <a:off x="8660757" y="2978148"/>
-            <a:ext cx="286975" cy="262191"/>
-          </a:xfrm>
-          <a:prstGeom prst="ellipse">
-            <a:avLst/>
-          </a:prstGeom>
-          <a:noFill/>
-          <a:ln w="44450">
-            <a:solidFill>
-              <a:srgbClr val="1F5FAD"/>
-            </a:solidFill>
-          </a:ln>
-        </p:spPr>
-        <p:txBody>
-          <a:bodyPr rtlCol="0" anchor="ctr"/>
-          <a:lstStyle/>
-          <a:p>
-            <a:pPr algn="ctr"/>
-          </a:p>
-        </p:txBody>
-      </p:sp>
-      <p:sp>
-        <p:nvSpPr>
-          <p:cNvPr id="17" name="Oval 16"/>
-          <p:cNvSpPr/>
-          <p:nvPr/>
-        </p:nvSpPr>
-        <p:spPr>
-          <a:xfrm>
-            <a:off x="8272494" y="2535098"/>
-            <a:ext cx="274320" cy="274320"/>
-          </a:xfrm>
-          <a:prstGeom prst="ellipse">
-            <a:avLst/>
-          </a:prstGeom>
-          <a:solidFill>
-            <a:srgbClr val="E09B00"/>
-          </a:solidFill>
-          <a:ln w="12700">
-            <a:solidFill>
-              <a:srgbClr val="FFFFFF"/>
-            </a:solidFill>
-          </a:ln>
-          <a:effectLst/>
-        </p:spPr>
-        <p:txBody>
-          <a:bodyPr rtlCol="0" anchor="ctr" wrap="none" lIns="0" rIns="0" tIns="0" bIns="0"/>
-          <a:lstStyle/>
-          <a:p>
-            <a:pPr algn="ctr">
-              <a:lnSpc>
-                <a:spcPct val="100000"/>
-              </a:lnSpc>
-              <a:spcBef>
-                <a:spcPts val="0"/>
-              </a:spcBef>
-              <a:spcAft>
-                <a:spcPts val="0"/>
-              </a:spcAft>
-            </a:pPr>
-            <a:r>
-              <a:rPr sz="1300" b="1" i="0">
-                <a:solidFill>
-                  <a:srgbClr val="FFFFFF"/>
-                </a:solidFill>
-                <a:latin typeface="Arial"/>
-              </a:rPr>
-              <a:t>1</a:t>
-            </a:r>
-          </a:p>
-        </p:txBody>
-      </p:sp>
-      <p:sp>
-        <p:nvSpPr>
-          <p:cNvPr id="18" name="Oval 17"/>
-          <p:cNvSpPr/>
-          <p:nvPr/>
-        </p:nvSpPr>
-        <p:spPr>
-          <a:xfrm>
-            <a:off x="9097548" y="2535098"/>
-            <a:ext cx="274320" cy="274320"/>
-          </a:xfrm>
-          <a:prstGeom prst="ellipse">
-            <a:avLst/>
-          </a:prstGeom>
-          <a:solidFill>
-            <a:srgbClr val="C62828"/>
-          </a:solidFill>
-          <a:ln w="12700">
-            <a:solidFill>
-              <a:srgbClr val="FFFFFF"/>
-            </a:solidFill>
-          </a:ln>
-          <a:effectLst/>
-        </p:spPr>
-        <p:txBody>
-          <a:bodyPr rtlCol="0" anchor="ctr" wrap="none" lIns="0" rIns="0" tIns="0" bIns="0"/>
-          <a:lstStyle/>
-          <a:p>
-            <a:pPr algn="ctr">
-              <a:lnSpc>
-                <a:spcPct val="100000"/>
-              </a:lnSpc>
-              <a:spcBef>
-                <a:spcPts val="0"/>
-              </a:spcBef>
-              <a:spcAft>
-                <a:spcPts val="0"/>
-              </a:spcAft>
-            </a:pPr>
-            <a:r>
-              <a:rPr sz="1300" b="1" i="0">
-                <a:solidFill>
-                  <a:srgbClr val="FFFFFF"/>
-                </a:solidFill>
-                <a:latin typeface="Arial"/>
-              </a:rPr>
-              <a:t>2</a:t>
-            </a:r>
-          </a:p>
-        </p:txBody>
-      </p:sp>
-      <p:sp>
-        <p:nvSpPr>
-          <p:cNvPr id="19" name="Oval 18"/>
-          <p:cNvSpPr/>
-          <p:nvPr/>
-        </p:nvSpPr>
-        <p:spPr>
-          <a:xfrm>
-            <a:off x="8236622" y="3059480"/>
-            <a:ext cx="274320" cy="274320"/>
-          </a:xfrm>
-          <a:prstGeom prst="ellipse">
-            <a:avLst/>
-          </a:prstGeom>
-          <a:solidFill>
-            <a:srgbClr val="1F5FAD"/>
-          </a:solidFill>
-          <a:ln w="12700">
-            <a:solidFill>
-              <a:srgbClr val="FFFFFF"/>
-            </a:solidFill>
-          </a:ln>
-          <a:effectLst/>
-        </p:spPr>
-        <p:txBody>
-          <a:bodyPr rtlCol="0" anchor="ctr" wrap="none" lIns="0" rIns="0" tIns="0" bIns="0"/>
-          <a:lstStyle/>
-          <a:p>
-            <a:pPr algn="ctr">
-              <a:lnSpc>
-                <a:spcPct val="100000"/>
-              </a:lnSpc>
-              <a:spcBef>
-                <a:spcPts val="0"/>
-              </a:spcBef>
-              <a:spcAft>
-                <a:spcPts val="0"/>
-              </a:spcAft>
-            </a:pPr>
-            <a:r>
-              <a:rPr sz="1300" b="1" i="0">
-                <a:solidFill>
-                  <a:srgbClr val="FFFFFF"/>
-                </a:solidFill>
-                <a:latin typeface="Arial"/>
-              </a:rPr>
-              <a:t>3</a:t>
-            </a:r>
-          </a:p>
-        </p:txBody>
-      </p:sp>
-      <p:sp>
-        <p:nvSpPr>
-          <p:cNvPr id="20" name="TextBox 19"/>
-          <p:cNvSpPr txBox="1"/>
-          <p:nvPr/>
-        </p:nvSpPr>
-        <p:spPr>
-          <a:xfrm>
-            <a:off x="7680960" y="4324621"/>
-            <a:ext cx="3824934" cy="274320"/>
-          </a:xfrm>
-          <a:prstGeom prst="rect">
-            <a:avLst/>
-          </a:prstGeom>
-          <a:noFill/>
-        </p:spPr>
-        <p:txBody>
-          <a:bodyPr wrap="square" anchor="t" lIns="0" rIns="0" tIns="0" bIns="0">
-            <a:spAutoFit/>
-          </a:bodyPr>
-          <a:lstStyle/>
-          <a:p>
-            <a:pPr algn="l">
-              <a:lnSpc>
-                <a:spcPct val="100000"/>
-              </a:lnSpc>
-              <a:spcBef>
-                <a:spcPts val="0"/>
-              </a:spcBef>
-              <a:spcAft>
-                <a:spcPts val="0"/>
-              </a:spcAft>
-            </a:pPr>
-            <a:r>
-              <a:rPr sz="900" b="0" i="0">
-                <a:solidFill>
-                  <a:srgbClr val="818181"/>
-                </a:solidFill>
-                <a:latin typeface="Arial"/>
-              </a:rPr>
-              <a:t>Figure 7.06 - Lim, The Handbook of Technical Analysis (Wiley, 2016)</a:t>
-            </a:r>
-          </a:p>
-        </p:txBody>
-      </p:sp>
-      <p:sp>
-        <p:nvSpPr>
-          <p:cNvPr id="21" name="TextBox 20"/>
-          <p:cNvSpPr txBox="1"/>
-          <p:nvPr/>
-        </p:nvSpPr>
-        <p:spPr>
-          <a:xfrm>
-            <a:off x="5074920" y="6199632"/>
-            <a:ext cx="6339535" cy="457200"/>
-          </a:xfrm>
-          <a:prstGeom prst="rect">
-            <a:avLst/>
-          </a:prstGeom>
-          <a:noFill/>
-        </p:spPr>
-        <p:txBody>
-          <a:bodyPr wrap="square" anchor="t" lIns="0" rIns="0" tIns="0" bIns="0">
-            <a:spAutoFit/>
-          </a:bodyPr>
-          <a:lstStyle/>
-          <a:p>
-            <a:pPr algn="r">
-              <a:lnSpc>
-                <a:spcPct val="100000"/>
-              </a:lnSpc>
-              <a:spcBef>
-                <a:spcPts val="0"/>
-              </a:spcBef>
-              <a:spcAft>
-                <a:spcPts val="0"/>
-              </a:spcAft>
-            </a:pPr>
-            <a:r>
-              <a:rPr sz="1100" b="0" i="1">
-                <a:solidFill>
-                  <a:srgbClr val="818181"/>
-                </a:solidFill>
-                <a:latin typeface="Arial"/>
-              </a:rPr>
-              <a:t>Lim (2016), p. 213, Figure 7.6. The numbered marks are for teaching.</a:t>
+              <a:t>Lim (2016), pp. 216 to 218; the 16 names follow the book's order.</a:t>
             </a:r>
           </a:p>
         </p:txBody>
@@ -26282,7 +25624,7 @@
                 </a:solidFill>
                 <a:latin typeface="Palatino"/>
               </a:rPr>
-              <a:t>Review answer 7: ideal inside-bar reversal</a:t>
+              <a:t>Review answers 5 and 6</a:t>
             </a:r>
           </a:p>
         </p:txBody>
@@ -26371,7 +25713,7 @@
         <p:spPr>
           <a:xfrm>
             <a:off x="777240" y="1965960"/>
-            <a:ext cx="6949440" cy="3108960"/>
+            <a:ext cx="6583680" cy="3108960"/>
           </a:xfrm>
           <a:prstGeom prst="rect">
             <a:avLst/>
@@ -26402,7 +25744,7 @@
                 </a:solidFill>
                 <a:latin typeface="Arial"/>
               </a:rPr>
-              <a:t>Inside reversal: the inside bar stays within the prior high and low, then breaks in the reversal direction.</a:t>
+              <a:t>5. Volume: high volume can strengthen a wide final reversal bar; low volume can signal uncertainty. Pattern 1 allows larger middle volume to be more bearish.</a:t>
             </a:r>
           </a:p>
           <a:p>
@@ -26424,7 +25766,7 @@
                 </a:solidFill>
                 <a:latin typeface="Arial"/>
               </a:rPr>
-              <a:t>Ideal: first bar wide on high volume; second narrow on very low volume. Barrier and trend context strengthen </a:t>
+              <a:t>6. Figure 7.6: pattern 1 </a:t>
             </a:r>
             <a:r>
               <a:rPr sz="1700" b="1" i="0">
@@ -26442,7 +25784,7 @@
                 </a:solidFill>
                 <a:latin typeface="Arial"/>
               </a:rPr>
-              <a:t> </a:t>
+              <a:t> has first and third closes near low with a large middle bar; pattern 2 </a:t>
             </a:r>
             <a:r>
               <a:rPr sz="1700" b="1" i="0">
@@ -26460,7 +25802,25 @@
                 </a:solidFill>
                 <a:latin typeface="Arial"/>
               </a:rPr>
-              <a:t>.</a:t>
+              <a:t> has a narrow, low-volume middle bar. Blue </a:t>
+            </a:r>
+            <a:r>
+              <a:rPr sz="1700" b="1" i="0">
+                <a:solidFill>
+                  <a:srgbClr val="1F5FAD"/>
+                </a:solidFill>
+                <a:latin typeface="Arial"/>
+              </a:rPr>
+              <a:t>(3)</a:t>
+            </a:r>
+            <a:r>
+              <a:rPr sz="1700" b="0" i="0">
+                <a:solidFill>
+                  <a:srgbClr val="1A1A1A"/>
+                </a:solidFill>
+                <a:latin typeface="Arial"/>
+              </a:rPr>
+              <a:t> marks shared uptrend.</a:t>
             </a:r>
           </a:p>
           <a:p>
@@ -26482,83 +25842,7 @@
                 </a:solidFill>
                 <a:latin typeface="Arial"/>
               </a:rPr>
-              <a:t>Figure 7.25 marks wide </a:t>
-            </a:r>
-            <a:r>
-              <a:rPr sz="1700" b="1" i="0">
-                <a:solidFill>
-                  <a:srgbClr val="E09B00"/>
-                </a:solidFill>
-                <a:latin typeface="Arial"/>
-              </a:rPr>
-              <a:t>(1)</a:t>
-            </a:r>
-            <a:r>
-              <a:rPr sz="1700" b="0" i="0">
-                <a:solidFill>
-                  <a:srgbClr val="1A1A1A"/>
-                </a:solidFill>
-                <a:latin typeface="Arial"/>
-              </a:rPr>
-              <a:t>, narrow inside </a:t>
-            </a:r>
-            <a:r>
-              <a:rPr sz="1700" b="1" i="0">
-                <a:solidFill>
-                  <a:srgbClr val="C62828"/>
-                </a:solidFill>
-                <a:latin typeface="Arial"/>
-              </a:rPr>
-              <a:t>(2)</a:t>
-            </a:r>
-            <a:r>
-              <a:rPr sz="1700" b="0" i="0">
-                <a:solidFill>
-                  <a:srgbClr val="1A1A1A"/>
-                </a:solidFill>
-                <a:latin typeface="Arial"/>
-              </a:rPr>
-              <a:t>, and oscillator region </a:t>
-            </a:r>
-            <a:r>
-              <a:rPr sz="1700" b="1" i="0">
-                <a:solidFill>
-                  <a:srgbClr val="1F5FAD"/>
-                </a:solidFill>
-                <a:latin typeface="Arial"/>
-              </a:rPr>
-              <a:t>(3)</a:t>
-            </a:r>
-            <a:r>
-              <a:rPr sz="1700" b="0" i="0">
-                <a:solidFill>
-                  <a:srgbClr val="1A1A1A"/>
-                </a:solidFill>
-                <a:latin typeface="Arial"/>
-              </a:rPr>
-              <a:t>. Chapter 7 gives no formula.</a:t>
-            </a:r>
-          </a:p>
-          <a:p>
-            <a:pPr algn="l">
-              <a:lnSpc>
-                <a:spcPct val="105000"/>
-              </a:lnSpc>
-              <a:spcBef>
-                <a:spcPts val="0"/>
-              </a:spcBef>
-              <a:spcAft>
-                <a:spcPts val="1100"/>
-              </a:spcAft>
-            </a:pPr>
-            <a:r>
-              <a:rPr sz="1700" b="0" i="0">
-                <a:solidFill>
-                  <a:srgbClr val="1A1A1A"/>
-                </a:solidFill>
-                <a:latin typeface="Arial"/>
-              </a:rPr>
-              <a:t>Harami is one-fourth to one-third the prior range; an inside bar has no restriction.</a:t>
+              <a:t>Wider outer ranges and gaps add potential reliability. Chapter 7 supplies evidence, not a complete trade plan.</a:t>
             </a:r>
           </a:p>
         </p:txBody>
@@ -26571,7 +25855,7 @@
         </p:nvSpPr>
         <p:spPr>
           <a:xfrm>
-            <a:off x="777240" y="5001768"/>
+            <a:off x="777240" y="4837176"/>
             <a:ext cx="82296" cy="694944"/>
           </a:xfrm>
           <a:prstGeom prst="rect">
@@ -26601,8 +25885,8 @@
         </p:nvSpPr>
         <p:spPr>
           <a:xfrm>
-            <a:off x="1069848" y="5038344"/>
-            <a:ext cx="6656832" cy="694944"/>
+            <a:off x="1069848" y="4873752"/>
+            <a:ext cx="6291072" cy="694944"/>
           </a:xfrm>
           <a:prstGeom prst="rect">
             <a:avLst/>
@@ -26633,7 +25917,7 @@
                 </a:solidFill>
                 <a:latin typeface="Arial"/>
               </a:rPr>
-              <a:t>The inside condition comes first; reversal direction comes from the later break.</a:t>
+              <a:t>Pattern evidence does not make a complete trade plan.</a:t>
             </a:r>
           </a:p>
         </p:txBody>
@@ -26646,8 +25930,8 @@
         </p:nvSpPr>
         <p:spPr>
           <a:xfrm>
-            <a:off x="8046719" y="1810512"/>
-            <a:ext cx="3459174" cy="2070117"/>
+            <a:off x="7680960" y="1810512"/>
+            <a:ext cx="3824934" cy="2422669"/>
           </a:xfrm>
           <a:prstGeom prst="rect">
             <a:avLst/>
@@ -26678,8 +25962,8 @@
         </p:nvSpPr>
         <p:spPr>
           <a:xfrm>
-            <a:off x="8165592" y="1929384"/>
-            <a:ext cx="3221431" cy="1832373"/>
+            <a:off x="7799832" y="1929384"/>
+            <a:ext cx="3587190" cy="2184925"/>
           </a:xfrm>
           <a:prstGeom prst="rect">
             <a:avLst/>
@@ -26710,8 +25994,8 @@
         </p:nvSpPr>
         <p:spPr>
           <a:xfrm>
-            <a:off x="8165592" y="1929384"/>
-            <a:ext cx="3221431" cy="50800"/>
+            <a:off x="7799832" y="1929384"/>
+            <a:ext cx="3587190" cy="50800"/>
           </a:xfrm>
           <a:prstGeom prst="rect">
             <a:avLst/>
@@ -26740,8 +26024,8 @@
         </p:nvSpPr>
         <p:spPr>
           <a:xfrm>
-            <a:off x="8439912" y="2203703"/>
-            <a:ext cx="2672790" cy="1375173"/>
+            <a:off x="8074152" y="2203703"/>
+            <a:ext cx="3038550" cy="1727725"/>
           </a:xfrm>
           <a:prstGeom prst="rect">
             <a:avLst/>
@@ -26772,7 +26056,7 @@
                 </a:solidFill>
                 <a:latin typeface="Arial"/>
               </a:rPr>
-              <a:t>FIGURE 7.25</a:t>
+              <a:t>FIGURE 7.06</a:t>
             </a:r>
           </a:p>
           <a:p>
@@ -26788,29 +26072,29 @@
               </a:spcAft>
             </a:pPr>
             <a:r>
-              <a:rPr sz="1300" b="0" i="0">
+              <a:rPr sz="1500" b="0" i="0">
                 <a:solidFill>
                   <a:srgbClr val="1A1A1A"/>
                 </a:solidFill>
                 <a:latin typeface="Palatino"/>
               </a:rPr>
-              <a:t>Figure 7.25's ITC Holdings chart, with the wide first bar, the narrow inside bar, and the lower oscillator region marked.</a:t>
-            </a:r>
-          </a:p>
-        </p:txBody>
-      </p:sp>
-      <p:sp>
-        <p:nvSpPr>
-          <p:cNvPr id="14" name="Oval 13"/>
+              <a:t>Figure 7.6's three bearish triple-bar schematics, with the first two structures marked for the review answer.</a:t>
+            </a:r>
+          </a:p>
+        </p:txBody>
+      </p:sp>
+      <p:sp>
+        <p:nvSpPr>
+          <p:cNvPr id="14" name="Rectangle 13"/>
           <p:cNvSpPr/>
           <p:nvPr/>
         </p:nvSpPr>
         <p:spPr>
           <a:xfrm>
-            <a:off x="10001807" y="2204240"/>
-            <a:ext cx="193285" cy="439769"/>
-          </a:xfrm>
-          <a:prstGeom prst="ellipse">
+            <a:off x="8589014" y="1973082"/>
+            <a:ext cx="645694" cy="1442050"/>
+          </a:xfrm>
+          <a:prstGeom prst="rect">
             <a:avLst/>
           </a:prstGeom>
           <a:noFill/>
@@ -26830,16 +26114,16 @@
       </p:sp>
       <p:sp>
         <p:nvSpPr>
-          <p:cNvPr id="15" name="Oval 14"/>
+          <p:cNvPr id="15" name="Rectangle 14"/>
           <p:cNvSpPr/>
           <p:nvPr/>
         </p:nvSpPr>
         <p:spPr>
           <a:xfrm>
-            <a:off x="10323950" y="2204240"/>
-            <a:ext cx="193285" cy="439769"/>
-          </a:xfrm>
-          <a:prstGeom prst="ellipse">
+            <a:off x="9414067" y="1973082"/>
+            <a:ext cx="645694" cy="1442050"/>
+          </a:xfrm>
+          <a:prstGeom prst="rect">
             <a:avLst/>
           </a:prstGeom>
           <a:noFill/>
@@ -26865,8 +26149,8 @@
         </p:nvSpPr>
         <p:spPr>
           <a:xfrm>
-            <a:off x="10034021" y="3193721"/>
-            <a:ext cx="225500" cy="311503"/>
+            <a:off x="8660757" y="2978148"/>
+            <a:ext cx="286975" cy="262191"/>
           </a:xfrm>
           <a:prstGeom prst="ellipse">
             <a:avLst/>
@@ -26894,7 +26178,7 @@
         </p:nvSpPr>
         <p:spPr>
           <a:xfrm>
-            <a:off x="9735790" y="1975461"/>
+            <a:off x="8272494" y="2535098"/>
             <a:ext cx="274320" cy="274320"/>
           </a:xfrm>
           <a:prstGeom prst="ellipse">
@@ -26945,7 +26229,7 @@
         </p:nvSpPr>
         <p:spPr>
           <a:xfrm>
-            <a:off x="10508933" y="1975461"/>
+            <a:off x="9097548" y="2535098"/>
             <a:ext cx="274320" cy="274320"/>
           </a:xfrm>
           <a:prstGeom prst="ellipse">
@@ -26996,7 +26280,7 @@
         </p:nvSpPr>
         <p:spPr>
           <a:xfrm>
-            <a:off x="10347862" y="3459683"/>
+            <a:off x="8236622" y="3059480"/>
             <a:ext cx="274320" cy="274320"/>
           </a:xfrm>
           <a:prstGeom prst="ellipse">
@@ -27047,8 +26331,8 @@
         </p:nvSpPr>
         <p:spPr>
           <a:xfrm>
-            <a:off x="8046719" y="3972069"/>
-            <a:ext cx="3459174" cy="274320"/>
+            <a:off x="7680960" y="4324621"/>
+            <a:ext cx="3824934" cy="274320"/>
           </a:xfrm>
           <a:prstGeom prst="rect">
             <a:avLst/>
@@ -27079,7 +26363,7 @@
                 </a:solidFill>
                 <a:latin typeface="Arial"/>
               </a:rPr>
-              <a:t>Figure 7.25 - Lim, The Handbook of Technical Analysis (Wiley, 2016)</a:t>
+              <a:t>Figure 7.06 - Lim, The Handbook of Technical Analysis (Wiley, 2016)</a:t>
             </a:r>
           </a:p>
         </p:txBody>
@@ -27124,7 +26408,7 @@
                 </a:solidFill>
                 <a:latin typeface="Arial"/>
               </a:rPr>
-              <a:t>Lim (2016), p. 225, Figure 7.25. The numbered marks are for teaching.</a:t>
+              <a:t>Lim (2016), p. 213, Figure 7.6. The numbered marks are for teaching.</a:t>
             </a:r>
           </a:p>
         </p:txBody>
@@ -27138,6 +26422,935 @@
 </file>
 
 <file path=ppt/slides/slide34.xml><?xml version="1.0" encoding="utf-8"?>
+<p:sld xmlns:a="http://schemas.openxmlformats.org/drawingml/2006/main" xmlns:p="http://schemas.openxmlformats.org/presentationml/2006/main" xmlns:r="http://schemas.openxmlformats.org/officeDocument/2006/relationships">
+  <p:cSld>
+    <p:spTree>
+      <p:nvGrpSpPr>
+        <p:cNvPr id="1" name=""/>
+        <p:cNvGrpSpPr/>
+        <p:nvPr/>
+      </p:nvGrpSpPr>
+      <p:grpSpPr/>
+      <p:sp>
+        <p:nvSpPr>
+          <p:cNvPr id="2" name="Rectangle 1"/>
+          <p:cNvSpPr/>
+          <p:nvPr/>
+        </p:nvSpPr>
+        <p:spPr>
+          <a:xfrm>
+            <a:off x="0" y="0"/>
+            <a:ext cx="12191695" cy="6858000"/>
+          </a:xfrm>
+          <a:prstGeom prst="rect">
+            <a:avLst/>
+          </a:prstGeom>
+          <a:solidFill>
+            <a:srgbClr val="FAF8F2"/>
+          </a:solidFill>
+          <a:ln>
+            <a:noFill/>
+          </a:ln>
+          <a:effectLst/>
+        </p:spPr>
+        <p:txBody>
+          <a:bodyPr rtlCol="0" anchor="ctr"/>
+          <a:lstStyle/>
+          <a:p>
+            <a:pPr algn="ctr"/>
+          </a:p>
+        </p:txBody>
+      </p:sp>
+      <p:sp>
+        <p:nvSpPr>
+          <p:cNvPr id="3" name="Rectangle 2"/>
+          <p:cNvSpPr/>
+          <p:nvPr/>
+        </p:nvSpPr>
+        <p:spPr>
+          <a:xfrm>
+            <a:off x="0" y="0"/>
+            <a:ext cx="12191695" cy="146304"/>
+          </a:xfrm>
+          <a:prstGeom prst="rect">
+            <a:avLst/>
+          </a:prstGeom>
+          <a:solidFill>
+            <a:srgbClr val="007A33"/>
+          </a:solidFill>
+          <a:ln>
+            <a:noFill/>
+          </a:ln>
+          <a:effectLst/>
+        </p:spPr>
+        <p:txBody>
+          <a:bodyPr rtlCol="0" anchor="ctr"/>
+          <a:lstStyle/>
+          <a:p>
+            <a:pPr algn="ctr"/>
+          </a:p>
+        </p:txBody>
+      </p:sp>
+      <p:sp>
+        <p:nvSpPr>
+          <p:cNvPr id="4" name="TextBox 3"/>
+          <p:cNvSpPr txBox="1"/>
+          <p:nvPr/>
+        </p:nvSpPr>
+        <p:spPr>
+          <a:xfrm>
+            <a:off x="777240" y="658368"/>
+            <a:ext cx="10637215" cy="914400"/>
+          </a:xfrm>
+          <a:prstGeom prst="rect">
+            <a:avLst/>
+          </a:prstGeom>
+          <a:noFill/>
+        </p:spPr>
+        <p:txBody>
+          <a:bodyPr wrap="square" anchor="t" lIns="0" rIns="0" tIns="0" bIns="0">
+            <a:spAutoFit/>
+          </a:bodyPr>
+          <a:lstStyle/>
+          <a:p>
+            <a:pPr algn="l">
+              <a:lnSpc>
+                <a:spcPct val="105000"/>
+              </a:lnSpc>
+              <a:spcBef>
+                <a:spcPts val="0"/>
+              </a:spcBef>
+              <a:spcAft>
+                <a:spcPts val="0"/>
+              </a:spcAft>
+            </a:pPr>
+            <a:r>
+              <a:rPr sz="3000" b="0" i="0">
+                <a:solidFill>
+                  <a:srgbClr val="007A33"/>
+                </a:solidFill>
+                <a:latin typeface="Palatino"/>
+              </a:rPr>
+              <a:t>Review answer 7: ideal inside-bar reversal</a:t>
+            </a:r>
+          </a:p>
+        </p:txBody>
+      </p:sp>
+      <p:sp>
+        <p:nvSpPr>
+          <p:cNvPr id="5" name="Rectangle 4"/>
+          <p:cNvSpPr/>
+          <p:nvPr/>
+        </p:nvSpPr>
+        <p:spPr>
+          <a:xfrm>
+            <a:off x="777240" y="1572768"/>
+            <a:ext cx="10637215" cy="15875"/>
+          </a:xfrm>
+          <a:prstGeom prst="rect">
+            <a:avLst/>
+          </a:prstGeom>
+          <a:solidFill>
+            <a:srgbClr val="D7E0D9"/>
+          </a:solidFill>
+          <a:ln>
+            <a:noFill/>
+          </a:ln>
+          <a:effectLst/>
+        </p:spPr>
+        <p:txBody>
+          <a:bodyPr rtlCol="0" anchor="ctr"/>
+          <a:lstStyle/>
+          <a:p>
+            <a:pPr algn="ctr"/>
+          </a:p>
+        </p:txBody>
+      </p:sp>
+      <p:sp>
+        <p:nvSpPr>
+          <p:cNvPr id="6" name="TextBox 5"/>
+          <p:cNvSpPr txBox="1"/>
+          <p:nvPr/>
+        </p:nvSpPr>
+        <p:spPr>
+          <a:xfrm>
+            <a:off x="777240" y="6199632"/>
+            <a:ext cx="10637215" cy="310896"/>
+          </a:xfrm>
+          <a:prstGeom prst="rect">
+            <a:avLst/>
+          </a:prstGeom>
+          <a:noFill/>
+        </p:spPr>
+        <p:txBody>
+          <a:bodyPr wrap="square" anchor="t" lIns="0" rIns="0" tIns="0" bIns="0">
+            <a:spAutoFit/>
+          </a:bodyPr>
+          <a:lstStyle/>
+          <a:p>
+            <a:pPr algn="l">
+              <a:lnSpc>
+                <a:spcPct val="100000"/>
+              </a:lnSpc>
+              <a:spcBef>
+                <a:spcPts val="0"/>
+              </a:spcBef>
+              <a:spcAft>
+                <a:spcPts val="0"/>
+              </a:spcAft>
+            </a:pPr>
+            <a:r>
+              <a:rPr sz="1200" b="0" i="0">
+                <a:solidFill>
+                  <a:srgbClr val="818181"/>
+                </a:solidFill>
+                <a:latin typeface="Arial"/>
+              </a:rPr>
+              <a:t>Chapter 7 - Wrap up</a:t>
+            </a:r>
+          </a:p>
+        </p:txBody>
+      </p:sp>
+      <p:sp>
+        <p:nvSpPr>
+          <p:cNvPr id="7" name="TextBox 6"/>
+          <p:cNvSpPr txBox="1"/>
+          <p:nvPr/>
+        </p:nvSpPr>
+        <p:spPr>
+          <a:xfrm>
+            <a:off x="777240" y="1965960"/>
+            <a:ext cx="6949440" cy="3108960"/>
+          </a:xfrm>
+          <a:prstGeom prst="rect">
+            <a:avLst/>
+          </a:prstGeom>
+          <a:noFill/>
+        </p:spPr>
+        <p:txBody>
+          <a:bodyPr wrap="square" anchor="t" lIns="0" rIns="0" tIns="0" bIns="0">
+            <a:spAutoFit/>
+          </a:bodyPr>
+          <a:lstStyle/>
+          <a:p>
+            <a:pPr algn="l">
+              <a:lnSpc>
+                <a:spcPct val="105000"/>
+              </a:lnSpc>
+              <a:spcBef>
+                <a:spcPts val="0"/>
+              </a:spcBef>
+              <a:spcAft>
+                <a:spcPts val="1100"/>
+              </a:spcAft>
+            </a:pPr>
+            <a:r>
+              <a:rPr sz="1600" b="0" i="0">
+                <a:solidFill>
+                  <a:srgbClr val="1A1A1A"/>
+                </a:solidFill>
+                <a:latin typeface="Arial"/>
+              </a:rPr>
+              <a:t>Inside reversal: the inside bar stays within the prior high and low, then breaks in the reversal direction.</a:t>
+            </a:r>
+          </a:p>
+          <a:p>
+            <a:pPr algn="l">
+              <a:lnSpc>
+                <a:spcPct val="105000"/>
+              </a:lnSpc>
+              <a:spcBef>
+                <a:spcPts val="0"/>
+              </a:spcBef>
+              <a:spcAft>
+                <a:spcPts val="1100"/>
+              </a:spcAft>
+            </a:pPr>
+            <a:r>
+              <a:rPr sz="1600" b="0" i="0">
+                <a:solidFill>
+                  <a:srgbClr val="1A1A1A"/>
+                </a:solidFill>
+                <a:latin typeface="Arial"/>
+              </a:rPr>
+              <a:t>Ideal: first bar wide on high volume; second narrow on very low volume. Barrier and trend context strengthen the potential reading.</a:t>
+            </a:r>
+          </a:p>
+          <a:p>
+            <a:pPr algn="l">
+              <a:lnSpc>
+                <a:spcPct val="105000"/>
+              </a:lnSpc>
+              <a:spcBef>
+                <a:spcPts val="0"/>
+              </a:spcBef>
+              <a:spcAft>
+                <a:spcPts val="1100"/>
+              </a:spcAft>
+            </a:pPr>
+            <a:r>
+              <a:rPr sz="1600" b="0" i="0">
+                <a:solidFill>
+                  <a:srgbClr val="1A1A1A"/>
+                </a:solidFill>
+                <a:latin typeface="Arial"/>
+              </a:rPr>
+              <a:t>Figure 7.25 marks wide </a:t>
+            </a:r>
+            <a:r>
+              <a:rPr sz="1600" b="1" i="0">
+                <a:solidFill>
+                  <a:srgbClr val="E09B00"/>
+                </a:solidFill>
+                <a:latin typeface="Arial"/>
+              </a:rPr>
+              <a:t>(1)</a:t>
+            </a:r>
+            <a:r>
+              <a:rPr sz="1600" b="0" i="0">
+                <a:solidFill>
+                  <a:srgbClr val="1A1A1A"/>
+                </a:solidFill>
+                <a:latin typeface="Arial"/>
+              </a:rPr>
+              <a:t>, narrow inside </a:t>
+            </a:r>
+            <a:r>
+              <a:rPr sz="1600" b="1" i="0">
+                <a:solidFill>
+                  <a:srgbClr val="C62828"/>
+                </a:solidFill>
+                <a:latin typeface="Arial"/>
+              </a:rPr>
+              <a:t>(2)</a:t>
+            </a:r>
+            <a:r>
+              <a:rPr sz="1600" b="0" i="0">
+                <a:solidFill>
+                  <a:srgbClr val="1A1A1A"/>
+                </a:solidFill>
+                <a:latin typeface="Arial"/>
+              </a:rPr>
+              <a:t>, and oscillator region </a:t>
+            </a:r>
+            <a:r>
+              <a:rPr sz="1600" b="1" i="0">
+                <a:solidFill>
+                  <a:srgbClr val="1F5FAD"/>
+                </a:solidFill>
+                <a:latin typeface="Arial"/>
+              </a:rPr>
+              <a:t>(3)</a:t>
+            </a:r>
+            <a:r>
+              <a:rPr sz="1600" b="0" i="0">
+                <a:solidFill>
+                  <a:srgbClr val="1A1A1A"/>
+                </a:solidFill>
+                <a:latin typeface="Arial"/>
+              </a:rPr>
+              <a:t>. Chapter 7 gives no formula.</a:t>
+            </a:r>
+          </a:p>
+          <a:p>
+            <a:pPr algn="l">
+              <a:lnSpc>
+                <a:spcPct val="105000"/>
+              </a:lnSpc>
+              <a:spcBef>
+                <a:spcPts val="0"/>
+              </a:spcBef>
+              <a:spcAft>
+                <a:spcPts val="1100"/>
+              </a:spcAft>
+            </a:pPr>
+            <a:r>
+              <a:rPr sz="1600" b="0" i="0">
+                <a:solidFill>
+                  <a:srgbClr val="1A1A1A"/>
+                </a:solidFill>
+                <a:latin typeface="Arial"/>
+              </a:rPr>
+              <a:t>Harami is one-fourth to one-third the prior range; an inside bar has no restriction.</a:t>
+            </a:r>
+          </a:p>
+        </p:txBody>
+      </p:sp>
+      <p:sp>
+        <p:nvSpPr>
+          <p:cNvPr id="8" name="Rectangle 7"/>
+          <p:cNvSpPr/>
+          <p:nvPr/>
+        </p:nvSpPr>
+        <p:spPr>
+          <a:xfrm>
+            <a:off x="777240" y="4873752"/>
+            <a:ext cx="82296" cy="664464"/>
+          </a:xfrm>
+          <a:prstGeom prst="rect">
+            <a:avLst/>
+          </a:prstGeom>
+          <a:solidFill>
+            <a:srgbClr val="F2A900"/>
+          </a:solidFill>
+          <a:ln>
+            <a:noFill/>
+          </a:ln>
+          <a:effectLst/>
+        </p:spPr>
+        <p:txBody>
+          <a:bodyPr rtlCol="0" anchor="ctr"/>
+          <a:lstStyle/>
+          <a:p>
+            <a:pPr algn="ctr"/>
+          </a:p>
+        </p:txBody>
+      </p:sp>
+      <p:sp>
+        <p:nvSpPr>
+          <p:cNvPr id="9" name="TextBox 8"/>
+          <p:cNvSpPr txBox="1"/>
+          <p:nvPr/>
+        </p:nvSpPr>
+        <p:spPr>
+          <a:xfrm>
+            <a:off x="1069848" y="4910328"/>
+            <a:ext cx="6656832" cy="664464"/>
+          </a:xfrm>
+          <a:prstGeom prst="rect">
+            <a:avLst/>
+          </a:prstGeom>
+          <a:noFill/>
+        </p:spPr>
+        <p:txBody>
+          <a:bodyPr wrap="square" anchor="t" lIns="0" rIns="0" tIns="0" bIns="0">
+            <a:spAutoFit/>
+          </a:bodyPr>
+          <a:lstStyle/>
+          <a:p>
+            <a:pPr algn="l">
+              <a:lnSpc>
+                <a:spcPct val="100000"/>
+              </a:lnSpc>
+              <a:spcBef>
+                <a:spcPts val="0"/>
+              </a:spcBef>
+              <a:spcAft>
+                <a:spcPts val="0"/>
+              </a:spcAft>
+            </a:pPr>
+            <a:r>
+              <a:rPr sz="1700" b="1" i="0">
+                <a:solidFill>
+                  <a:srgbClr val="1A1A1A"/>
+                </a:solidFill>
+                <a:latin typeface="Arial"/>
+              </a:rPr>
+              <a:t>The inside condition comes first; reversal direction comes from the later break.</a:t>
+            </a:r>
+          </a:p>
+        </p:txBody>
+      </p:sp>
+      <p:sp>
+        <p:nvSpPr>
+          <p:cNvPr id="10" name="Rectangle 9"/>
+          <p:cNvSpPr/>
+          <p:nvPr/>
+        </p:nvSpPr>
+        <p:spPr>
+          <a:xfrm>
+            <a:off x="8046719" y="1810512"/>
+            <a:ext cx="3459174" cy="2070117"/>
+          </a:xfrm>
+          <a:prstGeom prst="rect">
+            <a:avLst/>
+          </a:prstGeom>
+          <a:solidFill>
+            <a:srgbClr val="FFFFFF"/>
+          </a:solidFill>
+          <a:ln w="12700">
+            <a:solidFill>
+              <a:srgbClr val="D7E0D9"/>
+            </a:solidFill>
+          </a:ln>
+          <a:effectLst/>
+        </p:spPr>
+        <p:txBody>
+          <a:bodyPr rtlCol="0" anchor="ctr"/>
+          <a:lstStyle/>
+          <a:p>
+            <a:pPr algn="ctr"/>
+          </a:p>
+        </p:txBody>
+      </p:sp>
+      <p:sp>
+        <p:nvSpPr>
+          <p:cNvPr id="11" name="Rectangle 10"/>
+          <p:cNvSpPr/>
+          <p:nvPr/>
+        </p:nvSpPr>
+        <p:spPr>
+          <a:xfrm>
+            <a:off x="8165592" y="1929384"/>
+            <a:ext cx="3221431" cy="1832373"/>
+          </a:xfrm>
+          <a:prstGeom prst="rect">
+            <a:avLst/>
+          </a:prstGeom>
+          <a:solidFill>
+            <a:srgbClr val="FFFFFF"/>
+          </a:solidFill>
+          <a:ln w="12700">
+            <a:solidFill>
+              <a:srgbClr val="D7E0D9"/>
+            </a:solidFill>
+          </a:ln>
+          <a:effectLst/>
+        </p:spPr>
+        <p:txBody>
+          <a:bodyPr rtlCol="0" anchor="ctr"/>
+          <a:lstStyle/>
+          <a:p>
+            <a:pPr algn="ctr"/>
+          </a:p>
+        </p:txBody>
+      </p:sp>
+      <p:sp>
+        <p:nvSpPr>
+          <p:cNvPr id="12" name="Rectangle 11"/>
+          <p:cNvSpPr/>
+          <p:nvPr/>
+        </p:nvSpPr>
+        <p:spPr>
+          <a:xfrm>
+            <a:off x="8165592" y="1929384"/>
+            <a:ext cx="3221431" cy="50800"/>
+          </a:xfrm>
+          <a:prstGeom prst="rect">
+            <a:avLst/>
+          </a:prstGeom>
+          <a:solidFill>
+            <a:srgbClr val="F2A900"/>
+          </a:solidFill>
+          <a:ln>
+            <a:noFill/>
+          </a:ln>
+          <a:effectLst/>
+        </p:spPr>
+        <p:txBody>
+          <a:bodyPr rtlCol="0" anchor="ctr"/>
+          <a:lstStyle/>
+          <a:p>
+            <a:pPr algn="ctr"/>
+          </a:p>
+        </p:txBody>
+      </p:sp>
+      <p:sp>
+        <p:nvSpPr>
+          <p:cNvPr id="13" name="TextBox 12"/>
+          <p:cNvSpPr txBox="1"/>
+          <p:nvPr/>
+        </p:nvSpPr>
+        <p:spPr>
+          <a:xfrm>
+            <a:off x="8439912" y="2203703"/>
+            <a:ext cx="2672790" cy="1375173"/>
+          </a:xfrm>
+          <a:prstGeom prst="rect">
+            <a:avLst/>
+          </a:prstGeom>
+          <a:noFill/>
+        </p:spPr>
+        <p:txBody>
+          <a:bodyPr wrap="square" anchor="t" lIns="0" rIns="0" tIns="0" bIns="0">
+            <a:spAutoFit/>
+          </a:bodyPr>
+          <a:lstStyle/>
+          <a:p>
+            <a:pPr algn="l">
+              <a:lnSpc>
+                <a:spcPct val="100000"/>
+              </a:lnSpc>
+              <a:spcBef>
+                <a:spcPts val="0"/>
+              </a:spcBef>
+              <a:spcAft>
+                <a:spcPts val="400"/>
+              </a:spcAft>
+            </a:pPr>
+            <a:r>
+              <a:rPr sz="1100" b="1" i="0">
+                <a:solidFill>
+                  <a:srgbClr val="818181"/>
+                </a:solidFill>
+                <a:latin typeface="Arial"/>
+              </a:rPr>
+              <a:t>FIGURE 7.25</a:t>
+            </a:r>
+          </a:p>
+          <a:p>
+            <a:pPr algn="l">
+              <a:lnSpc>
+                <a:spcPct val="115000"/>
+              </a:lnSpc>
+              <a:spcBef>
+                <a:spcPts val="0"/>
+              </a:spcBef>
+              <a:spcAft>
+                <a:spcPts val="0"/>
+              </a:spcAft>
+            </a:pPr>
+            <a:r>
+              <a:rPr sz="1300" b="0" i="0">
+                <a:solidFill>
+                  <a:srgbClr val="1A1A1A"/>
+                </a:solidFill>
+                <a:latin typeface="Palatino"/>
+              </a:rPr>
+              <a:t>Figure 7.25's ITC Holdings chart, with the wide first bar, the narrow inside bar, and the lower oscillator region marked.</a:t>
+            </a:r>
+          </a:p>
+        </p:txBody>
+      </p:sp>
+      <p:sp>
+        <p:nvSpPr>
+          <p:cNvPr id="14" name="Oval 13"/>
+          <p:cNvSpPr/>
+          <p:nvPr/>
+        </p:nvSpPr>
+        <p:spPr>
+          <a:xfrm>
+            <a:off x="10001807" y="2204240"/>
+            <a:ext cx="193285" cy="439769"/>
+          </a:xfrm>
+          <a:prstGeom prst="ellipse">
+            <a:avLst/>
+          </a:prstGeom>
+          <a:noFill/>
+          <a:ln w="44450">
+            <a:solidFill>
+              <a:srgbClr val="E09B00"/>
+            </a:solidFill>
+          </a:ln>
+        </p:spPr>
+        <p:txBody>
+          <a:bodyPr rtlCol="0" anchor="ctr"/>
+          <a:lstStyle/>
+          <a:p>
+            <a:pPr algn="ctr"/>
+          </a:p>
+        </p:txBody>
+      </p:sp>
+      <p:sp>
+        <p:nvSpPr>
+          <p:cNvPr id="15" name="Oval 14"/>
+          <p:cNvSpPr/>
+          <p:nvPr/>
+        </p:nvSpPr>
+        <p:spPr>
+          <a:xfrm>
+            <a:off x="10323950" y="2204240"/>
+            <a:ext cx="193285" cy="439769"/>
+          </a:xfrm>
+          <a:prstGeom prst="ellipse">
+            <a:avLst/>
+          </a:prstGeom>
+          <a:noFill/>
+          <a:ln w="44450">
+            <a:solidFill>
+              <a:srgbClr val="C62828"/>
+            </a:solidFill>
+          </a:ln>
+        </p:spPr>
+        <p:txBody>
+          <a:bodyPr rtlCol="0" anchor="ctr"/>
+          <a:lstStyle/>
+          <a:p>
+            <a:pPr algn="ctr"/>
+          </a:p>
+        </p:txBody>
+      </p:sp>
+      <p:sp>
+        <p:nvSpPr>
+          <p:cNvPr id="16" name="Oval 15"/>
+          <p:cNvSpPr/>
+          <p:nvPr/>
+        </p:nvSpPr>
+        <p:spPr>
+          <a:xfrm>
+            <a:off x="10034021" y="3193721"/>
+            <a:ext cx="225500" cy="311503"/>
+          </a:xfrm>
+          <a:prstGeom prst="ellipse">
+            <a:avLst/>
+          </a:prstGeom>
+          <a:noFill/>
+          <a:ln w="44450">
+            <a:solidFill>
+              <a:srgbClr val="1F5FAD"/>
+            </a:solidFill>
+          </a:ln>
+        </p:spPr>
+        <p:txBody>
+          <a:bodyPr rtlCol="0" anchor="ctr"/>
+          <a:lstStyle/>
+          <a:p>
+            <a:pPr algn="ctr"/>
+          </a:p>
+        </p:txBody>
+      </p:sp>
+      <p:sp>
+        <p:nvSpPr>
+          <p:cNvPr id="17" name="Oval 16"/>
+          <p:cNvSpPr/>
+          <p:nvPr/>
+        </p:nvSpPr>
+        <p:spPr>
+          <a:xfrm>
+            <a:off x="9735790" y="1975461"/>
+            <a:ext cx="274320" cy="274320"/>
+          </a:xfrm>
+          <a:prstGeom prst="ellipse">
+            <a:avLst/>
+          </a:prstGeom>
+          <a:solidFill>
+            <a:srgbClr val="E09B00"/>
+          </a:solidFill>
+          <a:ln w="12700">
+            <a:solidFill>
+              <a:srgbClr val="FFFFFF"/>
+            </a:solidFill>
+          </a:ln>
+          <a:effectLst/>
+        </p:spPr>
+        <p:txBody>
+          <a:bodyPr rtlCol="0" anchor="ctr" wrap="none" lIns="0" rIns="0" tIns="0" bIns="0"/>
+          <a:lstStyle/>
+          <a:p>
+            <a:pPr algn="ctr">
+              <a:lnSpc>
+                <a:spcPct val="100000"/>
+              </a:lnSpc>
+              <a:spcBef>
+                <a:spcPts val="0"/>
+              </a:spcBef>
+              <a:spcAft>
+                <a:spcPts val="0"/>
+              </a:spcAft>
+            </a:pPr>
+            <a:r>
+              <a:rPr sz="1300" b="1" i="0">
+                <a:solidFill>
+                  <a:srgbClr val="FFFFFF"/>
+                </a:solidFill>
+                <a:latin typeface="Arial"/>
+              </a:rPr>
+              <a:t>1</a:t>
+            </a:r>
+          </a:p>
+        </p:txBody>
+      </p:sp>
+      <p:sp>
+        <p:nvSpPr>
+          <p:cNvPr id="18" name="Oval 17"/>
+          <p:cNvSpPr/>
+          <p:nvPr/>
+        </p:nvSpPr>
+        <p:spPr>
+          <a:xfrm>
+            <a:off x="10508933" y="1975461"/>
+            <a:ext cx="274320" cy="274320"/>
+          </a:xfrm>
+          <a:prstGeom prst="ellipse">
+            <a:avLst/>
+          </a:prstGeom>
+          <a:solidFill>
+            <a:srgbClr val="C62828"/>
+          </a:solidFill>
+          <a:ln w="12700">
+            <a:solidFill>
+              <a:srgbClr val="FFFFFF"/>
+            </a:solidFill>
+          </a:ln>
+          <a:effectLst/>
+        </p:spPr>
+        <p:txBody>
+          <a:bodyPr rtlCol="0" anchor="ctr" wrap="none" lIns="0" rIns="0" tIns="0" bIns="0"/>
+          <a:lstStyle/>
+          <a:p>
+            <a:pPr algn="ctr">
+              <a:lnSpc>
+                <a:spcPct val="100000"/>
+              </a:lnSpc>
+              <a:spcBef>
+                <a:spcPts val="0"/>
+              </a:spcBef>
+              <a:spcAft>
+                <a:spcPts val="0"/>
+              </a:spcAft>
+            </a:pPr>
+            <a:r>
+              <a:rPr sz="1300" b="1" i="0">
+                <a:solidFill>
+                  <a:srgbClr val="FFFFFF"/>
+                </a:solidFill>
+                <a:latin typeface="Arial"/>
+              </a:rPr>
+              <a:t>2</a:t>
+            </a:r>
+          </a:p>
+        </p:txBody>
+      </p:sp>
+      <p:sp>
+        <p:nvSpPr>
+          <p:cNvPr id="19" name="Oval 18"/>
+          <p:cNvSpPr/>
+          <p:nvPr/>
+        </p:nvSpPr>
+        <p:spPr>
+          <a:xfrm>
+            <a:off x="10347862" y="3459683"/>
+            <a:ext cx="274320" cy="274320"/>
+          </a:xfrm>
+          <a:prstGeom prst="ellipse">
+            <a:avLst/>
+          </a:prstGeom>
+          <a:solidFill>
+            <a:srgbClr val="1F5FAD"/>
+          </a:solidFill>
+          <a:ln w="12700">
+            <a:solidFill>
+              <a:srgbClr val="FFFFFF"/>
+            </a:solidFill>
+          </a:ln>
+          <a:effectLst/>
+        </p:spPr>
+        <p:txBody>
+          <a:bodyPr rtlCol="0" anchor="ctr" wrap="none" lIns="0" rIns="0" tIns="0" bIns="0"/>
+          <a:lstStyle/>
+          <a:p>
+            <a:pPr algn="ctr">
+              <a:lnSpc>
+                <a:spcPct val="100000"/>
+              </a:lnSpc>
+              <a:spcBef>
+                <a:spcPts val="0"/>
+              </a:spcBef>
+              <a:spcAft>
+                <a:spcPts val="0"/>
+              </a:spcAft>
+            </a:pPr>
+            <a:r>
+              <a:rPr sz="1300" b="1" i="0">
+                <a:solidFill>
+                  <a:srgbClr val="FFFFFF"/>
+                </a:solidFill>
+                <a:latin typeface="Arial"/>
+              </a:rPr>
+              <a:t>3</a:t>
+            </a:r>
+          </a:p>
+        </p:txBody>
+      </p:sp>
+      <p:sp>
+        <p:nvSpPr>
+          <p:cNvPr id="20" name="TextBox 19"/>
+          <p:cNvSpPr txBox="1"/>
+          <p:nvPr/>
+        </p:nvSpPr>
+        <p:spPr>
+          <a:xfrm>
+            <a:off x="8046719" y="3972069"/>
+            <a:ext cx="3459174" cy="274320"/>
+          </a:xfrm>
+          <a:prstGeom prst="rect">
+            <a:avLst/>
+          </a:prstGeom>
+          <a:noFill/>
+        </p:spPr>
+        <p:txBody>
+          <a:bodyPr wrap="square" anchor="t" lIns="0" rIns="0" tIns="0" bIns="0">
+            <a:spAutoFit/>
+          </a:bodyPr>
+          <a:lstStyle/>
+          <a:p>
+            <a:pPr algn="l">
+              <a:lnSpc>
+                <a:spcPct val="100000"/>
+              </a:lnSpc>
+              <a:spcBef>
+                <a:spcPts val="0"/>
+              </a:spcBef>
+              <a:spcAft>
+                <a:spcPts val="0"/>
+              </a:spcAft>
+            </a:pPr>
+            <a:r>
+              <a:rPr sz="900" b="0" i="0">
+                <a:solidFill>
+                  <a:srgbClr val="818181"/>
+                </a:solidFill>
+                <a:latin typeface="Arial"/>
+              </a:rPr>
+              <a:t>Figure 7.25 - Lim, The Handbook of Technical Analysis (Wiley, 2016)</a:t>
+            </a:r>
+          </a:p>
+        </p:txBody>
+      </p:sp>
+      <p:sp>
+        <p:nvSpPr>
+          <p:cNvPr id="21" name="TextBox 20"/>
+          <p:cNvSpPr txBox="1"/>
+          <p:nvPr/>
+        </p:nvSpPr>
+        <p:spPr>
+          <a:xfrm>
+            <a:off x="5074920" y="6199632"/>
+            <a:ext cx="6339535" cy="457200"/>
+          </a:xfrm>
+          <a:prstGeom prst="rect">
+            <a:avLst/>
+          </a:prstGeom>
+          <a:noFill/>
+        </p:spPr>
+        <p:txBody>
+          <a:bodyPr wrap="square" anchor="t" lIns="0" rIns="0" tIns="0" bIns="0">
+            <a:spAutoFit/>
+          </a:bodyPr>
+          <a:lstStyle/>
+          <a:p>
+            <a:pPr algn="r">
+              <a:lnSpc>
+                <a:spcPct val="100000"/>
+              </a:lnSpc>
+              <a:spcBef>
+                <a:spcPts val="0"/>
+              </a:spcBef>
+              <a:spcAft>
+                <a:spcPts val="0"/>
+              </a:spcAft>
+            </a:pPr>
+            <a:r>
+              <a:rPr sz="1100" b="0" i="1">
+                <a:solidFill>
+                  <a:srgbClr val="818181"/>
+                </a:solidFill>
+                <a:latin typeface="Arial"/>
+              </a:rPr>
+              <a:t>Lim (2016), p. 225, Figure 7.25. The numbered marks are for teaching.</a:t>
+            </a:r>
+          </a:p>
+        </p:txBody>
+      </p:sp>
+    </p:spTree>
+  </p:cSld>
+  <p:clrMapOvr>
+    <a:masterClrMapping/>
+  </p:clrMapOvr>
+</p:sld>
+</file>
+
+<file path=ppt/slides/slide35.xml><?xml version="1.0" encoding="utf-8"?>
 <p:sld xmlns:a="http://schemas.openxmlformats.org/drawingml/2006/main" xmlns:p="http://schemas.openxmlformats.org/presentationml/2006/main" xmlns:r="http://schemas.openxmlformats.org/officeDocument/2006/relationships">
   <p:cSld>
     <p:spTree>

</xml_diff>

<commit_message>
Complete Chapter 7 sample review fixes
</commit_message>
<xml_diff>
--- a/chapter-07/FIN1209-Chapter-07.pptx
+++ b/chapter-07/FIN1209-Chapter-07.pptx
@@ -1578,7 +1578,7 @@
           <a:p>
             <a:r>
               <a:rPr sz="1400"/>
-              <a:t>- The blue mark is the above-average volume panel below the marked bar. The later bars show that the decline does not have to be immediate.</a:t>
+              <a:t>- The three marks identify open, new high, and close. The later bars show that the decline does not have to be immediate.</a:t>
             </a:r>
           </a:p>
         </p:txBody>
@@ -5048,7 +5048,7 @@
                 </a:solidFill>
                 <a:latin typeface="Palatino"/>
               </a:rPr>
-              <a:t>Exhaustion bar versus pin bar: numbers first</a:t>
+              <a:t>Two reversal warnings</a:t>
             </a:r>
           </a:p>
         </p:txBody>
@@ -5137,7 +5137,7 @@
         <p:spPr>
           <a:xfrm>
             <a:off x="777240" y="1965960"/>
-            <a:ext cx="5852160" cy="3108960"/>
+            <a:ext cx="6035040" cy="3108960"/>
           </a:xfrm>
           <a:prstGeom prst="rect">
             <a:avLst/>
@@ -5162,13 +5162,13 @@
               </a:spcAft>
             </a:pPr>
             <a:r>
-              <a:rPr sz="1500" b="0" i="0">
+              <a:rPr sz="1700" b="0" i="0">
                 <a:solidFill>
                   <a:srgbClr val="1A1A1A"/>
                 </a:solidFill>
                 <a:latin typeface="Arial"/>
               </a:rPr>
-              <a:t>Left values: prior high 65.00; O 65.40, H 66.20, L 60.00, C 60.50; next O 60.20, no gap.</a:t>
+              <a:t>Exhaustion bar (Lim, p. 226): uptrend open above prior high, close near low, no gap to next bar.</a:t>
             </a:r>
           </a:p>
           <a:p>
@@ -5184,13 +5184,13 @@
               </a:spcAft>
             </a:pPr>
             <a:r>
-              <a:rPr sz="1500" b="0" i="0">
+              <a:rPr sz="1700" b="0" i="0">
                 <a:solidFill>
                   <a:srgbClr val="1A1A1A"/>
                 </a:solidFill>
                 <a:latin typeface="Arial"/>
               </a:rPr>
-              <a:t>Right values: support 40.00; low 38.80, close 40.60, volume 0.8 million; price closes back above support.</a:t>
+              <a:t>Pin bar (Lim, p. 227): “Pinocchio bars or Pin bars, are single bar misrepresentations of market strength or weakness.”</a:t>
             </a:r>
           </a:p>
           <a:p>
@@ -5206,13 +5206,67 @@
               </a:spcAft>
             </a:pPr>
             <a:r>
-              <a:rPr sz="1500" b="0" i="0">
+              <a:rPr sz="1700" b="0" i="0">
                 <a:solidFill>
                   <a:srgbClr val="1A1A1A"/>
                 </a:solidFill>
                 <a:latin typeface="Arial"/>
               </a:rPr>
-              <a:t>[1] and [2] label price action. [3] marks the no-gap test on the left and the pin bar on the right.</a:t>
+              <a:t>Chart: </a:t>
+            </a:r>
+            <a:r>
+              <a:rPr sz="1700" b="1" i="0">
+                <a:solidFill>
+                  <a:srgbClr val="E09B00"/>
+                </a:solidFill>
+                <a:latin typeface="Arial"/>
+              </a:rPr>
+              <a:t>(1)</a:t>
+            </a:r>
+            <a:r>
+              <a:rPr sz="1700" b="0" i="0">
+                <a:solidFill>
+                  <a:srgbClr val="1A1A1A"/>
+                </a:solidFill>
+                <a:latin typeface="Arial"/>
+              </a:rPr>
+              <a:t> left O 65.40 &gt; 65.00; </a:t>
+            </a:r>
+            <a:r>
+              <a:rPr sz="1700" b="1" i="0">
+                <a:solidFill>
+                  <a:srgbClr val="C62828"/>
+                </a:solidFill>
+                <a:latin typeface="Arial"/>
+              </a:rPr>
+              <a:t>(2)</a:t>
+            </a:r>
+            <a:r>
+              <a:rPr sz="1700" b="0" i="0">
+                <a:solidFill>
+                  <a:srgbClr val="1A1A1A"/>
+                </a:solidFill>
+                <a:latin typeface="Arial"/>
+              </a:rPr>
+              <a:t> left C 60.50 near L, next O 60.20 no gap; </a:t>
+            </a:r>
+            <a:r>
+              <a:rPr sz="1700" b="1" i="0">
+                <a:solidFill>
+                  <a:srgbClr val="1F5FAD"/>
+                </a:solidFill>
+                <a:latin typeface="Arial"/>
+              </a:rPr>
+              <a:t>(3)</a:t>
+            </a:r>
+            <a:r>
+              <a:rPr sz="1700" b="0" i="0">
+                <a:solidFill>
+                  <a:srgbClr val="1A1A1A"/>
+                </a:solidFill>
+                <a:latin typeface="Arial"/>
+              </a:rPr>
+              <a:t> right L 38.80 below support 40.00, a barrier. Ours.</a:t>
             </a:r>
           </a:p>
           <a:p>
@@ -5228,35 +5282,13 @@
               </a:spcAft>
             </a:pPr>
             <a:r>
-              <a:rPr sz="1500" b="0" i="0">
+              <a:rPr sz="1700" b="0" i="0">
                 <a:solidFill>
                   <a:srgbClr val="1A1A1A"/>
                 </a:solidFill>
                 <a:latin typeface="Arial"/>
               </a:rPr>
-              <a:t>Lim: "Exhaustion bars are regarded as reversal bars." (p. 226) A pin bar is a "single bar misrepresentation." (p. 227)</a:t>
-            </a:r>
-          </a:p>
-          <a:p>
-            <a:pPr algn="l">
-              <a:lnSpc>
-                <a:spcPct val="105000"/>
-              </a:lnSpc>
-              <a:spcBef>
-                <a:spcPts val="0"/>
-              </a:spcBef>
-              <a:spcAft>
-                <a:spcPts val="1100"/>
-              </a:spcAft>
-            </a:pPr>
-            <a:r>
-              <a:rPr sz="1500" b="0" i="0">
-                <a:solidFill>
-                  <a:srgbClr val="1A1A1A"/>
-                </a:solidFill>
-                <a:latin typeface="Arial"/>
-              </a:rPr>
-              <a:t>Exhaustion warns of a tiring trend; pin warns of a false breakout. No gap separates exhaustion from an island formation. Wait for close, barrier, and volume context.</a:t>
+              <a:t>No gap distinguishes exhaustion from an island (Lim, p. 226). Exhaustion warns a tiring trend; pin warns a false breakout. Next, test key reversal.</a:t>
             </a:r>
           </a:p>
         </p:txBody>
@@ -5269,8 +5301,8 @@
         </p:nvSpPr>
         <p:spPr>
           <a:xfrm>
-            <a:off x="6949440" y="1810512"/>
-            <a:ext cx="4465014" cy="2979757"/>
+            <a:off x="7132319" y="1810512"/>
+            <a:ext cx="4282135" cy="2861132"/>
           </a:xfrm>
           <a:prstGeom prst="rect">
             <a:avLst/>
@@ -5309,8 +5341,8 @@
         </p:blipFill>
         <p:spPr>
           <a:xfrm>
-            <a:off x="7068312" y="1929384"/>
-            <a:ext cx="4227270" cy="2742013"/>
+            <a:off x="7251191" y="1929384"/>
+            <a:ext cx="4044391" cy="2623388"/>
           </a:xfrm>
           <a:prstGeom prst="rect">
             <a:avLst/>
@@ -5319,14 +5351,254 @@
       </p:pic>
       <p:sp>
         <p:nvSpPr>
-          <p:cNvPr id="10" name="TextBox 9"/>
+          <p:cNvPr id="10" name="Oval 9"/>
+          <p:cNvSpPr/>
+          <p:nvPr/>
+        </p:nvSpPr>
+        <p:spPr>
+          <a:xfrm>
+            <a:off x="8060070" y="2637698"/>
+            <a:ext cx="283107" cy="236104"/>
+          </a:xfrm>
+          <a:prstGeom prst="ellipse">
+            <a:avLst/>
+          </a:prstGeom>
+          <a:noFill/>
+          <a:ln w="44450">
+            <a:solidFill>
+              <a:srgbClr val="E09B00"/>
+            </a:solidFill>
+          </a:ln>
+        </p:spPr>
+        <p:txBody>
+          <a:bodyPr rtlCol="0" anchor="ctr"/>
+          <a:lstStyle/>
+          <a:p>
+            <a:pPr algn="ctr"/>
+          </a:p>
+        </p:txBody>
+      </p:sp>
+      <p:sp>
+        <p:nvSpPr>
+          <p:cNvPr id="11" name="Oval 10"/>
+          <p:cNvSpPr/>
+          <p:nvPr/>
+        </p:nvSpPr>
+        <p:spPr>
+          <a:xfrm>
+            <a:off x="8060070" y="3293546"/>
+            <a:ext cx="283107" cy="236104"/>
+          </a:xfrm>
+          <a:prstGeom prst="ellipse">
+            <a:avLst/>
+          </a:prstGeom>
+          <a:noFill/>
+          <a:ln w="44450">
+            <a:solidFill>
+              <a:srgbClr val="C62828"/>
+            </a:solidFill>
+          </a:ln>
+        </p:spPr>
+        <p:txBody>
+          <a:bodyPr rtlCol="0" anchor="ctr"/>
+          <a:lstStyle/>
+          <a:p>
+            <a:pPr algn="ctr"/>
+          </a:p>
+        </p:txBody>
+      </p:sp>
+      <p:sp>
+        <p:nvSpPr>
+          <p:cNvPr id="12" name="Oval 11"/>
+          <p:cNvSpPr/>
+          <p:nvPr/>
+        </p:nvSpPr>
+        <p:spPr>
+          <a:xfrm>
+            <a:off x="10041821" y="3136142"/>
+            <a:ext cx="283107" cy="262338"/>
+          </a:xfrm>
+          <a:prstGeom prst="ellipse">
+            <a:avLst/>
+          </a:prstGeom>
+          <a:noFill/>
+          <a:ln w="44450">
+            <a:solidFill>
+              <a:srgbClr val="1F5FAD"/>
+            </a:solidFill>
+          </a:ln>
+        </p:spPr>
+        <p:txBody>
+          <a:bodyPr rtlCol="0" anchor="ctr"/>
+          <a:lstStyle/>
+          <a:p>
+            <a:pPr algn="ctr"/>
+          </a:p>
+        </p:txBody>
+      </p:sp>
+      <p:sp>
+        <p:nvSpPr>
+          <p:cNvPr id="13" name="Oval 12"/>
+          <p:cNvSpPr/>
+          <p:nvPr/>
+        </p:nvSpPr>
+        <p:spPr>
+          <a:xfrm>
+            <a:off x="7661958" y="2429783"/>
+            <a:ext cx="310896" cy="310896"/>
+          </a:xfrm>
+          <a:prstGeom prst="ellipse">
+            <a:avLst/>
+          </a:prstGeom>
+          <a:solidFill>
+            <a:srgbClr val="E09B00"/>
+          </a:solidFill>
+          <a:ln w="12700">
+            <a:solidFill>
+              <a:srgbClr val="FFFFFF"/>
+            </a:solidFill>
+          </a:ln>
+          <a:effectLst/>
+        </p:spPr>
+        <p:txBody>
+          <a:bodyPr rtlCol="0" anchor="ctr" wrap="none" lIns="0" rIns="0" tIns="0" bIns="0"/>
+          <a:lstStyle/>
+          <a:p>
+            <a:pPr algn="ctr">
+              <a:lnSpc>
+                <a:spcPct val="100000"/>
+              </a:lnSpc>
+              <a:spcBef>
+                <a:spcPts val="0"/>
+              </a:spcBef>
+              <a:spcAft>
+                <a:spcPts val="0"/>
+              </a:spcAft>
+            </a:pPr>
+            <a:r>
+              <a:rPr sz="1300" b="1" i="0">
+                <a:solidFill>
+                  <a:srgbClr val="FFFFFF"/>
+                </a:solidFill>
+                <a:latin typeface="Arial"/>
+              </a:rPr>
+              <a:t>1</a:t>
+            </a:r>
+          </a:p>
+        </p:txBody>
+      </p:sp>
+      <p:sp>
+        <p:nvSpPr>
+          <p:cNvPr id="14" name="Oval 13"/>
+          <p:cNvSpPr/>
+          <p:nvPr/>
+        </p:nvSpPr>
+        <p:spPr>
+          <a:xfrm>
+            <a:off x="7661958" y="3505372"/>
+            <a:ext cx="310896" cy="310896"/>
+          </a:xfrm>
+          <a:prstGeom prst="ellipse">
+            <a:avLst/>
+          </a:prstGeom>
+          <a:solidFill>
+            <a:srgbClr val="C62828"/>
+          </a:solidFill>
+          <a:ln w="12700">
+            <a:solidFill>
+              <a:srgbClr val="FFFFFF"/>
+            </a:solidFill>
+          </a:ln>
+          <a:effectLst/>
+        </p:spPr>
+        <p:txBody>
+          <a:bodyPr rtlCol="0" anchor="ctr" wrap="none" lIns="0" rIns="0" tIns="0" bIns="0"/>
+          <a:lstStyle/>
+          <a:p>
+            <a:pPr algn="ctr">
+              <a:lnSpc>
+                <a:spcPct val="100000"/>
+              </a:lnSpc>
+              <a:spcBef>
+                <a:spcPts val="0"/>
+              </a:spcBef>
+              <a:spcAft>
+                <a:spcPts val="0"/>
+              </a:spcAft>
+            </a:pPr>
+            <a:r>
+              <a:rPr sz="1300" b="1" i="0">
+                <a:solidFill>
+                  <a:srgbClr val="FFFFFF"/>
+                </a:solidFill>
+                <a:latin typeface="Arial"/>
+              </a:rPr>
+              <a:t>2</a:t>
+            </a:r>
+          </a:p>
+        </p:txBody>
+      </p:sp>
+      <p:sp>
+        <p:nvSpPr>
+          <p:cNvPr id="15" name="Oval 14"/>
+          <p:cNvSpPr/>
+          <p:nvPr/>
+        </p:nvSpPr>
+        <p:spPr>
+          <a:xfrm>
+            <a:off x="10412144" y="3243033"/>
+            <a:ext cx="310896" cy="310896"/>
+          </a:xfrm>
+          <a:prstGeom prst="ellipse">
+            <a:avLst/>
+          </a:prstGeom>
+          <a:solidFill>
+            <a:srgbClr val="1F5FAD"/>
+          </a:solidFill>
+          <a:ln w="12700">
+            <a:solidFill>
+              <a:srgbClr val="FFFFFF"/>
+            </a:solidFill>
+          </a:ln>
+          <a:effectLst/>
+        </p:spPr>
+        <p:txBody>
+          <a:bodyPr rtlCol="0" anchor="ctr" wrap="none" lIns="0" rIns="0" tIns="0" bIns="0"/>
+          <a:lstStyle/>
+          <a:p>
+            <a:pPr algn="ctr">
+              <a:lnSpc>
+                <a:spcPct val="100000"/>
+              </a:lnSpc>
+              <a:spcBef>
+                <a:spcPts val="0"/>
+              </a:spcBef>
+              <a:spcAft>
+                <a:spcPts val="0"/>
+              </a:spcAft>
+            </a:pPr>
+            <a:r>
+              <a:rPr sz="1300" b="1" i="0">
+                <a:solidFill>
+                  <a:srgbClr val="FFFFFF"/>
+                </a:solidFill>
+                <a:latin typeface="Arial"/>
+              </a:rPr>
+              <a:t>3</a:t>
+            </a:r>
+          </a:p>
+        </p:txBody>
+      </p:sp>
+      <p:sp>
+        <p:nvSpPr>
+          <p:cNvPr id="16" name="TextBox 15"/>
           <p:cNvSpPr txBox="1"/>
           <p:nvPr/>
         </p:nvSpPr>
         <p:spPr>
           <a:xfrm>
-            <a:off x="6949440" y="4881709"/>
-            <a:ext cx="4465014" cy="274320"/>
+            <a:off x="7132319" y="4763084"/>
+            <a:ext cx="4282135" cy="274320"/>
           </a:xfrm>
           <a:prstGeom prst="rect">
             <a:avLst/>
@@ -5364,7 +5636,7 @@
       </p:sp>
       <p:sp>
         <p:nvSpPr>
-          <p:cNvPr id="11" name="TextBox 10"/>
+          <p:cNvPr id="17" name="TextBox 16"/>
           <p:cNvSpPr txBox="1"/>
           <p:nvPr/>
         </p:nvSpPr>
@@ -5574,7 +5846,7 @@
                 </a:solidFill>
                 <a:latin typeface="Arial"/>
               </a:rPr>
-              <a:t>Key reversal bars</a:t>
+              <a:t>From “Figure 7.15: three observations”</a:t>
             </a:r>
           </a:p>
         </p:txBody>
@@ -5588,7 +5860,7 @@
         <p:spPr>
           <a:xfrm>
             <a:off x="777240" y="1207008"/>
-            <a:ext cx="5303520" cy="2293112"/>
+            <a:ext cx="5303520" cy="2614422"/>
           </a:xfrm>
           <a:prstGeom prst="rect">
             <a:avLst/>
@@ -5663,7 +5935,7 @@
         <p:spPr>
           <a:xfrm>
             <a:off x="1005840" y="1618488"/>
-            <a:ext cx="4846320" cy="500379"/>
+            <a:ext cx="4846320" cy="588009"/>
           </a:xfrm>
           <a:prstGeom prst="rect">
             <a:avLst/>
@@ -5688,13 +5960,13 @@
               </a:spcAft>
             </a:pPr>
             <a:r>
-              <a:rPr sz="1400" b="1" i="0">
+              <a:rPr sz="1700" b="1" i="0">
                 <a:solidFill>
                   <a:srgbClr val="FFFFFF"/>
                 </a:solidFill>
                 <a:latin typeface="Arial"/>
               </a:rPr>
-              <a:t>A bearish key reversal bar must make a higher high than the previous bar and then:</a:t>
+              <a:t>A bearish key reversal makes a higher high, then:</a:t>
             </a:r>
           </a:p>
         </p:txBody>
@@ -5707,8 +5979,8 @@
         </p:nvSpPr>
         <p:spPr>
           <a:xfrm>
-            <a:off x="1005840" y="2192020"/>
-            <a:ext cx="4846320" cy="1335531"/>
+            <a:off x="1005840" y="2279650"/>
+            <a:ext cx="4846320" cy="1569211"/>
           </a:xfrm>
           <a:prstGeom prst="rect">
             <a:avLst/>
@@ -5733,13 +6005,13 @@
               </a:spcAft>
             </a:pPr>
             <a:r>
-              <a:rPr sz="1300" b="0" i="0">
+              <a:rPr sz="1700" b="0" i="0">
                 <a:solidFill>
                   <a:srgbClr val="FFFFFF"/>
                 </a:solidFill>
                 <a:latin typeface="Arial"/>
               </a:rPr>
-              <a:t>A.  Close near or below the previous close</a:t>
+              <a:t>A.  Near or below prior close</a:t>
             </a:r>
           </a:p>
           <a:p>
@@ -5755,13 +6027,13 @@
               </a:spcAft>
             </a:pPr>
             <a:r>
-              <a:rPr sz="1300" b="0" i="0">
+              <a:rPr sz="1700" b="0" i="0">
                 <a:solidFill>
                   <a:srgbClr val="FFFFFF"/>
                 </a:solidFill>
                 <a:latin typeface="Arial"/>
               </a:rPr>
-              <a:t>B.  Close above the previous high</a:t>
+              <a:t>B.  Above prior high</a:t>
             </a:r>
           </a:p>
           <a:p>
@@ -5777,13 +6049,13 @@
               </a:spcAft>
             </a:pPr>
             <a:r>
-              <a:rPr sz="1300" b="0" i="0">
+              <a:rPr sz="1700" b="0" i="0">
                 <a:solidFill>
                   <a:srgbClr val="FFFFFF"/>
                 </a:solidFill>
                 <a:latin typeface="Arial"/>
               </a:rPr>
-              <a:t>C.  Open below the previous low</a:t>
+              <a:t>C.  Below prior low</a:t>
             </a:r>
           </a:p>
           <a:p>
@@ -5799,13 +6071,13 @@
               </a:spcAft>
             </a:pPr>
             <a:r>
-              <a:rPr sz="1300" b="0" i="0">
+              <a:rPr sz="1700" b="0" i="0">
                 <a:solidFill>
                   <a:srgbClr val="FFFFFF"/>
                 </a:solidFill>
                 <a:latin typeface="Arial"/>
               </a:rPr>
-              <a:t>D.  Trade on low volume only</a:t>
+              <a:t>D.  On low volume only</a:t>
             </a:r>
           </a:p>
         </p:txBody>
@@ -5818,8 +6090,8 @@
         </p:nvSpPr>
         <p:spPr>
           <a:xfrm>
-            <a:off x="777240" y="3664712"/>
-            <a:ext cx="5303520" cy="2088642"/>
+            <a:off x="777240" y="3986022"/>
+            <a:ext cx="5303520" cy="2366137"/>
           </a:xfrm>
           <a:prstGeom prst="rect">
             <a:avLst/>
@@ -5848,7 +6120,7 @@
         </p:nvSpPr>
         <p:spPr>
           <a:xfrm>
-            <a:off x="1005840" y="3829304"/>
+            <a:off x="1005840" y="4150614"/>
             <a:ext cx="4846320" cy="228600"/>
           </a:xfrm>
           <a:prstGeom prst="rect">
@@ -5893,8 +6165,8 @@
         </p:nvSpPr>
         <p:spPr>
           <a:xfrm>
-            <a:off x="1005840" y="4076192"/>
-            <a:ext cx="4846320" cy="295909"/>
+            <a:off x="1005840" y="4397502"/>
+            <a:ext cx="4846320" cy="339725"/>
           </a:xfrm>
           <a:prstGeom prst="rect">
             <a:avLst/>
@@ -5919,13 +6191,13 @@
               </a:spcAft>
             </a:pPr>
             <a:r>
-              <a:rPr sz="1400" b="1" i="0">
+              <a:rPr sz="1700" b="1" i="0">
                 <a:solidFill>
                   <a:srgbClr val="FFFFFF"/>
                 </a:solidFill>
                 <a:latin typeface="Arial"/>
               </a:rPr>
-              <a:t>On Figure 7.15, what does blue mark 3 identify?</a:t>
+              <a:t>On Figure 7.15, blue mark 3 identifies:</a:t>
             </a:r>
           </a:p>
         </p:txBody>
@@ -5938,8 +6210,8 @@
         </p:nvSpPr>
         <p:spPr>
           <a:xfrm>
-            <a:off x="1005840" y="4445254"/>
-            <a:ext cx="4846320" cy="1335532"/>
+            <a:off x="1005840" y="4810379"/>
+            <a:ext cx="4846320" cy="1569212"/>
           </a:xfrm>
           <a:prstGeom prst="rect">
             <a:avLst/>
@@ -5964,13 +6236,13 @@
               </a:spcAft>
             </a:pPr>
             <a:r>
-              <a:rPr sz="1300" b="0" i="0">
+              <a:rPr sz="1700" b="0" i="0">
                 <a:solidFill>
                   <a:srgbClr val="FFFFFF"/>
                 </a:solidFill>
                 <a:latin typeface="Arial"/>
               </a:rPr>
-              <a:t>A.  The previous bar's close</a:t>
+              <a:t>A.  Prior close</a:t>
             </a:r>
           </a:p>
           <a:p>
@@ -5986,13 +6258,13 @@
               </a:spcAft>
             </a:pPr>
             <a:r>
-              <a:rPr sz="1300" b="0" i="0">
+              <a:rPr sz="1700" b="0" i="0">
                 <a:solidFill>
                   <a:srgbClr val="FFFFFF"/>
                 </a:solidFill>
                 <a:latin typeface="Arial"/>
               </a:rPr>
-              <a:t>B.  The new high</a:t>
+              <a:t>B.  New high</a:t>
             </a:r>
           </a:p>
           <a:p>
@@ -6008,13 +6280,13 @@
               </a:spcAft>
             </a:pPr>
             <a:r>
-              <a:rPr sz="1300" b="0" i="0">
+              <a:rPr sz="1700" b="0" i="0">
                 <a:solidFill>
                   <a:srgbClr val="FFFFFF"/>
                 </a:solidFill>
                 <a:latin typeface="Arial"/>
               </a:rPr>
-              <a:t>C.  The above-average volume</a:t>
+              <a:t>C.  Close below prior close</a:t>
             </a:r>
           </a:p>
           <a:p>
@@ -6030,13 +6302,13 @@
               </a:spcAft>
             </a:pPr>
             <a:r>
-              <a:rPr sz="1300" b="0" i="0">
+              <a:rPr sz="1700" b="0" i="0">
                 <a:solidFill>
                   <a:srgbClr val="FFFFFF"/>
                 </a:solidFill>
                 <a:latin typeface="Arial"/>
               </a:rPr>
-              <a:t>D.  The later consolidation</a:t>
+              <a:t>D.  Later consolidation</a:t>
             </a:r>
           </a:p>
         </p:txBody>
@@ -6197,7 +6469,7 @@
                 </a:solidFill>
                 <a:latin typeface="Palatino"/>
               </a:rPr>
-              <a:t>The Apple daily chart, cropped to the key reversal day and its surrounding bars. The marked bar opens above the previous high, forms a new high, closes below the previous close, and has above average volume.</a:t>
+              <a:t>The Apple daily chart, cropped to the key reversal day and its surrounding bars. The marked bar opens above the previous high, forms a new high, and closes below the previous close.</a:t>
             </a:r>
           </a:p>
         </p:txBody>
@@ -6210,8 +6482,8 @@
         </p:nvSpPr>
         <p:spPr>
           <a:xfrm>
-            <a:off x="8658191" y="1408176"/>
-            <a:ext cx="641406" cy="946404"/>
+            <a:off x="8658191" y="1737360"/>
+            <a:ext cx="285069" cy="329183"/>
           </a:xfrm>
           <a:prstGeom prst="ellipse">
             <a:avLst/>
@@ -6239,8 +6511,8 @@
         </p:nvSpPr>
         <p:spPr>
           <a:xfrm>
-            <a:off x="8658191" y="2189988"/>
-            <a:ext cx="641406" cy="946404"/>
+            <a:off x="8800726" y="1408176"/>
+            <a:ext cx="249435" cy="329184"/>
           </a:xfrm>
           <a:prstGeom prst="ellipse">
             <a:avLst/>
@@ -6268,8 +6540,8 @@
         </p:nvSpPr>
         <p:spPr>
           <a:xfrm>
-            <a:off x="8622558" y="4329684"/>
-            <a:ext cx="712673" cy="1069848"/>
+            <a:off x="8907627" y="2313432"/>
+            <a:ext cx="285069" cy="329184"/>
           </a:xfrm>
           <a:prstGeom prst="ellipse">
             <a:avLst/>
@@ -6297,7 +6569,7 @@
         </p:nvSpPr>
         <p:spPr>
           <a:xfrm>
-            <a:off x="9179783" y="1335024"/>
+            <a:off x="8217674" y="1499616"/>
             <a:ext cx="310896" cy="310896"/>
           </a:xfrm>
           <a:prstGeom prst="ellipse">
@@ -6348,7 +6620,7 @@
         </p:nvSpPr>
         <p:spPr>
           <a:xfrm>
-            <a:off x="9322318" y="2939796"/>
+            <a:off x="9179783" y="1252728"/>
             <a:ext cx="310896" cy="310896"/>
           </a:xfrm>
           <a:prstGeom prst="ellipse">
@@ -6399,7 +6671,7 @@
         </p:nvSpPr>
         <p:spPr>
           <a:xfrm>
-            <a:off x="9322318" y="4791456"/>
+            <a:off x="9357951" y="2569464"/>
             <a:ext cx="310896" cy="310896"/>
           </a:xfrm>
           <a:prstGeom prst="ellipse">
@@ -6699,7 +6971,7 @@
                 </a:solidFill>
                 <a:latin typeface="Arial"/>
               </a:rPr>
-              <a:t>Key reversal bars</a:t>
+              <a:t>From “Figure 7.15: three observations”</a:t>
             </a:r>
           </a:p>
         </p:txBody>
@@ -6713,7 +6985,7 @@
         <p:spPr>
           <a:xfrm>
             <a:off x="777240" y="1207008"/>
-            <a:ext cx="5303520" cy="2352675"/>
+            <a:ext cx="5303520" cy="2265045"/>
           </a:xfrm>
           <a:prstGeom prst="rect">
             <a:avLst/>
@@ -6745,7 +7017,7 @@
         <p:spPr>
           <a:xfrm>
             <a:off x="777240" y="1207008"/>
-            <a:ext cx="91440" cy="2352675"/>
+            <a:ext cx="91440" cy="2265045"/>
           </a:xfrm>
           <a:prstGeom prst="rect">
             <a:avLst/>
@@ -6775,7 +7047,7 @@
         <p:spPr>
           <a:xfrm>
             <a:off x="1097280" y="1389888"/>
-            <a:ext cx="4754880" cy="529590"/>
+            <a:ext cx="4754880" cy="588009"/>
           </a:xfrm>
           <a:prstGeom prst="rect">
             <a:avLst/>
@@ -6800,13 +7072,13 @@
               </a:spcAft>
             </a:pPr>
             <a:r>
-              <a:rPr sz="1500" b="0" i="0">
+              <a:rPr sz="1700" b="0" i="0">
                 <a:solidFill>
                   <a:srgbClr val="818181"/>
                 </a:solidFill>
                 <a:latin typeface="Arial"/>
               </a:rPr>
-              <a:t>Q1   A bearish key reversal bar must make a higher high than the previous bar and then:</a:t>
+              <a:t>Q1   A bearish key reversal makes a higher high, then:</a:t>
             </a:r>
           </a:p>
         </p:txBody>
@@ -6819,8 +7091,8 @@
         </p:nvSpPr>
         <p:spPr>
           <a:xfrm>
-            <a:off x="1097280" y="2010918"/>
-            <a:ext cx="4754880" cy="1548765"/>
+            <a:off x="1097280" y="2069338"/>
+            <a:ext cx="4754880" cy="1402715"/>
           </a:xfrm>
           <a:prstGeom prst="rect">
             <a:avLst/>
@@ -6845,13 +7117,13 @@
               </a:spcAft>
             </a:pPr>
             <a:r>
-              <a:rPr sz="1800" b="1" i="0">
+              <a:rPr sz="2000" b="1" i="0">
                 <a:solidFill>
                   <a:srgbClr val="007A33"/>
                 </a:solidFill>
                 <a:latin typeface="Courier New"/>
               </a:rPr>
-              <a:t>A.  Close near or below the previous close</a:t>
+              <a:t>A.  Near or below prior close</a:t>
             </a:r>
           </a:p>
           <a:p>
@@ -6867,7 +7139,7 @@
               </a:spcAft>
             </a:pPr>
             <a:r>
-              <a:rPr sz="1500" b="0" i="0">
+              <a:rPr sz="1700" b="0" i="0">
                 <a:solidFill>
                   <a:srgbClr val="1A1A1A"/>
                 </a:solidFill>
@@ -6886,8 +7158,8 @@
         </p:nvSpPr>
         <p:spPr>
           <a:xfrm>
-            <a:off x="777240" y="3742563"/>
-            <a:ext cx="5303520" cy="1870710"/>
+            <a:off x="777240" y="3654933"/>
+            <a:ext cx="5303520" cy="2016760"/>
           </a:xfrm>
           <a:prstGeom prst="rect">
             <a:avLst/>
@@ -6918,8 +7190,8 @@
         </p:nvSpPr>
         <p:spPr>
           <a:xfrm>
-            <a:off x="777240" y="3742563"/>
-            <a:ext cx="91440" cy="1870710"/>
+            <a:off x="777240" y="3654933"/>
+            <a:ext cx="91440" cy="2016760"/>
           </a:xfrm>
           <a:prstGeom prst="rect">
             <a:avLst/>
@@ -6948,8 +7220,8 @@
         </p:nvSpPr>
         <p:spPr>
           <a:xfrm>
-            <a:off x="1097280" y="3925443"/>
-            <a:ext cx="4754880" cy="529590"/>
+            <a:off x="1097280" y="3837813"/>
+            <a:ext cx="4754880" cy="339725"/>
           </a:xfrm>
           <a:prstGeom prst="rect">
             <a:avLst/>
@@ -6974,13 +7246,13 @@
               </a:spcAft>
             </a:pPr>
             <a:r>
-              <a:rPr sz="1500" b="0" i="0">
+              <a:rPr sz="1700" b="0" i="0">
                 <a:solidFill>
                   <a:srgbClr val="818181"/>
                 </a:solidFill>
                 <a:latin typeface="Arial"/>
               </a:rPr>
-              <a:t>Q2   On Figure 7.15, what does blue mark 3 identify?</a:t>
+              <a:t>Q2   On Figure 7.15, blue mark 3 identifies:</a:t>
             </a:r>
           </a:p>
         </p:txBody>
@@ -6993,8 +7265,8 @@
         </p:nvSpPr>
         <p:spPr>
           <a:xfrm>
-            <a:off x="1097280" y="4546473"/>
-            <a:ext cx="4754880" cy="1066799"/>
+            <a:off x="1097280" y="4268978"/>
+            <a:ext cx="4754880" cy="1402715"/>
           </a:xfrm>
           <a:prstGeom prst="rect">
             <a:avLst/>
@@ -7019,13 +7291,13 @@
               </a:spcAft>
             </a:pPr>
             <a:r>
-              <a:rPr sz="1800" b="1" i="0">
+              <a:rPr sz="2000" b="1" i="0">
                 <a:solidFill>
                   <a:srgbClr val="007A33"/>
                 </a:solidFill>
                 <a:latin typeface="Courier New"/>
               </a:rPr>
-              <a:t>C.  The above-average volume</a:t>
+              <a:t>C.  Close below prior close</a:t>
             </a:r>
           </a:p>
           <a:p>
@@ -7041,13 +7313,13 @@
               </a:spcAft>
             </a:pPr>
             <a:r>
-              <a:rPr sz="1500" b="0" i="0">
+              <a:rPr sz="1700" b="0" i="0">
                 <a:solidFill>
                   <a:srgbClr val="1A1A1A"/>
                 </a:solidFill>
                 <a:latin typeface="Arial"/>
               </a:rPr>
-              <a:t>Blue mark 3 identifies the above-average volume below the key reversal bar.</a:t>
+              <a:t>The preceding slide maps blue mark 3 to the close below the previous close (Lim, p. 219).</a:t>
             </a:r>
           </a:p>
         </p:txBody>
@@ -7208,7 +7480,7 @@
                 </a:solidFill>
                 <a:latin typeface="Palatino"/>
               </a:rPr>
-              <a:t>The Apple daily chart, cropped to the key reversal day and its surrounding bars. The marked bar opens above the previous high, forms a new high, closes below the previous close, and has above average volume.</a:t>
+              <a:t>The Apple daily chart, cropped to the key reversal day and its surrounding bars. The marked bar opens above the previous high, forms a new high, and closes below the previous close.</a:t>
             </a:r>
           </a:p>
         </p:txBody>
@@ -7221,8 +7493,8 @@
         </p:nvSpPr>
         <p:spPr>
           <a:xfrm>
-            <a:off x="8658191" y="1408176"/>
-            <a:ext cx="641406" cy="946404"/>
+            <a:off x="8658191" y="1737360"/>
+            <a:ext cx="285069" cy="329183"/>
           </a:xfrm>
           <a:prstGeom prst="ellipse">
             <a:avLst/>
@@ -7250,8 +7522,8 @@
         </p:nvSpPr>
         <p:spPr>
           <a:xfrm>
-            <a:off x="8658191" y="2189988"/>
-            <a:ext cx="641406" cy="946404"/>
+            <a:off x="8800726" y="1408176"/>
+            <a:ext cx="249435" cy="329184"/>
           </a:xfrm>
           <a:prstGeom prst="ellipse">
             <a:avLst/>
@@ -7279,8 +7551,8 @@
         </p:nvSpPr>
         <p:spPr>
           <a:xfrm>
-            <a:off x="8622558" y="4329684"/>
-            <a:ext cx="712673" cy="1069848"/>
+            <a:off x="8907627" y="2313432"/>
+            <a:ext cx="285069" cy="329184"/>
           </a:xfrm>
           <a:prstGeom prst="ellipse">
             <a:avLst/>
@@ -7308,7 +7580,7 @@
         </p:nvSpPr>
         <p:spPr>
           <a:xfrm>
-            <a:off x="9179783" y="1335024"/>
+            <a:off x="8217674" y="1499616"/>
             <a:ext cx="310896" cy="310896"/>
           </a:xfrm>
           <a:prstGeom prst="ellipse">
@@ -7359,7 +7631,7 @@
         </p:nvSpPr>
         <p:spPr>
           <a:xfrm>
-            <a:off x="9322318" y="2939796"/>
+            <a:off x="9179783" y="1252728"/>
             <a:ext cx="310896" cy="310896"/>
           </a:xfrm>
           <a:prstGeom prst="ellipse">
@@ -7410,7 +7682,7 @@
         </p:nvSpPr>
         <p:spPr>
           <a:xfrm>
-            <a:off x="9322318" y="4791456"/>
+            <a:off x="9357951" y="2569464"/>
             <a:ext cx="310896" cy="310896"/>
           </a:xfrm>
           <a:prstGeom prst="ellipse">
@@ -7710,7 +7982,7 @@
                 </a:solidFill>
                 <a:latin typeface="Arial"/>
               </a:rPr>
-              <a:t>Key reversal review</a:t>
+              <a:t>From “Figure 7.15: three observations”</a:t>
             </a:r>
           </a:p>
         </p:txBody>
@@ -7724,7 +7996,7 @@
         <p:spPr>
           <a:xfrm>
             <a:off x="777240" y="1207008"/>
-            <a:ext cx="5303520" cy="2293112"/>
+            <a:ext cx="5303520" cy="2614422"/>
           </a:xfrm>
           <a:prstGeom prst="rect">
             <a:avLst/>
@@ -7799,7 +8071,7 @@
         <p:spPr>
           <a:xfrm>
             <a:off x="1005840" y="1618488"/>
-            <a:ext cx="4846320" cy="500379"/>
+            <a:ext cx="4846320" cy="588009"/>
           </a:xfrm>
           <a:prstGeom prst="rect">
             <a:avLst/>
@@ -7824,7 +8096,7 @@
               </a:spcAft>
             </a:pPr>
             <a:r>
-              <a:rPr sz="1400" b="1" i="0">
+              <a:rPr sz="1700" b="1" i="0">
                 <a:solidFill>
                   <a:srgbClr val="FFFFFF"/>
                 </a:solidFill>
@@ -7843,8 +8115,8 @@
         </p:nvSpPr>
         <p:spPr>
           <a:xfrm>
-            <a:off x="1005840" y="2192020"/>
-            <a:ext cx="4846320" cy="1335531"/>
+            <a:off x="1005840" y="2279650"/>
+            <a:ext cx="4846320" cy="1569211"/>
           </a:xfrm>
           <a:prstGeom prst="rect">
             <a:avLst/>
@@ -7869,7 +8141,7 @@
               </a:spcAft>
             </a:pPr>
             <a:r>
-              <a:rPr sz="1300" b="0" i="0">
+              <a:rPr sz="1700" b="0" i="0">
                 <a:solidFill>
                   <a:srgbClr val="FFFFFF"/>
                 </a:solidFill>
@@ -7891,7 +8163,7 @@
               </a:spcAft>
             </a:pPr>
             <a:r>
-              <a:rPr sz="1300" b="0" i="0">
+              <a:rPr sz="1700" b="0" i="0">
                 <a:solidFill>
                   <a:srgbClr val="FFFFFF"/>
                 </a:solidFill>
@@ -7913,7 +8185,7 @@
               </a:spcAft>
             </a:pPr>
             <a:r>
-              <a:rPr sz="1300" b="0" i="0">
+              <a:rPr sz="1700" b="0" i="0">
                 <a:solidFill>
                   <a:srgbClr val="FFFFFF"/>
                 </a:solidFill>
@@ -7935,7 +8207,7 @@
               </a:spcAft>
             </a:pPr>
             <a:r>
-              <a:rPr sz="1300" b="0" i="0">
+              <a:rPr sz="1700" b="0" i="0">
                 <a:solidFill>
                   <a:srgbClr val="FFFFFF"/>
                 </a:solidFill>
@@ -7954,8 +8226,8 @@
         </p:nvSpPr>
         <p:spPr>
           <a:xfrm>
-            <a:off x="777240" y="3664712"/>
-            <a:ext cx="5303520" cy="2088642"/>
+            <a:off x="777240" y="3986022"/>
+            <a:ext cx="5303520" cy="2366137"/>
           </a:xfrm>
           <a:prstGeom prst="rect">
             <a:avLst/>
@@ -7984,7 +8256,7 @@
         </p:nvSpPr>
         <p:spPr>
           <a:xfrm>
-            <a:off x="1005840" y="3829304"/>
+            <a:off x="1005840" y="4150614"/>
             <a:ext cx="4846320" cy="228600"/>
           </a:xfrm>
           <a:prstGeom prst="rect">
@@ -8029,8 +8301,8 @@
         </p:nvSpPr>
         <p:spPr>
           <a:xfrm>
-            <a:off x="1005840" y="4076192"/>
-            <a:ext cx="4846320" cy="295909"/>
+            <a:off x="1005840" y="4397502"/>
+            <a:ext cx="4846320" cy="339725"/>
           </a:xfrm>
           <a:prstGeom prst="rect">
             <a:avLst/>
@@ -8055,7 +8327,7 @@
               </a:spcAft>
             </a:pPr>
             <a:r>
-              <a:rPr sz="1400" b="1" i="0">
+              <a:rPr sz="1700" b="1" i="0">
                 <a:solidFill>
                   <a:srgbClr val="FFFFFF"/>
                 </a:solidFill>
@@ -8074,8 +8346,8 @@
         </p:nvSpPr>
         <p:spPr>
           <a:xfrm>
-            <a:off x="1005840" y="4445254"/>
-            <a:ext cx="4846320" cy="1335532"/>
+            <a:off x="1005840" y="4810379"/>
+            <a:ext cx="4846320" cy="1569212"/>
           </a:xfrm>
           <a:prstGeom prst="rect">
             <a:avLst/>
@@ -8100,13 +8372,13 @@
               </a:spcAft>
             </a:pPr>
             <a:r>
-              <a:rPr sz="1300" b="0" i="0">
+              <a:rPr sz="1700" b="0" i="0">
                 <a:solidFill>
                   <a:srgbClr val="FFFFFF"/>
                 </a:solidFill>
                 <a:latin typeface="Arial"/>
               </a:rPr>
-              <a:t>A.  Downtrend</a:t>
+              <a:t>A.  Monthly chart only</a:t>
             </a:r>
           </a:p>
           <a:p>
@@ -8122,13 +8394,13 @@
               </a:spcAft>
             </a:pPr>
             <a:r>
-              <a:rPr sz="1300" b="0" i="0">
+              <a:rPr sz="1700" b="0" i="0">
                 <a:solidFill>
                   <a:srgbClr val="FFFFFF"/>
                 </a:solidFill>
                 <a:latin typeface="Arial"/>
               </a:rPr>
-              <a:t>B.  Flat market only</a:t>
+              <a:t>B.  Downtrend</a:t>
             </a:r>
           </a:p>
           <a:p>
@@ -8144,13 +8416,13 @@
               </a:spcAft>
             </a:pPr>
             <a:r>
-              <a:rPr sz="1300" b="0" i="0">
+              <a:rPr sz="1700" b="0" i="0">
                 <a:solidFill>
                   <a:srgbClr val="FFFFFF"/>
                 </a:solidFill>
                 <a:latin typeface="Arial"/>
               </a:rPr>
-              <a:t>C.  Monthly chart only</a:t>
+              <a:t>C.  Flat market only</a:t>
             </a:r>
           </a:p>
           <a:p>
@@ -8166,7 +8438,7 @@
               </a:spcAft>
             </a:pPr>
             <a:r>
-              <a:rPr sz="1300" b="0" i="0">
+              <a:rPr sz="1700" b="0" i="0">
                 <a:solidFill>
                   <a:srgbClr val="FFFFFF"/>
                 </a:solidFill>
@@ -8333,7 +8605,7 @@
                 </a:solidFill>
                 <a:latin typeface="Palatino"/>
               </a:rPr>
-              <a:t>The Apple daily chart, cropped to the key reversal day and its surrounding bars. The marked bar opens above the previous high, forms a new high, closes below the previous close, and has above average volume.</a:t>
+              <a:t>The Apple daily chart, cropped to the key reversal day and its surrounding bars. The marked bar opens above the previous high, forms a new high, and closes below the previous close.</a:t>
             </a:r>
           </a:p>
         </p:txBody>
@@ -8346,8 +8618,8 @@
         </p:nvSpPr>
         <p:spPr>
           <a:xfrm>
-            <a:off x="8658191" y="1408176"/>
-            <a:ext cx="641406" cy="946404"/>
+            <a:off x="8658191" y="1737360"/>
+            <a:ext cx="285069" cy="329183"/>
           </a:xfrm>
           <a:prstGeom prst="ellipse">
             <a:avLst/>
@@ -8375,8 +8647,8 @@
         </p:nvSpPr>
         <p:spPr>
           <a:xfrm>
-            <a:off x="8658191" y="2189988"/>
-            <a:ext cx="641406" cy="946404"/>
+            <a:off x="8800726" y="1408176"/>
+            <a:ext cx="249435" cy="329184"/>
           </a:xfrm>
           <a:prstGeom prst="ellipse">
             <a:avLst/>
@@ -8404,8 +8676,8 @@
         </p:nvSpPr>
         <p:spPr>
           <a:xfrm>
-            <a:off x="8622558" y="4329684"/>
-            <a:ext cx="712673" cy="1069848"/>
+            <a:off x="8907627" y="2313432"/>
+            <a:ext cx="285069" cy="329184"/>
           </a:xfrm>
           <a:prstGeom prst="ellipse">
             <a:avLst/>
@@ -8433,7 +8705,7 @@
         </p:nvSpPr>
         <p:spPr>
           <a:xfrm>
-            <a:off x="9179783" y="1335024"/>
+            <a:off x="8217674" y="1499616"/>
             <a:ext cx="310896" cy="310896"/>
           </a:xfrm>
           <a:prstGeom prst="ellipse">
@@ -8484,7 +8756,7 @@
         </p:nvSpPr>
         <p:spPr>
           <a:xfrm>
-            <a:off x="9322318" y="2939796"/>
+            <a:off x="9179783" y="1252728"/>
             <a:ext cx="310896" cy="310896"/>
           </a:xfrm>
           <a:prstGeom prst="ellipse">
@@ -8535,7 +8807,7 @@
         </p:nvSpPr>
         <p:spPr>
           <a:xfrm>
-            <a:off x="9322318" y="4791456"/>
+            <a:off x="9357951" y="2569464"/>
             <a:ext cx="310896" cy="310896"/>
           </a:xfrm>
           <a:prstGeom prst="ellipse">
@@ -8835,7 +9107,7 @@
                 </a:solidFill>
                 <a:latin typeface="Arial"/>
               </a:rPr>
-              <a:t>Key reversal review</a:t>
+              <a:t>From “Figure 7.15: three observations”</a:t>
             </a:r>
           </a:p>
         </p:txBody>
@@ -8849,7 +9121,7 @@
         <p:spPr>
           <a:xfrm>
             <a:off x="777240" y="1207008"/>
-            <a:ext cx="5303520" cy="1958340"/>
+            <a:ext cx="5303520" cy="2016759"/>
           </a:xfrm>
           <a:prstGeom prst="rect">
             <a:avLst/>
@@ -8881,7 +9153,7 @@
         <p:spPr>
           <a:xfrm>
             <a:off x="777240" y="1207008"/>
-            <a:ext cx="91440" cy="1958340"/>
+            <a:ext cx="91440" cy="2016759"/>
           </a:xfrm>
           <a:prstGeom prst="rect">
             <a:avLst/>
@@ -8911,7 +9183,7 @@
         <p:spPr>
           <a:xfrm>
             <a:off x="1097280" y="1389888"/>
-            <a:ext cx="4754880" cy="558800"/>
+            <a:ext cx="4754880" cy="588009"/>
           </a:xfrm>
           <a:prstGeom prst="rect">
             <a:avLst/>
@@ -8936,7 +9208,7 @@
               </a:spcAft>
             </a:pPr>
             <a:r>
-              <a:rPr sz="1600" b="0" i="0">
+              <a:rPr sz="1700" b="0" i="0">
                 <a:solidFill>
                   <a:srgbClr val="818181"/>
                 </a:solidFill>
@@ -8955,8 +9227,8 @@
         </p:nvSpPr>
         <p:spPr>
           <a:xfrm>
-            <a:off x="1097280" y="2040128"/>
-            <a:ext cx="4754880" cy="1125220"/>
+            <a:off x="1097280" y="2069338"/>
+            <a:ext cx="4754880" cy="1154429"/>
           </a:xfrm>
           <a:prstGeom prst="rect">
             <a:avLst/>
@@ -9003,7 +9275,7 @@
               </a:spcAft>
             </a:pPr>
             <a:r>
-              <a:rPr sz="1600" b="0" i="0">
+              <a:rPr sz="1700" b="0" i="0">
                 <a:solidFill>
                   <a:srgbClr val="1A1A1A"/>
                 </a:solidFill>
@@ -9022,8 +9294,8 @@
         </p:nvSpPr>
         <p:spPr>
           <a:xfrm>
-            <a:off x="777240" y="3348228"/>
-            <a:ext cx="5303520" cy="1724660"/>
+            <a:off x="777240" y="3406647"/>
+            <a:ext cx="5303520" cy="1768475"/>
           </a:xfrm>
           <a:prstGeom prst="rect">
             <a:avLst/>
@@ -9054,8 +9326,8 @@
         </p:nvSpPr>
         <p:spPr>
           <a:xfrm>
-            <a:off x="777240" y="3348228"/>
-            <a:ext cx="91440" cy="1724660"/>
+            <a:off x="777240" y="3406647"/>
+            <a:ext cx="91440" cy="1768475"/>
           </a:xfrm>
           <a:prstGeom prst="rect">
             <a:avLst/>
@@ -9084,8 +9356,8 @@
         </p:nvSpPr>
         <p:spPr>
           <a:xfrm>
-            <a:off x="1097280" y="3531108"/>
-            <a:ext cx="4754880" cy="325119"/>
+            <a:off x="1097280" y="3589528"/>
+            <a:ext cx="4754880" cy="339725"/>
           </a:xfrm>
           <a:prstGeom prst="rect">
             <a:avLst/>
@@ -9110,7 +9382,7 @@
               </a:spcAft>
             </a:pPr>
             <a:r>
-              <a:rPr sz="1600" b="0" i="0">
+              <a:rPr sz="1700" b="0" i="0">
                 <a:solidFill>
                   <a:srgbClr val="818181"/>
                 </a:solidFill>
@@ -9129,8 +9401,8 @@
         </p:nvSpPr>
         <p:spPr>
           <a:xfrm>
-            <a:off x="1097280" y="3947668"/>
-            <a:ext cx="4754880" cy="1125220"/>
+            <a:off x="1097280" y="4020693"/>
+            <a:ext cx="4754880" cy="1154429"/>
           </a:xfrm>
           <a:prstGeom prst="rect">
             <a:avLst/>
@@ -9161,7 +9433,7 @@
                 </a:solidFill>
                 <a:latin typeface="Courier New"/>
               </a:rPr>
-              <a:t>B.  Flat market only</a:t>
+              <a:t>B.  Downtrend</a:t>
             </a:r>
           </a:p>
           <a:p>
@@ -9177,7 +9449,7 @@
               </a:spcAft>
             </a:pPr>
             <a:r>
-              <a:rPr sz="1600" b="0" i="0">
+              <a:rPr sz="1700" b="0" i="0">
                 <a:solidFill>
                   <a:srgbClr val="1A1A1A"/>
                 </a:solidFill>
@@ -9344,7 +9616,7 @@
                 </a:solidFill>
                 <a:latin typeface="Palatino"/>
               </a:rPr>
-              <a:t>The Apple daily chart, cropped to the key reversal day and its surrounding bars. The marked bar opens above the previous high, forms a new high, closes below the previous close, and has above average volume.</a:t>
+              <a:t>The Apple daily chart, cropped to the key reversal day and its surrounding bars. The marked bar opens above the previous high, forms a new high, and closes below the previous close.</a:t>
             </a:r>
           </a:p>
         </p:txBody>
@@ -9357,8 +9629,8 @@
         </p:nvSpPr>
         <p:spPr>
           <a:xfrm>
-            <a:off x="8658191" y="1408176"/>
-            <a:ext cx="641406" cy="946404"/>
+            <a:off x="8658191" y="1737360"/>
+            <a:ext cx="285069" cy="329183"/>
           </a:xfrm>
           <a:prstGeom prst="ellipse">
             <a:avLst/>
@@ -9386,8 +9658,8 @@
         </p:nvSpPr>
         <p:spPr>
           <a:xfrm>
-            <a:off x="8658191" y="2189988"/>
-            <a:ext cx="641406" cy="946404"/>
+            <a:off x="8800726" y="1408176"/>
+            <a:ext cx="249435" cy="329184"/>
           </a:xfrm>
           <a:prstGeom prst="ellipse">
             <a:avLst/>
@@ -9415,8 +9687,8 @@
         </p:nvSpPr>
         <p:spPr>
           <a:xfrm>
-            <a:off x="8622558" y="4329684"/>
-            <a:ext cx="712673" cy="1069848"/>
+            <a:off x="8907627" y="2313432"/>
+            <a:ext cx="285069" cy="329184"/>
           </a:xfrm>
           <a:prstGeom prst="ellipse">
             <a:avLst/>
@@ -9444,7 +9716,7 @@
         </p:nvSpPr>
         <p:spPr>
           <a:xfrm>
-            <a:off x="9179783" y="1335024"/>
+            <a:off x="8217674" y="1499616"/>
             <a:ext cx="310896" cy="310896"/>
           </a:xfrm>
           <a:prstGeom prst="ellipse">
@@ -9495,7 +9767,7 @@
         </p:nvSpPr>
         <p:spPr>
           <a:xfrm>
-            <a:off x="9322318" y="2939796"/>
+            <a:off x="9179783" y="1252728"/>
             <a:ext cx="310896" cy="310896"/>
           </a:xfrm>
           <a:prstGeom prst="ellipse">
@@ -9546,7 +9818,7 @@
         </p:nvSpPr>
         <p:spPr>
           <a:xfrm>
-            <a:off x="9322318" y="4791456"/>
+            <a:off x="9357951" y="2569464"/>
             <a:ext cx="310896" cy="310896"/>
           </a:xfrm>
           <a:prstGeom prst="ellipse">
@@ -12181,7 +12453,7 @@
                 </a:solidFill>
                 <a:latin typeface="Palatino"/>
               </a:rPr>
-              <a:t>Bearish key reversal: numbers first</a:t>
+              <a:t>Three marked observations</a:t>
             </a:r>
           </a:p>
         </p:txBody>
@@ -12270,7 +12542,7 @@
         <p:spPr>
           <a:xfrm>
             <a:off x="777240" y="1965960"/>
-            <a:ext cx="5303520" cy="3108960"/>
+            <a:ext cx="6035040" cy="3108960"/>
           </a:xfrm>
           <a:prstGeom prst="rect">
             <a:avLst/>
@@ -12295,13 +12567,13 @@
               </a:spcAft>
             </a:pPr>
             <a:r>
-              <a:rPr sz="1500" b="0" i="0">
+              <a:rPr sz="1900" b="0" i="0">
                 <a:solidFill>
                   <a:srgbClr val="1A1A1A"/>
                 </a:solidFill>
                 <a:latin typeface="Arial"/>
               </a:rPr>
-              <a:t>Prior bar: open 50.80, high 52.00, low 50.60, close 51.10, volume 2.0 million.</a:t>
+              <a:t>A key reversal is an uptrend bar with a higher high, then a close near or below the previous close (Lim, p. 218).</a:t>
             </a:r>
           </a:p>
           <a:p>
@@ -12317,13 +12589,13 @@
               </a:spcAft>
             </a:pPr>
             <a:r>
-              <a:rPr sz="1500" b="0" i="0">
+              <a:rPr sz="1900" b="0" i="0">
                 <a:solidFill>
                   <a:srgbClr val="1A1A1A"/>
                 </a:solidFill>
                 <a:latin typeface="Arial"/>
               </a:rPr>
-              <a:t>New bar: open 52.30, high 53.20, low 49.90, close 50.80, volume 4.2 million.</a:t>
+              <a:t>Prior: O 50.80, H 52.00, L 50.60, C 51.10. New: O 52.30, H 53.20, L 49.90, C 50.80. Ours, invented.</a:t>
             </a:r>
           </a:p>
           <a:p>
@@ -12339,35 +12611,58 @@
               </a:spcAft>
             </a:pPr>
             <a:r>
-              <a:rPr sz="1500" b="0" i="0">
+              <a:rPr sz="1900" b="1" i="0">
+                <a:solidFill>
+                  <a:srgbClr val="E09B00"/>
+                </a:solidFill>
+                <a:latin typeface="Arial"/>
+              </a:rPr>
+              <a:t>(1)</a:t>
+            </a:r>
+            <a:r>
+              <a:rPr sz="1900" b="0" i="0">
                 <a:solidFill>
                   <a:srgbClr val="1A1A1A"/>
                 </a:solidFill>
                 <a:latin typeface="Arial"/>
               </a:rPr>
-              <a:t>[1] Open above the old high. [2] Make a new high. [3] Close below the old close. Then compare volume.</a:t>
-            </a:r>
-          </a:p>
-          <a:p>
-            <a:pPr algn="l">
-              <a:lnSpc>
-                <a:spcPct val="105000"/>
-              </a:lnSpc>
-              <a:spcBef>
-                <a:spcPts val="0"/>
-              </a:spcBef>
-              <a:spcAft>
-                <a:spcPts val="1100"/>
-              </a:spcAft>
-            </a:pPr>
-            <a:r>
-              <a:rPr sz="1500" b="0" i="0">
+              <a:t> open above old high; </a:t>
+            </a:r>
+            <a:r>
+              <a:rPr sz="1900" b="1" i="0">
+                <a:solidFill>
+                  <a:srgbClr val="C62828"/>
+                </a:solidFill>
+                <a:latin typeface="Arial"/>
+              </a:rPr>
+              <a:t>(2)</a:t>
+            </a:r>
+            <a:r>
+              <a:rPr sz="1900" b="0" i="0">
                 <a:solidFill>
                   <a:srgbClr val="1A1A1A"/>
                 </a:solidFill>
                 <a:latin typeface="Arial"/>
               </a:rPr>
-              <a:t>The wider bar can make downside follow-through potentially more reliable, but the decline may wait through consolidation.</a:t>
+              <a:t> new high; </a:t>
+            </a:r>
+            <a:r>
+              <a:rPr sz="1900" b="1" i="0">
+                <a:solidFill>
+                  <a:srgbClr val="1F5FAD"/>
+                </a:solidFill>
+                <a:latin typeface="Arial"/>
+              </a:rPr>
+              <a:t>(3)</a:t>
+            </a:r>
+            <a:r>
+              <a:rPr sz="1900" b="0" i="0">
+                <a:solidFill>
+                  <a:srgbClr val="1A1A1A"/>
+                </a:solidFill>
+                <a:latin typeface="Arial"/>
+              </a:rPr>
+              <a:t> close below old close. Volume is shares traded: 4.2m versus 2.0m (Chapter 6, “Volume and bar range: Chapter 5's four cases”). Next, Figure 7.15.</a:t>
             </a:r>
           </a:p>
         </p:txBody>
@@ -12380,83 +12675,8 @@
         </p:nvSpPr>
         <p:spPr>
           <a:xfrm>
-            <a:off x="777240" y="4985766"/>
-            <a:ext cx="82296" cy="633984"/>
-          </a:xfrm>
-          <a:prstGeom prst="rect">
-            <a:avLst/>
-          </a:prstGeom>
-          <a:solidFill>
-            <a:srgbClr val="F2A900"/>
-          </a:solidFill>
-          <a:ln>
-            <a:noFill/>
-          </a:ln>
-          <a:effectLst/>
-        </p:spPr>
-        <p:txBody>
-          <a:bodyPr rtlCol="0" anchor="ctr"/>
-          <a:lstStyle/>
-          <a:p>
-            <a:pPr algn="ctr"/>
-          </a:p>
-        </p:txBody>
-      </p:sp>
-      <p:sp>
-        <p:nvSpPr>
-          <p:cNvPr id="9" name="TextBox 8"/>
-          <p:cNvSpPr txBox="1"/>
-          <p:nvPr/>
-        </p:nvSpPr>
-        <p:spPr>
-          <a:xfrm>
-            <a:off x="1069848" y="5022342"/>
-            <a:ext cx="5010912" cy="633984"/>
-          </a:xfrm>
-          <a:prstGeom prst="rect">
-            <a:avLst/>
-          </a:prstGeom>
-          <a:noFill/>
-        </p:spPr>
-        <p:txBody>
-          <a:bodyPr wrap="square" anchor="t" lIns="0" rIns="0" tIns="0" bIns="0">
-            <a:spAutoFit/>
-          </a:bodyPr>
-          <a:lstStyle/>
-          <a:p>
-            <a:pPr algn="l">
-              <a:lnSpc>
-                <a:spcPct val="100000"/>
-              </a:lnSpc>
-              <a:spcBef>
-                <a:spcPts val="0"/>
-              </a:spcBef>
-              <a:spcAft>
-                <a:spcPts val="0"/>
-              </a:spcAft>
-            </a:pPr>
-            <a:r>
-              <a:rPr sz="1600" b="1" i="0">
-                <a:solidFill>
-                  <a:srgbClr val="1A1A1A"/>
-                </a:solidFill>
-                <a:latin typeface="Arial"/>
-              </a:rPr>
-              <a:t>A warning of potential reversal, not a promise of immediate decline.</a:t>
-            </a:r>
-          </a:p>
-        </p:txBody>
-      </p:sp>
-      <p:sp>
-        <p:nvSpPr>
-          <p:cNvPr id="10" name="Rectangle 9"/>
-          <p:cNvSpPr/>
-          <p:nvPr/>
-        </p:nvSpPr>
-        <p:spPr>
-          <a:xfrm>
-            <a:off x="6402171" y="1810512"/>
-            <a:ext cx="5010912" cy="3749039"/>
+            <a:off x="7132319" y="1810512"/>
+            <a:ext cx="4282135" cy="3212928"/>
           </a:xfrm>
           <a:prstGeom prst="rect">
             <a:avLst/>
@@ -12481,7 +12701,7 @@
       </p:sp>
       <p:pic>
         <p:nvPicPr>
-          <p:cNvPr id="11" name="Picture 10" descr="chart-b.png"/>
+          <p:cNvPr id="9" name="Picture 8" descr="chart-b.png"/>
           <p:cNvPicPr>
             <a:picLocks noChangeAspect="1"/>
           </p:cNvPicPr>
@@ -12495,8 +12715,8 @@
         </p:blipFill>
         <p:spPr>
           <a:xfrm>
-            <a:off x="6521043" y="1929384"/>
-            <a:ext cx="4773168" cy="3511296"/>
+            <a:off x="7251191" y="1929384"/>
+            <a:ext cx="4044391" cy="2975184"/>
           </a:xfrm>
           <a:prstGeom prst="rect">
             <a:avLst/>
@@ -12505,14 +12725,254 @@
       </p:pic>
       <p:sp>
         <p:nvSpPr>
-          <p:cNvPr id="12" name="TextBox 11"/>
+          <p:cNvPr id="10" name="Oval 9"/>
+          <p:cNvSpPr/>
+          <p:nvPr/>
+        </p:nvSpPr>
+        <p:spPr>
+          <a:xfrm>
+            <a:off x="9677826" y="2732683"/>
+            <a:ext cx="242663" cy="178511"/>
+          </a:xfrm>
+          <a:prstGeom prst="ellipse">
+            <a:avLst/>
+          </a:prstGeom>
+          <a:noFill/>
+          <a:ln w="44450">
+            <a:solidFill>
+              <a:srgbClr val="E09B00"/>
+            </a:solidFill>
+          </a:ln>
+        </p:spPr>
+        <p:txBody>
+          <a:bodyPr rtlCol="0" anchor="ctr"/>
+          <a:lstStyle/>
+          <a:p>
+            <a:pPr algn="ctr"/>
+          </a:p>
+        </p:txBody>
+      </p:sp>
+      <p:sp>
+        <p:nvSpPr>
+          <p:cNvPr id="11" name="Oval 10"/>
+          <p:cNvSpPr/>
+          <p:nvPr/>
+        </p:nvSpPr>
+        <p:spPr>
+          <a:xfrm>
+            <a:off x="9677826" y="2435165"/>
+            <a:ext cx="242663" cy="178511"/>
+          </a:xfrm>
+          <a:prstGeom prst="ellipse">
+            <a:avLst/>
+          </a:prstGeom>
+          <a:noFill/>
+          <a:ln w="44450">
+            <a:solidFill>
+              <a:srgbClr val="C62828"/>
+            </a:solidFill>
+          </a:ln>
+        </p:spPr>
+        <p:txBody>
+          <a:bodyPr rtlCol="0" anchor="ctr"/>
+          <a:lstStyle/>
+          <a:p>
+            <a:pPr algn="ctr"/>
+          </a:p>
+        </p:txBody>
+      </p:sp>
+      <p:sp>
+        <p:nvSpPr>
+          <p:cNvPr id="12" name="Oval 11"/>
+          <p:cNvSpPr/>
+          <p:nvPr/>
+        </p:nvSpPr>
+        <p:spPr>
+          <a:xfrm>
+            <a:off x="9677826" y="3476479"/>
+            <a:ext cx="242663" cy="178511"/>
+          </a:xfrm>
+          <a:prstGeom prst="ellipse">
+            <a:avLst/>
+          </a:prstGeom>
+          <a:noFill/>
+          <a:ln w="44450">
+            <a:solidFill>
+              <a:srgbClr val="1F5FAD"/>
+            </a:solidFill>
+          </a:ln>
+        </p:spPr>
+        <p:txBody>
+          <a:bodyPr rtlCol="0" anchor="ctr"/>
+          <a:lstStyle/>
+          <a:p>
+            <a:pPr algn="ctr"/>
+          </a:p>
+        </p:txBody>
+      </p:sp>
+      <p:sp>
+        <p:nvSpPr>
+          <p:cNvPr id="13" name="Oval 12"/>
+          <p:cNvSpPr/>
+          <p:nvPr/>
+        </p:nvSpPr>
+        <p:spPr>
+          <a:xfrm>
+            <a:off x="9239271" y="2606987"/>
+            <a:ext cx="310896" cy="310896"/>
+          </a:xfrm>
+          <a:prstGeom prst="ellipse">
+            <a:avLst/>
+          </a:prstGeom>
+          <a:solidFill>
+            <a:srgbClr val="E09B00"/>
+          </a:solidFill>
+          <a:ln w="12700">
+            <a:solidFill>
+              <a:srgbClr val="FFFFFF"/>
+            </a:solidFill>
+          </a:ln>
+          <a:effectLst/>
+        </p:spPr>
+        <p:txBody>
+          <a:bodyPr rtlCol="0" anchor="ctr" wrap="none" lIns="0" rIns="0" tIns="0" bIns="0"/>
+          <a:lstStyle/>
+          <a:p>
+            <a:pPr algn="ctr">
+              <a:lnSpc>
+                <a:spcPct val="100000"/>
+              </a:lnSpc>
+              <a:spcBef>
+                <a:spcPts val="0"/>
+              </a:spcBef>
+              <a:spcAft>
+                <a:spcPts val="0"/>
+              </a:spcAft>
+            </a:pPr>
+            <a:r>
+              <a:rPr sz="1300" b="1" i="0">
+                <a:solidFill>
+                  <a:srgbClr val="FFFFFF"/>
+                </a:solidFill>
+                <a:latin typeface="Arial"/>
+              </a:rPr>
+              <a:t>1</a:t>
+            </a:r>
+          </a:p>
+        </p:txBody>
+      </p:sp>
+      <p:sp>
+        <p:nvSpPr>
+          <p:cNvPr id="14" name="Oval 13"/>
+          <p:cNvSpPr/>
+          <p:nvPr/>
+        </p:nvSpPr>
+        <p:spPr>
+          <a:xfrm>
+            <a:off x="10048149" y="2249965"/>
+            <a:ext cx="310896" cy="310896"/>
+          </a:xfrm>
+          <a:prstGeom prst="ellipse">
+            <a:avLst/>
+          </a:prstGeom>
+          <a:solidFill>
+            <a:srgbClr val="C62828"/>
+          </a:solidFill>
+          <a:ln w="12700">
+            <a:solidFill>
+              <a:srgbClr val="FFFFFF"/>
+            </a:solidFill>
+          </a:ln>
+          <a:effectLst/>
+        </p:spPr>
+        <p:txBody>
+          <a:bodyPr rtlCol="0" anchor="ctr" wrap="none" lIns="0" rIns="0" tIns="0" bIns="0"/>
+          <a:lstStyle/>
+          <a:p>
+            <a:pPr algn="ctr">
+              <a:lnSpc>
+                <a:spcPct val="100000"/>
+              </a:lnSpc>
+              <a:spcBef>
+                <a:spcPts val="0"/>
+              </a:spcBef>
+              <a:spcAft>
+                <a:spcPts val="0"/>
+              </a:spcAft>
+            </a:pPr>
+            <a:r>
+              <a:rPr sz="1300" b="1" i="0">
+                <a:solidFill>
+                  <a:srgbClr val="FFFFFF"/>
+                </a:solidFill>
+                <a:latin typeface="Arial"/>
+              </a:rPr>
+              <a:t>2</a:t>
+            </a:r>
+          </a:p>
+        </p:txBody>
+      </p:sp>
+      <p:sp>
+        <p:nvSpPr>
+          <p:cNvPr id="15" name="Oval 14"/>
+          <p:cNvSpPr/>
+          <p:nvPr/>
+        </p:nvSpPr>
+        <p:spPr>
+          <a:xfrm>
+            <a:off x="10088593" y="3499542"/>
+            <a:ext cx="310896" cy="310896"/>
+          </a:xfrm>
+          <a:prstGeom prst="ellipse">
+            <a:avLst/>
+          </a:prstGeom>
+          <a:solidFill>
+            <a:srgbClr val="1F5FAD"/>
+          </a:solidFill>
+          <a:ln w="12700">
+            <a:solidFill>
+              <a:srgbClr val="FFFFFF"/>
+            </a:solidFill>
+          </a:ln>
+          <a:effectLst/>
+        </p:spPr>
+        <p:txBody>
+          <a:bodyPr rtlCol="0" anchor="ctr" wrap="none" lIns="0" rIns="0" tIns="0" bIns="0"/>
+          <a:lstStyle/>
+          <a:p>
+            <a:pPr algn="ctr">
+              <a:lnSpc>
+                <a:spcPct val="100000"/>
+              </a:lnSpc>
+              <a:spcBef>
+                <a:spcPts val="0"/>
+              </a:spcBef>
+              <a:spcAft>
+                <a:spcPts val="0"/>
+              </a:spcAft>
+            </a:pPr>
+            <a:r>
+              <a:rPr sz="1300" b="1" i="0">
+                <a:solidFill>
+                  <a:srgbClr val="FFFFFF"/>
+                </a:solidFill>
+                <a:latin typeface="Arial"/>
+              </a:rPr>
+              <a:t>3</a:t>
+            </a:r>
+          </a:p>
+        </p:txBody>
+      </p:sp>
+      <p:sp>
+        <p:nvSpPr>
+          <p:cNvPr id="16" name="TextBox 15"/>
           <p:cNvSpPr txBox="1"/>
           <p:nvPr/>
         </p:nvSpPr>
         <p:spPr>
           <a:xfrm>
-            <a:off x="6400799" y="5650991"/>
-            <a:ext cx="5013655" cy="274320"/>
+            <a:off x="7132319" y="5114880"/>
+            <a:ext cx="4282135" cy="274320"/>
           </a:xfrm>
           <a:prstGeom prst="rect">
             <a:avLst/>
@@ -12550,7 +13010,7 @@
       </p:sp>
       <p:sp>
         <p:nvSpPr>
-          <p:cNvPr id="13" name="TextBox 12"/>
+          <p:cNvPr id="17" name="TextBox 16"/>
           <p:cNvSpPr txBox="1"/>
           <p:nvPr/>
         </p:nvSpPr>
@@ -12711,7 +13171,7 @@
                 </a:solidFill>
                 <a:latin typeface="Palatino"/>
               </a:rPr>
-              <a:t>Bearish key reversal: definition and figure reading</a:t>
+              <a:t>Figure 7.15: three observations</a:t>
             </a:r>
           </a:p>
         </p:txBody>
@@ -12800,7 +13260,7 @@
         <p:spPr>
           <a:xfrm>
             <a:off x="777240" y="1965960"/>
-            <a:ext cx="5623560" cy="3108960"/>
+            <a:ext cx="6035040" cy="3108960"/>
           </a:xfrm>
           <a:prstGeom prst="rect">
             <a:avLst/>
@@ -12825,13 +13285,13 @@
               </a:spcAft>
             </a:pPr>
             <a:r>
-              <a:rPr sz="1500" b="0" i="0">
+              <a:rPr sz="1800" b="0" i="0">
                 <a:solidFill>
                   <a:srgbClr val="1A1A1A"/>
                 </a:solidFill>
                 <a:latin typeface="Arial"/>
               </a:rPr>
-              <a:t>Definition (p. 218): "A bearish key reversal forms a higher high, then closes near or below the previous close."</a:t>
+              <a:t>From “Three marked observations”: a key reversal makes a higher high, then closes near or below the previous close (Lim, p. 218).</a:t>
             </a:r>
           </a:p>
           <a:p>
@@ -12847,7 +13307,7 @@
               </a:spcAft>
             </a:pPr>
             <a:r>
-              <a:rPr sz="1500" b="0" i="0">
+              <a:rPr sz="1800" b="0" i="0">
                 <a:solidFill>
                   <a:srgbClr val="1A1A1A"/>
                 </a:solidFill>
@@ -12856,7 +13316,7 @@
               <a:t>Figure 7.15: </a:t>
             </a:r>
             <a:r>
-              <a:rPr sz="1500" b="1" i="0">
+              <a:rPr sz="1800" b="1" i="0">
                 <a:solidFill>
                   <a:srgbClr val="E09B00"/>
                 </a:solidFill>
@@ -12865,16 +13325,16 @@
               <a:t>(1)</a:t>
             </a:r>
             <a:r>
-              <a:rPr sz="1500" b="0" i="0">
+              <a:rPr sz="1800" b="0" i="0">
                 <a:solidFill>
                   <a:srgbClr val="1A1A1A"/>
                 </a:solidFill>
                 <a:latin typeface="Arial"/>
               </a:rPr>
-              <a:t> opens above the prior high, </a:t>
-            </a:r>
-            <a:r>
-              <a:rPr sz="1500" b="1" i="0">
+              <a:t> open above prior high, </a:t>
+            </a:r>
+            <a:r>
+              <a:rPr sz="1800" b="1" i="0">
                 <a:solidFill>
                   <a:srgbClr val="C62828"/>
                 </a:solidFill>
@@ -12883,16 +13343,16 @@
               <a:t>(2)</a:t>
             </a:r>
             <a:r>
-              <a:rPr sz="1500" b="0" i="0">
+              <a:rPr sz="1800" b="0" i="0">
                 <a:solidFill>
                   <a:srgbClr val="1A1A1A"/>
                 </a:solidFill>
                 <a:latin typeface="Arial"/>
               </a:rPr>
-              <a:t> forms a new high, and </a:t>
-            </a:r>
-            <a:r>
-              <a:rPr sz="1500" b="1" i="0">
+              <a:t> new high, </a:t>
+            </a:r>
+            <a:r>
+              <a:rPr sz="1800" b="1" i="0">
                 <a:solidFill>
                   <a:srgbClr val="1F5FAD"/>
                 </a:solidFill>
@@ -12901,13 +13361,13 @@
               <a:t>(3)</a:t>
             </a:r>
             <a:r>
-              <a:rPr sz="1500" b="0" i="0">
+              <a:rPr sz="1800" b="0" i="0">
                 <a:solidFill>
                   <a:srgbClr val="1A1A1A"/>
                 </a:solidFill>
                 <a:latin typeface="Arial"/>
               </a:rPr>
-              <a:t> closes below the prior close. Volume is above average.</a:t>
+              <a:t> close below prior close (Lim, p. 219).</a:t>
             </a:r>
           </a:p>
           <a:p>
@@ -12923,35 +13383,13 @@
               </a:spcAft>
             </a:pPr>
             <a:r>
-              <a:rPr sz="1500" b="0" i="0">
+              <a:rPr sz="1800" b="0" i="0">
                 <a:solidFill>
                   <a:srgbClr val="1A1A1A"/>
                 </a:solidFill>
                 <a:latin typeface="Arial"/>
               </a:rPr>
-              <a:t>Meaning: a potential downside warning. Consolidation may come before decline.</a:t>
-            </a:r>
-          </a:p>
-          <a:p>
-            <a:pPr algn="l">
-              <a:lnSpc>
-                <a:spcPct val="105000"/>
-              </a:lnSpc>
-              <a:spcBef>
-                <a:spcPts val="0"/>
-              </a:spcBef>
-              <a:spcAft>
-                <a:spcPts val="1100"/>
-              </a:spcAft>
-            </a:pPr>
-            <a:r>
-              <a:rPr sz="1500" b="0" i="0">
-                <a:solidFill>
-                  <a:srgbClr val="1A1A1A"/>
-                </a:solidFill>
-                <a:latin typeface="Arial"/>
-              </a:rPr>
-              <a:t>Action: check the 16 reversal characteristics and a significant resistance barrier.</a:t>
+              <a:t>Meaning/action: potential warning; consolidation may precede decline. Check Lim's 16-item p. 217 list, recalled in Chapter 5 slide “16 Volume and Price Action Reversal Characteristics”, and barrier context from “Barrier proximity”. No indicator formulas here. Next, compare the bullish converse.</a:t>
             </a:r>
           </a:p>
         </p:txBody>
@@ -12964,82 +13402,7 @@
         </p:nvSpPr>
         <p:spPr>
           <a:xfrm>
-            <a:off x="777240" y="4985766"/>
-            <a:ext cx="82296" cy="633984"/>
-          </a:xfrm>
-          <a:prstGeom prst="rect">
-            <a:avLst/>
-          </a:prstGeom>
-          <a:solidFill>
-            <a:srgbClr val="F2A900"/>
-          </a:solidFill>
-          <a:ln>
-            <a:noFill/>
-          </a:ln>
-          <a:effectLst/>
-        </p:spPr>
-        <p:txBody>
-          <a:bodyPr rtlCol="0" anchor="ctr"/>
-          <a:lstStyle/>
-          <a:p>
-            <a:pPr algn="ctr"/>
-          </a:p>
-        </p:txBody>
-      </p:sp>
-      <p:sp>
-        <p:nvSpPr>
-          <p:cNvPr id="9" name="TextBox 8"/>
-          <p:cNvSpPr txBox="1"/>
-          <p:nvPr/>
-        </p:nvSpPr>
-        <p:spPr>
-          <a:xfrm>
-            <a:off x="1069848" y="5022342"/>
-            <a:ext cx="5330952" cy="633984"/>
-          </a:xfrm>
-          <a:prstGeom prst="rect">
-            <a:avLst/>
-          </a:prstGeom>
-          <a:noFill/>
-        </p:spPr>
-        <p:txBody>
-          <a:bodyPr wrap="square" anchor="t" lIns="0" rIns="0" tIns="0" bIns="0">
-            <a:spAutoFit/>
-          </a:bodyPr>
-          <a:lstStyle/>
-          <a:p>
-            <a:pPr algn="l">
-              <a:lnSpc>
-                <a:spcPct val="100000"/>
-              </a:lnSpc>
-              <a:spcBef>
-                <a:spcPts val="0"/>
-              </a:spcBef>
-              <a:spcAft>
-                <a:spcPts val="0"/>
-              </a:spcAft>
-            </a:pPr>
-            <a:r>
-              <a:rPr sz="1600" b="1" i="0">
-                <a:solidFill>
-                  <a:srgbClr val="1A1A1A"/>
-                </a:solidFill>
-                <a:latin typeface="Arial"/>
-              </a:rPr>
-              <a:t>The five steps identify a warning; context decides how much weight to give it.</a:t>
-            </a:r>
-          </a:p>
-        </p:txBody>
-      </p:sp>
-      <p:sp>
-        <p:nvSpPr>
-          <p:cNvPr id="10" name="Rectangle 9"/>
-          <p:cNvSpPr/>
-          <p:nvPr/>
-        </p:nvSpPr>
-        <p:spPr>
-          <a:xfrm>
-            <a:off x="7428405" y="1810512"/>
+            <a:off x="7634145" y="1810512"/>
             <a:ext cx="3278484" cy="3749039"/>
           </a:xfrm>
           <a:prstGeom prst="rect">
@@ -13065,13 +13428,13 @@
       </p:sp>
       <p:sp>
         <p:nvSpPr>
-          <p:cNvPr id="11" name="Rectangle 10"/>
+          <p:cNvPr id="9" name="Rectangle 8"/>
           <p:cNvSpPr/>
           <p:nvPr/>
         </p:nvSpPr>
         <p:spPr>
           <a:xfrm>
-            <a:off x="7547277" y="1929384"/>
+            <a:off x="7753017" y="1929384"/>
             <a:ext cx="3040740" cy="3511296"/>
           </a:xfrm>
           <a:prstGeom prst="rect">
@@ -13097,13 +13460,13 @@
       </p:sp>
       <p:sp>
         <p:nvSpPr>
-          <p:cNvPr id="12" name="Rectangle 11"/>
+          <p:cNvPr id="10" name="Rectangle 9"/>
           <p:cNvSpPr/>
           <p:nvPr/>
         </p:nvSpPr>
         <p:spPr>
           <a:xfrm>
-            <a:off x="7547277" y="1929384"/>
+            <a:off x="7753017" y="1929384"/>
             <a:ext cx="3040740" cy="50800"/>
           </a:xfrm>
           <a:prstGeom prst="rect">
@@ -13127,13 +13490,13 @@
       </p:sp>
       <p:sp>
         <p:nvSpPr>
-          <p:cNvPr id="13" name="TextBox 12"/>
+          <p:cNvPr id="11" name="TextBox 10"/>
           <p:cNvSpPr txBox="1"/>
           <p:nvPr/>
         </p:nvSpPr>
         <p:spPr>
           <a:xfrm>
-            <a:off x="7821597" y="2203703"/>
+            <a:off x="8027337" y="2203703"/>
             <a:ext cx="2492100" cy="3054096"/>
           </a:xfrm>
           <a:prstGeom prst="rect">
@@ -13187,21 +13550,21 @@
                 </a:solidFill>
                 <a:latin typeface="Palatino"/>
               </a:rPr>
-              <a:t>The Apple daily chart, cropped to the key reversal day and its surrounding bars. The marked bar opens above the previous high, forms a new high, closes below the previous close, and has above average volume.</a:t>
-            </a:r>
-          </a:p>
-        </p:txBody>
-      </p:sp>
-      <p:sp>
-        <p:nvSpPr>
-          <p:cNvPr id="14" name="Oval 13"/>
+              <a:t>The Apple daily chart, cropped to the key reversal day and its surrounding bars. The marked bar opens above the previous high, forms a new high, and closes below the previous close.</a:t>
+            </a:r>
+          </a:p>
+        </p:txBody>
+      </p:sp>
+      <p:sp>
+        <p:nvSpPr>
+          <p:cNvPr id="12" name="Oval 11"/>
           <p:cNvSpPr/>
           <p:nvPr/>
         </p:nvSpPr>
         <p:spPr>
           <a:xfrm>
-            <a:off x="8854795" y="1999609"/>
-            <a:ext cx="547333" cy="807598"/>
+            <a:off x="9060535" y="2280513"/>
+            <a:ext cx="243259" cy="280903"/>
           </a:xfrm>
           <a:prstGeom prst="ellipse">
             <a:avLst/>
@@ -13223,14 +13586,14 @@
       </p:sp>
       <p:sp>
         <p:nvSpPr>
-          <p:cNvPr id="15" name="Oval 14"/>
+          <p:cNvPr id="13" name="Oval 12"/>
           <p:cNvSpPr/>
           <p:nvPr/>
         </p:nvSpPr>
         <p:spPr>
           <a:xfrm>
-            <a:off x="8854795" y="2666756"/>
-            <a:ext cx="547333" cy="807598"/>
+            <a:off x="9182165" y="1999609"/>
+            <a:ext cx="212851" cy="280903"/>
           </a:xfrm>
           <a:prstGeom prst="ellipse">
             <a:avLst/>
@@ -13252,14 +13615,14 @@
       </p:sp>
       <p:sp>
         <p:nvSpPr>
-          <p:cNvPr id="16" name="Oval 15"/>
+          <p:cNvPr id="14" name="Oval 13"/>
           <p:cNvSpPr/>
           <p:nvPr/>
         </p:nvSpPr>
         <p:spPr>
           <a:xfrm>
-            <a:off x="8824388" y="4492630"/>
-            <a:ext cx="608148" cy="912936"/>
+            <a:off x="9273387" y="2772095"/>
+            <a:ext cx="243259" cy="280903"/>
           </a:xfrm>
           <a:prstGeom prst="ellipse">
             <a:avLst/>
@@ -13281,13 +13644,13 @@
       </p:sp>
       <p:sp>
         <p:nvSpPr>
-          <p:cNvPr id="17" name="Oval 16"/>
+          <p:cNvPr id="15" name="Oval 14"/>
           <p:cNvSpPr/>
           <p:nvPr/>
         </p:nvSpPr>
         <p:spPr>
           <a:xfrm>
-            <a:off x="9277088" y="1914387"/>
+            <a:off x="8661828" y="2054839"/>
             <a:ext cx="310896" cy="310896"/>
           </a:xfrm>
           <a:prstGeom prst="ellipse">
@@ -13332,13 +13695,13 @@
       </p:sp>
       <p:sp>
         <p:nvSpPr>
-          <p:cNvPr id="18" name="Oval 17"/>
+          <p:cNvPr id="16" name="Oval 15"/>
           <p:cNvSpPr/>
           <p:nvPr/>
         </p:nvSpPr>
         <p:spPr>
           <a:xfrm>
-            <a:off x="9398717" y="3283793"/>
+            <a:off x="9482828" y="1844161"/>
             <a:ext cx="310896" cy="310896"/>
           </a:xfrm>
           <a:prstGeom prst="ellipse">
@@ -13383,13 +13746,13 @@
       </p:sp>
       <p:sp>
         <p:nvSpPr>
-          <p:cNvPr id="19" name="Oval 18"/>
+          <p:cNvPr id="17" name="Oval 16"/>
           <p:cNvSpPr/>
           <p:nvPr/>
         </p:nvSpPr>
         <p:spPr>
           <a:xfrm>
-            <a:off x="9398717" y="4863876"/>
+            <a:off x="9634865" y="2967776"/>
             <a:ext cx="310896" cy="310896"/>
           </a:xfrm>
           <a:prstGeom prst="ellipse">
@@ -13434,14 +13797,14 @@
       </p:sp>
       <p:sp>
         <p:nvSpPr>
-          <p:cNvPr id="20" name="TextBox 19"/>
+          <p:cNvPr id="18" name="TextBox 17"/>
           <p:cNvSpPr txBox="1"/>
           <p:nvPr/>
         </p:nvSpPr>
         <p:spPr>
           <a:xfrm>
-            <a:off x="6720840" y="5650991"/>
-            <a:ext cx="4693614" cy="274320"/>
+            <a:off x="7132319" y="5650991"/>
+            <a:ext cx="4282135" cy="274320"/>
           </a:xfrm>
           <a:prstGeom prst="rect">
             <a:avLst/>
@@ -13466,7 +13829,7 @@
               </a:spcAft>
             </a:pPr>
             <a:r>
-              <a:rPr sz="1100" b="0" i="0">
+              <a:rPr sz="1000" b="0" i="0">
                 <a:solidFill>
                   <a:srgbClr val="818181"/>
                 </a:solidFill>
@@ -13479,7 +13842,7 @@
       </p:sp>
       <p:sp>
         <p:nvSpPr>
-          <p:cNvPr id="21" name="TextBox 20"/>
+          <p:cNvPr id="19" name="TextBox 18"/>
           <p:cNvSpPr txBox="1"/>
           <p:nvPr/>
         </p:nvSpPr>

</xml_diff>

<commit_message>
Refine Chapter 7 sample review layout
</commit_message>
<xml_diff>
--- a/chapter-07/FIN1209-Chapter-07.pptx
+++ b/chapter-07/FIN1209-Chapter-07.pptx
@@ -5048,7 +5048,7 @@
                 </a:solidFill>
                 <a:latin typeface="Palatino"/>
               </a:rPr>
-              <a:t>Two reversal warnings</a:t>
+              <a:t>Exhaustion bar versus pin bar</a:t>
             </a:r>
           </a:p>
         </p:txBody>
@@ -5288,7 +5288,7 @@
                 </a:solidFill>
                 <a:latin typeface="Arial"/>
               </a:rPr>
-              <a:t>No gap distinguishes exhaustion from an island (Lim, p. 226). Exhaustion warns a tiring trend; pin warns a false breakout. Next, test key reversal.</a:t>
+              <a:t>No gap follows the exhaustion bar (Lim, p. 226). Exhaustion warns a tiring trend; pin warns a false breakout. Next, test key reversal.</a:t>
             </a:r>
           </a:p>
         </p:txBody>
@@ -5357,8 +5357,8 @@
         </p:nvSpPr>
         <p:spPr>
           <a:xfrm>
-            <a:off x="8060070" y="2637698"/>
-            <a:ext cx="283107" cy="236104"/>
+            <a:off x="8060070" y="2690166"/>
+            <a:ext cx="202219" cy="131169"/>
           </a:xfrm>
           <a:prstGeom prst="ellipse">
             <a:avLst/>
@@ -5386,8 +5386,8 @@
         </p:nvSpPr>
         <p:spPr>
           <a:xfrm>
-            <a:off x="8060070" y="3293546"/>
-            <a:ext cx="283107" cy="236104"/>
+            <a:off x="8060070" y="3372247"/>
+            <a:ext cx="202219" cy="131169"/>
           </a:xfrm>
           <a:prstGeom prst="ellipse">
             <a:avLst/>
@@ -5415,8 +5415,8 @@
         </p:nvSpPr>
         <p:spPr>
           <a:xfrm>
-            <a:off x="10041821" y="3136142"/>
-            <a:ext cx="283107" cy="262338"/>
+            <a:off x="10001377" y="3109908"/>
+            <a:ext cx="202219" cy="131169"/>
           </a:xfrm>
           <a:prstGeom prst="ellipse">
             <a:avLst/>
@@ -5444,7 +5444,7 @@
         </p:nvSpPr>
         <p:spPr>
           <a:xfrm>
-            <a:off x="7661958" y="2429783"/>
+            <a:off x="7581070" y="2377315"/>
             <a:ext cx="310896" cy="310896"/>
           </a:xfrm>
           <a:prstGeom prst="ellipse">
@@ -5495,7 +5495,7 @@
         </p:nvSpPr>
         <p:spPr>
           <a:xfrm>
-            <a:off x="7661958" y="3505372"/>
+            <a:off x="7581070" y="3584074"/>
             <a:ext cx="310896" cy="310896"/>
           </a:xfrm>
           <a:prstGeom prst="ellipse">
@@ -5546,7 +5546,7 @@
         </p:nvSpPr>
         <p:spPr>
           <a:xfrm>
-            <a:off x="10412144" y="3243033"/>
+            <a:off x="10412144" y="3295501"/>
             <a:ext cx="310896" cy="310896"/>
           </a:xfrm>
           <a:prstGeom prst="ellipse">
@@ -5860,7 +5860,7 @@
         <p:spPr>
           <a:xfrm>
             <a:off x="777240" y="1207008"/>
-            <a:ext cx="5303520" cy="2614422"/>
+            <a:ext cx="5303520" cy="2038349"/>
           </a:xfrm>
           <a:prstGeom prst="rect">
             <a:avLst/>
@@ -5889,7 +5889,7 @@
         </p:nvSpPr>
         <p:spPr>
           <a:xfrm>
-            <a:off x="1005840" y="1371600"/>
+            <a:off x="1005840" y="1298448"/>
             <a:ext cx="4846320" cy="228600"/>
           </a:xfrm>
           <a:prstGeom prst="rect">
@@ -5934,7 +5934,7 @@
         </p:nvSpPr>
         <p:spPr>
           <a:xfrm>
-            <a:off x="1005840" y="1618488"/>
+            <a:off x="1005840" y="1499616"/>
             <a:ext cx="4846320" cy="588009"/>
           </a:xfrm>
           <a:prstGeom prst="rect">
@@ -5979,8 +5979,8 @@
         </p:nvSpPr>
         <p:spPr>
           <a:xfrm>
-            <a:off x="1005840" y="2279650"/>
-            <a:ext cx="4846320" cy="1569211"/>
+            <a:off x="1005840" y="2069338"/>
+            <a:ext cx="4846320" cy="1102867"/>
           </a:xfrm>
           <a:prstGeom prst="rect">
             <a:avLst/>
@@ -5995,13 +5995,13 @@
           <a:p>
             <a:pPr algn="l">
               <a:lnSpc>
-                <a:spcPct val="112000"/>
-              </a:lnSpc>
-              <a:spcBef>
-                <a:spcPts val="0"/>
-              </a:spcBef>
-              <a:spcAft>
-                <a:spcPts val="600"/>
+                <a:spcPct val="105000"/>
+              </a:lnSpc>
+              <a:spcBef>
+                <a:spcPts val="0"/>
+              </a:spcBef>
+              <a:spcAft>
+                <a:spcPts val="200"/>
               </a:spcAft>
             </a:pPr>
             <a:r>
@@ -6017,13 +6017,13 @@
           <a:p>
             <a:pPr algn="l">
               <a:lnSpc>
-                <a:spcPct val="112000"/>
-              </a:lnSpc>
-              <a:spcBef>
-                <a:spcPts val="0"/>
-              </a:spcBef>
-              <a:spcAft>
-                <a:spcPts val="600"/>
+                <a:spcPct val="105000"/>
+              </a:lnSpc>
+              <a:spcBef>
+                <a:spcPts val="0"/>
+              </a:spcBef>
+              <a:spcAft>
+                <a:spcPts val="200"/>
               </a:spcAft>
             </a:pPr>
             <a:r>
@@ -6039,13 +6039,13 @@
           <a:p>
             <a:pPr algn="l">
               <a:lnSpc>
-                <a:spcPct val="112000"/>
-              </a:lnSpc>
-              <a:spcBef>
-                <a:spcPts val="0"/>
-              </a:spcBef>
-              <a:spcAft>
-                <a:spcPts val="600"/>
+                <a:spcPct val="105000"/>
+              </a:lnSpc>
+              <a:spcBef>
+                <a:spcPts val="0"/>
+              </a:spcBef>
+              <a:spcAft>
+                <a:spcPts val="200"/>
               </a:spcAft>
             </a:pPr>
             <a:r>
@@ -6061,13 +6061,13 @@
           <a:p>
             <a:pPr algn="l">
               <a:lnSpc>
-                <a:spcPct val="112000"/>
-              </a:lnSpc>
-              <a:spcBef>
-                <a:spcPts val="0"/>
-              </a:spcBef>
-              <a:spcAft>
-                <a:spcPts val="600"/>
+                <a:spcPct val="105000"/>
+              </a:lnSpc>
+              <a:spcBef>
+                <a:spcPts val="0"/>
+              </a:spcBef>
+              <a:spcAft>
+                <a:spcPts val="200"/>
               </a:spcAft>
             </a:pPr>
             <a:r>
@@ -6090,8 +6090,8 @@
         </p:nvSpPr>
         <p:spPr>
           <a:xfrm>
-            <a:off x="777240" y="3986022"/>
-            <a:ext cx="5303520" cy="2366137"/>
+            <a:off x="777240" y="3336798"/>
+            <a:ext cx="5303520" cy="1790065"/>
           </a:xfrm>
           <a:prstGeom prst="rect">
             <a:avLst/>
@@ -6120,7 +6120,7 @@
         </p:nvSpPr>
         <p:spPr>
           <a:xfrm>
-            <a:off x="1005840" y="4150614"/>
+            <a:off x="1005840" y="3428238"/>
             <a:ext cx="4846320" cy="228600"/>
           </a:xfrm>
           <a:prstGeom prst="rect">
@@ -6165,7 +6165,7 @@
         </p:nvSpPr>
         <p:spPr>
           <a:xfrm>
-            <a:off x="1005840" y="4397502"/>
+            <a:off x="1005840" y="3629406"/>
             <a:ext cx="4846320" cy="339725"/>
           </a:xfrm>
           <a:prstGeom prst="rect">
@@ -6210,8 +6210,8 @@
         </p:nvSpPr>
         <p:spPr>
           <a:xfrm>
-            <a:off x="1005840" y="4810379"/>
-            <a:ext cx="4846320" cy="1569212"/>
+            <a:off x="1005840" y="3950843"/>
+            <a:ext cx="4846320" cy="1102868"/>
           </a:xfrm>
           <a:prstGeom prst="rect">
             <a:avLst/>
@@ -6226,13 +6226,13 @@
           <a:p>
             <a:pPr algn="l">
               <a:lnSpc>
-                <a:spcPct val="112000"/>
-              </a:lnSpc>
-              <a:spcBef>
-                <a:spcPts val="0"/>
-              </a:spcBef>
-              <a:spcAft>
-                <a:spcPts val="600"/>
+                <a:spcPct val="105000"/>
+              </a:lnSpc>
+              <a:spcBef>
+                <a:spcPts val="0"/>
+              </a:spcBef>
+              <a:spcAft>
+                <a:spcPts val="200"/>
               </a:spcAft>
             </a:pPr>
             <a:r>
@@ -6248,13 +6248,13 @@
           <a:p>
             <a:pPr algn="l">
               <a:lnSpc>
-                <a:spcPct val="112000"/>
-              </a:lnSpc>
-              <a:spcBef>
-                <a:spcPts val="0"/>
-              </a:spcBef>
-              <a:spcAft>
-                <a:spcPts val="600"/>
+                <a:spcPct val="105000"/>
+              </a:lnSpc>
+              <a:spcBef>
+                <a:spcPts val="0"/>
+              </a:spcBef>
+              <a:spcAft>
+                <a:spcPts val="200"/>
               </a:spcAft>
             </a:pPr>
             <a:r>
@@ -6270,13 +6270,13 @@
           <a:p>
             <a:pPr algn="l">
               <a:lnSpc>
-                <a:spcPct val="112000"/>
-              </a:lnSpc>
-              <a:spcBef>
-                <a:spcPts val="0"/>
-              </a:spcBef>
-              <a:spcAft>
-                <a:spcPts val="600"/>
+                <a:spcPct val="105000"/>
+              </a:lnSpc>
+              <a:spcBef>
+                <a:spcPts val="0"/>
+              </a:spcBef>
+              <a:spcAft>
+                <a:spcPts val="200"/>
               </a:spcAft>
             </a:pPr>
             <a:r>
@@ -6292,13 +6292,13 @@
           <a:p>
             <a:pPr algn="l">
               <a:lnSpc>
-                <a:spcPct val="112000"/>
-              </a:lnSpc>
-              <a:spcBef>
-                <a:spcPts val="0"/>
-              </a:spcBef>
-              <a:spcAft>
-                <a:spcPts val="600"/>
+                <a:spcPct val="105000"/>
+              </a:lnSpc>
+              <a:spcBef>
+                <a:spcPts val="0"/>
+              </a:spcBef>
+              <a:spcAft>
+                <a:spcPts val="200"/>
               </a:spcAft>
             </a:pPr>
             <a:r>
@@ -6308,7 +6308,7 @@
                 </a:solidFill>
                 <a:latin typeface="Arial"/>
               </a:rPr>
-              <a:t>D.  Later consolidation</a:t>
+              <a:t>D.  Later bars</a:t>
             </a:r>
           </a:p>
         </p:txBody>
@@ -6569,8 +6569,8 @@
         </p:nvSpPr>
         <p:spPr>
           <a:xfrm>
-            <a:off x="8217674" y="1499616"/>
-            <a:ext cx="310896" cy="310896"/>
+            <a:off x="8159180" y="1394460"/>
+            <a:ext cx="356616" cy="356616"/>
           </a:xfrm>
           <a:prstGeom prst="ellipse">
             <a:avLst/>
@@ -6620,8 +6620,8 @@
         </p:nvSpPr>
         <p:spPr>
           <a:xfrm>
-            <a:off x="9179783" y="1252728"/>
-            <a:ext cx="310896" cy="310896"/>
+            <a:off x="9192557" y="1188720"/>
+            <a:ext cx="356616" cy="356616"/>
           </a:xfrm>
           <a:prstGeom prst="ellipse">
             <a:avLst/>
@@ -6671,8 +6671,8 @@
         </p:nvSpPr>
         <p:spPr>
           <a:xfrm>
-            <a:off x="9357951" y="2569464"/>
-            <a:ext cx="310896" cy="310896"/>
+            <a:off x="9406359" y="2587752"/>
+            <a:ext cx="356616" cy="356616"/>
           </a:xfrm>
           <a:prstGeom prst="ellipse">
             <a:avLst/>
@@ -7332,8 +7332,8 @@
         </p:nvSpPr>
         <p:spPr>
           <a:xfrm>
-            <a:off x="7007071" y="1207008"/>
-            <a:ext cx="3801111" cy="4352544"/>
+            <a:off x="7006359" y="1207008"/>
+            <a:ext cx="3802536" cy="4352544"/>
           </a:xfrm>
           <a:prstGeom prst="rect">
             <a:avLst/>
@@ -7364,8 +7364,8 @@
         </p:nvSpPr>
         <p:spPr>
           <a:xfrm>
-            <a:off x="7125943" y="1325880"/>
-            <a:ext cx="3563367" cy="4114800"/>
+            <a:off x="7125231" y="1325880"/>
+            <a:ext cx="3564792" cy="4114800"/>
           </a:xfrm>
           <a:prstGeom prst="rect">
             <a:avLst/>
@@ -7396,8 +7396,8 @@
         </p:nvSpPr>
         <p:spPr>
           <a:xfrm>
-            <a:off x="7125943" y="1325880"/>
-            <a:ext cx="3563367" cy="50800"/>
+            <a:off x="7125231" y="1325880"/>
+            <a:ext cx="3564792" cy="50800"/>
           </a:xfrm>
           <a:prstGeom prst="rect">
             <a:avLst/>
@@ -7426,8 +7426,8 @@
         </p:nvSpPr>
         <p:spPr>
           <a:xfrm>
-            <a:off x="7400263" y="1600200"/>
-            <a:ext cx="3014727" cy="3657600"/>
+            <a:off x="7399551" y="1600200"/>
+            <a:ext cx="3016152" cy="3657600"/>
           </a:xfrm>
           <a:prstGeom prst="rect">
             <a:avLst/>
@@ -7493,8 +7493,8 @@
         </p:nvSpPr>
         <p:spPr>
           <a:xfrm>
-            <a:off x="8658191" y="1737360"/>
-            <a:ext cx="285069" cy="329183"/>
+            <a:off x="8658091" y="1737360"/>
+            <a:ext cx="285183" cy="329183"/>
           </a:xfrm>
           <a:prstGeom prst="ellipse">
             <a:avLst/>
@@ -7522,8 +7522,8 @@
         </p:nvSpPr>
         <p:spPr>
           <a:xfrm>
-            <a:off x="8800726" y="1408176"/>
-            <a:ext cx="249435" cy="329184"/>
+            <a:off x="8800683" y="1408176"/>
+            <a:ext cx="249535" cy="329184"/>
           </a:xfrm>
           <a:prstGeom prst="ellipse">
             <a:avLst/>
@@ -7552,7 +7552,7 @@
         <p:spPr>
           <a:xfrm>
             <a:off x="8907627" y="2313432"/>
-            <a:ext cx="285069" cy="329184"/>
+            <a:ext cx="285183" cy="329184"/>
           </a:xfrm>
           <a:prstGeom prst="ellipse">
             <a:avLst/>
@@ -7580,8 +7580,8 @@
         </p:nvSpPr>
         <p:spPr>
           <a:xfrm>
-            <a:off x="8217674" y="1499616"/>
-            <a:ext cx="310896" cy="310896"/>
+            <a:off x="8158952" y="1394460"/>
+            <a:ext cx="356616" cy="356616"/>
           </a:xfrm>
           <a:prstGeom prst="ellipse">
             <a:avLst/>
@@ -7631,8 +7631,8 @@
         </p:nvSpPr>
         <p:spPr>
           <a:xfrm>
-            <a:off x="9179783" y="1252728"/>
-            <a:ext cx="310896" cy="310896"/>
+            <a:off x="9192742" y="1188720"/>
+            <a:ext cx="356616" cy="356616"/>
           </a:xfrm>
           <a:prstGeom prst="ellipse">
             <a:avLst/>
@@ -7682,8 +7682,8 @@
         </p:nvSpPr>
         <p:spPr>
           <a:xfrm>
-            <a:off x="9357951" y="2569464"/>
-            <a:ext cx="310896" cy="310896"/>
+            <a:off x="9406630" y="2587752"/>
+            <a:ext cx="356616" cy="356616"/>
           </a:xfrm>
           <a:prstGeom prst="ellipse">
             <a:avLst/>
@@ -7996,7 +7996,7 @@
         <p:spPr>
           <a:xfrm>
             <a:off x="777240" y="1207008"/>
-            <a:ext cx="5303520" cy="2614422"/>
+            <a:ext cx="5303520" cy="2038349"/>
           </a:xfrm>
           <a:prstGeom prst="rect">
             <a:avLst/>
@@ -8025,7 +8025,7 @@
         </p:nvSpPr>
         <p:spPr>
           <a:xfrm>
-            <a:off x="1005840" y="1371600"/>
+            <a:off x="1005840" y="1298448"/>
             <a:ext cx="4846320" cy="228600"/>
           </a:xfrm>
           <a:prstGeom prst="rect">
@@ -8070,7 +8070,7 @@
         </p:nvSpPr>
         <p:spPr>
           <a:xfrm>
-            <a:off x="1005840" y="1618488"/>
+            <a:off x="1005840" y="1499616"/>
             <a:ext cx="4846320" cy="588009"/>
           </a:xfrm>
           <a:prstGeom prst="rect">
@@ -8115,8 +8115,8 @@
         </p:nvSpPr>
         <p:spPr>
           <a:xfrm>
-            <a:off x="1005840" y="2279650"/>
-            <a:ext cx="4846320" cy="1569211"/>
+            <a:off x="1005840" y="2069338"/>
+            <a:ext cx="4846320" cy="1102867"/>
           </a:xfrm>
           <a:prstGeom prst="rect">
             <a:avLst/>
@@ -8131,13 +8131,13 @@
           <a:p>
             <a:pPr algn="l">
               <a:lnSpc>
-                <a:spcPct val="112000"/>
-              </a:lnSpc>
-              <a:spcBef>
-                <a:spcPts val="0"/>
-              </a:spcBef>
-              <a:spcAft>
-                <a:spcPts val="600"/>
+                <a:spcPct val="105000"/>
+              </a:lnSpc>
+              <a:spcBef>
+                <a:spcPts val="0"/>
+              </a:spcBef>
+              <a:spcAft>
+                <a:spcPts val="200"/>
               </a:spcAft>
             </a:pPr>
             <a:r>
@@ -8153,13 +8153,13 @@
           <a:p>
             <a:pPr algn="l">
               <a:lnSpc>
-                <a:spcPct val="112000"/>
-              </a:lnSpc>
-              <a:spcBef>
-                <a:spcPts val="0"/>
-              </a:spcBef>
-              <a:spcAft>
-                <a:spcPts val="600"/>
+                <a:spcPct val="105000"/>
+              </a:lnSpc>
+              <a:spcBef>
+                <a:spcPts val="0"/>
+              </a:spcBef>
+              <a:spcAft>
+                <a:spcPts val="200"/>
               </a:spcAft>
             </a:pPr>
             <a:r>
@@ -8175,13 +8175,13 @@
           <a:p>
             <a:pPr algn="l">
               <a:lnSpc>
-                <a:spcPct val="112000"/>
-              </a:lnSpc>
-              <a:spcBef>
-                <a:spcPts val="0"/>
-              </a:spcBef>
-              <a:spcAft>
-                <a:spcPts val="600"/>
+                <a:spcPct val="105000"/>
+              </a:lnSpc>
+              <a:spcBef>
+                <a:spcPts val="0"/>
+              </a:spcBef>
+              <a:spcAft>
+                <a:spcPts val="200"/>
               </a:spcAft>
             </a:pPr>
             <a:r>
@@ -8197,13 +8197,13 @@
           <a:p>
             <a:pPr algn="l">
               <a:lnSpc>
-                <a:spcPct val="112000"/>
-              </a:lnSpc>
-              <a:spcBef>
-                <a:spcPts val="0"/>
-              </a:spcBef>
-              <a:spcAft>
-                <a:spcPts val="600"/>
+                <a:spcPct val="105000"/>
+              </a:lnSpc>
+              <a:spcBef>
+                <a:spcPts val="0"/>
+              </a:spcBef>
+              <a:spcAft>
+                <a:spcPts val="200"/>
               </a:spcAft>
             </a:pPr>
             <a:r>
@@ -8226,8 +8226,8 @@
         </p:nvSpPr>
         <p:spPr>
           <a:xfrm>
-            <a:off x="777240" y="3986022"/>
-            <a:ext cx="5303520" cy="2366137"/>
+            <a:off x="777240" y="3336798"/>
+            <a:ext cx="5303520" cy="1790065"/>
           </a:xfrm>
           <a:prstGeom prst="rect">
             <a:avLst/>
@@ -8256,7 +8256,7 @@
         </p:nvSpPr>
         <p:spPr>
           <a:xfrm>
-            <a:off x="1005840" y="4150614"/>
+            <a:off x="1005840" y="3428238"/>
             <a:ext cx="4846320" cy="228600"/>
           </a:xfrm>
           <a:prstGeom prst="rect">
@@ -8301,7 +8301,7 @@
         </p:nvSpPr>
         <p:spPr>
           <a:xfrm>
-            <a:off x="1005840" y="4397502"/>
+            <a:off x="1005840" y="3629406"/>
             <a:ext cx="4846320" cy="339725"/>
           </a:xfrm>
           <a:prstGeom prst="rect">
@@ -8346,8 +8346,8 @@
         </p:nvSpPr>
         <p:spPr>
           <a:xfrm>
-            <a:off x="1005840" y="4810379"/>
-            <a:ext cx="4846320" cy="1569212"/>
+            <a:off x="1005840" y="3950843"/>
+            <a:ext cx="4846320" cy="1102868"/>
           </a:xfrm>
           <a:prstGeom prst="rect">
             <a:avLst/>
@@ -8362,13 +8362,13 @@
           <a:p>
             <a:pPr algn="l">
               <a:lnSpc>
-                <a:spcPct val="112000"/>
-              </a:lnSpc>
-              <a:spcBef>
-                <a:spcPts val="0"/>
-              </a:spcBef>
-              <a:spcAft>
-                <a:spcPts val="600"/>
+                <a:spcPct val="105000"/>
+              </a:lnSpc>
+              <a:spcBef>
+                <a:spcPts val="0"/>
+              </a:spcBef>
+              <a:spcAft>
+                <a:spcPts val="200"/>
               </a:spcAft>
             </a:pPr>
             <a:r>
@@ -8384,13 +8384,13 @@
           <a:p>
             <a:pPr algn="l">
               <a:lnSpc>
-                <a:spcPct val="112000"/>
-              </a:lnSpc>
-              <a:spcBef>
-                <a:spcPts val="0"/>
-              </a:spcBef>
-              <a:spcAft>
-                <a:spcPts val="600"/>
+                <a:spcPct val="105000"/>
+              </a:lnSpc>
+              <a:spcBef>
+                <a:spcPts val="0"/>
+              </a:spcBef>
+              <a:spcAft>
+                <a:spcPts val="200"/>
               </a:spcAft>
             </a:pPr>
             <a:r>
@@ -8406,13 +8406,13 @@
           <a:p>
             <a:pPr algn="l">
               <a:lnSpc>
-                <a:spcPct val="112000"/>
-              </a:lnSpc>
-              <a:spcBef>
-                <a:spcPts val="0"/>
-              </a:spcBef>
-              <a:spcAft>
-                <a:spcPts val="600"/>
+                <a:spcPct val="105000"/>
+              </a:lnSpc>
+              <a:spcBef>
+                <a:spcPts val="0"/>
+              </a:spcBef>
+              <a:spcAft>
+                <a:spcPts val="200"/>
               </a:spcAft>
             </a:pPr>
             <a:r>
@@ -8428,13 +8428,13 @@
           <a:p>
             <a:pPr algn="l">
               <a:lnSpc>
-                <a:spcPct val="112000"/>
-              </a:lnSpc>
-              <a:spcBef>
-                <a:spcPts val="0"/>
-              </a:spcBef>
-              <a:spcAft>
-                <a:spcPts val="600"/>
+                <a:spcPct val="105000"/>
+              </a:lnSpc>
+              <a:spcBef>
+                <a:spcPts val="0"/>
+              </a:spcBef>
+              <a:spcAft>
+                <a:spcPts val="200"/>
               </a:spcAft>
             </a:pPr>
             <a:r>
@@ -8705,8 +8705,8 @@
         </p:nvSpPr>
         <p:spPr>
           <a:xfrm>
-            <a:off x="8217674" y="1499616"/>
-            <a:ext cx="310896" cy="310896"/>
+            <a:off x="8159180" y="1394460"/>
+            <a:ext cx="356616" cy="356616"/>
           </a:xfrm>
           <a:prstGeom prst="ellipse">
             <a:avLst/>
@@ -8756,8 +8756,8 @@
         </p:nvSpPr>
         <p:spPr>
           <a:xfrm>
-            <a:off x="9179783" y="1252728"/>
-            <a:ext cx="310896" cy="310896"/>
+            <a:off x="9192557" y="1188720"/>
+            <a:ext cx="356616" cy="356616"/>
           </a:xfrm>
           <a:prstGeom prst="ellipse">
             <a:avLst/>
@@ -8807,8 +8807,8 @@
         </p:nvSpPr>
         <p:spPr>
           <a:xfrm>
-            <a:off x="9357951" y="2569464"/>
-            <a:ext cx="310896" cy="310896"/>
+            <a:off x="9406359" y="2587752"/>
+            <a:ext cx="356616" cy="356616"/>
           </a:xfrm>
           <a:prstGeom prst="ellipse">
             <a:avLst/>
@@ -9468,8 +9468,8 @@
         </p:nvSpPr>
         <p:spPr>
           <a:xfrm>
-            <a:off x="7007071" y="1207008"/>
-            <a:ext cx="3801111" cy="4352544"/>
+            <a:off x="7006359" y="1207008"/>
+            <a:ext cx="3802536" cy="4352544"/>
           </a:xfrm>
           <a:prstGeom prst="rect">
             <a:avLst/>
@@ -9500,8 +9500,8 @@
         </p:nvSpPr>
         <p:spPr>
           <a:xfrm>
-            <a:off x="7125943" y="1325880"/>
-            <a:ext cx="3563367" cy="4114800"/>
+            <a:off x="7125231" y="1325880"/>
+            <a:ext cx="3564792" cy="4114800"/>
           </a:xfrm>
           <a:prstGeom prst="rect">
             <a:avLst/>
@@ -9532,8 +9532,8 @@
         </p:nvSpPr>
         <p:spPr>
           <a:xfrm>
-            <a:off x="7125943" y="1325880"/>
-            <a:ext cx="3563367" cy="50800"/>
+            <a:off x="7125231" y="1325880"/>
+            <a:ext cx="3564792" cy="50800"/>
           </a:xfrm>
           <a:prstGeom prst="rect">
             <a:avLst/>
@@ -9562,8 +9562,8 @@
         </p:nvSpPr>
         <p:spPr>
           <a:xfrm>
-            <a:off x="7400263" y="1600200"/>
-            <a:ext cx="3014727" cy="3657600"/>
+            <a:off x="7399551" y="1600200"/>
+            <a:ext cx="3016152" cy="3657600"/>
           </a:xfrm>
           <a:prstGeom prst="rect">
             <a:avLst/>
@@ -9629,8 +9629,8 @@
         </p:nvSpPr>
         <p:spPr>
           <a:xfrm>
-            <a:off x="8658191" y="1737360"/>
-            <a:ext cx="285069" cy="329183"/>
+            <a:off x="8658091" y="1737360"/>
+            <a:ext cx="285183" cy="329183"/>
           </a:xfrm>
           <a:prstGeom prst="ellipse">
             <a:avLst/>
@@ -9658,8 +9658,8 @@
         </p:nvSpPr>
         <p:spPr>
           <a:xfrm>
-            <a:off x="8800726" y="1408176"/>
-            <a:ext cx="249435" cy="329184"/>
+            <a:off x="8800683" y="1408176"/>
+            <a:ext cx="249535" cy="329184"/>
           </a:xfrm>
           <a:prstGeom prst="ellipse">
             <a:avLst/>
@@ -9688,7 +9688,7 @@
         <p:spPr>
           <a:xfrm>
             <a:off x="8907627" y="2313432"/>
-            <a:ext cx="285069" cy="329184"/>
+            <a:ext cx="285183" cy="329184"/>
           </a:xfrm>
           <a:prstGeom prst="ellipse">
             <a:avLst/>
@@ -9716,8 +9716,8 @@
         </p:nvSpPr>
         <p:spPr>
           <a:xfrm>
-            <a:off x="8217674" y="1499616"/>
-            <a:ext cx="310896" cy="310896"/>
+            <a:off x="8158952" y="1394460"/>
+            <a:ext cx="356616" cy="356616"/>
           </a:xfrm>
           <a:prstGeom prst="ellipse">
             <a:avLst/>
@@ -9767,8 +9767,8 @@
         </p:nvSpPr>
         <p:spPr>
           <a:xfrm>
-            <a:off x="9179783" y="1252728"/>
-            <a:ext cx="310896" cy="310896"/>
+            <a:off x="9192742" y="1188720"/>
+            <a:ext cx="356616" cy="356616"/>
           </a:xfrm>
           <a:prstGeom prst="ellipse">
             <a:avLst/>
@@ -9818,8 +9818,8 @@
         </p:nvSpPr>
         <p:spPr>
           <a:xfrm>
-            <a:off x="9357951" y="2569464"/>
-            <a:ext cx="310896" cy="310896"/>
+            <a:off x="9406630" y="2587752"/>
+            <a:ext cx="356616" cy="356616"/>
           </a:xfrm>
           <a:prstGeom prst="ellipse">
             <a:avLst/>
@@ -12453,7 +12453,7 @@
                 </a:solidFill>
                 <a:latin typeface="Palatino"/>
               </a:rPr>
-              <a:t>Three marked observations</a:t>
+              <a:t>Bearish key reversal: the numbers first</a:t>
             </a:r>
           </a:p>
         </p:txBody>
@@ -12542,7 +12542,7 @@
         <p:spPr>
           <a:xfrm>
             <a:off x="777240" y="1965960"/>
-            <a:ext cx="6035040" cy="3108960"/>
+            <a:ext cx="5303520" cy="3108960"/>
           </a:xfrm>
           <a:prstGeom prst="rect">
             <a:avLst/>
@@ -12567,7 +12567,7 @@
               </a:spcAft>
             </a:pPr>
             <a:r>
-              <a:rPr sz="1900" b="0" i="0">
+              <a:rPr sz="2000" b="0" i="0">
                 <a:solidFill>
                   <a:srgbClr val="1A1A1A"/>
                 </a:solidFill>
@@ -12589,7 +12589,7 @@
               </a:spcAft>
             </a:pPr>
             <a:r>
-              <a:rPr sz="1900" b="0" i="0">
+              <a:rPr sz="2000" b="0" i="0">
                 <a:solidFill>
                   <a:srgbClr val="1A1A1A"/>
                 </a:solidFill>
@@ -12611,7 +12611,7 @@
               </a:spcAft>
             </a:pPr>
             <a:r>
-              <a:rPr sz="1900" b="1" i="0">
+              <a:rPr sz="2000" b="1" i="0">
                 <a:solidFill>
                   <a:srgbClr val="E09B00"/>
                 </a:solidFill>
@@ -12620,7 +12620,7 @@
               <a:t>(1)</a:t>
             </a:r>
             <a:r>
-              <a:rPr sz="1900" b="0" i="0">
+              <a:rPr sz="2000" b="0" i="0">
                 <a:solidFill>
                   <a:srgbClr val="1A1A1A"/>
                 </a:solidFill>
@@ -12629,7 +12629,7 @@
               <a:t> open above old high; </a:t>
             </a:r>
             <a:r>
-              <a:rPr sz="1900" b="1" i="0">
+              <a:rPr sz="2000" b="1" i="0">
                 <a:solidFill>
                   <a:srgbClr val="C62828"/>
                 </a:solidFill>
@@ -12638,7 +12638,7 @@
               <a:t>(2)</a:t>
             </a:r>
             <a:r>
-              <a:rPr sz="1900" b="0" i="0">
+              <a:rPr sz="2000" b="0" i="0">
                 <a:solidFill>
                   <a:srgbClr val="1A1A1A"/>
                 </a:solidFill>
@@ -12647,7 +12647,7 @@
               <a:t> new high; </a:t>
             </a:r>
             <a:r>
-              <a:rPr sz="1900" b="1" i="0">
+              <a:rPr sz="2000" b="1" i="0">
                 <a:solidFill>
                   <a:srgbClr val="1F5FAD"/>
                 </a:solidFill>
@@ -12656,13 +12656,13 @@
               <a:t>(3)</a:t>
             </a:r>
             <a:r>
-              <a:rPr sz="1900" b="0" i="0">
+              <a:rPr sz="2000" b="0" i="0">
                 <a:solidFill>
                   <a:srgbClr val="1A1A1A"/>
                 </a:solidFill>
                 <a:latin typeface="Arial"/>
               </a:rPr>
-              <a:t> close below old close. Volume is shares traded: 4.2m versus 2.0m (Chapter 6, “Volume and bar range: Chapter 5's four cases”). Next, Figure 7.15.</a:t>
+              <a:t> close below old close. Volume is the number of shares traded (Chapter 6): 4.2m versus 2.0m. Next, Figure 7.15.</a:t>
             </a:r>
           </a:p>
         </p:txBody>
@@ -12675,8 +12675,8 @@
         </p:nvSpPr>
         <p:spPr>
           <a:xfrm>
-            <a:off x="7132319" y="1810512"/>
-            <a:ext cx="4282135" cy="3212928"/>
+            <a:off x="6402171" y="1810512"/>
+            <a:ext cx="5010912" cy="3749039"/>
           </a:xfrm>
           <a:prstGeom prst="rect">
             <a:avLst/>
@@ -12715,8 +12715,8 @@
         </p:blipFill>
         <p:spPr>
           <a:xfrm>
-            <a:off x="7251191" y="1929384"/>
-            <a:ext cx="4044391" cy="2975184"/>
+            <a:off x="6521043" y="1929384"/>
+            <a:ext cx="4773168" cy="3511296"/>
           </a:xfrm>
           <a:prstGeom prst="rect">
             <a:avLst/>
@@ -12731,8 +12731,8 @@
         </p:nvSpPr>
         <p:spPr>
           <a:xfrm>
-            <a:off x="9677826" y="2732683"/>
-            <a:ext cx="242663" cy="178511"/>
+            <a:off x="9146285" y="2947659"/>
+            <a:ext cx="238658" cy="175564"/>
           </a:xfrm>
           <a:prstGeom prst="ellipse">
             <a:avLst/>
@@ -12760,8 +12760,8 @@
         </p:nvSpPr>
         <p:spPr>
           <a:xfrm>
-            <a:off x="9677826" y="2435165"/>
-            <a:ext cx="242663" cy="178511"/>
+            <a:off x="9146285" y="2561417"/>
+            <a:ext cx="238658" cy="175564"/>
           </a:xfrm>
           <a:prstGeom prst="ellipse">
             <a:avLst/>
@@ -12789,8 +12789,8 @@
         </p:nvSpPr>
         <p:spPr>
           <a:xfrm>
-            <a:off x="9677826" y="3476479"/>
-            <a:ext cx="242663" cy="178511"/>
+            <a:off x="9146285" y="3755257"/>
+            <a:ext cx="238658" cy="175564"/>
           </a:xfrm>
           <a:prstGeom prst="ellipse">
             <a:avLst/>
@@ -12818,7 +12818,7 @@
         </p:nvSpPr>
         <p:spPr>
           <a:xfrm>
-            <a:off x="9239271" y="2606987"/>
+            <a:off x="8608984" y="2967776"/>
             <a:ext cx="310896" cy="310896"/>
           </a:xfrm>
           <a:prstGeom prst="ellipse">
@@ -12869,7 +12869,7 @@
         </p:nvSpPr>
         <p:spPr>
           <a:xfrm>
-            <a:off x="10048149" y="2249965"/>
+            <a:off x="9945471" y="2230404"/>
             <a:ext cx="310896" cy="310896"/>
           </a:xfrm>
           <a:prstGeom prst="ellipse">
@@ -12920,7 +12920,7 @@
         </p:nvSpPr>
         <p:spPr>
           <a:xfrm>
-            <a:off x="10088593" y="3499542"/>
+            <a:off x="9993203" y="3915826"/>
             <a:ext cx="310896" cy="310896"/>
           </a:xfrm>
           <a:prstGeom prst="ellipse">
@@ -12971,8 +12971,8 @@
         </p:nvSpPr>
         <p:spPr>
           <a:xfrm>
-            <a:off x="7132319" y="5114880"/>
-            <a:ext cx="4282135" cy="274320"/>
+            <a:off x="6400799" y="5650991"/>
+            <a:ext cx="5013655" cy="274320"/>
           </a:xfrm>
           <a:prstGeom prst="rect">
             <a:avLst/>
@@ -13650,8 +13650,8 @@
         </p:nvSpPr>
         <p:spPr>
           <a:xfrm>
-            <a:off x="8661828" y="2054839"/>
-            <a:ext cx="310896" cy="310896"/>
+            <a:off x="8608561" y="1961753"/>
+            <a:ext cx="356616" cy="356616"/>
           </a:xfrm>
           <a:prstGeom prst="ellipse">
             <a:avLst/>
@@ -13701,8 +13701,8 @@
         </p:nvSpPr>
         <p:spPr>
           <a:xfrm>
-            <a:off x="9482828" y="1844161"/>
-            <a:ext cx="310896" cy="310896"/>
+            <a:off x="9490375" y="1786188"/>
+            <a:ext cx="356616" cy="356616"/>
           </a:xfrm>
           <a:prstGeom prst="ellipse">
             <a:avLst/>
@@ -13752,8 +13752,8 @@
         </p:nvSpPr>
         <p:spPr>
           <a:xfrm>
-            <a:off x="9634865" y="2967776"/>
-            <a:ext cx="310896" cy="310896"/>
+            <a:off x="9672820" y="2980029"/>
+            <a:ext cx="356616" cy="356616"/>
           </a:xfrm>
           <a:prstGeom prst="ellipse">
             <a:avLst/>

</xml_diff>

<commit_message>
Enlarge Chapter 7 sample charts
</commit_message>
<xml_diff>
--- a/chapter-07/FIN1209-Chapter-07.pptx
+++ b/chapter-07/FIN1209-Chapter-07.pptx
@@ -5137,7 +5137,7 @@
         <p:spPr>
           <a:xfrm>
             <a:off x="777240" y="1965960"/>
-            <a:ext cx="6035040" cy="3108960"/>
+            <a:ext cx="3200400" cy="3108960"/>
           </a:xfrm>
           <a:prstGeom prst="rect">
             <a:avLst/>
@@ -5168,7 +5168,7 @@
                 </a:solidFill>
                 <a:latin typeface="Arial"/>
               </a:rPr>
-              <a:t>Exhaustion bar (Lim, p. 226): uptrend open above prior high, close near low, no gap to next bar.</a:t>
+              <a:t>Exhaustion: uptrend, open above prior high, close near low, no gap next bar (Lim, p. 226).</a:t>
             </a:r>
           </a:p>
           <a:p>
@@ -5190,7 +5190,7 @@
                 </a:solidFill>
                 <a:latin typeface="Arial"/>
               </a:rPr>
-              <a:t>Pin bar (Lim, p. 227): “Pinocchio bars or Pin bars, are single bar misrepresentations of market strength or weakness.”</a:t>
+              <a:t>Pin bar: false barrier penetration, then rapid retracement (Lim, p. 227).</a:t>
             </a:r>
           </a:p>
           <a:p>
@@ -5206,22 +5206,31 @@
               </a:spcAft>
             </a:pPr>
             <a:r>
+              <a:rPr sz="1700" b="1" i="0">
+                <a:solidFill>
+                  <a:srgbClr val="E09B00"/>
+                </a:solidFill>
+                <a:latin typeface="Arial"/>
+              </a:rPr>
+              <a:t>(1)</a:t>
+            </a:r>
+            <a:r>
               <a:rPr sz="1700" b="0" i="0">
                 <a:solidFill>
                   <a:srgbClr val="1A1A1A"/>
                 </a:solidFill>
                 <a:latin typeface="Arial"/>
               </a:rPr>
-              <a:t>Chart: </a:t>
+              <a:t> O65.40 &gt;65.00. </a:t>
             </a:r>
             <a:r>
               <a:rPr sz="1700" b="1" i="0">
                 <a:solidFill>
-                  <a:srgbClr val="E09B00"/>
-                </a:solidFill>
-                <a:latin typeface="Arial"/>
-              </a:rPr>
-              <a:t>(1)</a:t>
+                  <a:srgbClr val="C62828"/>
+                </a:solidFill>
+                <a:latin typeface="Arial"/>
+              </a:rPr>
+              <a:t>(2)</a:t>
             </a:r>
             <a:r>
               <a:rPr sz="1700" b="0" i="0">
@@ -5230,16 +5239,16 @@
                 </a:solidFill>
                 <a:latin typeface="Arial"/>
               </a:rPr>
-              <a:t> left O 65.40 &gt; 65.00; </a:t>
+              <a:t> C60.50 near L; next O60.20, no gap. </a:t>
             </a:r>
             <a:r>
               <a:rPr sz="1700" b="1" i="0">
                 <a:solidFill>
-                  <a:srgbClr val="C62828"/>
-                </a:solidFill>
-                <a:latin typeface="Arial"/>
-              </a:rPr>
-              <a:t>(2)</a:t>
+                  <a:srgbClr val="1F5FAD"/>
+                </a:solidFill>
+                <a:latin typeface="Arial"/>
+              </a:rPr>
+              <a:t>(3)</a:t>
             </a:r>
             <a:r>
               <a:rPr sz="1700" b="0" i="0">
@@ -5248,47 +5257,7 @@
                 </a:solidFill>
                 <a:latin typeface="Arial"/>
               </a:rPr>
-              <a:t> left C 60.50 near L, next O 60.20 no gap; </a:t>
-            </a:r>
-            <a:r>
-              <a:rPr sz="1700" b="1" i="0">
-                <a:solidFill>
-                  <a:srgbClr val="1F5FAD"/>
-                </a:solidFill>
-                <a:latin typeface="Arial"/>
-              </a:rPr>
-              <a:t>(3)</a:t>
-            </a:r>
-            <a:r>
-              <a:rPr sz="1700" b="0" i="0">
-                <a:solidFill>
-                  <a:srgbClr val="1A1A1A"/>
-                </a:solidFill>
-                <a:latin typeface="Arial"/>
-              </a:rPr>
-              <a:t> right L 38.80 below support 40.00, a barrier. Ours.</a:t>
-            </a:r>
-          </a:p>
-          <a:p>
-            <a:pPr algn="l">
-              <a:lnSpc>
-                <a:spcPct val="105000"/>
-              </a:lnSpc>
-              <a:spcBef>
-                <a:spcPts val="0"/>
-              </a:spcBef>
-              <a:spcAft>
-                <a:spcPts val="1100"/>
-              </a:spcAft>
-            </a:pPr>
-            <a:r>
-              <a:rPr sz="1700" b="0" i="0">
-                <a:solidFill>
-                  <a:srgbClr val="1A1A1A"/>
-                </a:solidFill>
-                <a:latin typeface="Arial"/>
-              </a:rPr>
-              <a:t>No gap follows the exhaustion bar (Lim, p. 226). Exhaustion warns a tiring trend; pin warns a false breakout. Next, test key reversal.</a:t>
+              <a:t> L38.80 &lt; support40.00. Ours. Next: key reversal.</a:t>
             </a:r>
           </a:p>
         </p:txBody>
@@ -5301,8 +5270,8 @@
         </p:nvSpPr>
         <p:spPr>
           <a:xfrm>
-            <a:off x="7132319" y="1810512"/>
-            <a:ext cx="4282135" cy="2861132"/>
+            <a:off x="4390491" y="1810512"/>
+            <a:ext cx="7754112" cy="3749039"/>
           </a:xfrm>
           <a:prstGeom prst="rect">
             <a:avLst/>
@@ -5341,8 +5310,8 @@
         </p:blipFill>
         <p:spPr>
           <a:xfrm>
-            <a:off x="7251191" y="1929384"/>
-            <a:ext cx="4044391" cy="2623388"/>
+            <a:off x="4509363" y="1929384"/>
+            <a:ext cx="7516368" cy="3511296"/>
           </a:xfrm>
           <a:prstGeom prst="rect">
             <a:avLst/>
@@ -5357,8 +5326,8 @@
         </p:nvSpPr>
         <p:spPr>
           <a:xfrm>
-            <a:off x="8060070" y="2690166"/>
-            <a:ext cx="202219" cy="131169"/>
+            <a:off x="6388455" y="2947659"/>
+            <a:ext cx="375818" cy="175564"/>
           </a:xfrm>
           <a:prstGeom prst="ellipse">
             <a:avLst/>
@@ -5386,8 +5355,8 @@
         </p:nvSpPr>
         <p:spPr>
           <a:xfrm>
-            <a:off x="8060070" y="3372247"/>
-            <a:ext cx="202219" cy="131169"/>
+            <a:off x="6388455" y="3860596"/>
+            <a:ext cx="375818" cy="175564"/>
           </a:xfrm>
           <a:prstGeom prst="ellipse">
             <a:avLst/>
@@ -5415,8 +5384,8 @@
         </p:nvSpPr>
         <p:spPr>
           <a:xfrm>
-            <a:off x="10001377" y="3109908"/>
-            <a:ext cx="202219" cy="131169"/>
+            <a:off x="10146639" y="3509467"/>
+            <a:ext cx="375818" cy="175564"/>
           </a:xfrm>
           <a:prstGeom prst="ellipse">
             <a:avLst/>
@@ -5444,7 +5413,7 @@
         </p:nvSpPr>
         <p:spPr>
           <a:xfrm>
-            <a:off x="7581070" y="2377315"/>
+            <a:off x="5255879" y="2581534"/>
             <a:ext cx="310896" cy="310896"/>
           </a:xfrm>
           <a:prstGeom prst="ellipse">
@@ -5495,7 +5464,7 @@
         </p:nvSpPr>
         <p:spPr>
           <a:xfrm>
-            <a:off x="7581070" y="3584074"/>
+            <a:off x="5255879" y="4196730"/>
             <a:ext cx="310896" cy="310896"/>
           </a:xfrm>
           <a:prstGeom prst="ellipse">
@@ -5546,7 +5515,7 @@
         </p:nvSpPr>
         <p:spPr>
           <a:xfrm>
-            <a:off x="10412144" y="3295501"/>
+            <a:off x="10968319" y="3810487"/>
             <a:ext cx="310896" cy="310896"/>
           </a:xfrm>
           <a:prstGeom prst="ellipse">
@@ -5597,8 +5566,8 @@
         </p:nvSpPr>
         <p:spPr>
           <a:xfrm>
-            <a:off x="7132319" y="4763084"/>
-            <a:ext cx="4282135" cy="274320"/>
+            <a:off x="4297679" y="5650991"/>
+            <a:ext cx="7939735" cy="274320"/>
           </a:xfrm>
           <a:prstGeom prst="rect">
             <a:avLst/>
@@ -5623,7 +5592,7 @@
               </a:spcAft>
             </a:pPr>
             <a:r>
-              <a:rPr sz="900" b="0" i="0">
+              <a:rPr sz="1200" b="0" i="0">
                 <a:solidFill>
                   <a:srgbClr val="818181"/>
                 </a:solidFill>
@@ -12542,7 +12511,7 @@
         <p:spPr>
           <a:xfrm>
             <a:off x="777240" y="1965960"/>
-            <a:ext cx="5303520" cy="3108960"/>
+            <a:ext cx="3200400" cy="3108960"/>
           </a:xfrm>
           <a:prstGeom prst="rect">
             <a:avLst/>
@@ -12567,13 +12536,13 @@
               </a:spcAft>
             </a:pPr>
             <a:r>
-              <a:rPr sz="2000" b="0" i="0">
+              <a:rPr sz="1800" b="0" i="0">
                 <a:solidFill>
                   <a:srgbClr val="1A1A1A"/>
                 </a:solidFill>
                 <a:latin typeface="Arial"/>
               </a:rPr>
-              <a:t>A key reversal is an uptrend bar with a higher high, then a close near or below the previous close (Lim, p. 218).</a:t>
+              <a:t>Higher high, then close near or below prior close (Lim, p. 218).</a:t>
             </a:r>
           </a:p>
           <a:p>
@@ -12589,13 +12558,13 @@
               </a:spcAft>
             </a:pPr>
             <a:r>
-              <a:rPr sz="2000" b="0" i="0">
+              <a:rPr sz="1800" b="0" i="0">
                 <a:solidFill>
                   <a:srgbClr val="1A1A1A"/>
                 </a:solidFill>
                 <a:latin typeface="Arial"/>
               </a:rPr>
-              <a:t>Prior: O 50.80, H 52.00, L 50.60, C 51.10. New: O 52.30, H 53.20, L 49.90, C 50.80. Ours, invented.</a:t>
+              <a:t>Prior O 50.80 H 52.00 L 50.60 C 51.10. New O 52.30 H 53.20 L 49.90 C 50.80. Ours.</a:t>
             </a:r>
           </a:p>
           <a:p>
@@ -12611,7 +12580,7 @@
               </a:spcAft>
             </a:pPr>
             <a:r>
-              <a:rPr sz="2000" b="1" i="0">
+              <a:rPr sz="1800" b="1" i="0">
                 <a:solidFill>
                   <a:srgbClr val="E09B00"/>
                 </a:solidFill>
@@ -12620,16 +12589,16 @@
               <a:t>(1)</a:t>
             </a:r>
             <a:r>
-              <a:rPr sz="2000" b="0" i="0">
+              <a:rPr sz="1800" b="0" i="0">
                 <a:solidFill>
                   <a:srgbClr val="1A1A1A"/>
                 </a:solidFill>
                 <a:latin typeface="Arial"/>
               </a:rPr>
-              <a:t> open above old high; </a:t>
-            </a:r>
-            <a:r>
-              <a:rPr sz="2000" b="1" i="0">
+              <a:t> Open above old high. </a:t>
+            </a:r>
+            <a:r>
+              <a:rPr sz="1800" b="1" i="0">
                 <a:solidFill>
                   <a:srgbClr val="C62828"/>
                 </a:solidFill>
@@ -12638,16 +12607,16 @@
               <a:t>(2)</a:t>
             </a:r>
             <a:r>
-              <a:rPr sz="2000" b="0" i="0">
+              <a:rPr sz="1800" b="0" i="0">
                 <a:solidFill>
                   <a:srgbClr val="1A1A1A"/>
                 </a:solidFill>
                 <a:latin typeface="Arial"/>
               </a:rPr>
-              <a:t> new high; </a:t>
-            </a:r>
-            <a:r>
-              <a:rPr sz="2000" b="1" i="0">
+              <a:t> New high. </a:t>
+            </a:r>
+            <a:r>
+              <a:rPr sz="1800" b="1" i="0">
                 <a:solidFill>
                   <a:srgbClr val="1F5FAD"/>
                 </a:solidFill>
@@ -12656,13 +12625,13 @@
               <a:t>(3)</a:t>
             </a:r>
             <a:r>
-              <a:rPr sz="2000" b="0" i="0">
+              <a:rPr sz="1800" b="0" i="0">
                 <a:solidFill>
                   <a:srgbClr val="1A1A1A"/>
                 </a:solidFill>
                 <a:latin typeface="Arial"/>
               </a:rPr>
-              <a:t> close below old close. Volume is the number of shares traded (Chapter 6): 4.2m versus 2.0m. Next, Figure 7.15.</a:t>
+              <a:t> Close below old close. Volume shares: 4.2m versus 2.0m (Chapter 6). Next Figure 7.15.</a:t>
             </a:r>
           </a:p>
         </p:txBody>
@@ -12675,8 +12644,8 @@
         </p:nvSpPr>
         <p:spPr>
           <a:xfrm>
-            <a:off x="6402171" y="1810512"/>
-            <a:ext cx="5010912" cy="3749039"/>
+            <a:off x="4390491" y="1810512"/>
+            <a:ext cx="7754112" cy="3749039"/>
           </a:xfrm>
           <a:prstGeom prst="rect">
             <a:avLst/>
@@ -12715,8 +12684,8 @@
         </p:blipFill>
         <p:spPr>
           <a:xfrm>
-            <a:off x="6521043" y="1929384"/>
-            <a:ext cx="4773168" cy="3511296"/>
+            <a:off x="4509363" y="1929384"/>
+            <a:ext cx="7516368" cy="3511296"/>
           </a:xfrm>
           <a:prstGeom prst="rect">
             <a:avLst/>
@@ -12731,8 +12700,8 @@
         </p:nvSpPr>
         <p:spPr>
           <a:xfrm>
-            <a:off x="9146285" y="2947659"/>
-            <a:ext cx="238658" cy="175564"/>
+            <a:off x="9319839" y="2947659"/>
+            <a:ext cx="375818" cy="175564"/>
           </a:xfrm>
           <a:prstGeom prst="ellipse">
             <a:avLst/>
@@ -12760,8 +12729,8 @@
         </p:nvSpPr>
         <p:spPr>
           <a:xfrm>
-            <a:off x="9146285" y="2561417"/>
-            <a:ext cx="238658" cy="175564"/>
+            <a:off x="9319839" y="2561417"/>
+            <a:ext cx="375818" cy="175564"/>
           </a:xfrm>
           <a:prstGeom prst="ellipse">
             <a:avLst/>
@@ -12789,8 +12758,8 @@
         </p:nvSpPr>
         <p:spPr>
           <a:xfrm>
-            <a:off x="9146285" y="3755257"/>
-            <a:ext cx="238658" cy="175564"/>
+            <a:off x="9319839" y="3755257"/>
+            <a:ext cx="375818" cy="175564"/>
           </a:xfrm>
           <a:prstGeom prst="ellipse">
             <a:avLst/>
@@ -12818,7 +12787,7 @@
         </p:nvSpPr>
         <p:spPr>
           <a:xfrm>
-            <a:off x="8608984" y="2967776"/>
+            <a:off x="8262426" y="2967776"/>
             <a:ext cx="310896" cy="310896"/>
           </a:xfrm>
           <a:prstGeom prst="ellipse">
@@ -12869,7 +12838,7 @@
         </p:nvSpPr>
         <p:spPr>
           <a:xfrm>
-            <a:off x="9945471" y="2230404"/>
+            <a:off x="10141518" y="2230404"/>
             <a:ext cx="310896" cy="310896"/>
           </a:xfrm>
           <a:prstGeom prst="ellipse">
@@ -12920,7 +12889,7 @@
         </p:nvSpPr>
         <p:spPr>
           <a:xfrm>
-            <a:off x="9993203" y="3915826"/>
+            <a:off x="10141518" y="3950939"/>
             <a:ext cx="310896" cy="310896"/>
           </a:xfrm>
           <a:prstGeom prst="ellipse">
@@ -12971,8 +12940,8 @@
         </p:nvSpPr>
         <p:spPr>
           <a:xfrm>
-            <a:off x="6400799" y="5650991"/>
-            <a:ext cx="5013655" cy="274320"/>
+            <a:off x="4297679" y="5650991"/>
+            <a:ext cx="7939735" cy="274320"/>
           </a:xfrm>
           <a:prstGeom prst="rect">
             <a:avLst/>
@@ -12997,7 +12966,7 @@
               </a:spcAft>
             </a:pPr>
             <a:r>
-              <a:rPr sz="900" b="0" i="0">
+              <a:rPr sz="1200" b="0" i="0">
                 <a:solidFill>
                   <a:srgbClr val="818181"/>
                 </a:solidFill>

</xml_diff>

<commit_message>
Restore Chapter 7 sample teaching detail
</commit_message>
<xml_diff>
--- a/chapter-07/FIN1209-Chapter-07.pptx
+++ b/chapter-07/FIN1209-Chapter-07.pptx
@@ -5137,7 +5137,7 @@
         <p:spPr>
           <a:xfrm>
             <a:off x="777240" y="1965960"/>
-            <a:ext cx="3200400" cy="3108960"/>
+            <a:ext cx="3291840" cy="3108960"/>
           </a:xfrm>
           <a:prstGeom prst="rect">
             <a:avLst/>
@@ -5168,7 +5168,7 @@
                 </a:solidFill>
                 <a:latin typeface="Arial"/>
               </a:rPr>
-              <a:t>Exhaustion: uptrend, open above prior high, close near low, no gap next bar (Lim, p. 226).</a:t>
+              <a:t>Exhaustion: in an uptrend, it opens at 65.40 above prior high 65.00, reaches 66.20, and closes at 60.50; the next bar opens at 60.20 with no gap.</a:t>
             </a:r>
           </a:p>
           <a:p>
@@ -5190,7 +5190,7 @@
                 </a:solidFill>
                 <a:latin typeface="Arial"/>
               </a:rPr>
-              <a:t>Pin bar: false barrier penetration, then rapid retracement (Lim, p. 227).</a:t>
+              <a:t>Pin bar: it penetrates support at 40.00 to 38.80, then rapidly retraces and closes at 40.60.</a:t>
             </a:r>
           </a:p>
           <a:p>
@@ -5206,58 +5206,13 @@
               </a:spcAft>
             </a:pPr>
             <a:r>
-              <a:rPr sz="1700" b="1" i="0">
-                <a:solidFill>
-                  <a:srgbClr val="E09B00"/>
+              <a:rPr sz="1700" b="0" i="0">
+                <a:solidFill>
+                  <a:srgbClr val="1A1A1A"/>
                 </a:solidFill>
                 <a:latin typeface="Arial"/>
               </a:rPr>
-              <a:t>(1)</a:t>
-            </a:r>
-            <a:r>
-              <a:rPr sz="1700" b="0" i="0">
-                <a:solidFill>
-                  <a:srgbClr val="1A1A1A"/>
-                </a:solidFill>
-                <a:latin typeface="Arial"/>
-              </a:rPr>
-              <a:t> O65.40 &gt;65.00. </a:t>
-            </a:r>
-            <a:r>
-              <a:rPr sz="1700" b="1" i="0">
-                <a:solidFill>
-                  <a:srgbClr val="C62828"/>
-                </a:solidFill>
-                <a:latin typeface="Arial"/>
-              </a:rPr>
-              <a:t>(2)</a:t>
-            </a:r>
-            <a:r>
-              <a:rPr sz="1700" b="0" i="0">
-                <a:solidFill>
-                  <a:srgbClr val="1A1A1A"/>
-                </a:solidFill>
-                <a:latin typeface="Arial"/>
-              </a:rPr>
-              <a:t> C60.50 near L; next O60.20, no gap. </a:t>
-            </a:r>
-            <a:r>
-              <a:rPr sz="1700" b="1" i="0">
-                <a:solidFill>
-                  <a:srgbClr val="1F5FAD"/>
-                </a:solidFill>
-                <a:latin typeface="Arial"/>
-              </a:rPr>
-              <a:t>(3)</a:t>
-            </a:r>
-            <a:r>
-              <a:rPr sz="1700" b="0" i="0">
-                <a:solidFill>
-                  <a:srgbClr val="1A1A1A"/>
-                </a:solidFill>
-                <a:latin typeface="Arial"/>
-              </a:rPr>
-              <a:t> L38.80 &lt; support40.00. Ours. Next: key reversal.</a:t>
+              <a:t>Meaning/action: exhaustion warns of a tiring trend; a pin bar warns of a false breakout.</a:t>
             </a:r>
           </a:p>
         </p:txBody>
@@ -5566,8 +5521,8 @@
         </p:nvSpPr>
         <p:spPr>
           <a:xfrm>
-            <a:off x="4297679" y="5650991"/>
-            <a:ext cx="7939735" cy="274320"/>
+            <a:off x="4389120" y="5650991"/>
+            <a:ext cx="7756855" cy="274320"/>
           </a:xfrm>
           <a:prstGeom prst="rect">
             <a:avLst/>
@@ -6538,6 +6493,35 @@
         </p:nvSpPr>
         <p:spPr>
           <a:xfrm>
+            <a:off x="8765092" y="4494276"/>
+            <a:ext cx="285069" cy="370331"/>
+          </a:xfrm>
+          <a:prstGeom prst="ellipse">
+            <a:avLst/>
+          </a:prstGeom>
+          <a:noFill/>
+          <a:ln w="44450">
+            <a:solidFill>
+              <a:srgbClr val="7B3FA0"/>
+            </a:solidFill>
+          </a:ln>
+        </p:spPr>
+        <p:txBody>
+          <a:bodyPr rtlCol="0" anchor="ctr"/>
+          <a:lstStyle/>
+          <a:p>
+            <a:pPr algn="ctr"/>
+          </a:p>
+        </p:txBody>
+      </p:sp>
+      <p:sp>
+        <p:nvSpPr>
+          <p:cNvPr id="22" name="Oval 21"/>
+          <p:cNvSpPr/>
+          <p:nvPr/>
+        </p:nvSpPr>
+        <p:spPr>
+          <a:xfrm>
             <a:off x="8159180" y="1394460"/>
             <a:ext cx="356616" cy="356616"/>
           </a:xfrm>
@@ -6583,7 +6567,7 @@
       </p:sp>
       <p:sp>
         <p:nvSpPr>
-          <p:cNvPr id="22" name="Oval 21"/>
+          <p:cNvPr id="23" name="Oval 22"/>
           <p:cNvSpPr/>
           <p:nvPr/>
         </p:nvSpPr>
@@ -6634,7 +6618,7 @@
       </p:sp>
       <p:sp>
         <p:nvSpPr>
-          <p:cNvPr id="23" name="Oval 22"/>
+          <p:cNvPr id="24" name="Oval 23"/>
           <p:cNvSpPr/>
           <p:nvPr/>
         </p:nvSpPr>
@@ -6685,7 +6669,58 @@
       </p:sp>
       <p:sp>
         <p:nvSpPr>
-          <p:cNvPr id="24" name="TextBox 23"/>
+          <p:cNvPr id="25" name="Oval 24"/>
+          <p:cNvSpPr/>
+          <p:nvPr/>
+        </p:nvSpPr>
+        <p:spPr>
+          <a:xfrm>
+            <a:off x="9545264" y="4636008"/>
+            <a:ext cx="292608" cy="292608"/>
+          </a:xfrm>
+          <a:prstGeom prst="ellipse">
+            <a:avLst/>
+          </a:prstGeom>
+          <a:solidFill>
+            <a:srgbClr val="7B3FA0"/>
+          </a:solidFill>
+          <a:ln w="12700">
+            <a:solidFill>
+              <a:srgbClr val="FFFFFF"/>
+            </a:solidFill>
+          </a:ln>
+          <a:effectLst/>
+        </p:spPr>
+        <p:txBody>
+          <a:bodyPr rtlCol="0" anchor="ctr" wrap="none" lIns="0" rIns="0" tIns="0" bIns="0"/>
+          <a:lstStyle/>
+          <a:p>
+            <a:pPr algn="ctr">
+              <a:lnSpc>
+                <a:spcPct val="100000"/>
+              </a:lnSpc>
+              <a:spcBef>
+                <a:spcPts val="0"/>
+              </a:spcBef>
+              <a:spcAft>
+                <a:spcPts val="0"/>
+              </a:spcAft>
+            </a:pPr>
+            <a:r>
+              <a:rPr sz="1300" b="1" i="0">
+                <a:solidFill>
+                  <a:srgbClr val="FFFFFF"/>
+                </a:solidFill>
+                <a:latin typeface="Arial"/>
+              </a:rPr>
+              <a:t>4</a:t>
+            </a:r>
+          </a:p>
+        </p:txBody>
+      </p:sp>
+      <p:sp>
+        <p:nvSpPr>
+          <p:cNvPr id="26" name="TextBox 25"/>
           <p:cNvSpPr txBox="1"/>
           <p:nvPr/>
         </p:nvSpPr>
@@ -6730,7 +6765,7 @@
       </p:sp>
       <p:sp>
         <p:nvSpPr>
-          <p:cNvPr id="25" name="TextBox 24"/>
+          <p:cNvPr id="27" name="TextBox 26"/>
           <p:cNvSpPr txBox="1"/>
           <p:nvPr/>
         </p:nvSpPr>
@@ -7301,8 +7336,8 @@
         </p:nvSpPr>
         <p:spPr>
           <a:xfrm>
-            <a:off x="7006359" y="1207008"/>
-            <a:ext cx="3802536" cy="4352544"/>
+            <a:off x="6935804" y="1207008"/>
+            <a:ext cx="3943646" cy="4352544"/>
           </a:xfrm>
           <a:prstGeom prst="rect">
             <a:avLst/>
@@ -7333,8 +7368,8 @@
         </p:nvSpPr>
         <p:spPr>
           <a:xfrm>
-            <a:off x="7125231" y="1325880"/>
-            <a:ext cx="3564792" cy="4114800"/>
+            <a:off x="7054676" y="1325880"/>
+            <a:ext cx="3705902" cy="4114800"/>
           </a:xfrm>
           <a:prstGeom prst="rect">
             <a:avLst/>
@@ -7365,8 +7400,8 @@
         </p:nvSpPr>
         <p:spPr>
           <a:xfrm>
-            <a:off x="7125231" y="1325880"/>
-            <a:ext cx="3564792" cy="50800"/>
+            <a:off x="7054676" y="1325880"/>
+            <a:ext cx="3705902" cy="50800"/>
           </a:xfrm>
           <a:prstGeom prst="rect">
             <a:avLst/>
@@ -7395,8 +7430,8 @@
         </p:nvSpPr>
         <p:spPr>
           <a:xfrm>
-            <a:off x="7399551" y="1600200"/>
-            <a:ext cx="3016152" cy="3657600"/>
+            <a:off x="7328996" y="1600200"/>
+            <a:ext cx="3157262" cy="3657600"/>
           </a:xfrm>
           <a:prstGeom prst="rect">
             <a:avLst/>
@@ -7462,8 +7497,8 @@
         </p:nvSpPr>
         <p:spPr>
           <a:xfrm>
-            <a:off x="8658091" y="1737360"/>
-            <a:ext cx="285183" cy="329183"/>
+            <a:off x="8648214" y="1737360"/>
+            <a:ext cx="296472" cy="329183"/>
           </a:xfrm>
           <a:prstGeom prst="ellipse">
             <a:avLst/>
@@ -7491,8 +7526,8 @@
         </p:nvSpPr>
         <p:spPr>
           <a:xfrm>
-            <a:off x="8800683" y="1408176"/>
-            <a:ext cx="249535" cy="329184"/>
+            <a:off x="8796450" y="1408176"/>
+            <a:ext cx="259413" cy="329184"/>
           </a:xfrm>
           <a:prstGeom prst="ellipse">
             <a:avLst/>
@@ -7521,7 +7556,7 @@
         <p:spPr>
           <a:xfrm>
             <a:off x="8907627" y="2313432"/>
-            <a:ext cx="285183" cy="329184"/>
+            <a:ext cx="296472" cy="329184"/>
           </a:xfrm>
           <a:prstGeom prst="ellipse">
             <a:avLst/>
@@ -7549,7 +7584,36 @@
         </p:nvSpPr>
         <p:spPr>
           <a:xfrm>
-            <a:off x="8158952" y="1394460"/>
+            <a:off x="8759391" y="4494276"/>
+            <a:ext cx="296472" cy="370331"/>
+          </a:xfrm>
+          <a:prstGeom prst="ellipse">
+            <a:avLst/>
+          </a:prstGeom>
+          <a:noFill/>
+          <a:ln w="44450">
+            <a:solidFill>
+              <a:srgbClr val="7B3FA0"/>
+            </a:solidFill>
+          </a:ln>
+        </p:spPr>
+        <p:txBody>
+          <a:bodyPr rtlCol="0" anchor="ctr"/>
+          <a:lstStyle/>
+          <a:p>
+            <a:pPr algn="ctr"/>
+          </a:p>
+        </p:txBody>
+      </p:sp>
+      <p:sp>
+        <p:nvSpPr>
+          <p:cNvPr id="22" name="Oval 21"/>
+          <p:cNvSpPr/>
+          <p:nvPr/>
+        </p:nvSpPr>
+        <p:spPr>
+          <a:xfrm>
+            <a:off x="8136375" y="1394460"/>
             <a:ext cx="356616" cy="356616"/>
           </a:xfrm>
           <a:prstGeom prst="ellipse">
@@ -7594,13 +7658,13 @@
       </p:sp>
       <p:sp>
         <p:nvSpPr>
-          <p:cNvPr id="22" name="Oval 21"/>
+          <p:cNvPr id="23" name="Oval 22"/>
           <p:cNvSpPr/>
           <p:nvPr/>
         </p:nvSpPr>
         <p:spPr>
           <a:xfrm>
-            <a:off x="9192742" y="1188720"/>
+            <a:off x="9211086" y="1188720"/>
             <a:ext cx="356616" cy="356616"/>
           </a:xfrm>
           <a:prstGeom prst="ellipse">
@@ -7645,13 +7709,13 @@
       </p:sp>
       <p:sp>
         <p:nvSpPr>
-          <p:cNvPr id="23" name="Oval 22"/>
+          <p:cNvPr id="24" name="Oval 23"/>
           <p:cNvSpPr/>
           <p:nvPr/>
         </p:nvSpPr>
         <p:spPr>
           <a:xfrm>
-            <a:off x="9406630" y="2587752"/>
+            <a:off x="9433440" y="2587752"/>
             <a:ext cx="356616" cy="356616"/>
           </a:xfrm>
           <a:prstGeom prst="ellipse">
@@ -7696,7 +7760,58 @@
       </p:sp>
       <p:sp>
         <p:nvSpPr>
-          <p:cNvPr id="24" name="TextBox 23"/>
+          <p:cNvPr id="25" name="Oval 24"/>
+          <p:cNvSpPr/>
+          <p:nvPr/>
+        </p:nvSpPr>
+        <p:spPr>
+          <a:xfrm>
+            <a:off x="9576622" y="4636008"/>
+            <a:ext cx="292608" cy="292608"/>
+          </a:xfrm>
+          <a:prstGeom prst="ellipse">
+            <a:avLst/>
+          </a:prstGeom>
+          <a:solidFill>
+            <a:srgbClr val="7B3FA0"/>
+          </a:solidFill>
+          <a:ln w="12700">
+            <a:solidFill>
+              <a:srgbClr val="FFFFFF"/>
+            </a:solidFill>
+          </a:ln>
+          <a:effectLst/>
+        </p:spPr>
+        <p:txBody>
+          <a:bodyPr rtlCol="0" anchor="ctr" wrap="none" lIns="0" rIns="0" tIns="0" bIns="0"/>
+          <a:lstStyle/>
+          <a:p>
+            <a:pPr algn="ctr">
+              <a:lnSpc>
+                <a:spcPct val="100000"/>
+              </a:lnSpc>
+              <a:spcBef>
+                <a:spcPts val="0"/>
+              </a:spcBef>
+              <a:spcAft>
+                <a:spcPts val="0"/>
+              </a:spcAft>
+            </a:pPr>
+            <a:r>
+              <a:rPr sz="1300" b="1" i="0">
+                <a:solidFill>
+                  <a:srgbClr val="FFFFFF"/>
+                </a:solidFill>
+                <a:latin typeface="Arial"/>
+              </a:rPr>
+              <a:t>4</a:t>
+            </a:r>
+          </a:p>
+        </p:txBody>
+      </p:sp>
+      <p:sp>
+        <p:nvSpPr>
+          <p:cNvPr id="26" name="TextBox 25"/>
           <p:cNvSpPr txBox="1"/>
           <p:nvPr/>
         </p:nvSpPr>
@@ -7741,7 +7856,7 @@
       </p:sp>
       <p:sp>
         <p:nvSpPr>
-          <p:cNvPr id="25" name="TextBox 24"/>
+          <p:cNvPr id="27" name="TextBox 26"/>
           <p:cNvSpPr txBox="1"/>
           <p:nvPr/>
         </p:nvSpPr>
@@ -8674,6 +8789,35 @@
         </p:nvSpPr>
         <p:spPr>
           <a:xfrm>
+            <a:off x="8765092" y="4494276"/>
+            <a:ext cx="285069" cy="370331"/>
+          </a:xfrm>
+          <a:prstGeom prst="ellipse">
+            <a:avLst/>
+          </a:prstGeom>
+          <a:noFill/>
+          <a:ln w="44450">
+            <a:solidFill>
+              <a:srgbClr val="7B3FA0"/>
+            </a:solidFill>
+          </a:ln>
+        </p:spPr>
+        <p:txBody>
+          <a:bodyPr rtlCol="0" anchor="ctr"/>
+          <a:lstStyle/>
+          <a:p>
+            <a:pPr algn="ctr"/>
+          </a:p>
+        </p:txBody>
+      </p:sp>
+      <p:sp>
+        <p:nvSpPr>
+          <p:cNvPr id="22" name="Oval 21"/>
+          <p:cNvSpPr/>
+          <p:nvPr/>
+        </p:nvSpPr>
+        <p:spPr>
+          <a:xfrm>
             <a:off x="8159180" y="1394460"/>
             <a:ext cx="356616" cy="356616"/>
           </a:xfrm>
@@ -8719,7 +8863,7 @@
       </p:sp>
       <p:sp>
         <p:nvSpPr>
-          <p:cNvPr id="22" name="Oval 21"/>
+          <p:cNvPr id="23" name="Oval 22"/>
           <p:cNvSpPr/>
           <p:nvPr/>
         </p:nvSpPr>
@@ -8770,7 +8914,7 @@
       </p:sp>
       <p:sp>
         <p:nvSpPr>
-          <p:cNvPr id="23" name="Oval 22"/>
+          <p:cNvPr id="24" name="Oval 23"/>
           <p:cNvSpPr/>
           <p:nvPr/>
         </p:nvSpPr>
@@ -8821,7 +8965,58 @@
       </p:sp>
       <p:sp>
         <p:nvSpPr>
-          <p:cNvPr id="24" name="TextBox 23"/>
+          <p:cNvPr id="25" name="Oval 24"/>
+          <p:cNvSpPr/>
+          <p:nvPr/>
+        </p:nvSpPr>
+        <p:spPr>
+          <a:xfrm>
+            <a:off x="9545264" y="4636008"/>
+            <a:ext cx="292608" cy="292608"/>
+          </a:xfrm>
+          <a:prstGeom prst="ellipse">
+            <a:avLst/>
+          </a:prstGeom>
+          <a:solidFill>
+            <a:srgbClr val="7B3FA0"/>
+          </a:solidFill>
+          <a:ln w="12700">
+            <a:solidFill>
+              <a:srgbClr val="FFFFFF"/>
+            </a:solidFill>
+          </a:ln>
+          <a:effectLst/>
+        </p:spPr>
+        <p:txBody>
+          <a:bodyPr rtlCol="0" anchor="ctr" wrap="none" lIns="0" rIns="0" tIns="0" bIns="0"/>
+          <a:lstStyle/>
+          <a:p>
+            <a:pPr algn="ctr">
+              <a:lnSpc>
+                <a:spcPct val="100000"/>
+              </a:lnSpc>
+              <a:spcBef>
+                <a:spcPts val="0"/>
+              </a:spcBef>
+              <a:spcAft>
+                <a:spcPts val="0"/>
+              </a:spcAft>
+            </a:pPr>
+            <a:r>
+              <a:rPr sz="1300" b="1" i="0">
+                <a:solidFill>
+                  <a:srgbClr val="FFFFFF"/>
+                </a:solidFill>
+                <a:latin typeface="Arial"/>
+              </a:rPr>
+              <a:t>4</a:t>
+            </a:r>
+          </a:p>
+        </p:txBody>
+      </p:sp>
+      <p:sp>
+        <p:nvSpPr>
+          <p:cNvPr id="26" name="TextBox 25"/>
           <p:cNvSpPr txBox="1"/>
           <p:nvPr/>
         </p:nvSpPr>
@@ -8866,7 +9061,7 @@
       </p:sp>
       <p:sp>
         <p:nvSpPr>
-          <p:cNvPr id="25" name="TextBox 24"/>
+          <p:cNvPr id="27" name="TextBox 26"/>
           <p:cNvSpPr txBox="1"/>
           <p:nvPr/>
         </p:nvSpPr>
@@ -9437,8 +9632,8 @@
         </p:nvSpPr>
         <p:spPr>
           <a:xfrm>
-            <a:off x="7006359" y="1207008"/>
-            <a:ext cx="3802536" cy="4352544"/>
+            <a:off x="6935804" y="1207008"/>
+            <a:ext cx="3943646" cy="4352544"/>
           </a:xfrm>
           <a:prstGeom prst="rect">
             <a:avLst/>
@@ -9469,8 +9664,8 @@
         </p:nvSpPr>
         <p:spPr>
           <a:xfrm>
-            <a:off x="7125231" y="1325880"/>
-            <a:ext cx="3564792" cy="4114800"/>
+            <a:off x="7054676" y="1325880"/>
+            <a:ext cx="3705902" cy="4114800"/>
           </a:xfrm>
           <a:prstGeom prst="rect">
             <a:avLst/>
@@ -9501,8 +9696,8 @@
         </p:nvSpPr>
         <p:spPr>
           <a:xfrm>
-            <a:off x="7125231" y="1325880"/>
-            <a:ext cx="3564792" cy="50800"/>
+            <a:off x="7054676" y="1325880"/>
+            <a:ext cx="3705902" cy="50800"/>
           </a:xfrm>
           <a:prstGeom prst="rect">
             <a:avLst/>
@@ -9531,8 +9726,8 @@
         </p:nvSpPr>
         <p:spPr>
           <a:xfrm>
-            <a:off x="7399551" y="1600200"/>
-            <a:ext cx="3016152" cy="3657600"/>
+            <a:off x="7328996" y="1600200"/>
+            <a:ext cx="3157262" cy="3657600"/>
           </a:xfrm>
           <a:prstGeom prst="rect">
             <a:avLst/>
@@ -9598,8 +9793,8 @@
         </p:nvSpPr>
         <p:spPr>
           <a:xfrm>
-            <a:off x="8658091" y="1737360"/>
-            <a:ext cx="285183" cy="329183"/>
+            <a:off x="8648214" y="1737360"/>
+            <a:ext cx="296472" cy="329183"/>
           </a:xfrm>
           <a:prstGeom prst="ellipse">
             <a:avLst/>
@@ -9627,8 +9822,8 @@
         </p:nvSpPr>
         <p:spPr>
           <a:xfrm>
-            <a:off x="8800683" y="1408176"/>
-            <a:ext cx="249535" cy="329184"/>
+            <a:off x="8796450" y="1408176"/>
+            <a:ext cx="259413" cy="329184"/>
           </a:xfrm>
           <a:prstGeom prst="ellipse">
             <a:avLst/>
@@ -9657,7 +9852,7 @@
         <p:spPr>
           <a:xfrm>
             <a:off x="8907627" y="2313432"/>
-            <a:ext cx="285183" cy="329184"/>
+            <a:ext cx="296472" cy="329184"/>
           </a:xfrm>
           <a:prstGeom prst="ellipse">
             <a:avLst/>
@@ -9685,7 +9880,36 @@
         </p:nvSpPr>
         <p:spPr>
           <a:xfrm>
-            <a:off x="8158952" y="1394460"/>
+            <a:off x="8759391" y="4494276"/>
+            <a:ext cx="296472" cy="370331"/>
+          </a:xfrm>
+          <a:prstGeom prst="ellipse">
+            <a:avLst/>
+          </a:prstGeom>
+          <a:noFill/>
+          <a:ln w="44450">
+            <a:solidFill>
+              <a:srgbClr val="7B3FA0"/>
+            </a:solidFill>
+          </a:ln>
+        </p:spPr>
+        <p:txBody>
+          <a:bodyPr rtlCol="0" anchor="ctr"/>
+          <a:lstStyle/>
+          <a:p>
+            <a:pPr algn="ctr"/>
+          </a:p>
+        </p:txBody>
+      </p:sp>
+      <p:sp>
+        <p:nvSpPr>
+          <p:cNvPr id="22" name="Oval 21"/>
+          <p:cNvSpPr/>
+          <p:nvPr/>
+        </p:nvSpPr>
+        <p:spPr>
+          <a:xfrm>
+            <a:off x="8136375" y="1394460"/>
             <a:ext cx="356616" cy="356616"/>
           </a:xfrm>
           <a:prstGeom prst="ellipse">
@@ -9730,13 +9954,13 @@
       </p:sp>
       <p:sp>
         <p:nvSpPr>
-          <p:cNvPr id="22" name="Oval 21"/>
+          <p:cNvPr id="23" name="Oval 22"/>
           <p:cNvSpPr/>
           <p:nvPr/>
         </p:nvSpPr>
         <p:spPr>
           <a:xfrm>
-            <a:off x="9192742" y="1188720"/>
+            <a:off x="9211086" y="1188720"/>
             <a:ext cx="356616" cy="356616"/>
           </a:xfrm>
           <a:prstGeom prst="ellipse">
@@ -9781,13 +10005,13 @@
       </p:sp>
       <p:sp>
         <p:nvSpPr>
-          <p:cNvPr id="23" name="Oval 22"/>
+          <p:cNvPr id="24" name="Oval 23"/>
           <p:cNvSpPr/>
           <p:nvPr/>
         </p:nvSpPr>
         <p:spPr>
           <a:xfrm>
-            <a:off x="9406630" y="2587752"/>
+            <a:off x="9433440" y="2587752"/>
             <a:ext cx="356616" cy="356616"/>
           </a:xfrm>
           <a:prstGeom prst="ellipse">
@@ -9832,7 +10056,58 @@
       </p:sp>
       <p:sp>
         <p:nvSpPr>
-          <p:cNvPr id="24" name="TextBox 23"/>
+          <p:cNvPr id="25" name="Oval 24"/>
+          <p:cNvSpPr/>
+          <p:nvPr/>
+        </p:nvSpPr>
+        <p:spPr>
+          <a:xfrm>
+            <a:off x="9576622" y="4636008"/>
+            <a:ext cx="292608" cy="292608"/>
+          </a:xfrm>
+          <a:prstGeom prst="ellipse">
+            <a:avLst/>
+          </a:prstGeom>
+          <a:solidFill>
+            <a:srgbClr val="7B3FA0"/>
+          </a:solidFill>
+          <a:ln w="12700">
+            <a:solidFill>
+              <a:srgbClr val="FFFFFF"/>
+            </a:solidFill>
+          </a:ln>
+          <a:effectLst/>
+        </p:spPr>
+        <p:txBody>
+          <a:bodyPr rtlCol="0" anchor="ctr" wrap="none" lIns="0" rIns="0" tIns="0" bIns="0"/>
+          <a:lstStyle/>
+          <a:p>
+            <a:pPr algn="ctr">
+              <a:lnSpc>
+                <a:spcPct val="100000"/>
+              </a:lnSpc>
+              <a:spcBef>
+                <a:spcPts val="0"/>
+              </a:spcBef>
+              <a:spcAft>
+                <a:spcPts val="0"/>
+              </a:spcAft>
+            </a:pPr>
+            <a:r>
+              <a:rPr sz="1300" b="1" i="0">
+                <a:solidFill>
+                  <a:srgbClr val="FFFFFF"/>
+                </a:solidFill>
+                <a:latin typeface="Arial"/>
+              </a:rPr>
+              <a:t>4</a:t>
+            </a:r>
+          </a:p>
+        </p:txBody>
+      </p:sp>
+      <p:sp>
+        <p:nvSpPr>
+          <p:cNvPr id="26" name="TextBox 25"/>
           <p:cNvSpPr txBox="1"/>
           <p:nvPr/>
         </p:nvSpPr>
@@ -9877,7 +10152,7 @@
       </p:sp>
       <p:sp>
         <p:nvSpPr>
-          <p:cNvPr id="25" name="TextBox 24"/>
+          <p:cNvPr id="27" name="TextBox 26"/>
           <p:cNvSpPr txBox="1"/>
           <p:nvPr/>
         </p:nvSpPr>
@@ -12542,7 +12817,7 @@
                 </a:solidFill>
                 <a:latin typeface="Arial"/>
               </a:rPr>
-              <a:t>Higher high, then close near or below prior close (Lim, p. 218).</a:t>
+              <a:t>Step 1. The prior bar opens at 50.80, reaches a high of 52.00, falls to a low of 50.60, and closes at 51.10.</a:t>
             </a:r>
           </a:p>
           <a:p>
@@ -12564,7 +12839,7 @@
                 </a:solidFill>
                 <a:latin typeface="Arial"/>
               </a:rPr>
-              <a:t>Prior O 50.80 H 52.00 L 50.60 C 51.10. New O 52.30 H 53.20 L 49.90 C 50.80. Ours.</a:t>
+              <a:t>Step 2. The new bar opens at 52.30, above the prior high of 52.00.</a:t>
             </a:r>
           </a:p>
           <a:p>
@@ -12580,58 +12855,13 @@
               </a:spcAft>
             </a:pPr>
             <a:r>
-              <a:rPr sz="1800" b="1" i="0">
-                <a:solidFill>
-                  <a:srgbClr val="E09B00"/>
+              <a:rPr sz="1800" b="0" i="0">
+                <a:solidFill>
+                  <a:srgbClr val="1A1A1A"/>
                 </a:solidFill>
                 <a:latin typeface="Arial"/>
               </a:rPr>
-              <a:t>(1)</a:t>
-            </a:r>
-            <a:r>
-              <a:rPr sz="1800" b="0" i="0">
-                <a:solidFill>
-                  <a:srgbClr val="1A1A1A"/>
-                </a:solidFill>
-                <a:latin typeface="Arial"/>
-              </a:rPr>
-              <a:t> Open above old high. </a:t>
-            </a:r>
-            <a:r>
-              <a:rPr sz="1800" b="1" i="0">
-                <a:solidFill>
-                  <a:srgbClr val="C62828"/>
-                </a:solidFill>
-                <a:latin typeface="Arial"/>
-              </a:rPr>
-              <a:t>(2)</a:t>
-            </a:r>
-            <a:r>
-              <a:rPr sz="1800" b="0" i="0">
-                <a:solidFill>
-                  <a:srgbClr val="1A1A1A"/>
-                </a:solidFill>
-                <a:latin typeface="Arial"/>
-              </a:rPr>
-              <a:t> New high. </a:t>
-            </a:r>
-            <a:r>
-              <a:rPr sz="1800" b="1" i="0">
-                <a:solidFill>
-                  <a:srgbClr val="1F5FAD"/>
-                </a:solidFill>
-                <a:latin typeface="Arial"/>
-              </a:rPr>
-              <a:t>(3)</a:t>
-            </a:r>
-            <a:r>
-              <a:rPr sz="1800" b="0" i="0">
-                <a:solidFill>
-                  <a:srgbClr val="1A1A1A"/>
-                </a:solidFill>
-                <a:latin typeface="Arial"/>
-              </a:rPr>
-              <a:t> Close below old close. Volume shares: 4.2m versus 2.0m (Chapter 6). Next Figure 7.15.</a:t>
+              <a:t>Step 3. It reaches a new high of 53.20, then falls to a low of 49.90.</a:t>
             </a:r>
           </a:p>
         </p:txBody>
@@ -13254,13 +13484,13 @@
               </a:spcAft>
             </a:pPr>
             <a:r>
-              <a:rPr sz="1800" b="0" i="0">
+              <a:rPr sz="2000" b="0" i="0">
                 <a:solidFill>
                   <a:srgbClr val="1A1A1A"/>
                 </a:solidFill>
                 <a:latin typeface="Arial"/>
               </a:rPr>
-              <a:t>From “Three marked observations”: a key reversal makes a higher high, then closes near or below the previous close (Lim, p. 218).</a:t>
+              <a:t>Step 4. The new bar closes at 50.80, below the prior close of 51.10.</a:t>
             </a:r>
           </a:p>
           <a:p>
@@ -13276,89 +13506,35 @@
               </a:spcAft>
             </a:pPr>
             <a:r>
-              <a:rPr sz="1800" b="0" i="0">
+              <a:rPr sz="2000" b="0" i="0">
                 <a:solidFill>
                   <a:srgbClr val="1A1A1A"/>
                 </a:solidFill>
                 <a:latin typeface="Arial"/>
               </a:rPr>
-              <a:t>Figure 7.15: </a:t>
-            </a:r>
-            <a:r>
-              <a:rPr sz="1800" b="1" i="0">
-                <a:solidFill>
-                  <a:srgbClr val="E09B00"/>
+              <a:t>Step 5. Volume is 4.2 million shares, versus 2.0 million on the prior bar. On Figure 7.15, mark 4 identifies the volume reading.</a:t>
+            </a:r>
+          </a:p>
+          <a:p>
+            <a:pPr algn="l">
+              <a:lnSpc>
+                <a:spcPct val="105000"/>
+              </a:lnSpc>
+              <a:spcBef>
+                <a:spcPts val="0"/>
+              </a:spcBef>
+              <a:spcAft>
+                <a:spcPts val="1100"/>
+              </a:spcAft>
+            </a:pPr>
+            <a:r>
+              <a:rPr sz="2000" b="0" i="0">
+                <a:solidFill>
+                  <a:srgbClr val="1A1A1A"/>
                 </a:solidFill>
                 <a:latin typeface="Arial"/>
               </a:rPr>
-              <a:t>(1)</a:t>
-            </a:r>
-            <a:r>
-              <a:rPr sz="1800" b="0" i="0">
-                <a:solidFill>
-                  <a:srgbClr val="1A1A1A"/>
-                </a:solidFill>
-                <a:latin typeface="Arial"/>
-              </a:rPr>
-              <a:t> open above prior high, </a:t>
-            </a:r>
-            <a:r>
-              <a:rPr sz="1800" b="1" i="0">
-                <a:solidFill>
-                  <a:srgbClr val="C62828"/>
-                </a:solidFill>
-                <a:latin typeface="Arial"/>
-              </a:rPr>
-              <a:t>(2)</a:t>
-            </a:r>
-            <a:r>
-              <a:rPr sz="1800" b="0" i="0">
-                <a:solidFill>
-                  <a:srgbClr val="1A1A1A"/>
-                </a:solidFill>
-                <a:latin typeface="Arial"/>
-              </a:rPr>
-              <a:t> new high, </a:t>
-            </a:r>
-            <a:r>
-              <a:rPr sz="1800" b="1" i="0">
-                <a:solidFill>
-                  <a:srgbClr val="1F5FAD"/>
-                </a:solidFill>
-                <a:latin typeface="Arial"/>
-              </a:rPr>
-              <a:t>(3)</a:t>
-            </a:r>
-            <a:r>
-              <a:rPr sz="1800" b="0" i="0">
-                <a:solidFill>
-                  <a:srgbClr val="1A1A1A"/>
-                </a:solidFill>
-                <a:latin typeface="Arial"/>
-              </a:rPr>
-              <a:t> close below prior close (Lim, p. 219).</a:t>
-            </a:r>
-          </a:p>
-          <a:p>
-            <a:pPr algn="l">
-              <a:lnSpc>
-                <a:spcPct val="105000"/>
-              </a:lnSpc>
-              <a:spcBef>
-                <a:spcPts val="0"/>
-              </a:spcBef>
-              <a:spcAft>
-                <a:spcPts val="1100"/>
-              </a:spcAft>
-            </a:pPr>
-            <a:r>
-              <a:rPr sz="1800" b="0" i="0">
-                <a:solidFill>
-                  <a:srgbClr val="1A1A1A"/>
-                </a:solidFill>
-                <a:latin typeface="Arial"/>
-              </a:rPr>
-              <a:t>Meaning/action: potential warning; consolidation may precede decline. Check Lim's 16-item p. 217 list, recalled in Chapter 5 slide “16 Volume and Price Action Reversal Characteristics”, and barrier context from “Barrier proximity”. No indicator formulas here. Next, compare the bullish converse.</a:t>
+              <a:t>Meaning/action: this is a potential warning, not a promise. The book's chart shows consolidation may precede decline. Next, compare the bullish converse.</a:t>
             </a:r>
           </a:p>
         </p:txBody>
@@ -13619,6 +13795,35 @@
         </p:nvSpPr>
         <p:spPr>
           <a:xfrm>
+            <a:off x="9151757" y="4633081"/>
+            <a:ext cx="243259" cy="316016"/>
+          </a:xfrm>
+          <a:prstGeom prst="ellipse">
+            <a:avLst/>
+          </a:prstGeom>
+          <a:noFill/>
+          <a:ln w="44450">
+            <a:solidFill>
+              <a:srgbClr val="7B3FA0"/>
+            </a:solidFill>
+          </a:ln>
+        </p:spPr>
+        <p:txBody>
+          <a:bodyPr rtlCol="0" anchor="ctr"/>
+          <a:lstStyle/>
+          <a:p>
+            <a:pPr algn="ctr"/>
+          </a:p>
+        </p:txBody>
+      </p:sp>
+      <p:sp>
+        <p:nvSpPr>
+          <p:cNvPr id="16" name="Oval 15"/>
+          <p:cNvSpPr/>
+          <p:nvPr/>
+        </p:nvSpPr>
+        <p:spPr>
+          <a:xfrm>
             <a:off x="8608561" y="1961753"/>
             <a:ext cx="356616" cy="356616"/>
           </a:xfrm>
@@ -13664,7 +13869,7 @@
       </p:sp>
       <p:sp>
         <p:nvSpPr>
-          <p:cNvPr id="16" name="Oval 15"/>
+          <p:cNvPr id="17" name="Oval 16"/>
           <p:cNvSpPr/>
           <p:nvPr/>
         </p:nvSpPr>
@@ -13715,7 +13920,7 @@
       </p:sp>
       <p:sp>
         <p:nvSpPr>
-          <p:cNvPr id="17" name="Oval 16"/>
+          <p:cNvPr id="18" name="Oval 17"/>
           <p:cNvSpPr/>
           <p:nvPr/>
         </p:nvSpPr>
@@ -13766,7 +13971,58 @@
       </p:sp>
       <p:sp>
         <p:nvSpPr>
-          <p:cNvPr id="18" name="TextBox 17"/>
+          <p:cNvPr id="19" name="Oval 18"/>
+          <p:cNvSpPr/>
+          <p:nvPr/>
+        </p:nvSpPr>
+        <p:spPr>
+          <a:xfrm>
+            <a:off x="9796046" y="4732568"/>
+            <a:ext cx="292608" cy="292608"/>
+          </a:xfrm>
+          <a:prstGeom prst="ellipse">
+            <a:avLst/>
+          </a:prstGeom>
+          <a:solidFill>
+            <a:srgbClr val="7B3FA0"/>
+          </a:solidFill>
+          <a:ln w="12700">
+            <a:solidFill>
+              <a:srgbClr val="FFFFFF"/>
+            </a:solidFill>
+          </a:ln>
+          <a:effectLst/>
+        </p:spPr>
+        <p:txBody>
+          <a:bodyPr rtlCol="0" anchor="ctr" wrap="none" lIns="0" rIns="0" tIns="0" bIns="0"/>
+          <a:lstStyle/>
+          <a:p>
+            <a:pPr algn="ctr">
+              <a:lnSpc>
+                <a:spcPct val="100000"/>
+              </a:lnSpc>
+              <a:spcBef>
+                <a:spcPts val="0"/>
+              </a:spcBef>
+              <a:spcAft>
+                <a:spcPts val="0"/>
+              </a:spcAft>
+            </a:pPr>
+            <a:r>
+              <a:rPr sz="1300" b="1" i="0">
+                <a:solidFill>
+                  <a:srgbClr val="FFFFFF"/>
+                </a:solidFill>
+                <a:latin typeface="Arial"/>
+              </a:rPr>
+              <a:t>4</a:t>
+            </a:r>
+          </a:p>
+        </p:txBody>
+      </p:sp>
+      <p:sp>
+        <p:nvSpPr>
+          <p:cNvPr id="20" name="TextBox 19"/>
           <p:cNvSpPr txBox="1"/>
           <p:nvPr/>
         </p:nvSpPr>
@@ -13811,7 +14067,7 @@
       </p:sp>
       <p:sp>
         <p:nvSpPr>
-          <p:cNvPr id="19" name="TextBox 18"/>
+          <p:cNvPr id="21" name="TextBox 20"/>
           <p:cNvSpPr txBox="1"/>
           <p:nvPr/>
         </p:nvSpPr>

</xml_diff>

<commit_message>
Clarify Chapter 7 key reversal samples
</commit_message>
<xml_diff>
--- a/chapter-07/FIN1209-Chapter-07.pptx
+++ b/chapter-07/FIN1209-Chapter-07.pptx
@@ -1495,13 +1495,13 @@
           <a:p>
             <a:r>
               <a:rPr sz="1400"/>
-              <a:t>- Read the prior high and prior close lines before reading marks 1 to 3.</a:t>
+              <a:t>- Read the prior high and prior close lines before reading marks 1 to 4.</a:t>
             </a:r>
           </a:p>
           <a:p>
             <a:r>
               <a:rPr sz="1400"/>
-              <a:t>- The second bar opens above 52.00, reaches a new high of 53.20, and closes at 50.80, below the prior close of 51.10.</a:t>
+              <a:t>- The second bar opens above 52.00, reaches a new high of 53.20, and closes at 50.80, below the prior close of 51.10. Mark 4 identifies the 4.2 million-share volume bar.</a:t>
             </a:r>
           </a:p>
         </p:txBody>
@@ -1572,13 +1572,13 @@
           <a:p>
             <a:r>
               <a:rPr sz="1400"/>
-              <a:t>- Read the worked PHP example first. Then use the crop to locate the same three actions in the book's chart.</a:t>
+              <a:t>- Read the book's definition first, then explain marks 1 to 4 in the same order: gap/open, new high, close, and above-average volume.</a:t>
             </a:r>
           </a:p>
           <a:p>
             <a:r>
               <a:rPr sz="1400"/>
-              <a:t>- The three marks identify open, new high, and close. The later bars show that the decline does not have to be immediate.</a:t>
+              <a:t>- The figure shows consolidation before the later decline. Keep the word potentially: this is a warning, not a promise.</a:t>
             </a:r>
           </a:p>
         </p:txBody>
@@ -6493,35 +6493,6 @@
         </p:nvSpPr>
         <p:spPr>
           <a:xfrm>
-            <a:off x="8765092" y="4494276"/>
-            <a:ext cx="285069" cy="370331"/>
-          </a:xfrm>
-          <a:prstGeom prst="ellipse">
-            <a:avLst/>
-          </a:prstGeom>
-          <a:noFill/>
-          <a:ln w="44450">
-            <a:solidFill>
-              <a:srgbClr val="7B3FA0"/>
-            </a:solidFill>
-          </a:ln>
-        </p:spPr>
-        <p:txBody>
-          <a:bodyPr rtlCol="0" anchor="ctr"/>
-          <a:lstStyle/>
-          <a:p>
-            <a:pPr algn="ctr"/>
-          </a:p>
-        </p:txBody>
-      </p:sp>
-      <p:sp>
-        <p:nvSpPr>
-          <p:cNvPr id="22" name="Oval 21"/>
-          <p:cNvSpPr/>
-          <p:nvPr/>
-        </p:nvSpPr>
-        <p:spPr>
-          <a:xfrm>
             <a:off x="8159180" y="1394460"/>
             <a:ext cx="356616" cy="356616"/>
           </a:xfrm>
@@ -6567,7 +6538,7 @@
       </p:sp>
       <p:sp>
         <p:nvSpPr>
-          <p:cNvPr id="23" name="Oval 22"/>
+          <p:cNvPr id="22" name="Oval 21"/>
           <p:cNvSpPr/>
           <p:nvPr/>
         </p:nvSpPr>
@@ -6618,7 +6589,7 @@
       </p:sp>
       <p:sp>
         <p:nvSpPr>
-          <p:cNvPr id="24" name="Oval 23"/>
+          <p:cNvPr id="23" name="Oval 22"/>
           <p:cNvSpPr/>
           <p:nvPr/>
         </p:nvSpPr>
@@ -6669,58 +6640,7 @@
       </p:sp>
       <p:sp>
         <p:nvSpPr>
-          <p:cNvPr id="25" name="Oval 24"/>
-          <p:cNvSpPr/>
-          <p:nvPr/>
-        </p:nvSpPr>
-        <p:spPr>
-          <a:xfrm>
-            <a:off x="9545264" y="4636008"/>
-            <a:ext cx="292608" cy="292608"/>
-          </a:xfrm>
-          <a:prstGeom prst="ellipse">
-            <a:avLst/>
-          </a:prstGeom>
-          <a:solidFill>
-            <a:srgbClr val="7B3FA0"/>
-          </a:solidFill>
-          <a:ln w="12700">
-            <a:solidFill>
-              <a:srgbClr val="FFFFFF"/>
-            </a:solidFill>
-          </a:ln>
-          <a:effectLst/>
-        </p:spPr>
-        <p:txBody>
-          <a:bodyPr rtlCol="0" anchor="ctr" wrap="none" lIns="0" rIns="0" tIns="0" bIns="0"/>
-          <a:lstStyle/>
-          <a:p>
-            <a:pPr algn="ctr">
-              <a:lnSpc>
-                <a:spcPct val="100000"/>
-              </a:lnSpc>
-              <a:spcBef>
-                <a:spcPts val="0"/>
-              </a:spcBef>
-              <a:spcAft>
-                <a:spcPts val="0"/>
-              </a:spcAft>
-            </a:pPr>
-            <a:r>
-              <a:rPr sz="1300" b="1" i="0">
-                <a:solidFill>
-                  <a:srgbClr val="FFFFFF"/>
-                </a:solidFill>
-                <a:latin typeface="Arial"/>
-              </a:rPr>
-              <a:t>4</a:t>
-            </a:r>
-          </a:p>
-        </p:txBody>
-      </p:sp>
-      <p:sp>
-        <p:nvSpPr>
-          <p:cNvPr id="26" name="TextBox 25"/>
+          <p:cNvPr id="24" name="TextBox 23"/>
           <p:cNvSpPr txBox="1"/>
           <p:nvPr/>
         </p:nvSpPr>
@@ -6765,7 +6685,7 @@
       </p:sp>
       <p:sp>
         <p:nvSpPr>
-          <p:cNvPr id="27" name="TextBox 26"/>
+          <p:cNvPr id="25" name="TextBox 24"/>
           <p:cNvSpPr txBox="1"/>
           <p:nvPr/>
         </p:nvSpPr>
@@ -7584,35 +7504,6 @@
         </p:nvSpPr>
         <p:spPr>
           <a:xfrm>
-            <a:off x="8759391" y="4494276"/>
-            <a:ext cx="296472" cy="370331"/>
-          </a:xfrm>
-          <a:prstGeom prst="ellipse">
-            <a:avLst/>
-          </a:prstGeom>
-          <a:noFill/>
-          <a:ln w="44450">
-            <a:solidFill>
-              <a:srgbClr val="7B3FA0"/>
-            </a:solidFill>
-          </a:ln>
-        </p:spPr>
-        <p:txBody>
-          <a:bodyPr rtlCol="0" anchor="ctr"/>
-          <a:lstStyle/>
-          <a:p>
-            <a:pPr algn="ctr"/>
-          </a:p>
-        </p:txBody>
-      </p:sp>
-      <p:sp>
-        <p:nvSpPr>
-          <p:cNvPr id="22" name="Oval 21"/>
-          <p:cNvSpPr/>
-          <p:nvPr/>
-        </p:nvSpPr>
-        <p:spPr>
-          <a:xfrm>
             <a:off x="8136375" y="1394460"/>
             <a:ext cx="356616" cy="356616"/>
           </a:xfrm>
@@ -7658,7 +7549,7 @@
       </p:sp>
       <p:sp>
         <p:nvSpPr>
-          <p:cNvPr id="23" name="Oval 22"/>
+          <p:cNvPr id="22" name="Oval 21"/>
           <p:cNvSpPr/>
           <p:nvPr/>
         </p:nvSpPr>
@@ -7709,7 +7600,7 @@
       </p:sp>
       <p:sp>
         <p:nvSpPr>
-          <p:cNvPr id="24" name="Oval 23"/>
+          <p:cNvPr id="23" name="Oval 22"/>
           <p:cNvSpPr/>
           <p:nvPr/>
         </p:nvSpPr>
@@ -7760,58 +7651,7 @@
       </p:sp>
       <p:sp>
         <p:nvSpPr>
-          <p:cNvPr id="25" name="Oval 24"/>
-          <p:cNvSpPr/>
-          <p:nvPr/>
-        </p:nvSpPr>
-        <p:spPr>
-          <a:xfrm>
-            <a:off x="9576622" y="4636008"/>
-            <a:ext cx="292608" cy="292608"/>
-          </a:xfrm>
-          <a:prstGeom prst="ellipse">
-            <a:avLst/>
-          </a:prstGeom>
-          <a:solidFill>
-            <a:srgbClr val="7B3FA0"/>
-          </a:solidFill>
-          <a:ln w="12700">
-            <a:solidFill>
-              <a:srgbClr val="FFFFFF"/>
-            </a:solidFill>
-          </a:ln>
-          <a:effectLst/>
-        </p:spPr>
-        <p:txBody>
-          <a:bodyPr rtlCol="0" anchor="ctr" wrap="none" lIns="0" rIns="0" tIns="0" bIns="0"/>
-          <a:lstStyle/>
-          <a:p>
-            <a:pPr algn="ctr">
-              <a:lnSpc>
-                <a:spcPct val="100000"/>
-              </a:lnSpc>
-              <a:spcBef>
-                <a:spcPts val="0"/>
-              </a:spcBef>
-              <a:spcAft>
-                <a:spcPts val="0"/>
-              </a:spcAft>
-            </a:pPr>
-            <a:r>
-              <a:rPr sz="1300" b="1" i="0">
-                <a:solidFill>
-                  <a:srgbClr val="FFFFFF"/>
-                </a:solidFill>
-                <a:latin typeface="Arial"/>
-              </a:rPr>
-              <a:t>4</a:t>
-            </a:r>
-          </a:p>
-        </p:txBody>
-      </p:sp>
-      <p:sp>
-        <p:nvSpPr>
-          <p:cNvPr id="26" name="TextBox 25"/>
+          <p:cNvPr id="24" name="TextBox 23"/>
           <p:cNvSpPr txBox="1"/>
           <p:nvPr/>
         </p:nvSpPr>
@@ -7856,7 +7696,7 @@
       </p:sp>
       <p:sp>
         <p:nvSpPr>
-          <p:cNvPr id="27" name="TextBox 26"/>
+          <p:cNvPr id="25" name="TextBox 24"/>
           <p:cNvSpPr txBox="1"/>
           <p:nvPr/>
         </p:nvSpPr>
@@ -8789,35 +8629,6 @@
         </p:nvSpPr>
         <p:spPr>
           <a:xfrm>
-            <a:off x="8765092" y="4494276"/>
-            <a:ext cx="285069" cy="370331"/>
-          </a:xfrm>
-          <a:prstGeom prst="ellipse">
-            <a:avLst/>
-          </a:prstGeom>
-          <a:noFill/>
-          <a:ln w="44450">
-            <a:solidFill>
-              <a:srgbClr val="7B3FA0"/>
-            </a:solidFill>
-          </a:ln>
-        </p:spPr>
-        <p:txBody>
-          <a:bodyPr rtlCol="0" anchor="ctr"/>
-          <a:lstStyle/>
-          <a:p>
-            <a:pPr algn="ctr"/>
-          </a:p>
-        </p:txBody>
-      </p:sp>
-      <p:sp>
-        <p:nvSpPr>
-          <p:cNvPr id="22" name="Oval 21"/>
-          <p:cNvSpPr/>
-          <p:nvPr/>
-        </p:nvSpPr>
-        <p:spPr>
-          <a:xfrm>
             <a:off x="8159180" y="1394460"/>
             <a:ext cx="356616" cy="356616"/>
           </a:xfrm>
@@ -8863,7 +8674,7 @@
       </p:sp>
       <p:sp>
         <p:nvSpPr>
-          <p:cNvPr id="23" name="Oval 22"/>
+          <p:cNvPr id="22" name="Oval 21"/>
           <p:cNvSpPr/>
           <p:nvPr/>
         </p:nvSpPr>
@@ -8914,7 +8725,7 @@
       </p:sp>
       <p:sp>
         <p:nvSpPr>
-          <p:cNvPr id="24" name="Oval 23"/>
+          <p:cNvPr id="23" name="Oval 22"/>
           <p:cNvSpPr/>
           <p:nvPr/>
         </p:nvSpPr>
@@ -8965,58 +8776,7 @@
       </p:sp>
       <p:sp>
         <p:nvSpPr>
-          <p:cNvPr id="25" name="Oval 24"/>
-          <p:cNvSpPr/>
-          <p:nvPr/>
-        </p:nvSpPr>
-        <p:spPr>
-          <a:xfrm>
-            <a:off x="9545264" y="4636008"/>
-            <a:ext cx="292608" cy="292608"/>
-          </a:xfrm>
-          <a:prstGeom prst="ellipse">
-            <a:avLst/>
-          </a:prstGeom>
-          <a:solidFill>
-            <a:srgbClr val="7B3FA0"/>
-          </a:solidFill>
-          <a:ln w="12700">
-            <a:solidFill>
-              <a:srgbClr val="FFFFFF"/>
-            </a:solidFill>
-          </a:ln>
-          <a:effectLst/>
-        </p:spPr>
-        <p:txBody>
-          <a:bodyPr rtlCol="0" anchor="ctr" wrap="none" lIns="0" rIns="0" tIns="0" bIns="0"/>
-          <a:lstStyle/>
-          <a:p>
-            <a:pPr algn="ctr">
-              <a:lnSpc>
-                <a:spcPct val="100000"/>
-              </a:lnSpc>
-              <a:spcBef>
-                <a:spcPts val="0"/>
-              </a:spcBef>
-              <a:spcAft>
-                <a:spcPts val="0"/>
-              </a:spcAft>
-            </a:pPr>
-            <a:r>
-              <a:rPr sz="1300" b="1" i="0">
-                <a:solidFill>
-                  <a:srgbClr val="FFFFFF"/>
-                </a:solidFill>
-                <a:latin typeface="Arial"/>
-              </a:rPr>
-              <a:t>4</a:t>
-            </a:r>
-          </a:p>
-        </p:txBody>
-      </p:sp>
-      <p:sp>
-        <p:nvSpPr>
-          <p:cNvPr id="26" name="TextBox 25"/>
+          <p:cNvPr id="24" name="TextBox 23"/>
           <p:cNvSpPr txBox="1"/>
           <p:nvPr/>
         </p:nvSpPr>
@@ -9061,7 +8821,7 @@
       </p:sp>
       <p:sp>
         <p:nvSpPr>
-          <p:cNvPr id="27" name="TextBox 26"/>
+          <p:cNvPr id="25" name="TextBox 24"/>
           <p:cNvSpPr txBox="1"/>
           <p:nvPr/>
         </p:nvSpPr>
@@ -9880,35 +9640,6 @@
         </p:nvSpPr>
         <p:spPr>
           <a:xfrm>
-            <a:off x="8759391" y="4494276"/>
-            <a:ext cx="296472" cy="370331"/>
-          </a:xfrm>
-          <a:prstGeom prst="ellipse">
-            <a:avLst/>
-          </a:prstGeom>
-          <a:noFill/>
-          <a:ln w="44450">
-            <a:solidFill>
-              <a:srgbClr val="7B3FA0"/>
-            </a:solidFill>
-          </a:ln>
-        </p:spPr>
-        <p:txBody>
-          <a:bodyPr rtlCol="0" anchor="ctr"/>
-          <a:lstStyle/>
-          <a:p>
-            <a:pPr algn="ctr"/>
-          </a:p>
-        </p:txBody>
-      </p:sp>
-      <p:sp>
-        <p:nvSpPr>
-          <p:cNvPr id="22" name="Oval 21"/>
-          <p:cNvSpPr/>
-          <p:nvPr/>
-        </p:nvSpPr>
-        <p:spPr>
-          <a:xfrm>
             <a:off x="8136375" y="1394460"/>
             <a:ext cx="356616" cy="356616"/>
           </a:xfrm>
@@ -9954,7 +9685,7 @@
       </p:sp>
       <p:sp>
         <p:nvSpPr>
-          <p:cNvPr id="23" name="Oval 22"/>
+          <p:cNvPr id="22" name="Oval 21"/>
           <p:cNvSpPr/>
           <p:nvPr/>
         </p:nvSpPr>
@@ -10005,7 +9736,7 @@
       </p:sp>
       <p:sp>
         <p:nvSpPr>
-          <p:cNvPr id="24" name="Oval 23"/>
+          <p:cNvPr id="23" name="Oval 22"/>
           <p:cNvSpPr/>
           <p:nvPr/>
         </p:nvSpPr>
@@ -10056,58 +9787,7 @@
       </p:sp>
       <p:sp>
         <p:nvSpPr>
-          <p:cNvPr id="25" name="Oval 24"/>
-          <p:cNvSpPr/>
-          <p:nvPr/>
-        </p:nvSpPr>
-        <p:spPr>
-          <a:xfrm>
-            <a:off x="9576622" y="4636008"/>
-            <a:ext cx="292608" cy="292608"/>
-          </a:xfrm>
-          <a:prstGeom prst="ellipse">
-            <a:avLst/>
-          </a:prstGeom>
-          <a:solidFill>
-            <a:srgbClr val="7B3FA0"/>
-          </a:solidFill>
-          <a:ln w="12700">
-            <a:solidFill>
-              <a:srgbClr val="FFFFFF"/>
-            </a:solidFill>
-          </a:ln>
-          <a:effectLst/>
-        </p:spPr>
-        <p:txBody>
-          <a:bodyPr rtlCol="0" anchor="ctr" wrap="none" lIns="0" rIns="0" tIns="0" bIns="0"/>
-          <a:lstStyle/>
-          <a:p>
-            <a:pPr algn="ctr">
-              <a:lnSpc>
-                <a:spcPct val="100000"/>
-              </a:lnSpc>
-              <a:spcBef>
-                <a:spcPts val="0"/>
-              </a:spcBef>
-              <a:spcAft>
-                <a:spcPts val="0"/>
-              </a:spcAft>
-            </a:pPr>
-            <a:r>
-              <a:rPr sz="1300" b="1" i="0">
-                <a:solidFill>
-                  <a:srgbClr val="FFFFFF"/>
-                </a:solidFill>
-                <a:latin typeface="Arial"/>
-              </a:rPr>
-              <a:t>4</a:t>
-            </a:r>
-          </a:p>
-        </p:txBody>
-      </p:sp>
-      <p:sp>
-        <p:nvSpPr>
-          <p:cNvPr id="26" name="TextBox 25"/>
+          <p:cNvPr id="24" name="TextBox 23"/>
           <p:cNvSpPr txBox="1"/>
           <p:nvPr/>
         </p:nvSpPr>
@@ -10152,7 +9832,7 @@
       </p:sp>
       <p:sp>
         <p:nvSpPr>
-          <p:cNvPr id="27" name="TextBox 26"/>
+          <p:cNvPr id="25" name="TextBox 24"/>
           <p:cNvSpPr txBox="1"/>
           <p:nvPr/>
         </p:nvSpPr>
@@ -12786,7 +12466,7 @@
         <p:spPr>
           <a:xfrm>
             <a:off x="777240" y="1965960"/>
-            <a:ext cx="3200400" cy="3108960"/>
+            <a:ext cx="3886200" cy="3108960"/>
           </a:xfrm>
           <a:prstGeom prst="rect">
             <a:avLst/>
@@ -12811,13 +12491,13 @@
               </a:spcAft>
             </a:pPr>
             <a:r>
-              <a:rPr sz="1800" b="0" i="0">
+              <a:rPr sz="1600" b="0" i="0">
                 <a:solidFill>
                   <a:srgbClr val="1A1A1A"/>
                 </a:solidFill>
                 <a:latin typeface="Arial"/>
               </a:rPr>
-              <a:t>Step 1. The prior bar opens at 50.80, reaches a high of 52.00, falls to a low of 50.60, and closes at 51.10.</a:t>
+              <a:t>Step 1. Prior bar: open 50.80, high 52.00, low 50.60, close 51.10.</a:t>
             </a:r>
           </a:p>
           <a:p>
@@ -12833,13 +12513,31 @@
               </a:spcAft>
             </a:pPr>
             <a:r>
-              <a:rPr sz="1800" b="0" i="0">
+              <a:rPr sz="1600" b="0" i="0">
                 <a:solidFill>
                   <a:srgbClr val="1A1A1A"/>
                 </a:solidFill>
                 <a:latin typeface="Arial"/>
               </a:rPr>
-              <a:t>Step 2. The new bar opens at 52.30, above the prior high of 52.00.</a:t>
+              <a:t>Step 2. It opens at 52.30 above prior high 52.00 </a:t>
+            </a:r>
+            <a:r>
+              <a:rPr sz="1600" b="1" i="0">
+                <a:solidFill>
+                  <a:srgbClr val="E09B00"/>
+                </a:solidFill>
+                <a:latin typeface="Arial"/>
+              </a:rPr>
+              <a:t>(1)</a:t>
+            </a:r>
+            <a:r>
+              <a:rPr sz="1600" b="0" i="0">
+                <a:solidFill>
+                  <a:srgbClr val="1A1A1A"/>
+                </a:solidFill>
+                <a:latin typeface="Arial"/>
+              </a:rPr>
+              <a:t>.</a:t>
             </a:r>
           </a:p>
           <a:p>
@@ -12855,13 +12553,111 @@
               </a:spcAft>
             </a:pPr>
             <a:r>
-              <a:rPr sz="1800" b="0" i="0">
+              <a:rPr sz="1600" b="0" i="0">
                 <a:solidFill>
                   <a:srgbClr val="1A1A1A"/>
                 </a:solidFill>
                 <a:latin typeface="Arial"/>
               </a:rPr>
-              <a:t>Step 3. It reaches a new high of 53.20, then falls to a low of 49.90.</a:t>
+              <a:t>Step 3. It makes a new high of 53.20 </a:t>
+            </a:r>
+            <a:r>
+              <a:rPr sz="1600" b="1" i="0">
+                <a:solidFill>
+                  <a:srgbClr val="C62828"/>
+                </a:solidFill>
+                <a:latin typeface="Arial"/>
+              </a:rPr>
+              <a:t>(2)</a:t>
+            </a:r>
+            <a:r>
+              <a:rPr sz="1600" b="0" i="0">
+                <a:solidFill>
+                  <a:srgbClr val="1A1A1A"/>
+                </a:solidFill>
+                <a:latin typeface="Arial"/>
+              </a:rPr>
+              <a:t>.</a:t>
+            </a:r>
+          </a:p>
+          <a:p>
+            <a:pPr algn="l">
+              <a:lnSpc>
+                <a:spcPct val="105000"/>
+              </a:lnSpc>
+              <a:spcBef>
+                <a:spcPts val="0"/>
+              </a:spcBef>
+              <a:spcAft>
+                <a:spcPts val="1100"/>
+              </a:spcAft>
+            </a:pPr>
+            <a:r>
+              <a:rPr sz="1600" b="0" i="0">
+                <a:solidFill>
+                  <a:srgbClr val="1A1A1A"/>
+                </a:solidFill>
+                <a:latin typeface="Arial"/>
+              </a:rPr>
+              <a:t>Step 4. It closes at 50.80 below prior close 51.10 </a:t>
+            </a:r>
+            <a:r>
+              <a:rPr sz="1600" b="1" i="0">
+                <a:solidFill>
+                  <a:srgbClr val="1F5FAD"/>
+                </a:solidFill>
+                <a:latin typeface="Arial"/>
+              </a:rPr>
+              <a:t>(3)</a:t>
+            </a:r>
+            <a:r>
+              <a:rPr sz="1600" b="0" i="0">
+                <a:solidFill>
+                  <a:srgbClr val="1A1A1A"/>
+                </a:solidFill>
+                <a:latin typeface="Arial"/>
+              </a:rPr>
+              <a:t>.</a:t>
+            </a:r>
+          </a:p>
+          <a:p>
+            <a:pPr algn="l">
+              <a:lnSpc>
+                <a:spcPct val="105000"/>
+              </a:lnSpc>
+              <a:spcBef>
+                <a:spcPts val="0"/>
+              </a:spcBef>
+              <a:spcAft>
+                <a:spcPts val="1100"/>
+              </a:spcAft>
+            </a:pPr>
+            <a:r>
+              <a:rPr sz="1600" b="0" i="0">
+                <a:solidFill>
+                  <a:srgbClr val="1A1A1A"/>
+                </a:solidFill>
+                <a:latin typeface="Arial"/>
+              </a:rPr>
+              <a:t>Step 5. Volume is 4.2 million versus 2.0 million </a:t>
+            </a:r>
+            <a:r>
+              <a:rPr sz="1600" b="1" i="0">
+                <a:solidFill>
+                  <a:srgbClr val="7B3FA0"/>
+                </a:solidFill>
+                <a:latin typeface="Arial"/>
+              </a:rPr>
+              <a:t>(4)</a:t>
+            </a:r>
+            <a:r>
+              <a:rPr sz="1600" b="0" i="0">
+                <a:solidFill>
+                  <a:srgbClr val="1A1A1A"/>
+                </a:solidFill>
+                <a:latin typeface="Arial"/>
+              </a:rPr>
+              <a:t>. That is a bearish key reversal (Lim, p. 218).</a:t>
             </a:r>
           </a:p>
         </p:txBody>
@@ -12874,8 +12670,8 @@
         </p:nvSpPr>
         <p:spPr>
           <a:xfrm>
-            <a:off x="4390491" y="1810512"/>
-            <a:ext cx="7754112" cy="3749039"/>
+            <a:off x="4983479" y="1810512"/>
+            <a:ext cx="6430975" cy="3130932"/>
           </a:xfrm>
           <a:prstGeom prst="rect">
             <a:avLst/>
@@ -12914,8 +12710,8 @@
         </p:blipFill>
         <p:spPr>
           <a:xfrm>
-            <a:off x="4509363" y="1929384"/>
-            <a:ext cx="7516368" cy="3511296"/>
+            <a:off x="5102351" y="1929384"/>
+            <a:ext cx="6193231" cy="2893188"/>
           </a:xfrm>
           <a:prstGeom prst="rect">
             <a:avLst/>
@@ -12930,8 +12726,8 @@
         </p:nvSpPr>
         <p:spPr>
           <a:xfrm>
-            <a:off x="9319839" y="2947659"/>
-            <a:ext cx="375818" cy="175564"/>
+            <a:off x="9066019" y="2768408"/>
+            <a:ext cx="309661" cy="144659"/>
           </a:xfrm>
           <a:prstGeom prst="ellipse">
             <a:avLst/>
@@ -12959,8 +12755,8 @@
         </p:nvSpPr>
         <p:spPr>
           <a:xfrm>
-            <a:off x="9319839" y="2561417"/>
-            <a:ext cx="375818" cy="175564"/>
+            <a:off x="9066019" y="2450157"/>
+            <a:ext cx="309661" cy="144659"/>
           </a:xfrm>
           <a:prstGeom prst="ellipse">
             <a:avLst/>
@@ -12988,8 +12784,8 @@
         </p:nvSpPr>
         <p:spPr>
           <a:xfrm>
-            <a:off x="9319839" y="3755257"/>
-            <a:ext cx="375818" cy="175564"/>
+            <a:off x="9066019" y="3433841"/>
+            <a:ext cx="309661" cy="144659"/>
           </a:xfrm>
           <a:prstGeom prst="ellipse">
             <a:avLst/>
@@ -13017,7 +12813,36 @@
         </p:nvSpPr>
         <p:spPr>
           <a:xfrm>
-            <a:off x="8262426" y="2967776"/>
+            <a:off x="9066019" y="4186070"/>
+            <a:ext cx="371593" cy="173591"/>
+          </a:xfrm>
+          <a:prstGeom prst="ellipse">
+            <a:avLst/>
+          </a:prstGeom>
+          <a:noFill/>
+          <a:ln w="44450">
+            <a:solidFill>
+              <a:srgbClr val="7B3FA0"/>
+            </a:solidFill>
+          </a:ln>
+        </p:spPr>
+        <p:txBody>
+          <a:bodyPr rtlCol="0" anchor="ctr"/>
+          <a:lstStyle/>
+          <a:p>
+            <a:pPr algn="ctr"/>
+          </a:p>
+        </p:txBody>
+      </p:sp>
+      <p:sp>
+        <p:nvSpPr>
+          <p:cNvPr id="14" name="Oval 13"/>
+          <p:cNvSpPr/>
+          <p:nvPr/>
+        </p:nvSpPr>
+        <p:spPr>
+          <a:xfrm>
+            <a:off x="8167384" y="2757619"/>
             <a:ext cx="310896" cy="310896"/>
           </a:xfrm>
           <a:prstGeom prst="ellipse">
@@ -13062,13 +12887,13 @@
       </p:sp>
       <p:sp>
         <p:nvSpPr>
-          <p:cNvPr id="14" name="Oval 13"/>
+          <p:cNvPr id="15" name="Oval 14"/>
           <p:cNvSpPr/>
           <p:nvPr/>
         </p:nvSpPr>
         <p:spPr>
           <a:xfrm>
-            <a:off x="10141518" y="2230404"/>
+            <a:off x="9715691" y="2150050"/>
             <a:ext cx="310896" cy="310896"/>
           </a:xfrm>
           <a:prstGeom prst="ellipse">
@@ -13113,13 +12938,13 @@
       </p:sp>
       <p:sp>
         <p:nvSpPr>
-          <p:cNvPr id="15" name="Oval 14"/>
+          <p:cNvPr id="16" name="Oval 15"/>
           <p:cNvSpPr/>
           <p:nvPr/>
         </p:nvSpPr>
         <p:spPr>
           <a:xfrm>
-            <a:off x="10141518" y="3950939"/>
+            <a:off x="9715691" y="3567712"/>
             <a:ext cx="310896" cy="310896"/>
           </a:xfrm>
           <a:prstGeom prst="ellipse">
@@ -13164,14 +12989,65 @@
       </p:sp>
       <p:sp>
         <p:nvSpPr>
-          <p:cNvPr id="16" name="TextBox 15"/>
+          <p:cNvPr id="17" name="Oval 16"/>
+          <p:cNvSpPr/>
+          <p:nvPr/>
+        </p:nvSpPr>
+        <p:spPr>
+          <a:xfrm>
+            <a:off x="9910632" y="4329085"/>
+            <a:ext cx="292608" cy="292608"/>
+          </a:xfrm>
+          <a:prstGeom prst="ellipse">
+            <a:avLst/>
+          </a:prstGeom>
+          <a:solidFill>
+            <a:srgbClr val="7B3FA0"/>
+          </a:solidFill>
+          <a:ln w="12700">
+            <a:solidFill>
+              <a:srgbClr val="FFFFFF"/>
+            </a:solidFill>
+          </a:ln>
+          <a:effectLst/>
+        </p:spPr>
+        <p:txBody>
+          <a:bodyPr rtlCol="0" anchor="ctr" wrap="none" lIns="0" rIns="0" tIns="0" bIns="0"/>
+          <a:lstStyle/>
+          <a:p>
+            <a:pPr algn="ctr">
+              <a:lnSpc>
+                <a:spcPct val="100000"/>
+              </a:lnSpc>
+              <a:spcBef>
+                <a:spcPts val="0"/>
+              </a:spcBef>
+              <a:spcAft>
+                <a:spcPts val="0"/>
+              </a:spcAft>
+            </a:pPr>
+            <a:r>
+              <a:rPr sz="1300" b="1" i="0">
+                <a:solidFill>
+                  <a:srgbClr val="FFFFFF"/>
+                </a:solidFill>
+                <a:latin typeface="Arial"/>
+              </a:rPr>
+              <a:t>4</a:t>
+            </a:r>
+          </a:p>
+        </p:txBody>
+      </p:sp>
+      <p:sp>
+        <p:nvSpPr>
+          <p:cNvPr id="18" name="TextBox 17"/>
           <p:cNvSpPr txBox="1"/>
           <p:nvPr/>
         </p:nvSpPr>
         <p:spPr>
           <a:xfrm>
-            <a:off x="4297679" y="5650991"/>
-            <a:ext cx="7939735" cy="274320"/>
+            <a:off x="4983479" y="5032884"/>
+            <a:ext cx="6430975" cy="274320"/>
           </a:xfrm>
           <a:prstGeom prst="rect">
             <a:avLst/>
@@ -13196,7 +13072,7 @@
               </a:spcAft>
             </a:pPr>
             <a:r>
-              <a:rPr sz="1200" b="0" i="0">
+              <a:rPr sz="1000" b="0" i="0">
                 <a:solidFill>
                   <a:srgbClr val="818181"/>
                 </a:solidFill>
@@ -13209,7 +13085,7 @@
       </p:sp>
       <p:sp>
         <p:nvSpPr>
-          <p:cNvPr id="17" name="TextBox 16"/>
+          <p:cNvPr id="19" name="TextBox 18"/>
           <p:cNvSpPr txBox="1"/>
           <p:nvPr/>
         </p:nvSpPr>
@@ -13370,7 +13246,7 @@
                 </a:solidFill>
                 <a:latin typeface="Palatino"/>
               </a:rPr>
-              <a:t>Figure 7.15: three observations</a:t>
+              <a:t>Figure 7.15: the same reading on a real chart</a:t>
             </a:r>
           </a:p>
         </p:txBody>
@@ -13484,13 +13360,13 @@
               </a:spcAft>
             </a:pPr>
             <a:r>
-              <a:rPr sz="2000" b="0" i="0">
+              <a:rPr sz="1700" b="0" i="0">
                 <a:solidFill>
                   <a:srgbClr val="1A1A1A"/>
                 </a:solidFill>
                 <a:latin typeface="Arial"/>
               </a:rPr>
-              <a:t>Step 4. The new bar closes at 50.80, below the prior close of 51.10.</a:t>
+              <a:t>Lim defines it: “A bearish key reversal bar forms a higher high than the previous bar and closes near or below the close of the previous bar.” (Lim, p. 218).</a:t>
             </a:r>
           </a:p>
           <a:p>
@@ -13506,13 +13382,49 @@
               </a:spcAft>
             </a:pPr>
             <a:r>
-              <a:rPr sz="2000" b="0" i="0">
+              <a:rPr sz="1700" b="0" i="0">
                 <a:solidFill>
                   <a:srgbClr val="1A1A1A"/>
                 </a:solidFill>
                 <a:latin typeface="Arial"/>
               </a:rPr>
-              <a:t>Step 5. Volume is 4.2 million shares, versus 2.0 million on the prior bar. On Figure 7.15, mark 4 identifies the volume reading.</a:t>
+              <a:t>Gold </a:t>
+            </a:r>
+            <a:r>
+              <a:rPr sz="1700" b="1" i="0">
+                <a:solidFill>
+                  <a:srgbClr val="E09B00"/>
+                </a:solidFill>
+                <a:latin typeface="Arial"/>
+              </a:rPr>
+              <a:t>(1)</a:t>
+            </a:r>
+            <a:r>
+              <a:rPr sz="1700" b="0" i="0">
+                <a:solidFill>
+                  <a:srgbClr val="1A1A1A"/>
+                </a:solidFill>
+                <a:latin typeface="Arial"/>
+              </a:rPr>
+              <a:t> marks the key reversal day opening above the prior high. Red </a:t>
+            </a:r>
+            <a:r>
+              <a:rPr sz="1700" b="1" i="0">
+                <a:solidFill>
+                  <a:srgbClr val="C62828"/>
+                </a:solidFill>
+                <a:latin typeface="Arial"/>
+              </a:rPr>
+              <a:t>(2)</a:t>
+            </a:r>
+            <a:r>
+              <a:rPr sz="1700" b="0" i="0">
+                <a:solidFill>
+                  <a:srgbClr val="1A1A1A"/>
+                </a:solidFill>
+                <a:latin typeface="Arial"/>
+              </a:rPr>
+              <a:t> marks its new high.</a:t>
             </a:r>
           </a:p>
           <a:p>
@@ -13528,13 +13440,71 @@
               </a:spcAft>
             </a:pPr>
             <a:r>
-              <a:rPr sz="2000" b="0" i="0">
+              <a:rPr sz="1700" b="0" i="0">
                 <a:solidFill>
                   <a:srgbClr val="1A1A1A"/>
                 </a:solidFill>
                 <a:latin typeface="Arial"/>
               </a:rPr>
-              <a:t>Meaning/action: this is a potential warning, not a promise. The book's chart shows consolidation may precede decline. Next, compare the bullish converse.</a:t>
+              <a:t>Blue </a:t>
+            </a:r>
+            <a:r>
+              <a:rPr sz="1700" b="1" i="0">
+                <a:solidFill>
+                  <a:srgbClr val="1F5FAD"/>
+                </a:solidFill>
+                <a:latin typeface="Arial"/>
+              </a:rPr>
+              <a:t>(3)</a:t>
+            </a:r>
+            <a:r>
+              <a:rPr sz="1700" b="0" i="0">
+                <a:solidFill>
+                  <a:srgbClr val="1A1A1A"/>
+                </a:solidFill>
+                <a:latin typeface="Arial"/>
+              </a:rPr>
+              <a:t> marks its close below the prior close. Purple </a:t>
+            </a:r>
+            <a:r>
+              <a:rPr sz="1700" b="1" i="0">
+                <a:solidFill>
+                  <a:srgbClr val="7B3FA0"/>
+                </a:solidFill>
+                <a:latin typeface="Arial"/>
+              </a:rPr>
+              <a:t>(4)</a:t>
+            </a:r>
+            <a:r>
+              <a:rPr sz="1700" b="0" i="0">
+                <a:solidFill>
+                  <a:srgbClr val="1A1A1A"/>
+                </a:solidFill>
+                <a:latin typeface="Arial"/>
+              </a:rPr>
+              <a:t> marks the above-average volume under it.</a:t>
+            </a:r>
+          </a:p>
+          <a:p>
+            <a:pPr algn="l">
+              <a:lnSpc>
+                <a:spcPct val="105000"/>
+              </a:lnSpc>
+              <a:spcBef>
+                <a:spcPts val="0"/>
+              </a:spcBef>
+              <a:spcAft>
+                <a:spcPts val="1100"/>
+              </a:spcAft>
+            </a:pPr>
+            <a:r>
+              <a:rPr sz="1700" b="0" i="0">
+                <a:solidFill>
+                  <a:srgbClr val="1A1A1A"/>
+                </a:solidFill>
+                <a:latin typeface="Arial"/>
+              </a:rPr>
+              <a:t>Meaning/action: a potential warning, not a promise. The book's chart shows consolidation before the decline. Check the 16 characteristics and barrier proximity.</a:t>
             </a:r>
           </a:p>
         </p:txBody>
@@ -13695,7 +13665,7 @@
                 </a:solidFill>
                 <a:latin typeface="Palatino"/>
               </a:rPr>
-              <a:t>The Apple daily chart, cropped to the key reversal day and its surrounding bars. The marked bar opens above the previous high, forms a new high, and closes below the previous close.</a:t>
+              <a:t>The Apple daily chart, cropped to the key reversal day and its surrounding bars. The marked day opens above the previous high, forms a new high, closes below the previous close, and has above average volume.</a:t>
             </a:r>
           </a:p>
         </p:txBody>
@@ -14105,7 +14075,7 @@
                 </a:solidFill>
                 <a:latin typeface="Arial"/>
               </a:rPr>
-              <a:t>Lim (2016), pp. 218 to 219, Figure 7.15. The crop and marks are for teaching; the worked PHP values are ours, invented.</a:t>
+              <a:t>Lim (2016), pp. 218 to 219, Figure 7.15. The crop and marks are for teaching; no invented example is on this slide.</a:t>
             </a:r>
           </a:p>
         </p:txBody>

</xml_diff>

<commit_message>
Align Figure 7.15 sample marks
</commit_message>
<xml_diff>
--- a/chapter-07/FIN1209-Chapter-07.pptx
+++ b/chapter-07/FIN1209-Chapter-07.pptx
@@ -13517,8 +13517,8 @@
         </p:nvSpPr>
         <p:spPr>
           <a:xfrm>
-            <a:off x="7634145" y="1810512"/>
-            <a:ext cx="3278484" cy="3749039"/>
+            <a:off x="7949864" y="1810512"/>
+            <a:ext cx="2647045" cy="3749039"/>
           </a:xfrm>
           <a:prstGeom prst="rect">
             <a:avLst/>
@@ -13549,8 +13549,8 @@
         </p:nvSpPr>
         <p:spPr>
           <a:xfrm>
-            <a:off x="7753017" y="1929384"/>
-            <a:ext cx="3040740" cy="3511296"/>
+            <a:off x="8068736" y="1929384"/>
+            <a:ext cx="2409301" cy="3511296"/>
           </a:xfrm>
           <a:prstGeom prst="rect">
             <a:avLst/>
@@ -13581,8 +13581,8 @@
         </p:nvSpPr>
         <p:spPr>
           <a:xfrm>
-            <a:off x="7753017" y="1929384"/>
-            <a:ext cx="3040740" cy="50800"/>
+            <a:off x="8068736" y="1929384"/>
+            <a:ext cx="2409301" cy="50800"/>
           </a:xfrm>
           <a:prstGeom prst="rect">
             <a:avLst/>
@@ -13611,8 +13611,8 @@
         </p:nvSpPr>
         <p:spPr>
           <a:xfrm>
-            <a:off x="8027337" y="2203703"/>
-            <a:ext cx="2492100" cy="3054096"/>
+            <a:off x="8343056" y="2203703"/>
+            <a:ext cx="1860661" cy="3054096"/>
           </a:xfrm>
           <a:prstGeom prst="rect">
             <a:avLst/>
@@ -13659,7 +13659,7 @@
               </a:spcAft>
             </a:pPr>
             <a:r>
-              <a:rPr sz="1500" b="0" i="0">
+              <a:rPr sz="1300" b="0" i="0">
                 <a:solidFill>
                   <a:srgbClr val="1A1A1A"/>
                 </a:solidFill>
@@ -13678,8 +13678,8 @@
         </p:nvSpPr>
         <p:spPr>
           <a:xfrm>
-            <a:off x="9060535" y="2280513"/>
-            <a:ext cx="243259" cy="280903"/>
+            <a:off x="9225201" y="2157618"/>
+            <a:ext cx="192744" cy="140451"/>
           </a:xfrm>
           <a:prstGeom prst="ellipse">
             <a:avLst/>
@@ -13707,8 +13707,8 @@
         </p:nvSpPr>
         <p:spPr>
           <a:xfrm>
-            <a:off x="9182165" y="1999609"/>
-            <a:ext cx="212851" cy="280903"/>
+            <a:off x="9249294" y="2052279"/>
+            <a:ext cx="144558" cy="140451"/>
           </a:xfrm>
           <a:prstGeom prst="ellipse">
             <a:avLst/>
@@ -13736,8 +13736,8 @@
         </p:nvSpPr>
         <p:spPr>
           <a:xfrm>
-            <a:off x="9273387" y="2772095"/>
-            <a:ext cx="243259" cy="280903"/>
+            <a:off x="9297480" y="2456078"/>
+            <a:ext cx="192744" cy="158008"/>
           </a:xfrm>
           <a:prstGeom prst="ellipse">
             <a:avLst/>
@@ -13765,8 +13765,8 @@
         </p:nvSpPr>
         <p:spPr>
           <a:xfrm>
-            <a:off x="9151757" y="4633081"/>
-            <a:ext cx="243259" cy="316016"/>
+            <a:off x="9225201" y="4633081"/>
+            <a:ext cx="192744" cy="280903"/>
           </a:xfrm>
           <a:prstGeom prst="ellipse">
             <a:avLst/>
@@ -13794,8 +13794,8 @@
         </p:nvSpPr>
         <p:spPr>
           <a:xfrm>
-            <a:off x="8608561" y="1961753"/>
-            <a:ext cx="356616" cy="356616"/>
+            <a:off x="8533902" y="2108240"/>
+            <a:ext cx="274320" cy="274320"/>
           </a:xfrm>
           <a:prstGeom prst="ellipse">
             <a:avLst/>
@@ -13845,8 +13845,8 @@
         </p:nvSpPr>
         <p:spPr>
           <a:xfrm>
-            <a:off x="9490375" y="1786188"/>
-            <a:ext cx="356616" cy="356616"/>
+            <a:off x="9690366" y="2002901"/>
+            <a:ext cx="274320" cy="274320"/>
           </a:xfrm>
           <a:prstGeom prst="ellipse">
             <a:avLst/>
@@ -13896,8 +13896,8 @@
         </p:nvSpPr>
         <p:spPr>
           <a:xfrm>
-            <a:off x="9672820" y="2980029"/>
-            <a:ext cx="356616" cy="356616"/>
+            <a:off x="9738552" y="2564709"/>
+            <a:ext cx="274320" cy="274320"/>
           </a:xfrm>
           <a:prstGeom prst="ellipse">
             <a:avLst/>
@@ -13947,8 +13947,8 @@
         </p:nvSpPr>
         <p:spPr>
           <a:xfrm>
-            <a:off x="9796046" y="4732568"/>
-            <a:ext cx="292608" cy="292608"/>
+            <a:off x="9473529" y="4741712"/>
+            <a:ext cx="274320" cy="274320"/>
           </a:xfrm>
           <a:prstGeom prst="ellipse">
             <a:avLst/>

</xml_diff>

<commit_message>
Fix Chapter 7 second reader findings
</commit_message>
<xml_diff>
--- a/chapter-07/FIN1209-Chapter-07.pptx
+++ b/chapter-07/FIN1209-Chapter-07.pptx
@@ -761,7 +761,7 @@
           <a:p>
             <a:r>
               <a:rPr sz="1400"/>
-              <a:t>- Let students calculate before revealing. Both answers are stated in the preceding worked slides.</a:t>
+              <a:t>- Let students calculate before revealing. Both answers are stated in the preceding worked slides and the marked bar remains visible.</a:t>
             </a:r>
           </a:p>
           <a:p>
@@ -838,7 +838,7 @@
           <a:p>
             <a:r>
               <a:rPr sz="1400"/>
-              <a:t>- Let students calculate before revealing. Both answers are stated in the preceding worked slides.</a:t>
+              <a:t>- Let students calculate before revealing. Both answers are stated in the preceding worked slides and the marked bar remains visible.</a:t>
             </a:r>
           </a:p>
           <a:p>
@@ -1140,7 +1140,7 @@
           <a:p>
             <a:r>
               <a:rPr sz="1400"/>
-              <a:t>- Read the four cases as a table even though the text is linear. Keep potential for every directional expectation.</a:t>
+              <a:t>- Read the four cases as a table. Keep potential for every directional expectation.</a:t>
             </a:r>
           </a:p>
         </p:txBody>
@@ -5809,7 +5809,7 @@
               </a:spcAft>
             </a:pPr>
             <a:r>
-              <a:rPr sz="1600" b="0" i="0">
+              <a:rPr sz="1700" b="0" i="0">
                 <a:solidFill>
                   <a:srgbClr val="FFFFFF"/>
                 </a:solidFill>
@@ -6456,7 +6456,7 @@
         <p:spPr>
           <a:xfrm>
             <a:off x="777240" y="1965960"/>
-            <a:ext cx="4892040" cy="3108960"/>
+            <a:ext cx="5074920" cy="3108960"/>
           </a:xfrm>
           <a:prstGeom prst="rect">
             <a:avLst/>
@@ -6481,16 +6481,16 @@
               </a:spcAft>
             </a:pPr>
             <a:r>
-              <a:rPr sz="1600" b="0" i="0">
+              <a:rPr sz="1700" b="0" i="0">
                 <a:solidFill>
                   <a:srgbClr val="1A1A1A"/>
                 </a:solidFill>
                 <a:latin typeface="Arial"/>
               </a:rPr>
-              <a:t>Now combine the questions. Ours, invented: two bars make a double formation; the second closes at 49.80 below the first low of 50.20 </a:t>
-            </a:r>
-            <a:r>
-              <a:rPr sz="1600" b="1" i="0">
+              <a:t>Ours, invented: two bars make a double formation </a:t>
+            </a:r>
+            <a:r>
+              <a:rPr sz="1700" b="1" i="0">
                 <a:solidFill>
                   <a:srgbClr val="E09B00"/>
                 </a:solidFill>
@@ -6499,13 +6499,13 @@
               <a:t>(1)</a:t>
             </a:r>
             <a:r>
-              <a:rPr sz="1600" b="0" i="0">
+              <a:rPr sz="1700" b="0" i="0">
                 <a:solidFill>
                   <a:srgbClr val="1A1A1A"/>
                 </a:solidFill>
                 <a:latin typeface="Arial"/>
               </a:rPr>
-              <a:t>.</a:t>
+              <a:t>. The second closes at 49.80 below first low 50.20.</a:t>
             </a:r>
           </a:p>
           <a:p>
@@ -6521,16 +6521,16 @@
               </a:spcAft>
             </a:pPr>
             <a:r>
-              <a:rPr sz="1600" b="0" i="0">
+              <a:rPr sz="1700" b="0" i="0">
                 <a:solidFill>
                   <a:srgbClr val="1A1A1A"/>
                 </a:solidFill>
                 <a:latin typeface="Arial"/>
               </a:rPr>
-              <a:t>The second bar is intrinsically bearish </a:t>
-            </a:r>
-            <a:r>
-              <a:rPr sz="1600" b="1" i="0">
+              <a:t>The second bar's intrinsic sentiment is bearish </a:t>
+            </a:r>
+            <a:r>
+              <a:rPr sz="1700" b="1" i="0">
                 <a:solidFill>
                   <a:srgbClr val="C62828"/>
                 </a:solidFill>
@@ -6539,7 +6539,7 @@
               <a:t>(2)</a:t>
             </a:r>
             <a:r>
-              <a:rPr sz="1600" b="0" i="0">
+              <a:rPr sz="1700" b="0" i="0">
                 <a:solidFill>
                   <a:srgbClr val="1A1A1A"/>
                 </a:solidFill>
@@ -6548,7 +6548,7 @@
               <a:t>. Prices rise into the pair </a:t>
             </a:r>
             <a:r>
-              <a:rPr sz="1600" b="1" i="0">
+              <a:rPr sz="1700" b="1" i="0">
                 <a:solidFill>
                   <a:srgbClr val="1F5FAD"/>
                 </a:solidFill>
@@ -6557,13 +6557,13 @@
               <a:t>(3)</a:t>
             </a:r>
             <a:r>
-              <a:rPr sz="1600" b="0" i="0">
+              <a:rPr sz="1700" b="0" i="0">
                 <a:solidFill>
                   <a:srgbClr val="1A1A1A"/>
                 </a:solidFill>
                 <a:latin typeface="Arial"/>
               </a:rPr>
-              <a:t>, so trend sentiment is bullish and the sentiments disagree.</a:t>
+              <a:t>, so bullish trend and bearish formation disagree.</a:t>
             </a:r>
           </a:p>
           <a:p>
@@ -6579,13 +6579,13 @@
               </a:spcAft>
             </a:pPr>
             <a:r>
-              <a:rPr sz="1600" b="0" i="0">
+              <a:rPr sz="1700" b="0" i="0">
                 <a:solidFill>
                   <a:srgbClr val="1A1A1A"/>
                 </a:solidFill>
                 <a:latin typeface="Arial"/>
               </a:rPr>
-              <a:t>Read: a double-bar potential reversal, not a promise of a fall.</a:t>
+              <a:t>Read: potential reversal, not a promise of a fall.</a:t>
             </a:r>
           </a:p>
         </p:txBody>
@@ -6598,8 +6598,8 @@
         </p:nvSpPr>
         <p:spPr>
           <a:xfrm>
-            <a:off x="777240" y="4965192"/>
-            <a:ext cx="82296" cy="664464"/>
+            <a:off x="777240" y="4837176"/>
+            <a:ext cx="82296" cy="694944"/>
           </a:xfrm>
           <a:prstGeom prst="rect">
             <a:avLst/>
@@ -6628,8 +6628,8 @@
         </p:nvSpPr>
         <p:spPr>
           <a:xfrm>
-            <a:off x="1069848" y="5001768"/>
-            <a:ext cx="4599432" cy="664464"/>
+            <a:off x="1069848" y="4873752"/>
+            <a:ext cx="4782312" cy="694944"/>
           </a:xfrm>
           <a:prstGeom prst="rect">
             <a:avLst/>
@@ -6654,7 +6654,7 @@
               </a:spcAft>
             </a:pPr>
             <a:r>
-              <a:rPr sz="1700" b="1" i="0">
+              <a:rPr sz="1800" b="1" i="0">
                 <a:solidFill>
                   <a:srgbClr val="1A1A1A"/>
                 </a:solidFill>
@@ -6673,8 +6673,8 @@
         </p:nvSpPr>
         <p:spPr>
           <a:xfrm>
-            <a:off x="8125071" y="1810512"/>
-            <a:ext cx="1153631" cy="3749039"/>
+            <a:off x="7636449" y="1810512"/>
+            <a:ext cx="2313755" cy="3749039"/>
           </a:xfrm>
           <a:prstGeom prst="rect">
             <a:avLst/>
@@ -6705,8 +6705,8 @@
         </p:nvSpPr>
         <p:spPr>
           <a:xfrm>
-            <a:off x="8243943" y="1929384"/>
-            <a:ext cx="915887" cy="3511296"/>
+            <a:off x="7755321" y="1929384"/>
+            <a:ext cx="2076011" cy="3511296"/>
           </a:xfrm>
           <a:prstGeom prst="rect">
             <a:avLst/>
@@ -6737,8 +6737,8 @@
         </p:nvSpPr>
         <p:spPr>
           <a:xfrm>
-            <a:off x="8243943" y="1929384"/>
-            <a:ext cx="915887" cy="50800"/>
+            <a:off x="7755321" y="1929384"/>
+            <a:ext cx="2076011" cy="50800"/>
           </a:xfrm>
           <a:prstGeom prst="rect">
             <a:avLst/>
@@ -6767,8 +6767,8 @@
         </p:nvSpPr>
         <p:spPr>
           <a:xfrm>
-            <a:off x="8518263" y="2203703"/>
-            <a:ext cx="367247" cy="3054096"/>
+            <a:off x="8029641" y="2203703"/>
+            <a:ext cx="1527371" cy="3054096"/>
           </a:xfrm>
           <a:prstGeom prst="rect">
             <a:avLst/>
@@ -6815,29 +6815,29 @@
               </a:spcAft>
             </a:pPr>
             <a:r>
-              <a:rPr sz="800" b="0" i="0">
+              <a:rPr sz="1500" b="0" i="0">
                 <a:solidFill>
                   <a:srgbClr val="1A1A1A"/>
                 </a:solidFill>
                 <a:latin typeface="Palatino"/>
               </a:rPr>
-              <a:t>Figure 7.3 crop showing two later intervals, their OHLC bars, and the rising price context used in the worked read.</a:t>
-            </a:r>
-          </a:p>
-        </p:txBody>
-      </p:sp>
-      <p:sp>
-        <p:nvSpPr>
-          <p:cNvPr id="14" name="Oval 13"/>
-          <p:cNvSpPr/>
-          <p:nvPr/>
-        </p:nvSpPr>
-        <p:spPr>
-          <a:xfrm>
-            <a:off x="8317214" y="2912546"/>
-            <a:ext cx="146541" cy="667146"/>
-          </a:xfrm>
-          <a:prstGeom prst="ellipse">
+              <a:t>Figure 7.3 crop showing the two counted OHLC bars, the second bar's location, and the rising price context used in the worked read.</a:t>
+            </a:r>
+          </a:p>
+        </p:txBody>
+      </p:sp>
+      <p:sp>
+        <p:nvSpPr>
+          <p:cNvPr id="14" name="Rectangle 13"/>
+          <p:cNvSpPr/>
+          <p:nvPr/>
+        </p:nvSpPr>
+        <p:spPr>
+          <a:xfrm>
+            <a:off x="8170524" y="3825483"/>
+            <a:ext cx="1017245" cy="1474744"/>
+          </a:xfrm>
+          <a:prstGeom prst="rect">
             <a:avLst/>
           </a:prstGeom>
           <a:noFill/>
@@ -6863,8 +6863,8 @@
         </p:nvSpPr>
         <p:spPr>
           <a:xfrm>
-            <a:off x="8665252" y="2561417"/>
-            <a:ext cx="146541" cy="737372"/>
+            <a:off x="8814087" y="4036161"/>
+            <a:ext cx="352921" cy="1193840"/>
           </a:xfrm>
           <a:prstGeom prst="ellipse">
             <a:avLst/>
@@ -6892,8 +6892,8 @@
         </p:nvSpPr>
         <p:spPr>
           <a:xfrm>
-            <a:off x="8885064" y="2280513"/>
-            <a:ext cx="146541" cy="702259"/>
+            <a:off x="8897128" y="2210287"/>
+            <a:ext cx="519002" cy="1228953"/>
           </a:xfrm>
           <a:prstGeom prst="ellipse">
             <a:avLst/>
@@ -6921,7 +6921,7 @@
         </p:nvSpPr>
         <p:spPr>
           <a:xfrm>
-            <a:off x="8143404" y="2573853"/>
+            <a:off x="7876427" y="3627241"/>
             <a:ext cx="256032" cy="256032"/>
           </a:xfrm>
           <a:prstGeom prst="ellipse">
@@ -6972,7 +6972,7 @@
         </p:nvSpPr>
         <p:spPr>
           <a:xfrm>
-            <a:off x="8729572" y="2257836"/>
+            <a:off x="9122034" y="3837919"/>
             <a:ext cx="256032" cy="256032"/>
           </a:xfrm>
           <a:prstGeom prst="ellipse">
@@ -7023,7 +7023,7 @@
         </p:nvSpPr>
         <p:spPr>
           <a:xfrm>
-            <a:off x="8940226" y="2047158"/>
+            <a:off x="9371155" y="1976932"/>
             <a:ext cx="256032" cy="256032"/>
           </a:xfrm>
           <a:prstGeom prst="ellipse">
@@ -7074,8 +7074,8 @@
         </p:nvSpPr>
         <p:spPr>
           <a:xfrm>
-            <a:off x="5989319" y="5650991"/>
-            <a:ext cx="5425135" cy="274320"/>
+            <a:off x="6172199" y="5650991"/>
+            <a:ext cx="5242255" cy="274320"/>
           </a:xfrm>
           <a:prstGeom prst="rect">
             <a:avLst/>
@@ -7337,7 +7337,7 @@
         <p:spPr>
           <a:xfrm>
             <a:off x="777240" y="1207008"/>
-            <a:ext cx="4998567" cy="4590288"/>
+            <a:ext cx="4572000" cy="2038349"/>
           </a:xfrm>
           <a:prstGeom prst="rect">
             <a:avLst/>
@@ -7366,8 +7366,8 @@
         </p:nvSpPr>
         <p:spPr>
           <a:xfrm>
-            <a:off x="1051560" y="1453896"/>
-            <a:ext cx="4449927" cy="228600"/>
+            <a:off x="1005840" y="1298448"/>
+            <a:ext cx="4114800" cy="228600"/>
           </a:xfrm>
           <a:prstGeom prst="rect">
             <a:avLst/>
@@ -7411,8 +7411,8 @@
         </p:nvSpPr>
         <p:spPr>
           <a:xfrm>
-            <a:off x="1051560" y="1737360"/>
-            <a:ext cx="4449927" cy="588009"/>
+            <a:off x="1005840" y="1499616"/>
+            <a:ext cx="4114800" cy="588009"/>
           </a:xfrm>
           <a:prstGeom prst="rect">
             <a:avLst/>
@@ -7456,8 +7456,8 @@
         </p:nvSpPr>
         <p:spPr>
           <a:xfrm>
-            <a:off x="1051560" y="2526538"/>
-            <a:ext cx="4449927" cy="2926080"/>
+            <a:off x="1005840" y="2069338"/>
+            <a:ext cx="4114800" cy="1102867"/>
           </a:xfrm>
           <a:prstGeom prst="rect">
             <a:avLst/>
@@ -7472,17 +7472,17 @@
           <a:p>
             <a:pPr algn="l">
               <a:lnSpc>
-                <a:spcPct val="112000"/>
-              </a:lnSpc>
-              <a:spcBef>
-                <a:spcPts val="0"/>
-              </a:spcBef>
-              <a:spcAft>
-                <a:spcPts val="900"/>
-              </a:spcAft>
-            </a:pPr>
-            <a:r>
-              <a:rPr sz="1500" b="0" i="0">
+                <a:spcPct val="105000"/>
+              </a:lnSpc>
+              <a:spcBef>
+                <a:spcPts val="0"/>
+              </a:spcBef>
+              <a:spcAft>
+                <a:spcPts val="200"/>
+              </a:spcAft>
+            </a:pPr>
+            <a:r>
+              <a:rPr sz="1700" b="0" i="0">
                 <a:solidFill>
                   <a:srgbClr val="FFFFFF"/>
                 </a:solidFill>
@@ -7494,17 +7494,17 @@
           <a:p>
             <a:pPr algn="l">
               <a:lnSpc>
-                <a:spcPct val="112000"/>
-              </a:lnSpc>
-              <a:spcBef>
-                <a:spcPts val="0"/>
-              </a:spcBef>
-              <a:spcAft>
-                <a:spcPts val="900"/>
-              </a:spcAft>
-            </a:pPr>
-            <a:r>
-              <a:rPr sz="1500" b="0" i="0">
+                <a:spcPct val="105000"/>
+              </a:lnSpc>
+              <a:spcBef>
+                <a:spcPts val="0"/>
+              </a:spcBef>
+              <a:spcAft>
+                <a:spcPts val="200"/>
+              </a:spcAft>
+            </a:pPr>
+            <a:r>
+              <a:rPr sz="1700" b="0" i="0">
                 <a:solidFill>
                   <a:srgbClr val="FFFFFF"/>
                 </a:solidFill>
@@ -7516,17 +7516,17 @@
           <a:p>
             <a:pPr algn="l">
               <a:lnSpc>
-                <a:spcPct val="112000"/>
-              </a:lnSpc>
-              <a:spcBef>
-                <a:spcPts val="0"/>
-              </a:spcBef>
-              <a:spcAft>
-                <a:spcPts val="900"/>
-              </a:spcAft>
-            </a:pPr>
-            <a:r>
-              <a:rPr sz="1500" b="0" i="0">
+                <a:spcPct val="105000"/>
+              </a:lnSpc>
+              <a:spcBef>
+                <a:spcPts val="0"/>
+              </a:spcBef>
+              <a:spcAft>
+                <a:spcPts val="200"/>
+              </a:spcAft>
+            </a:pPr>
+            <a:r>
+              <a:rPr sz="1700" b="0" i="0">
                 <a:solidFill>
                   <a:srgbClr val="FFFFFF"/>
                 </a:solidFill>
@@ -7538,17 +7538,17 @@
           <a:p>
             <a:pPr algn="l">
               <a:lnSpc>
-                <a:spcPct val="112000"/>
-              </a:lnSpc>
-              <a:spcBef>
-                <a:spcPts val="0"/>
-              </a:spcBef>
-              <a:spcAft>
-                <a:spcPts val="900"/>
-              </a:spcAft>
-            </a:pPr>
-            <a:r>
-              <a:rPr sz="1500" b="0" i="0">
+                <a:spcPct val="105000"/>
+              </a:lnSpc>
+              <a:spcBef>
+                <a:spcPts val="0"/>
+              </a:spcBef>
+              <a:spcAft>
+                <a:spcPts val="200"/>
+              </a:spcAft>
+            </a:pPr>
+            <a:r>
+              <a:rPr sz="1700" b="0" i="0">
                 <a:solidFill>
                   <a:srgbClr val="FFFFFF"/>
                 </a:solidFill>
@@ -7567,8 +7567,8 @@
         </p:nvSpPr>
         <p:spPr>
           <a:xfrm>
-            <a:off x="6415887" y="1207008"/>
-            <a:ext cx="4998567" cy="4590288"/>
+            <a:off x="777240" y="3336798"/>
+            <a:ext cx="4572000" cy="2038349"/>
           </a:xfrm>
           <a:prstGeom prst="rect">
             <a:avLst/>
@@ -7597,8 +7597,8 @@
         </p:nvSpPr>
         <p:spPr>
           <a:xfrm>
-            <a:off x="6690207" y="1453896"/>
-            <a:ext cx="4449927" cy="228600"/>
+            <a:off x="1005840" y="3428238"/>
+            <a:ext cx="4114800" cy="228600"/>
           </a:xfrm>
           <a:prstGeom prst="rect">
             <a:avLst/>
@@ -7642,8 +7642,8 @@
         </p:nvSpPr>
         <p:spPr>
           <a:xfrm>
-            <a:off x="6690207" y="1737360"/>
-            <a:ext cx="4449927" cy="588009"/>
+            <a:off x="1005840" y="3629406"/>
+            <a:ext cx="4114800" cy="588009"/>
           </a:xfrm>
           <a:prstGeom prst="rect">
             <a:avLst/>
@@ -7687,8 +7687,8 @@
         </p:nvSpPr>
         <p:spPr>
           <a:xfrm>
-            <a:off x="6690207" y="2526538"/>
-            <a:ext cx="4449927" cy="2926080"/>
+            <a:off x="1005840" y="4199128"/>
+            <a:ext cx="4114800" cy="1102867"/>
           </a:xfrm>
           <a:prstGeom prst="rect">
             <a:avLst/>
@@ -7703,96 +7703,622 @@
           <a:p>
             <a:pPr algn="l">
               <a:lnSpc>
-                <a:spcPct val="112000"/>
-              </a:lnSpc>
-              <a:spcBef>
-                <a:spcPts val="0"/>
-              </a:spcBef>
-              <a:spcAft>
-                <a:spcPts val="900"/>
+                <a:spcPct val="105000"/>
+              </a:lnSpc>
+              <a:spcBef>
+                <a:spcPts val="0"/>
+              </a:spcBef>
+              <a:spcAft>
+                <a:spcPts val="200"/>
+              </a:spcAft>
+            </a:pPr>
+            <a:r>
+              <a:rPr sz="1700" b="0" i="0">
+                <a:solidFill>
+                  <a:srgbClr val="FFFFFF"/>
+                </a:solidFill>
+                <a:latin typeface="Arial"/>
+              </a:rPr>
+              <a:t>A.  Open</a:t>
+            </a:r>
+          </a:p>
+          <a:p>
+            <a:pPr algn="l">
+              <a:lnSpc>
+                <a:spcPct val="105000"/>
+              </a:lnSpc>
+              <a:spcBef>
+                <a:spcPts val="0"/>
+              </a:spcBef>
+              <a:spcAft>
+                <a:spcPts val="200"/>
+              </a:spcAft>
+            </a:pPr>
+            <a:r>
+              <a:rPr sz="1700" b="0" i="0">
+                <a:solidFill>
+                  <a:srgbClr val="FFFFFF"/>
+                </a:solidFill>
+                <a:latin typeface="Arial"/>
+              </a:rPr>
+              <a:t>B.  High</a:t>
+            </a:r>
+          </a:p>
+          <a:p>
+            <a:pPr algn="l">
+              <a:lnSpc>
+                <a:spcPct val="105000"/>
+              </a:lnSpc>
+              <a:spcBef>
+                <a:spcPts val="0"/>
+              </a:spcBef>
+              <a:spcAft>
+                <a:spcPts val="200"/>
+              </a:spcAft>
+            </a:pPr>
+            <a:r>
+              <a:rPr sz="1700" b="0" i="0">
+                <a:solidFill>
+                  <a:srgbClr val="FFFFFF"/>
+                </a:solidFill>
+                <a:latin typeface="Arial"/>
+              </a:rPr>
+              <a:t>C.  Low</a:t>
+            </a:r>
+          </a:p>
+          <a:p>
+            <a:pPr algn="l">
+              <a:lnSpc>
+                <a:spcPct val="105000"/>
+              </a:lnSpc>
+              <a:spcBef>
+                <a:spcPts val="0"/>
+              </a:spcBef>
+              <a:spcAft>
+                <a:spcPts val="200"/>
+              </a:spcAft>
+            </a:pPr>
+            <a:r>
+              <a:rPr sz="1700" b="0" i="0">
+                <a:solidFill>
+                  <a:srgbClr val="FFFFFF"/>
+                </a:solidFill>
+                <a:latin typeface="Arial"/>
+              </a:rPr>
+              <a:t>D.  Close</a:t>
+            </a:r>
+          </a:p>
+        </p:txBody>
+      </p:sp>
+      <p:sp>
+        <p:nvSpPr>
+          <p:cNvPr id="14" name="Rectangle 13"/>
+          <p:cNvSpPr/>
+          <p:nvPr/>
+        </p:nvSpPr>
+        <p:spPr>
+          <a:xfrm>
+            <a:off x="5669279" y="1207008"/>
+            <a:ext cx="5745175" cy="4210962"/>
+          </a:xfrm>
+          <a:prstGeom prst="rect">
+            <a:avLst/>
+          </a:prstGeom>
+          <a:solidFill>
+            <a:srgbClr val="FFFFFF"/>
+          </a:solidFill>
+          <a:ln w="12700">
+            <a:solidFill>
+              <a:srgbClr val="D7E0D9"/>
+            </a:solidFill>
+          </a:ln>
+          <a:effectLst/>
+        </p:spPr>
+        <p:txBody>
+          <a:bodyPr rtlCol="0" anchor="ctr"/>
+          <a:lstStyle/>
+          <a:p>
+            <a:pPr algn="ctr"/>
+          </a:p>
+        </p:txBody>
+      </p:sp>
+      <p:sp>
+        <p:nvSpPr>
+          <p:cNvPr id="15" name="Rectangle 14"/>
+          <p:cNvSpPr/>
+          <p:nvPr/>
+        </p:nvSpPr>
+        <p:spPr>
+          <a:xfrm>
+            <a:off x="5788151" y="1325880"/>
+            <a:ext cx="5507431" cy="3973218"/>
+          </a:xfrm>
+          <a:prstGeom prst="rect">
+            <a:avLst/>
+          </a:prstGeom>
+          <a:solidFill>
+            <a:srgbClr val="FFFFFF"/>
+          </a:solidFill>
+          <a:ln w="12700">
+            <a:solidFill>
+              <a:srgbClr val="D7E0D9"/>
+            </a:solidFill>
+          </a:ln>
+          <a:effectLst/>
+        </p:spPr>
+        <p:txBody>
+          <a:bodyPr rtlCol="0" anchor="ctr"/>
+          <a:lstStyle/>
+          <a:p>
+            <a:pPr algn="ctr"/>
+          </a:p>
+        </p:txBody>
+      </p:sp>
+      <p:sp>
+        <p:nvSpPr>
+          <p:cNvPr id="16" name="Rectangle 15"/>
+          <p:cNvSpPr/>
+          <p:nvPr/>
+        </p:nvSpPr>
+        <p:spPr>
+          <a:xfrm>
+            <a:off x="5788151" y="1325880"/>
+            <a:ext cx="5507431" cy="50800"/>
+          </a:xfrm>
+          <a:prstGeom prst="rect">
+            <a:avLst/>
+          </a:prstGeom>
+          <a:solidFill>
+            <a:srgbClr val="F2A900"/>
+          </a:solidFill>
+          <a:ln>
+            <a:noFill/>
+          </a:ln>
+          <a:effectLst/>
+        </p:spPr>
+        <p:txBody>
+          <a:bodyPr rtlCol="0" anchor="ctr"/>
+          <a:lstStyle/>
+          <a:p>
+            <a:pPr algn="ctr"/>
+          </a:p>
+        </p:txBody>
+      </p:sp>
+      <p:sp>
+        <p:nvSpPr>
+          <p:cNvPr id="17" name="TextBox 16"/>
+          <p:cNvSpPr txBox="1"/>
+          <p:nvPr/>
+        </p:nvSpPr>
+        <p:spPr>
+          <a:xfrm>
+            <a:off x="6062471" y="1600200"/>
+            <a:ext cx="4958791" cy="3516018"/>
+          </a:xfrm>
+          <a:prstGeom prst="rect">
+            <a:avLst/>
+          </a:prstGeom>
+          <a:noFill/>
+        </p:spPr>
+        <p:txBody>
+          <a:bodyPr wrap="square" anchor="t" lIns="0" rIns="0" tIns="0" bIns="0">
+            <a:spAutoFit/>
+          </a:bodyPr>
+          <a:lstStyle/>
+          <a:p>
+            <a:pPr algn="l">
+              <a:lnSpc>
+                <a:spcPct val="100000"/>
+              </a:lnSpc>
+              <a:spcBef>
+                <a:spcPts val="0"/>
+              </a:spcBef>
+              <a:spcAft>
+                <a:spcPts val="400"/>
+              </a:spcAft>
+            </a:pPr>
+            <a:r>
+              <a:rPr sz="1100" b="1" i="0">
+                <a:solidFill>
+                  <a:srgbClr val="818181"/>
+                </a:solidFill>
+                <a:latin typeface="Arial"/>
+              </a:rPr>
+              <a:t>FIGURE 7.1</a:t>
+            </a:r>
+          </a:p>
+          <a:p>
+            <a:pPr algn="l">
+              <a:lnSpc>
+                <a:spcPct val="115000"/>
+              </a:lnSpc>
+              <a:spcBef>
+                <a:spcPts val="0"/>
+              </a:spcBef>
+              <a:spcAft>
+                <a:spcPts val="0"/>
               </a:spcAft>
             </a:pPr>
             <a:r>
               <a:rPr sz="1500" b="0" i="0">
                 <a:solidFill>
+                  <a:srgbClr val="1A1A1A"/>
+                </a:solidFill>
+                <a:latin typeface="Palatino"/>
+              </a:rPr>
+              <a:t>Figure 7.1: five minutes of changing price are filtered into one bar that keeps only the open, high, low and close. The range is the distance from high to low.</a:t>
+            </a:r>
+          </a:p>
+        </p:txBody>
+      </p:sp>
+      <p:sp>
+        <p:nvSpPr>
+          <p:cNvPr id="18" name="Oval 17"/>
+          <p:cNvSpPr/>
+          <p:nvPr/>
+        </p:nvSpPr>
+        <p:spPr>
+          <a:xfrm>
+            <a:off x="9202759" y="2835702"/>
+            <a:ext cx="385520" cy="317857"/>
+          </a:xfrm>
+          <a:prstGeom prst="ellipse">
+            <a:avLst/>
+          </a:prstGeom>
+          <a:noFill/>
+          <a:ln w="44450">
+            <a:solidFill>
+              <a:srgbClr val="E09B00"/>
+            </a:solidFill>
+          </a:ln>
+        </p:spPr>
+        <p:txBody>
+          <a:bodyPr rtlCol="0" anchor="ctr"/>
+          <a:lstStyle/>
+          <a:p>
+            <a:pPr algn="ctr"/>
+          </a:p>
+        </p:txBody>
+      </p:sp>
+      <p:sp>
+        <p:nvSpPr>
+          <p:cNvPr id="19" name="Oval 18"/>
+          <p:cNvSpPr/>
+          <p:nvPr/>
+        </p:nvSpPr>
+        <p:spPr>
+          <a:xfrm>
+            <a:off x="9202759" y="2120523"/>
+            <a:ext cx="385520" cy="317857"/>
+          </a:xfrm>
+          <a:prstGeom prst="ellipse">
+            <a:avLst/>
+          </a:prstGeom>
+          <a:noFill/>
+          <a:ln w="44450">
+            <a:solidFill>
+              <a:srgbClr val="C62828"/>
+            </a:solidFill>
+          </a:ln>
+        </p:spPr>
+        <p:txBody>
+          <a:bodyPr rtlCol="0" anchor="ctr"/>
+          <a:lstStyle/>
+          <a:p>
+            <a:pPr algn="ctr"/>
+          </a:p>
+        </p:txBody>
+      </p:sp>
+      <p:sp>
+        <p:nvSpPr>
+          <p:cNvPr id="20" name="Oval 19"/>
+          <p:cNvSpPr/>
+          <p:nvPr/>
+        </p:nvSpPr>
+        <p:spPr>
+          <a:xfrm>
+            <a:off x="9202759" y="4027668"/>
+            <a:ext cx="385520" cy="317857"/>
+          </a:xfrm>
+          <a:prstGeom prst="ellipse">
+            <a:avLst/>
+          </a:prstGeom>
+          <a:noFill/>
+          <a:ln w="44450">
+            <a:solidFill>
+              <a:srgbClr val="1F5FAD"/>
+            </a:solidFill>
+          </a:ln>
+        </p:spPr>
+        <p:txBody>
+          <a:bodyPr rtlCol="0" anchor="ctr"/>
+          <a:lstStyle/>
+          <a:p>
+            <a:pPr algn="ctr"/>
+          </a:p>
+        </p:txBody>
+      </p:sp>
+      <p:sp>
+        <p:nvSpPr>
+          <p:cNvPr id="21" name="Oval 20"/>
+          <p:cNvSpPr/>
+          <p:nvPr/>
+        </p:nvSpPr>
+        <p:spPr>
+          <a:xfrm>
+            <a:off x="9588279" y="3113828"/>
+            <a:ext cx="385520" cy="317857"/>
+          </a:xfrm>
+          <a:prstGeom prst="ellipse">
+            <a:avLst/>
+          </a:prstGeom>
+          <a:noFill/>
+          <a:ln w="44450">
+            <a:solidFill>
+              <a:srgbClr val="7B3FA0"/>
+            </a:solidFill>
+          </a:ln>
+        </p:spPr>
+        <p:txBody>
+          <a:bodyPr rtlCol="0" anchor="ctr"/>
+          <a:lstStyle/>
+          <a:p>
+            <a:pPr algn="ctr"/>
+          </a:p>
+        </p:txBody>
+      </p:sp>
+      <p:sp>
+        <p:nvSpPr>
+          <p:cNvPr id="22" name="Oval 21"/>
+          <p:cNvSpPr/>
+          <p:nvPr/>
+        </p:nvSpPr>
+        <p:spPr>
+          <a:xfrm>
+            <a:off x="8790227" y="2698542"/>
+            <a:ext cx="274320" cy="274320"/>
+          </a:xfrm>
+          <a:prstGeom prst="ellipse">
+            <a:avLst/>
+          </a:prstGeom>
+          <a:solidFill>
+            <a:srgbClr val="E09B00"/>
+          </a:solidFill>
+          <a:ln w="12700">
+            <a:solidFill>
+              <a:srgbClr val="FFFFFF"/>
+            </a:solidFill>
+          </a:ln>
+          <a:effectLst/>
+        </p:spPr>
+        <p:txBody>
+          <a:bodyPr rtlCol="0" anchor="ctr" wrap="none" lIns="0" rIns="0" tIns="0" bIns="0"/>
+          <a:lstStyle/>
+          <a:p>
+            <a:pPr algn="ctr">
+              <a:lnSpc>
+                <a:spcPct val="100000"/>
+              </a:lnSpc>
+              <a:spcBef>
+                <a:spcPts val="0"/>
+              </a:spcBef>
+              <a:spcAft>
+                <a:spcPts val="0"/>
+              </a:spcAft>
+            </a:pPr>
+            <a:r>
+              <a:rPr sz="1300" b="1" i="0">
+                <a:solidFill>
                   <a:srgbClr val="FFFFFF"/>
                 </a:solidFill>
                 <a:latin typeface="Arial"/>
               </a:rPr>
-              <a:t>A.  Open</a:t>
-            </a:r>
-          </a:p>
+              <a:t>1</a:t>
+            </a:r>
+          </a:p>
+        </p:txBody>
+      </p:sp>
+      <p:sp>
+        <p:nvSpPr>
+          <p:cNvPr id="23" name="Oval 22"/>
+          <p:cNvSpPr/>
+          <p:nvPr/>
+        </p:nvSpPr>
+        <p:spPr>
+          <a:xfrm>
+            <a:off x="9836639" y="1784702"/>
+            <a:ext cx="274320" cy="274320"/>
+          </a:xfrm>
+          <a:prstGeom prst="ellipse">
+            <a:avLst/>
+          </a:prstGeom>
+          <a:solidFill>
+            <a:srgbClr val="C62828"/>
+          </a:solidFill>
+          <a:ln w="12700">
+            <a:solidFill>
+              <a:srgbClr val="FFFFFF"/>
+            </a:solidFill>
+          </a:ln>
+          <a:effectLst/>
+        </p:spPr>
+        <p:txBody>
+          <a:bodyPr rtlCol="0" anchor="ctr" wrap="none" lIns="0" rIns="0" tIns="0" bIns="0"/>
+          <a:lstStyle/>
+          <a:p>
+            <a:pPr algn="ctr">
+              <a:lnSpc>
+                <a:spcPct val="100000"/>
+              </a:lnSpc>
+              <a:spcBef>
+                <a:spcPts val="0"/>
+              </a:spcBef>
+              <a:spcAft>
+                <a:spcPts val="0"/>
+              </a:spcAft>
+            </a:pPr>
+            <a:r>
+              <a:rPr sz="1300" b="1" i="0">
+                <a:solidFill>
+                  <a:srgbClr val="FFFFFF"/>
+                </a:solidFill>
+                <a:latin typeface="Arial"/>
+              </a:rPr>
+              <a:t>2</a:t>
+            </a:r>
+          </a:p>
+        </p:txBody>
+      </p:sp>
+      <p:sp>
+        <p:nvSpPr>
+          <p:cNvPr id="24" name="Oval 23"/>
+          <p:cNvSpPr/>
+          <p:nvPr/>
+        </p:nvSpPr>
+        <p:spPr>
+          <a:xfrm>
+            <a:off x="9836639" y="4446758"/>
+            <a:ext cx="274320" cy="274320"/>
+          </a:xfrm>
+          <a:prstGeom prst="ellipse">
+            <a:avLst/>
+          </a:prstGeom>
+          <a:solidFill>
+            <a:srgbClr val="1F5FAD"/>
+          </a:solidFill>
+          <a:ln w="12700">
+            <a:solidFill>
+              <a:srgbClr val="FFFFFF"/>
+            </a:solidFill>
+          </a:ln>
+          <a:effectLst/>
+        </p:spPr>
+        <p:txBody>
+          <a:bodyPr rtlCol="0" anchor="ctr" wrap="none" lIns="0" rIns="0" tIns="0" bIns="0"/>
+          <a:lstStyle/>
+          <a:p>
+            <a:pPr algn="ctr">
+              <a:lnSpc>
+                <a:spcPct val="100000"/>
+              </a:lnSpc>
+              <a:spcBef>
+                <a:spcPts val="0"/>
+              </a:spcBef>
+              <a:spcAft>
+                <a:spcPts val="0"/>
+              </a:spcAft>
+            </a:pPr>
+            <a:r>
+              <a:rPr sz="1300" b="1" i="0">
+                <a:solidFill>
+                  <a:srgbClr val="FFFFFF"/>
+                </a:solidFill>
+                <a:latin typeface="Arial"/>
+              </a:rPr>
+              <a:t>3</a:t>
+            </a:r>
+          </a:p>
+        </p:txBody>
+      </p:sp>
+      <p:sp>
+        <p:nvSpPr>
+          <p:cNvPr id="25" name="Oval 24"/>
+          <p:cNvSpPr/>
+          <p:nvPr/>
+        </p:nvSpPr>
+        <p:spPr>
+          <a:xfrm>
+            <a:off x="10222159" y="3294525"/>
+            <a:ext cx="274320" cy="274320"/>
+          </a:xfrm>
+          <a:prstGeom prst="ellipse">
+            <a:avLst/>
+          </a:prstGeom>
+          <a:solidFill>
+            <a:srgbClr val="7B3FA0"/>
+          </a:solidFill>
+          <a:ln w="12700">
+            <a:solidFill>
+              <a:srgbClr val="FFFFFF"/>
+            </a:solidFill>
+          </a:ln>
+          <a:effectLst/>
+        </p:spPr>
+        <p:txBody>
+          <a:bodyPr rtlCol="0" anchor="ctr" wrap="none" lIns="0" rIns="0" tIns="0" bIns="0"/>
+          <a:lstStyle/>
+          <a:p>
+            <a:pPr algn="ctr">
+              <a:lnSpc>
+                <a:spcPct val="100000"/>
+              </a:lnSpc>
+              <a:spcBef>
+                <a:spcPts val="0"/>
+              </a:spcBef>
+              <a:spcAft>
+                <a:spcPts val="0"/>
+              </a:spcAft>
+            </a:pPr>
+            <a:r>
+              <a:rPr sz="1300" b="1" i="0">
+                <a:solidFill>
+                  <a:srgbClr val="FFFFFF"/>
+                </a:solidFill>
+                <a:latin typeface="Arial"/>
+              </a:rPr>
+              <a:t>4</a:t>
+            </a:r>
+          </a:p>
+        </p:txBody>
+      </p:sp>
+      <p:sp>
+        <p:nvSpPr>
+          <p:cNvPr id="26" name="TextBox 25"/>
+          <p:cNvSpPr txBox="1"/>
+          <p:nvPr/>
+        </p:nvSpPr>
+        <p:spPr>
+          <a:xfrm>
+            <a:off x="5669279" y="5509410"/>
+            <a:ext cx="5745175" cy="274320"/>
+          </a:xfrm>
+          <a:prstGeom prst="rect">
+            <a:avLst/>
+          </a:prstGeom>
+          <a:noFill/>
+        </p:spPr>
+        <p:txBody>
+          <a:bodyPr wrap="square" anchor="t" lIns="0" rIns="0" tIns="0" bIns="0">
+            <a:spAutoFit/>
+          </a:bodyPr>
+          <a:lstStyle/>
           <a:p>
             <a:pPr algn="l">
               <a:lnSpc>
-                <a:spcPct val="112000"/>
-              </a:lnSpc>
-              <a:spcBef>
-                <a:spcPts val="0"/>
-              </a:spcBef>
-              <a:spcAft>
-                <a:spcPts val="900"/>
-              </a:spcAft>
-            </a:pPr>
-            <a:r>
-              <a:rPr sz="1500" b="0" i="0">
-                <a:solidFill>
-                  <a:srgbClr val="FFFFFF"/>
-                </a:solidFill>
-                <a:latin typeface="Arial"/>
-              </a:rPr>
-              <a:t>B.  High</a:t>
-            </a:r>
-          </a:p>
-          <a:p>
-            <a:pPr algn="l">
-              <a:lnSpc>
-                <a:spcPct val="112000"/>
-              </a:lnSpc>
-              <a:spcBef>
-                <a:spcPts val="0"/>
-              </a:spcBef>
-              <a:spcAft>
-                <a:spcPts val="900"/>
-              </a:spcAft>
-            </a:pPr>
-            <a:r>
-              <a:rPr sz="1500" b="0" i="0">
-                <a:solidFill>
-                  <a:srgbClr val="FFFFFF"/>
-                </a:solidFill>
-                <a:latin typeface="Arial"/>
-              </a:rPr>
-              <a:t>C.  Low</a:t>
-            </a:r>
-          </a:p>
-          <a:p>
-            <a:pPr algn="l">
-              <a:lnSpc>
-                <a:spcPct val="112000"/>
-              </a:lnSpc>
-              <a:spcBef>
-                <a:spcPts val="0"/>
-              </a:spcBef>
-              <a:spcAft>
-                <a:spcPts val="900"/>
-              </a:spcAft>
-            </a:pPr>
-            <a:r>
-              <a:rPr sz="1500" b="0" i="0">
-                <a:solidFill>
-                  <a:srgbClr val="FFFFFF"/>
-                </a:solidFill>
-                <a:latin typeface="Arial"/>
-              </a:rPr>
-              <a:t>D.  Close</a:t>
-            </a:r>
-          </a:p>
-        </p:txBody>
-      </p:sp>
-      <p:sp>
-        <p:nvSpPr>
-          <p:cNvPr id="14" name="TextBox 13"/>
+                <a:spcPct val="100000"/>
+              </a:lnSpc>
+              <a:spcBef>
+                <a:spcPts val="0"/>
+              </a:spcBef>
+              <a:spcAft>
+                <a:spcPts val="0"/>
+              </a:spcAft>
+            </a:pPr>
+            <a:r>
+              <a:rPr sz="1200" b="0" i="0">
+                <a:solidFill>
+                  <a:srgbClr val="818181"/>
+                </a:solidFill>
+                <a:latin typeface="Arial"/>
+              </a:rPr>
+              <a:t>Figure 7.1 - Lim, The Handbook of Technical Analysis (Wiley, 2016)</a:t>
+            </a:r>
+          </a:p>
+        </p:txBody>
+      </p:sp>
+      <p:sp>
+        <p:nvSpPr>
+          <p:cNvPr id="27" name="TextBox 26"/>
           <p:cNvSpPr txBox="1"/>
           <p:nvPr/>
         </p:nvSpPr>
@@ -8016,7 +8542,7 @@
         <p:spPr>
           <a:xfrm>
             <a:off x="777240" y="1207008"/>
-            <a:ext cx="10637215" cy="1628140"/>
+            <a:ext cx="4572000" cy="2235835"/>
           </a:xfrm>
           <a:prstGeom prst="rect">
             <a:avLst/>
@@ -8048,7 +8574,7 @@
         <p:spPr>
           <a:xfrm>
             <a:off x="777240" y="1207008"/>
-            <a:ext cx="91440" cy="1628140"/>
+            <a:ext cx="91440" cy="2235835"/>
           </a:xfrm>
           <a:prstGeom prst="rect">
             <a:avLst/>
@@ -8077,8 +8603,8 @@
         </p:nvSpPr>
         <p:spPr>
           <a:xfrm>
-            <a:off x="1143000" y="1444752"/>
-            <a:ext cx="9905695" cy="325119"/>
+            <a:off x="1097280" y="1389888"/>
+            <a:ext cx="4023360" cy="588009"/>
           </a:xfrm>
           <a:prstGeom prst="rect">
             <a:avLst/>
@@ -8103,7 +8629,7 @@
               </a:spcAft>
             </a:pPr>
             <a:r>
-              <a:rPr sz="1600" b="0" i="0">
+              <a:rPr sz="1700" b="0" i="0">
                 <a:solidFill>
                   <a:srgbClr val="818181"/>
                 </a:solidFill>
@@ -8122,8 +8648,8 @@
         </p:nvSpPr>
         <p:spPr>
           <a:xfrm>
-            <a:off x="1143000" y="1934464"/>
-            <a:ext cx="9905695" cy="1206500"/>
+            <a:off x="1097280" y="2069338"/>
+            <a:ext cx="4023360" cy="1373505"/>
           </a:xfrm>
           <a:prstGeom prst="rect">
             <a:avLst/>
@@ -8148,7 +8674,7 @@
               </a:spcAft>
             </a:pPr>
             <a:r>
-              <a:rPr sz="2000" b="1" i="0">
+              <a:rPr sz="1800" b="1" i="0">
                 <a:solidFill>
                   <a:srgbClr val="007A33"/>
                 </a:solidFill>
@@ -8163,14 +8689,14 @@
                 <a:spcPct val="115000"/>
               </a:lnSpc>
               <a:spcBef>
-                <a:spcPts val="700"/>
-              </a:spcBef>
-              <a:spcAft>
-                <a:spcPts val="0"/>
-              </a:spcAft>
-            </a:pPr>
-            <a:r>
-              <a:rPr sz="1600" b="0" i="0">
+                <a:spcPts val="500"/>
+              </a:spcBef>
+              <a:spcAft>
+                <a:spcPts val="0"/>
+              </a:spcAft>
+            </a:pPr>
+            <a:r>
+              <a:rPr sz="1700" b="0" i="0">
                 <a:solidFill>
                   <a:srgbClr val="1A1A1A"/>
                 </a:solidFill>
@@ -8189,8 +8715,8 @@
         </p:nvSpPr>
         <p:spPr>
           <a:xfrm>
-            <a:off x="777240" y="3082036"/>
-            <a:ext cx="10637215" cy="1861819"/>
+            <a:off x="777240" y="3625723"/>
+            <a:ext cx="4572000" cy="2484120"/>
           </a:xfrm>
           <a:prstGeom prst="rect">
             <a:avLst/>
@@ -8221,8 +8747,8 @@
         </p:nvSpPr>
         <p:spPr>
           <a:xfrm>
-            <a:off x="777240" y="3082036"/>
-            <a:ext cx="91440" cy="1861819"/>
+            <a:off x="777240" y="3625723"/>
+            <a:ext cx="91440" cy="2484120"/>
           </a:xfrm>
           <a:prstGeom prst="rect">
             <a:avLst/>
@@ -8251,8 +8777,8 @@
         </p:nvSpPr>
         <p:spPr>
           <a:xfrm>
-            <a:off x="1143000" y="3319780"/>
-            <a:ext cx="9905695" cy="325119"/>
+            <a:off x="1097280" y="3808603"/>
+            <a:ext cx="4023360" cy="588009"/>
           </a:xfrm>
           <a:prstGeom prst="rect">
             <a:avLst/>
@@ -8277,7 +8803,7 @@
               </a:spcAft>
             </a:pPr>
             <a:r>
-              <a:rPr sz="1600" b="0" i="0">
+              <a:rPr sz="1700" b="0" i="0">
                 <a:solidFill>
                   <a:srgbClr val="818181"/>
                 </a:solidFill>
@@ -8296,8 +8822,8 @@
         </p:nvSpPr>
         <p:spPr>
           <a:xfrm>
-            <a:off x="1143000" y="3809492"/>
-            <a:ext cx="9905695" cy="1206500"/>
+            <a:off x="1097280" y="4488053"/>
+            <a:ext cx="4023360" cy="1621790"/>
           </a:xfrm>
           <a:prstGeom prst="rect">
             <a:avLst/>
@@ -8322,7 +8848,7 @@
               </a:spcAft>
             </a:pPr>
             <a:r>
-              <a:rPr sz="2000" b="1" i="0">
+              <a:rPr sz="1800" b="1" i="0">
                 <a:solidFill>
                   <a:srgbClr val="007A33"/>
                 </a:solidFill>
@@ -8337,14 +8863,14 @@
                 <a:spcPct val="115000"/>
               </a:lnSpc>
               <a:spcBef>
-                <a:spcPts val="700"/>
-              </a:spcBef>
-              <a:spcAft>
-                <a:spcPts val="0"/>
-              </a:spcAft>
-            </a:pPr>
-            <a:r>
-              <a:rPr sz="1600" b="0" i="0">
+                <a:spcPts val="500"/>
+              </a:spcBef>
+              <a:spcAft>
+                <a:spcPts val="0"/>
+              </a:spcAft>
+            </a:pPr>
+            <a:r>
+              <a:rPr sz="1700" b="0" i="0">
                 <a:solidFill>
                   <a:srgbClr val="1A1A1A"/>
                 </a:solidFill>
@@ -8357,7 +8883,533 @@
       </p:sp>
       <p:sp>
         <p:nvSpPr>
-          <p:cNvPr id="14" name="TextBox 13"/>
+          <p:cNvPr id="14" name="Rectangle 13"/>
+          <p:cNvSpPr/>
+          <p:nvPr/>
+        </p:nvSpPr>
+        <p:spPr>
+          <a:xfrm>
+            <a:off x="5669279" y="1207008"/>
+            <a:ext cx="5745175" cy="4210962"/>
+          </a:xfrm>
+          <a:prstGeom prst="rect">
+            <a:avLst/>
+          </a:prstGeom>
+          <a:solidFill>
+            <a:srgbClr val="FFFFFF"/>
+          </a:solidFill>
+          <a:ln w="12700">
+            <a:solidFill>
+              <a:srgbClr val="D7E0D9"/>
+            </a:solidFill>
+          </a:ln>
+          <a:effectLst/>
+        </p:spPr>
+        <p:txBody>
+          <a:bodyPr rtlCol="0" anchor="ctr"/>
+          <a:lstStyle/>
+          <a:p>
+            <a:pPr algn="ctr"/>
+          </a:p>
+        </p:txBody>
+      </p:sp>
+      <p:sp>
+        <p:nvSpPr>
+          <p:cNvPr id="15" name="Rectangle 14"/>
+          <p:cNvSpPr/>
+          <p:nvPr/>
+        </p:nvSpPr>
+        <p:spPr>
+          <a:xfrm>
+            <a:off x="5788151" y="1325880"/>
+            <a:ext cx="5507431" cy="3973218"/>
+          </a:xfrm>
+          <a:prstGeom prst="rect">
+            <a:avLst/>
+          </a:prstGeom>
+          <a:solidFill>
+            <a:srgbClr val="FFFFFF"/>
+          </a:solidFill>
+          <a:ln w="12700">
+            <a:solidFill>
+              <a:srgbClr val="D7E0D9"/>
+            </a:solidFill>
+          </a:ln>
+          <a:effectLst/>
+        </p:spPr>
+        <p:txBody>
+          <a:bodyPr rtlCol="0" anchor="ctr"/>
+          <a:lstStyle/>
+          <a:p>
+            <a:pPr algn="ctr"/>
+          </a:p>
+        </p:txBody>
+      </p:sp>
+      <p:sp>
+        <p:nvSpPr>
+          <p:cNvPr id="16" name="Rectangle 15"/>
+          <p:cNvSpPr/>
+          <p:nvPr/>
+        </p:nvSpPr>
+        <p:spPr>
+          <a:xfrm>
+            <a:off x="5788151" y="1325880"/>
+            <a:ext cx="5507431" cy="50800"/>
+          </a:xfrm>
+          <a:prstGeom prst="rect">
+            <a:avLst/>
+          </a:prstGeom>
+          <a:solidFill>
+            <a:srgbClr val="F2A900"/>
+          </a:solidFill>
+          <a:ln>
+            <a:noFill/>
+          </a:ln>
+          <a:effectLst/>
+        </p:spPr>
+        <p:txBody>
+          <a:bodyPr rtlCol="0" anchor="ctr"/>
+          <a:lstStyle/>
+          <a:p>
+            <a:pPr algn="ctr"/>
+          </a:p>
+        </p:txBody>
+      </p:sp>
+      <p:sp>
+        <p:nvSpPr>
+          <p:cNvPr id="17" name="TextBox 16"/>
+          <p:cNvSpPr txBox="1"/>
+          <p:nvPr/>
+        </p:nvSpPr>
+        <p:spPr>
+          <a:xfrm>
+            <a:off x="6062471" y="1600200"/>
+            <a:ext cx="4958791" cy="3516018"/>
+          </a:xfrm>
+          <a:prstGeom prst="rect">
+            <a:avLst/>
+          </a:prstGeom>
+          <a:noFill/>
+        </p:spPr>
+        <p:txBody>
+          <a:bodyPr wrap="square" anchor="t" lIns="0" rIns="0" tIns="0" bIns="0">
+            <a:spAutoFit/>
+          </a:bodyPr>
+          <a:lstStyle/>
+          <a:p>
+            <a:pPr algn="l">
+              <a:lnSpc>
+                <a:spcPct val="100000"/>
+              </a:lnSpc>
+              <a:spcBef>
+                <a:spcPts val="0"/>
+              </a:spcBef>
+              <a:spcAft>
+                <a:spcPts val="400"/>
+              </a:spcAft>
+            </a:pPr>
+            <a:r>
+              <a:rPr sz="1100" b="1" i="0">
+                <a:solidFill>
+                  <a:srgbClr val="818181"/>
+                </a:solidFill>
+                <a:latin typeface="Arial"/>
+              </a:rPr>
+              <a:t>FIGURE 7.1</a:t>
+            </a:r>
+          </a:p>
+          <a:p>
+            <a:pPr algn="l">
+              <a:lnSpc>
+                <a:spcPct val="115000"/>
+              </a:lnSpc>
+              <a:spcBef>
+                <a:spcPts val="0"/>
+              </a:spcBef>
+              <a:spcAft>
+                <a:spcPts val="0"/>
+              </a:spcAft>
+            </a:pPr>
+            <a:r>
+              <a:rPr sz="1500" b="0" i="0">
+                <a:solidFill>
+                  <a:srgbClr val="1A1A1A"/>
+                </a:solidFill>
+                <a:latin typeface="Palatino"/>
+              </a:rPr>
+              <a:t>Figure 7.1: five minutes of changing price are filtered into one bar that keeps only the open, high, low and close. The range is the distance from high to low.</a:t>
+            </a:r>
+          </a:p>
+        </p:txBody>
+      </p:sp>
+      <p:sp>
+        <p:nvSpPr>
+          <p:cNvPr id="18" name="Oval 17"/>
+          <p:cNvSpPr/>
+          <p:nvPr/>
+        </p:nvSpPr>
+        <p:spPr>
+          <a:xfrm>
+            <a:off x="9202759" y="2835702"/>
+            <a:ext cx="385520" cy="317857"/>
+          </a:xfrm>
+          <a:prstGeom prst="ellipse">
+            <a:avLst/>
+          </a:prstGeom>
+          <a:noFill/>
+          <a:ln w="44450">
+            <a:solidFill>
+              <a:srgbClr val="E09B00"/>
+            </a:solidFill>
+          </a:ln>
+        </p:spPr>
+        <p:txBody>
+          <a:bodyPr rtlCol="0" anchor="ctr"/>
+          <a:lstStyle/>
+          <a:p>
+            <a:pPr algn="ctr"/>
+          </a:p>
+        </p:txBody>
+      </p:sp>
+      <p:sp>
+        <p:nvSpPr>
+          <p:cNvPr id="19" name="Oval 18"/>
+          <p:cNvSpPr/>
+          <p:nvPr/>
+        </p:nvSpPr>
+        <p:spPr>
+          <a:xfrm>
+            <a:off x="9202759" y="2120523"/>
+            <a:ext cx="385520" cy="317857"/>
+          </a:xfrm>
+          <a:prstGeom prst="ellipse">
+            <a:avLst/>
+          </a:prstGeom>
+          <a:noFill/>
+          <a:ln w="44450">
+            <a:solidFill>
+              <a:srgbClr val="C62828"/>
+            </a:solidFill>
+          </a:ln>
+        </p:spPr>
+        <p:txBody>
+          <a:bodyPr rtlCol="0" anchor="ctr"/>
+          <a:lstStyle/>
+          <a:p>
+            <a:pPr algn="ctr"/>
+          </a:p>
+        </p:txBody>
+      </p:sp>
+      <p:sp>
+        <p:nvSpPr>
+          <p:cNvPr id="20" name="Oval 19"/>
+          <p:cNvSpPr/>
+          <p:nvPr/>
+        </p:nvSpPr>
+        <p:spPr>
+          <a:xfrm>
+            <a:off x="9202759" y="4027668"/>
+            <a:ext cx="385520" cy="317857"/>
+          </a:xfrm>
+          <a:prstGeom prst="ellipse">
+            <a:avLst/>
+          </a:prstGeom>
+          <a:noFill/>
+          <a:ln w="44450">
+            <a:solidFill>
+              <a:srgbClr val="1F5FAD"/>
+            </a:solidFill>
+          </a:ln>
+        </p:spPr>
+        <p:txBody>
+          <a:bodyPr rtlCol="0" anchor="ctr"/>
+          <a:lstStyle/>
+          <a:p>
+            <a:pPr algn="ctr"/>
+          </a:p>
+        </p:txBody>
+      </p:sp>
+      <p:sp>
+        <p:nvSpPr>
+          <p:cNvPr id="21" name="Oval 20"/>
+          <p:cNvSpPr/>
+          <p:nvPr/>
+        </p:nvSpPr>
+        <p:spPr>
+          <a:xfrm>
+            <a:off x="9588279" y="3113828"/>
+            <a:ext cx="385520" cy="317857"/>
+          </a:xfrm>
+          <a:prstGeom prst="ellipse">
+            <a:avLst/>
+          </a:prstGeom>
+          <a:noFill/>
+          <a:ln w="44450">
+            <a:solidFill>
+              <a:srgbClr val="7B3FA0"/>
+            </a:solidFill>
+          </a:ln>
+        </p:spPr>
+        <p:txBody>
+          <a:bodyPr rtlCol="0" anchor="ctr"/>
+          <a:lstStyle/>
+          <a:p>
+            <a:pPr algn="ctr"/>
+          </a:p>
+        </p:txBody>
+      </p:sp>
+      <p:sp>
+        <p:nvSpPr>
+          <p:cNvPr id="22" name="Oval 21"/>
+          <p:cNvSpPr/>
+          <p:nvPr/>
+        </p:nvSpPr>
+        <p:spPr>
+          <a:xfrm>
+            <a:off x="8790227" y="2698542"/>
+            <a:ext cx="274320" cy="274320"/>
+          </a:xfrm>
+          <a:prstGeom prst="ellipse">
+            <a:avLst/>
+          </a:prstGeom>
+          <a:solidFill>
+            <a:srgbClr val="E09B00"/>
+          </a:solidFill>
+          <a:ln w="12700">
+            <a:solidFill>
+              <a:srgbClr val="FFFFFF"/>
+            </a:solidFill>
+          </a:ln>
+          <a:effectLst/>
+        </p:spPr>
+        <p:txBody>
+          <a:bodyPr rtlCol="0" anchor="ctr" wrap="none" lIns="0" rIns="0" tIns="0" bIns="0"/>
+          <a:lstStyle/>
+          <a:p>
+            <a:pPr algn="ctr">
+              <a:lnSpc>
+                <a:spcPct val="100000"/>
+              </a:lnSpc>
+              <a:spcBef>
+                <a:spcPts val="0"/>
+              </a:spcBef>
+              <a:spcAft>
+                <a:spcPts val="0"/>
+              </a:spcAft>
+            </a:pPr>
+            <a:r>
+              <a:rPr sz="1300" b="1" i="0">
+                <a:solidFill>
+                  <a:srgbClr val="FFFFFF"/>
+                </a:solidFill>
+                <a:latin typeface="Arial"/>
+              </a:rPr>
+              <a:t>1</a:t>
+            </a:r>
+          </a:p>
+        </p:txBody>
+      </p:sp>
+      <p:sp>
+        <p:nvSpPr>
+          <p:cNvPr id="23" name="Oval 22"/>
+          <p:cNvSpPr/>
+          <p:nvPr/>
+        </p:nvSpPr>
+        <p:spPr>
+          <a:xfrm>
+            <a:off x="9836639" y="1784702"/>
+            <a:ext cx="274320" cy="274320"/>
+          </a:xfrm>
+          <a:prstGeom prst="ellipse">
+            <a:avLst/>
+          </a:prstGeom>
+          <a:solidFill>
+            <a:srgbClr val="C62828"/>
+          </a:solidFill>
+          <a:ln w="12700">
+            <a:solidFill>
+              <a:srgbClr val="FFFFFF"/>
+            </a:solidFill>
+          </a:ln>
+          <a:effectLst/>
+        </p:spPr>
+        <p:txBody>
+          <a:bodyPr rtlCol="0" anchor="ctr" wrap="none" lIns="0" rIns="0" tIns="0" bIns="0"/>
+          <a:lstStyle/>
+          <a:p>
+            <a:pPr algn="ctr">
+              <a:lnSpc>
+                <a:spcPct val="100000"/>
+              </a:lnSpc>
+              <a:spcBef>
+                <a:spcPts val="0"/>
+              </a:spcBef>
+              <a:spcAft>
+                <a:spcPts val="0"/>
+              </a:spcAft>
+            </a:pPr>
+            <a:r>
+              <a:rPr sz="1300" b="1" i="0">
+                <a:solidFill>
+                  <a:srgbClr val="FFFFFF"/>
+                </a:solidFill>
+                <a:latin typeface="Arial"/>
+              </a:rPr>
+              <a:t>2</a:t>
+            </a:r>
+          </a:p>
+        </p:txBody>
+      </p:sp>
+      <p:sp>
+        <p:nvSpPr>
+          <p:cNvPr id="24" name="Oval 23"/>
+          <p:cNvSpPr/>
+          <p:nvPr/>
+        </p:nvSpPr>
+        <p:spPr>
+          <a:xfrm>
+            <a:off x="9836639" y="4446758"/>
+            <a:ext cx="274320" cy="274320"/>
+          </a:xfrm>
+          <a:prstGeom prst="ellipse">
+            <a:avLst/>
+          </a:prstGeom>
+          <a:solidFill>
+            <a:srgbClr val="1F5FAD"/>
+          </a:solidFill>
+          <a:ln w="12700">
+            <a:solidFill>
+              <a:srgbClr val="FFFFFF"/>
+            </a:solidFill>
+          </a:ln>
+          <a:effectLst/>
+        </p:spPr>
+        <p:txBody>
+          <a:bodyPr rtlCol="0" anchor="ctr" wrap="none" lIns="0" rIns="0" tIns="0" bIns="0"/>
+          <a:lstStyle/>
+          <a:p>
+            <a:pPr algn="ctr">
+              <a:lnSpc>
+                <a:spcPct val="100000"/>
+              </a:lnSpc>
+              <a:spcBef>
+                <a:spcPts val="0"/>
+              </a:spcBef>
+              <a:spcAft>
+                <a:spcPts val="0"/>
+              </a:spcAft>
+            </a:pPr>
+            <a:r>
+              <a:rPr sz="1300" b="1" i="0">
+                <a:solidFill>
+                  <a:srgbClr val="FFFFFF"/>
+                </a:solidFill>
+                <a:latin typeface="Arial"/>
+              </a:rPr>
+              <a:t>3</a:t>
+            </a:r>
+          </a:p>
+        </p:txBody>
+      </p:sp>
+      <p:sp>
+        <p:nvSpPr>
+          <p:cNvPr id="25" name="Oval 24"/>
+          <p:cNvSpPr/>
+          <p:nvPr/>
+        </p:nvSpPr>
+        <p:spPr>
+          <a:xfrm>
+            <a:off x="10222159" y="3294525"/>
+            <a:ext cx="274320" cy="274320"/>
+          </a:xfrm>
+          <a:prstGeom prst="ellipse">
+            <a:avLst/>
+          </a:prstGeom>
+          <a:solidFill>
+            <a:srgbClr val="7B3FA0"/>
+          </a:solidFill>
+          <a:ln w="12700">
+            <a:solidFill>
+              <a:srgbClr val="FFFFFF"/>
+            </a:solidFill>
+          </a:ln>
+          <a:effectLst/>
+        </p:spPr>
+        <p:txBody>
+          <a:bodyPr rtlCol="0" anchor="ctr" wrap="none" lIns="0" rIns="0" tIns="0" bIns="0"/>
+          <a:lstStyle/>
+          <a:p>
+            <a:pPr algn="ctr">
+              <a:lnSpc>
+                <a:spcPct val="100000"/>
+              </a:lnSpc>
+              <a:spcBef>
+                <a:spcPts val="0"/>
+              </a:spcBef>
+              <a:spcAft>
+                <a:spcPts val="0"/>
+              </a:spcAft>
+            </a:pPr>
+            <a:r>
+              <a:rPr sz="1300" b="1" i="0">
+                <a:solidFill>
+                  <a:srgbClr val="FFFFFF"/>
+                </a:solidFill>
+                <a:latin typeface="Arial"/>
+              </a:rPr>
+              <a:t>4</a:t>
+            </a:r>
+          </a:p>
+        </p:txBody>
+      </p:sp>
+      <p:sp>
+        <p:nvSpPr>
+          <p:cNvPr id="26" name="TextBox 25"/>
+          <p:cNvSpPr txBox="1"/>
+          <p:nvPr/>
+        </p:nvSpPr>
+        <p:spPr>
+          <a:xfrm>
+            <a:off x="5669279" y="5509410"/>
+            <a:ext cx="5745175" cy="274320"/>
+          </a:xfrm>
+          <a:prstGeom prst="rect">
+            <a:avLst/>
+          </a:prstGeom>
+          <a:noFill/>
+        </p:spPr>
+        <p:txBody>
+          <a:bodyPr wrap="square" anchor="t" lIns="0" rIns="0" tIns="0" bIns="0">
+            <a:spAutoFit/>
+          </a:bodyPr>
+          <a:lstStyle/>
+          <a:p>
+            <a:pPr algn="l">
+              <a:lnSpc>
+                <a:spcPct val="100000"/>
+              </a:lnSpc>
+              <a:spcBef>
+                <a:spcPts val="0"/>
+              </a:spcBef>
+              <a:spcAft>
+                <a:spcPts val="0"/>
+              </a:spcAft>
+            </a:pPr>
+            <a:r>
+              <a:rPr sz="1200" b="0" i="0">
+                <a:solidFill>
+                  <a:srgbClr val="818181"/>
+                </a:solidFill>
+                <a:latin typeface="Arial"/>
+              </a:rPr>
+              <a:t>Figure 7.1 - Lim, The Handbook of Technical Analysis (Wiley, 2016)</a:t>
+            </a:r>
+          </a:p>
+        </p:txBody>
+      </p:sp>
+      <p:sp>
+        <p:nvSpPr>
+          <p:cNvPr id="27" name="TextBox 26"/>
           <p:cNvSpPr txBox="1"/>
           <p:nvPr/>
         </p:nvSpPr>
@@ -9042,8 +10094,8 @@
         </p:nvSpPr>
         <p:spPr>
           <a:xfrm>
-            <a:off x="7886342" y="1207008"/>
-            <a:ext cx="1311049" cy="4352544"/>
+            <a:off x="7206582" y="1207008"/>
+            <a:ext cx="2670569" cy="4352544"/>
           </a:xfrm>
           <a:prstGeom prst="rect">
             <a:avLst/>
@@ -9074,8 +10126,8 @@
         </p:nvSpPr>
         <p:spPr>
           <a:xfrm>
-            <a:off x="8005214" y="1325880"/>
-            <a:ext cx="1073305" cy="4114800"/>
+            <a:off x="7325454" y="1325880"/>
+            <a:ext cx="2432825" cy="4114800"/>
           </a:xfrm>
           <a:prstGeom prst="rect">
             <a:avLst/>
@@ -9106,8 +10158,8 @@
         </p:nvSpPr>
         <p:spPr>
           <a:xfrm>
-            <a:off x="8005214" y="1325880"/>
-            <a:ext cx="1073305" cy="50800"/>
+            <a:off x="7325454" y="1325880"/>
+            <a:ext cx="2432825" cy="50800"/>
           </a:xfrm>
           <a:prstGeom prst="rect">
             <a:avLst/>
@@ -9136,8 +10188,8 @@
         </p:nvSpPr>
         <p:spPr>
           <a:xfrm>
-            <a:off x="8279534" y="1600200"/>
-            <a:ext cx="524665" cy="3657600"/>
+            <a:off x="7599774" y="1600200"/>
+            <a:ext cx="1884185" cy="3657600"/>
           </a:xfrm>
           <a:prstGeom prst="rect">
             <a:avLst/>
@@ -9184,29 +10236,29 @@
               </a:spcAft>
             </a:pPr>
             <a:r>
-              <a:rPr sz="900" b="0" i="0">
+              <a:rPr sz="1500" b="0" i="0">
                 <a:solidFill>
                   <a:srgbClr val="1A1A1A"/>
                 </a:solidFill>
                 <a:latin typeface="Palatino"/>
               </a:rPr>
-              <a:t>Figure 7.3 crop showing two later intervals, their OHLC bars, and the rising price context used in the worked read.</a:t>
-            </a:r>
-          </a:p>
-        </p:txBody>
-      </p:sp>
-      <p:sp>
-        <p:nvSpPr>
-          <p:cNvPr id="18" name="Oval 17"/>
-          <p:cNvSpPr/>
-          <p:nvPr/>
-        </p:nvSpPr>
-        <p:spPr>
-          <a:xfrm>
-            <a:off x="8091079" y="2478024"/>
-            <a:ext cx="171728" cy="781811"/>
-          </a:xfrm>
-          <a:prstGeom prst="ellipse">
+              <a:t>Figure 7.3 crop showing the two counted OHLC bars, the second bar's location, and the rising price context used in the worked read.</a:t>
+            </a:r>
+          </a:p>
+        </p:txBody>
+      </p:sp>
+      <p:sp>
+        <p:nvSpPr>
+          <p:cNvPr id="18" name="Rectangle 17"/>
+          <p:cNvSpPr/>
+          <p:nvPr/>
+        </p:nvSpPr>
+        <p:spPr>
+          <a:xfrm>
+            <a:off x="7812019" y="3547872"/>
+            <a:ext cx="1192084" cy="1728215"/>
+          </a:xfrm>
+          <a:prstGeom prst="rect">
             <a:avLst/>
           </a:prstGeom>
           <a:noFill/>
@@ -9232,8 +10284,8 @@
         </p:nvSpPr>
         <p:spPr>
           <a:xfrm>
-            <a:off x="8498935" y="2066544"/>
-            <a:ext cx="171728" cy="864108"/>
+            <a:off x="8566195" y="3794760"/>
+            <a:ext cx="413580" cy="1399031"/>
           </a:xfrm>
           <a:prstGeom prst="ellipse">
             <a:avLst/>
@@ -9261,8 +10313,8 @@
         </p:nvSpPr>
         <p:spPr>
           <a:xfrm>
-            <a:off x="8756528" y="1737360"/>
-            <a:ext cx="171728" cy="822959"/>
+            <a:off x="8663508" y="1655064"/>
+            <a:ext cx="608206" cy="1440180"/>
           </a:xfrm>
           <a:prstGeom prst="ellipse">
             <a:avLst/>
@@ -9290,7 +10342,7 @@
         </p:nvSpPr>
         <p:spPr>
           <a:xfrm>
-            <a:off x="7909397" y="2103120"/>
+            <a:off x="7489377" y="3337560"/>
             <a:ext cx="256032" cy="256032"/>
           </a:xfrm>
           <a:prstGeom prst="ellipse">
@@ -9341,7 +10393,7 @@
         </p:nvSpPr>
         <p:spPr>
           <a:xfrm>
-            <a:off x="8596313" y="1732788"/>
+            <a:off x="8949073" y="3584448"/>
             <a:ext cx="256032" cy="256032"/>
           </a:xfrm>
           <a:prstGeom prst="ellipse">
@@ -9392,7 +10444,7 @@
         </p:nvSpPr>
         <p:spPr>
           <a:xfrm>
-            <a:off x="8843173" y="1485900"/>
+            <a:off x="9241012" y="1403604"/>
             <a:ext cx="256032" cy="256032"/>
           </a:xfrm>
           <a:prstGeom prst="ellipse">
@@ -10053,8 +11105,8 @@
         </p:nvSpPr>
         <p:spPr>
           <a:xfrm>
-            <a:off x="7814789" y="1207008"/>
-            <a:ext cx="1454156" cy="4352544"/>
+            <a:off x="7135028" y="1207008"/>
+            <a:ext cx="2813677" cy="4352544"/>
           </a:xfrm>
           <a:prstGeom prst="rect">
             <a:avLst/>
@@ -10085,8 +11137,8 @@
         </p:nvSpPr>
         <p:spPr>
           <a:xfrm>
-            <a:off x="7933661" y="1325880"/>
-            <a:ext cx="1216412" cy="4114800"/>
+            <a:off x="7253900" y="1325880"/>
+            <a:ext cx="2575933" cy="4114800"/>
           </a:xfrm>
           <a:prstGeom prst="rect">
             <a:avLst/>
@@ -10117,8 +11169,8 @@
         </p:nvSpPr>
         <p:spPr>
           <a:xfrm>
-            <a:off x="7933661" y="1325880"/>
-            <a:ext cx="1216412" cy="50800"/>
+            <a:off x="7253900" y="1325880"/>
+            <a:ext cx="2575933" cy="50800"/>
           </a:xfrm>
           <a:prstGeom prst="rect">
             <a:avLst/>
@@ -10147,8 +11199,8 @@
         </p:nvSpPr>
         <p:spPr>
           <a:xfrm>
-            <a:off x="8207981" y="1600200"/>
-            <a:ext cx="667772" cy="3657600"/>
+            <a:off x="7528220" y="1600200"/>
+            <a:ext cx="2027293" cy="3657600"/>
           </a:xfrm>
           <a:prstGeom prst="rect">
             <a:avLst/>
@@ -10195,29 +11247,29 @@
               </a:spcAft>
             </a:pPr>
             <a:r>
-              <a:rPr sz="1100" b="0" i="0">
+              <a:rPr sz="1500" b="0" i="0">
                 <a:solidFill>
                   <a:srgbClr val="1A1A1A"/>
                 </a:solidFill>
                 <a:latin typeface="Palatino"/>
               </a:rPr>
-              <a:t>Figure 7.3 crop showing two later intervals, their OHLC bars, and the rising price context used in the worked read.</a:t>
-            </a:r>
-          </a:p>
-        </p:txBody>
-      </p:sp>
-      <p:sp>
-        <p:nvSpPr>
-          <p:cNvPr id="18" name="Oval 17"/>
-          <p:cNvSpPr/>
-          <p:nvPr/>
-        </p:nvSpPr>
-        <p:spPr>
-          <a:xfrm>
-            <a:off x="8030974" y="2478024"/>
-            <a:ext cx="194626" cy="781811"/>
-          </a:xfrm>
-          <a:prstGeom prst="ellipse">
+              <a:t>Figure 7.3 crop showing the two counted OHLC bars, the second bar's location, and the rising price context used in the worked read.</a:t>
+            </a:r>
+          </a:p>
+        </p:txBody>
+      </p:sp>
+      <p:sp>
+        <p:nvSpPr>
+          <p:cNvPr id="18" name="Rectangle 17"/>
+          <p:cNvSpPr/>
+          <p:nvPr/>
+        </p:nvSpPr>
+        <p:spPr>
+          <a:xfrm>
+            <a:off x="7769087" y="3547872"/>
+            <a:ext cx="1262207" cy="1728215"/>
+          </a:xfrm>
+          <a:prstGeom prst="rect">
             <a:avLst/>
           </a:prstGeom>
           <a:noFill/>
@@ -10243,8 +11295,8 @@
         </p:nvSpPr>
         <p:spPr>
           <a:xfrm>
-            <a:off x="8493210" y="2066544"/>
-            <a:ext cx="194626" cy="864108"/>
+            <a:off x="8567626" y="3794760"/>
+            <a:ext cx="437908" cy="1399031"/>
           </a:xfrm>
           <a:prstGeom prst="ellipse">
             <a:avLst/>
@@ -10272,8 +11324,8 @@
         </p:nvSpPr>
         <p:spPr>
           <a:xfrm>
-            <a:off x="8785150" y="1737360"/>
-            <a:ext cx="194626" cy="822959"/>
+            <a:off x="8670664" y="1655064"/>
+            <a:ext cx="643983" cy="1440180"/>
           </a:xfrm>
           <a:prstGeom prst="ellipse">
             <a:avLst/>
@@ -10301,7 +11353,7 @@
         </p:nvSpPr>
         <p:spPr>
           <a:xfrm>
-            <a:off x="7842137" y="2103120"/>
+            <a:off x="7434996" y="3337560"/>
             <a:ext cx="256032" cy="256032"/>
           </a:xfrm>
           <a:prstGeom prst="ellipse">
@@ -10352,7 +11404,7 @@
         </p:nvSpPr>
         <p:spPr>
           <a:xfrm>
-            <a:off x="8620641" y="1732788"/>
+            <a:off x="8980556" y="3584448"/>
             <a:ext cx="256032" cy="256032"/>
           </a:xfrm>
           <a:prstGeom prst="ellipse">
@@ -10403,7 +11455,7 @@
         </p:nvSpPr>
         <p:spPr>
           <a:xfrm>
-            <a:off x="8900416" y="1485900"/>
+            <a:off x="9289668" y="1403604"/>
             <a:ext cx="256032" cy="256032"/>
           </a:xfrm>
           <a:prstGeom prst="ellipse">
@@ -10818,7 +11870,7 @@
                 </a:solidFill>
                 <a:latin typeface="Arial"/>
               </a:rPr>
-              <a:t>Ours, invented: bullish formation plus uptrend means both sentiments are bullish and agree.</a:t>
+              <a:t>Ours, invented: an uptrend rises 4.0% over four bars; a bullish formation rises 2.0% over two bars. Both are bullish and agree.</a:t>
             </a:r>
           </a:p>
           <a:p>
@@ -11172,7 +12224,7 @@
         <p:spPr>
           <a:xfrm>
             <a:off x="777240" y="1965960"/>
-            <a:ext cx="10637215" cy="3108960"/>
+            <a:ext cx="4572000" cy="3108960"/>
           </a:xfrm>
           <a:prstGeom prst="rect">
             <a:avLst/>
@@ -11187,89 +12239,67 @@
           <a:p>
             <a:pPr algn="l">
               <a:lnSpc>
-                <a:spcPct val="118000"/>
-              </a:lnSpc>
-              <a:spcBef>
-                <a:spcPts val="0"/>
-              </a:spcBef>
-              <a:spcAft>
-                <a:spcPts val="1300"/>
-              </a:spcAft>
-            </a:pPr>
-            <a:r>
-              <a:rPr sz="2100" b="0" i="0">
+                <a:spcPct val="105000"/>
+              </a:lnSpc>
+              <a:spcBef>
+                <a:spcPts val="0"/>
+              </a:spcBef>
+              <a:spcAft>
+                <a:spcPts val="1100"/>
+              </a:spcAft>
+            </a:pPr>
+            <a:r>
+              <a:rPr sz="2000" b="0" i="0">
                 <a:solidFill>
                   <a:srgbClr val="1A1A1A"/>
                 </a:solidFill>
                 <a:latin typeface="Arial"/>
               </a:rPr>
-              <a:t>Now apply the rule to four invented cases: bullish plus bullish is continuation; bearish plus bearish is continuation.</a:t>
+              <a:t>Now apply four invented cases: +4.0% trend/+2.0% formation and -4.0%/-2.0% agree, so both continue.</a:t>
             </a:r>
           </a:p>
           <a:p>
             <a:pPr algn="l">
               <a:lnSpc>
-                <a:spcPct val="118000"/>
-              </a:lnSpc>
-              <a:spcBef>
-                <a:spcPts val="0"/>
-              </a:spcBef>
-              <a:spcAft>
-                <a:spcPts val="1300"/>
-              </a:spcAft>
-            </a:pPr>
-            <a:r>
-              <a:rPr sz="2100" b="0" i="0">
+                <a:spcPct val="105000"/>
+              </a:lnSpc>
+              <a:spcBef>
+                <a:spcPts val="0"/>
+              </a:spcBef>
+              <a:spcAft>
+                <a:spcPts val="1100"/>
+              </a:spcAft>
+            </a:pPr>
+            <a:r>
+              <a:rPr sz="2000" b="0" i="0">
                 <a:solidFill>
                   <a:srgbClr val="1A1A1A"/>
                 </a:solidFill>
                 <a:latin typeface="Arial"/>
               </a:rPr>
-              <a:t>Bullish trend plus bearish intrinsic is potential reversal. Bearish trend plus bullish intrinsic is also potential reversal.</a:t>
+              <a:t>+4.0%/-2.0% disagrees, so potential reversal; -4.0%/+2.0% also disagrees, so potential reversal.</a:t>
             </a:r>
           </a:p>
           <a:p>
             <a:pPr algn="l">
               <a:lnSpc>
-                <a:spcPct val="118000"/>
-              </a:lnSpc>
-              <a:spcBef>
-                <a:spcPts val="0"/>
-              </a:spcBef>
-              <a:spcAft>
-                <a:spcPts val="1300"/>
-              </a:spcAft>
-            </a:pPr>
-            <a:r>
-              <a:rPr sz="2100" b="0" i="0">
+                <a:spcPct val="105000"/>
+              </a:lnSpc>
+              <a:spcBef>
+                <a:spcPts val="0"/>
+              </a:spcBef>
+              <a:spcAft>
+                <a:spcPts val="1100"/>
+              </a:spcAft>
+            </a:pPr>
+            <a:r>
+              <a:rPr sz="2000" b="0" i="0">
                 <a:solidFill>
                   <a:srgbClr val="1A1A1A"/>
                 </a:solidFill>
                 <a:latin typeface="Arial"/>
               </a:rPr>
-              <a:t>The book says agreement means continuation and disagreement means reversal (Lim, p. 211).</a:t>
-            </a:r>
-          </a:p>
-          <a:p>
-            <a:pPr algn="l">
-              <a:lnSpc>
-                <a:spcPct val="118000"/>
-              </a:lnSpc>
-              <a:spcBef>
-                <a:spcPts val="0"/>
-              </a:spcBef>
-              <a:spcAft>
-                <a:spcPts val="1300"/>
-              </a:spcAft>
-            </a:pPr>
-            <a:r>
-              <a:rPr sz="2100" b="0" i="0">
-                <a:solidFill>
-                  <a:srgbClr val="1A1A1A"/>
-                </a:solidFill>
-                <a:latin typeface="Arial"/>
-              </a:rPr>
-              <a:t>Meaning/action: use both sentiments; neither alone gives the classification.</a:t>
+              <a:t>Lim's rule: agreement means continuation; disagreement means reversal (p. 211). Compare both sentiments.</a:t>
             </a:r>
           </a:p>
         </p:txBody>
@@ -11282,17 +12312,19 @@
         </p:nvSpPr>
         <p:spPr>
           <a:xfrm>
-            <a:off x="777240" y="5211318"/>
-            <a:ext cx="82296" cy="467614"/>
+            <a:off x="5669279" y="1810512"/>
+            <a:ext cx="5745175" cy="3087950"/>
           </a:xfrm>
           <a:prstGeom prst="rect">
             <a:avLst/>
           </a:prstGeom>
           <a:solidFill>
-            <a:srgbClr val="F2A900"/>
+            <a:srgbClr val="FFFFFF"/>
           </a:solidFill>
-          <a:ln>
-            <a:noFill/>
+          <a:ln w="12700">
+            <a:solidFill>
+              <a:srgbClr val="D7E0D9"/>
+            </a:solidFill>
           </a:ln>
           <a:effectLst/>
         </p:spPr>
@@ -11304,16 +12336,40 @@
           </a:p>
         </p:txBody>
       </p:sp>
-      <p:sp>
-        <p:nvSpPr>
-          <p:cNvPr id="9" name="TextBox 8"/>
+      <p:pic>
+        <p:nvPicPr>
+          <p:cNvPr id="9" name="Picture 8" descr="chart-s.png"/>
+          <p:cNvPicPr>
+            <a:picLocks noChangeAspect="1"/>
+          </p:cNvPicPr>
+          <p:nvPr/>
+        </p:nvPicPr>
+        <p:blipFill>
+          <a:blip r:embed="rId2"/>
+          <a:stretch>
+            <a:fillRect/>
+          </a:stretch>
+        </p:blipFill>
+        <p:spPr>
+          <a:xfrm>
+            <a:off x="5788151" y="1929384"/>
+            <a:ext cx="5507431" cy="2850206"/>
+          </a:xfrm>
+          <a:prstGeom prst="rect">
+            <a:avLst/>
+          </a:prstGeom>
+        </p:spPr>
+      </p:pic>
+      <p:sp>
+        <p:nvSpPr>
+          <p:cNvPr id="10" name="TextBox 9"/>
           <p:cNvSpPr txBox="1"/>
           <p:nvPr/>
         </p:nvSpPr>
         <p:spPr>
           <a:xfrm>
-            <a:off x="1069848" y="5247894"/>
-            <a:ext cx="10344607" cy="467614"/>
+            <a:off x="5669279" y="4989902"/>
+            <a:ext cx="5745175" cy="274320"/>
           </a:xfrm>
           <a:prstGeom prst="rect">
             <a:avLst/>
@@ -11328,30 +12384,30 @@
           <a:p>
             <a:pPr algn="l">
               <a:lnSpc>
-                <a:spcPct val="115000"/>
-              </a:lnSpc>
-              <a:spcBef>
-                <a:spcPts val="0"/>
-              </a:spcBef>
-              <a:spcAft>
-                <a:spcPts val="0"/>
-              </a:spcAft>
-            </a:pPr>
-            <a:r>
-              <a:rPr sz="2200" b="1" i="0">
-                <a:solidFill>
-                  <a:srgbClr val="1A1A1A"/>
-                </a:solidFill>
-                <a:latin typeface="Arial"/>
-              </a:rPr>
-              <a:t>The generic formations begin with this two-by-two reading.</a:t>
-            </a:r>
-          </a:p>
-        </p:txBody>
-      </p:sp>
-      <p:sp>
-        <p:nvSpPr>
-          <p:cNvPr id="10" name="TextBox 9"/>
+                <a:spcPct val="100000"/>
+              </a:lnSpc>
+              <a:spcBef>
+                <a:spcPts val="0"/>
+              </a:spcBef>
+              <a:spcAft>
+                <a:spcPts val="0"/>
+              </a:spcAft>
+            </a:pPr>
+            <a:r>
+              <a:rPr sz="900" b="0" i="0">
+                <a:solidFill>
+                  <a:srgbClr val="818181"/>
+                </a:solidFill>
+                <a:latin typeface="Arial"/>
+              </a:rPr>
+              <a:t>Chart S - FIN1209 teaching chart, drawn for this course. Illustrative data, not a real instrument.</a:t>
+            </a:r>
+          </a:p>
+        </p:txBody>
+      </p:sp>
+      <p:sp>
+        <p:nvSpPr>
+          <p:cNvPr id="11" name="TextBox 10"/>
           <p:cNvSpPr txBox="1"/>
           <p:nvPr/>
         </p:nvSpPr>
@@ -11575,7 +12631,7 @@
         <p:spPr>
           <a:xfrm>
             <a:off x="777240" y="1207008"/>
-            <a:ext cx="4998567" cy="4590288"/>
+            <a:ext cx="4572000" cy="2038349"/>
           </a:xfrm>
           <a:prstGeom prst="rect">
             <a:avLst/>
@@ -11604,8 +12660,8 @@
         </p:nvSpPr>
         <p:spPr>
           <a:xfrm>
-            <a:off x="1051560" y="1453896"/>
-            <a:ext cx="4449927" cy="228600"/>
+            <a:off x="1005840" y="1298448"/>
+            <a:ext cx="4114800" cy="228600"/>
           </a:xfrm>
           <a:prstGeom prst="rect">
             <a:avLst/>
@@ -11649,8 +12705,8 @@
         </p:nvSpPr>
         <p:spPr>
           <a:xfrm>
-            <a:off x="1051560" y="1737360"/>
-            <a:ext cx="4449927" cy="588009"/>
+            <a:off x="1005840" y="1499616"/>
+            <a:ext cx="4114800" cy="588009"/>
           </a:xfrm>
           <a:prstGeom prst="rect">
             <a:avLst/>
@@ -11694,8 +12750,8 @@
         </p:nvSpPr>
         <p:spPr>
           <a:xfrm>
-            <a:off x="1051560" y="2526538"/>
-            <a:ext cx="4449927" cy="2926080"/>
+            <a:off x="1005840" y="2069338"/>
+            <a:ext cx="4114800" cy="1102867"/>
           </a:xfrm>
           <a:prstGeom prst="rect">
             <a:avLst/>
@@ -11710,17 +12766,17 @@
           <a:p>
             <a:pPr algn="l">
               <a:lnSpc>
-                <a:spcPct val="112000"/>
-              </a:lnSpc>
-              <a:spcBef>
-                <a:spcPts val="0"/>
-              </a:spcBef>
-              <a:spcAft>
-                <a:spcPts val="900"/>
-              </a:spcAft>
-            </a:pPr>
-            <a:r>
-              <a:rPr sz="1500" b="0" i="0">
+                <a:spcPct val="105000"/>
+              </a:lnSpc>
+              <a:spcBef>
+                <a:spcPts val="0"/>
+              </a:spcBef>
+              <a:spcAft>
+                <a:spcPts val="200"/>
+              </a:spcAft>
+            </a:pPr>
+            <a:r>
+              <a:rPr sz="1700" b="0" i="0">
                 <a:solidFill>
                   <a:srgbClr val="FFFFFF"/>
                 </a:solidFill>
@@ -11732,17 +12788,17 @@
           <a:p>
             <a:pPr algn="l">
               <a:lnSpc>
-                <a:spcPct val="112000"/>
-              </a:lnSpc>
-              <a:spcBef>
-                <a:spcPts val="0"/>
-              </a:spcBef>
-              <a:spcAft>
-                <a:spcPts val="900"/>
-              </a:spcAft>
-            </a:pPr>
-            <a:r>
-              <a:rPr sz="1500" b="0" i="0">
+                <a:spcPct val="105000"/>
+              </a:lnSpc>
+              <a:spcBef>
+                <a:spcPts val="0"/>
+              </a:spcBef>
+              <a:spcAft>
+                <a:spcPts val="200"/>
+              </a:spcAft>
+            </a:pPr>
+            <a:r>
+              <a:rPr sz="1700" b="0" i="0">
                 <a:solidFill>
                   <a:srgbClr val="FFFFFF"/>
                 </a:solidFill>
@@ -11754,17 +12810,17 @@
           <a:p>
             <a:pPr algn="l">
               <a:lnSpc>
-                <a:spcPct val="112000"/>
-              </a:lnSpc>
-              <a:spcBef>
-                <a:spcPts val="0"/>
-              </a:spcBef>
-              <a:spcAft>
-                <a:spcPts val="900"/>
-              </a:spcAft>
-            </a:pPr>
-            <a:r>
-              <a:rPr sz="1500" b="0" i="0">
+                <a:spcPct val="105000"/>
+              </a:lnSpc>
+              <a:spcBef>
+                <a:spcPts val="0"/>
+              </a:spcBef>
+              <a:spcAft>
+                <a:spcPts val="200"/>
+              </a:spcAft>
+            </a:pPr>
+            <a:r>
+              <a:rPr sz="1700" b="0" i="0">
                 <a:solidFill>
                   <a:srgbClr val="FFFFFF"/>
                 </a:solidFill>
@@ -11776,17 +12832,17 @@
           <a:p>
             <a:pPr algn="l">
               <a:lnSpc>
-                <a:spcPct val="112000"/>
-              </a:lnSpc>
-              <a:spcBef>
-                <a:spcPts val="0"/>
-              </a:spcBef>
-              <a:spcAft>
-                <a:spcPts val="900"/>
-              </a:spcAft>
-            </a:pPr>
-            <a:r>
-              <a:rPr sz="1500" b="0" i="0">
+                <a:spcPct val="105000"/>
+              </a:lnSpc>
+              <a:spcBef>
+                <a:spcPts val="0"/>
+              </a:spcBef>
+              <a:spcAft>
+                <a:spcPts val="200"/>
+              </a:spcAft>
+            </a:pPr>
+            <a:r>
+              <a:rPr sz="1700" b="0" i="0">
                 <a:solidFill>
                   <a:srgbClr val="FFFFFF"/>
                 </a:solidFill>
@@ -11805,8 +12861,8 @@
         </p:nvSpPr>
         <p:spPr>
           <a:xfrm>
-            <a:off x="6415887" y="1207008"/>
-            <a:ext cx="4998567" cy="4590288"/>
+            <a:off x="777240" y="3336798"/>
+            <a:ext cx="4572000" cy="2038349"/>
           </a:xfrm>
           <a:prstGeom prst="rect">
             <a:avLst/>
@@ -11835,8 +12891,8 @@
         </p:nvSpPr>
         <p:spPr>
           <a:xfrm>
-            <a:off x="6690207" y="1453896"/>
-            <a:ext cx="4449927" cy="228600"/>
+            <a:off x="1005840" y="3428238"/>
+            <a:ext cx="4114800" cy="228600"/>
           </a:xfrm>
           <a:prstGeom prst="rect">
             <a:avLst/>
@@ -11880,8 +12936,8 @@
         </p:nvSpPr>
         <p:spPr>
           <a:xfrm>
-            <a:off x="6690207" y="1737360"/>
-            <a:ext cx="4449927" cy="588009"/>
+            <a:off x="1005840" y="3629406"/>
+            <a:ext cx="4114800" cy="588009"/>
           </a:xfrm>
           <a:prstGeom prst="rect">
             <a:avLst/>
@@ -11912,7 +12968,7 @@
                 </a:solidFill>
                 <a:latin typeface="Arial"/>
               </a:rPr>
-              <a:t>A bullish formation in an uptrend is a potential:</a:t>
+              <a:t>An inverted head and shoulders in an uptrend is a potential:</a:t>
             </a:r>
           </a:p>
         </p:txBody>
@@ -11925,8 +12981,8 @@
         </p:nvSpPr>
         <p:spPr>
           <a:xfrm>
-            <a:off x="6690207" y="2526538"/>
-            <a:ext cx="4449927" cy="2926080"/>
+            <a:off x="1005840" y="4199128"/>
+            <a:ext cx="4114800" cy="1102867"/>
           </a:xfrm>
           <a:prstGeom prst="rect">
             <a:avLst/>
@@ -11941,17 +12997,17 @@
           <a:p>
             <a:pPr algn="l">
               <a:lnSpc>
-                <a:spcPct val="112000"/>
-              </a:lnSpc>
-              <a:spcBef>
-                <a:spcPts val="0"/>
-              </a:spcBef>
-              <a:spcAft>
-                <a:spcPts val="900"/>
-              </a:spcAft>
-            </a:pPr>
-            <a:r>
-              <a:rPr sz="1500" b="0" i="0">
+                <a:spcPct val="105000"/>
+              </a:lnSpc>
+              <a:spcBef>
+                <a:spcPts val="0"/>
+              </a:spcBef>
+              <a:spcAft>
+                <a:spcPts val="200"/>
+              </a:spcAft>
+            </a:pPr>
+            <a:r>
+              <a:rPr sz="1700" b="0" i="0">
                 <a:solidFill>
                   <a:srgbClr val="FFFFFF"/>
                 </a:solidFill>
@@ -11963,17 +13019,17 @@
           <a:p>
             <a:pPr algn="l">
               <a:lnSpc>
-                <a:spcPct val="112000"/>
-              </a:lnSpc>
-              <a:spcBef>
-                <a:spcPts val="0"/>
-              </a:spcBef>
-              <a:spcAft>
-                <a:spcPts val="900"/>
-              </a:spcAft>
-            </a:pPr>
-            <a:r>
-              <a:rPr sz="1500" b="0" i="0">
+                <a:spcPct val="105000"/>
+              </a:lnSpc>
+              <a:spcBef>
+                <a:spcPts val="0"/>
+              </a:spcBef>
+              <a:spcAft>
+                <a:spcPts val="200"/>
+              </a:spcAft>
+            </a:pPr>
+            <a:r>
+              <a:rPr sz="1700" b="0" i="0">
                 <a:solidFill>
                   <a:srgbClr val="FFFFFF"/>
                 </a:solidFill>
@@ -11985,17 +13041,17 @@
           <a:p>
             <a:pPr algn="l">
               <a:lnSpc>
-                <a:spcPct val="112000"/>
-              </a:lnSpc>
-              <a:spcBef>
-                <a:spcPts val="0"/>
-              </a:spcBef>
-              <a:spcAft>
-                <a:spcPts val="900"/>
-              </a:spcAft>
-            </a:pPr>
-            <a:r>
-              <a:rPr sz="1500" b="0" i="0">
+                <a:spcPct val="105000"/>
+              </a:lnSpc>
+              <a:spcBef>
+                <a:spcPts val="0"/>
+              </a:spcBef>
+              <a:spcAft>
+                <a:spcPts val="200"/>
+              </a:spcAft>
+            </a:pPr>
+            <a:r>
+              <a:rPr sz="1700" b="0" i="0">
                 <a:solidFill>
                   <a:srgbClr val="FFFFFF"/>
                 </a:solidFill>
@@ -12007,17 +13063,17 @@
           <a:p>
             <a:pPr algn="l">
               <a:lnSpc>
-                <a:spcPct val="112000"/>
-              </a:lnSpc>
-              <a:spcBef>
-                <a:spcPts val="0"/>
-              </a:spcBef>
-              <a:spcAft>
-                <a:spcPts val="900"/>
-              </a:spcAft>
-            </a:pPr>
-            <a:r>
-              <a:rPr sz="1500" b="0" i="0">
+                <a:spcPct val="105000"/>
+              </a:lnSpc>
+              <a:spcBef>
+                <a:spcPts val="0"/>
+              </a:spcBef>
+              <a:spcAft>
+                <a:spcPts val="200"/>
+              </a:spcAft>
+            </a:pPr>
+            <a:r>
+              <a:rPr sz="1700" b="0" i="0">
                 <a:solidFill>
                   <a:srgbClr val="FFFFFF"/>
                 </a:solidFill>
@@ -12030,7 +13086,108 @@
       </p:sp>
       <p:sp>
         <p:nvSpPr>
-          <p:cNvPr id="14" name="TextBox 13"/>
+          <p:cNvPr id="14" name="Rectangle 13"/>
+          <p:cNvSpPr/>
+          <p:nvPr/>
+        </p:nvSpPr>
+        <p:spPr>
+          <a:xfrm>
+            <a:off x="5669279" y="1207008"/>
+            <a:ext cx="5745175" cy="3087950"/>
+          </a:xfrm>
+          <a:prstGeom prst="rect">
+            <a:avLst/>
+          </a:prstGeom>
+          <a:solidFill>
+            <a:srgbClr val="FFFFFF"/>
+          </a:solidFill>
+          <a:ln w="12700">
+            <a:solidFill>
+              <a:srgbClr val="D7E0D9"/>
+            </a:solidFill>
+          </a:ln>
+          <a:effectLst/>
+        </p:spPr>
+        <p:txBody>
+          <a:bodyPr rtlCol="0" anchor="ctr"/>
+          <a:lstStyle/>
+          <a:p>
+            <a:pPr algn="ctr"/>
+          </a:p>
+        </p:txBody>
+      </p:sp>
+      <p:pic>
+        <p:nvPicPr>
+          <p:cNvPr id="15" name="Picture 14" descr="chart-s.png"/>
+          <p:cNvPicPr>
+            <a:picLocks noChangeAspect="1"/>
+          </p:cNvPicPr>
+          <p:nvPr/>
+        </p:nvPicPr>
+        <p:blipFill>
+          <a:blip r:embed="rId2"/>
+          <a:stretch>
+            <a:fillRect/>
+          </a:stretch>
+        </p:blipFill>
+        <p:spPr>
+          <a:xfrm>
+            <a:off x="5788151" y="1325880"/>
+            <a:ext cx="5507431" cy="2850206"/>
+          </a:xfrm>
+          <a:prstGeom prst="rect">
+            <a:avLst/>
+          </a:prstGeom>
+        </p:spPr>
+      </p:pic>
+      <p:sp>
+        <p:nvSpPr>
+          <p:cNvPr id="16" name="TextBox 15"/>
+          <p:cNvSpPr txBox="1"/>
+          <p:nvPr/>
+        </p:nvSpPr>
+        <p:spPr>
+          <a:xfrm>
+            <a:off x="5669279" y="4386398"/>
+            <a:ext cx="5745175" cy="274320"/>
+          </a:xfrm>
+          <a:prstGeom prst="rect">
+            <a:avLst/>
+          </a:prstGeom>
+          <a:noFill/>
+        </p:spPr>
+        <p:txBody>
+          <a:bodyPr wrap="square" anchor="t" lIns="0" rIns="0" tIns="0" bIns="0">
+            <a:spAutoFit/>
+          </a:bodyPr>
+          <a:lstStyle/>
+          <a:p>
+            <a:pPr algn="l">
+              <a:lnSpc>
+                <a:spcPct val="100000"/>
+              </a:lnSpc>
+              <a:spcBef>
+                <a:spcPts val="0"/>
+              </a:spcBef>
+              <a:spcAft>
+                <a:spcPts val="0"/>
+              </a:spcAft>
+            </a:pPr>
+            <a:r>
+              <a:rPr sz="900" b="0" i="0">
+                <a:solidFill>
+                  <a:srgbClr val="818181"/>
+                </a:solidFill>
+                <a:latin typeface="Arial"/>
+              </a:rPr>
+              <a:t>Chart S - FIN1209 teaching chart, drawn for this course. Illustrative data, not a real instrument.</a:t>
+            </a:r>
+          </a:p>
+        </p:txBody>
+      </p:sp>
+      <p:sp>
+        <p:nvSpPr>
+          <p:cNvPr id="17" name="TextBox 16"/>
           <p:cNvSpPr txBox="1"/>
           <p:nvPr/>
         </p:nvSpPr>
@@ -12254,7 +13411,7 @@
         <p:spPr>
           <a:xfrm>
             <a:off x="777240" y="1207008"/>
-            <a:ext cx="10637215" cy="1861819"/>
+            <a:ext cx="4572000" cy="2484120"/>
           </a:xfrm>
           <a:prstGeom prst="rect">
             <a:avLst/>
@@ -12286,7 +13443,7 @@
         <p:spPr>
           <a:xfrm>
             <a:off x="777240" y="1207008"/>
-            <a:ext cx="91440" cy="1861819"/>
+            <a:ext cx="91440" cy="2484120"/>
           </a:xfrm>
           <a:prstGeom prst="rect">
             <a:avLst/>
@@ -12315,8 +13472,8 @@
         </p:nvSpPr>
         <p:spPr>
           <a:xfrm>
-            <a:off x="1143000" y="1444752"/>
-            <a:ext cx="9905695" cy="325119"/>
+            <a:off x="1097280" y="1389888"/>
+            <a:ext cx="4023360" cy="588009"/>
           </a:xfrm>
           <a:prstGeom prst="rect">
             <a:avLst/>
@@ -12341,7 +13498,7 @@
               </a:spcAft>
             </a:pPr>
             <a:r>
-              <a:rPr sz="1600" b="0" i="0">
+              <a:rPr sz="1700" b="0" i="0">
                 <a:solidFill>
                   <a:srgbClr val="818181"/>
                 </a:solidFill>
@@ -12360,8 +13517,8 @@
         </p:nvSpPr>
         <p:spPr>
           <a:xfrm>
-            <a:off x="1143000" y="1934464"/>
-            <a:ext cx="9905695" cy="1206500"/>
+            <a:off x="1097280" y="2069338"/>
+            <a:ext cx="4023360" cy="1621790"/>
           </a:xfrm>
           <a:prstGeom prst="rect">
             <a:avLst/>
@@ -12386,7 +13543,7 @@
               </a:spcAft>
             </a:pPr>
             <a:r>
-              <a:rPr sz="2000" b="1" i="0">
+              <a:rPr sz="1800" b="1" i="0">
                 <a:solidFill>
                   <a:srgbClr val="007A33"/>
                 </a:solidFill>
@@ -12401,14 +13558,14 @@
                 <a:spcPct val="115000"/>
               </a:lnSpc>
               <a:spcBef>
-                <a:spcPts val="700"/>
-              </a:spcBef>
-              <a:spcAft>
-                <a:spcPts val="0"/>
-              </a:spcAft>
-            </a:pPr>
-            <a:r>
-              <a:rPr sz="1600" b="0" i="0">
+                <a:spcPts val="500"/>
+              </a:spcBef>
+              <a:spcAft>
+                <a:spcPts val="0"/>
+              </a:spcAft>
+            </a:pPr>
+            <a:r>
+              <a:rPr sz="1700" b="0" i="0">
                 <a:solidFill>
                   <a:srgbClr val="1A1A1A"/>
                 </a:solidFill>
@@ -12427,8 +13584,8 @@
         </p:nvSpPr>
         <p:spPr>
           <a:xfrm>
-            <a:off x="777240" y="3315716"/>
-            <a:ext cx="10637215" cy="1861819"/>
+            <a:off x="777240" y="3874008"/>
+            <a:ext cx="4572000" cy="2235835"/>
           </a:xfrm>
           <a:prstGeom prst="rect">
             <a:avLst/>
@@ -12459,8 +13616,8 @@
         </p:nvSpPr>
         <p:spPr>
           <a:xfrm>
-            <a:off x="777240" y="3315716"/>
-            <a:ext cx="91440" cy="1861819"/>
+            <a:off x="777240" y="3874008"/>
+            <a:ext cx="91440" cy="2235835"/>
           </a:xfrm>
           <a:prstGeom prst="rect">
             <a:avLst/>
@@ -12489,8 +13646,8 @@
         </p:nvSpPr>
         <p:spPr>
           <a:xfrm>
-            <a:off x="1143000" y="3553460"/>
-            <a:ext cx="9905695" cy="325119"/>
+            <a:off x="1097280" y="4056888"/>
+            <a:ext cx="4023360" cy="588009"/>
           </a:xfrm>
           <a:prstGeom prst="rect">
             <a:avLst/>
@@ -12515,13 +13672,13 @@
               </a:spcAft>
             </a:pPr>
             <a:r>
-              <a:rPr sz="1600" b="0" i="0">
+              <a:rPr sz="1700" b="0" i="0">
                 <a:solidFill>
                   <a:srgbClr val="818181"/>
                 </a:solidFill>
                 <a:latin typeface="Arial"/>
               </a:rPr>
-              <a:t>Q2   A bullish formation in an uptrend is a potential:</a:t>
+              <a:t>Q2   An inverted head and shoulders in an uptrend is a potential:</a:t>
             </a:r>
           </a:p>
         </p:txBody>
@@ -12534,8 +13691,8 @@
         </p:nvSpPr>
         <p:spPr>
           <a:xfrm>
-            <a:off x="1143000" y="4043172"/>
-            <a:ext cx="9905695" cy="1206500"/>
+            <a:off x="1097280" y="4736338"/>
+            <a:ext cx="4023360" cy="1373505"/>
           </a:xfrm>
           <a:prstGeom prst="rect">
             <a:avLst/>
@@ -12560,7 +13717,7 @@
               </a:spcAft>
             </a:pPr>
             <a:r>
-              <a:rPr sz="2000" b="1" i="0">
+              <a:rPr sz="1800" b="1" i="0">
                 <a:solidFill>
                   <a:srgbClr val="007A33"/>
                 </a:solidFill>
@@ -12575,27 +13732,128 @@
                 <a:spcPct val="115000"/>
               </a:lnSpc>
               <a:spcBef>
-                <a:spcPts val="700"/>
-              </a:spcBef>
-              <a:spcAft>
-                <a:spcPts val="0"/>
-              </a:spcAft>
-            </a:pPr>
-            <a:r>
-              <a:rPr sz="1600" b="0" i="0">
+                <a:spcPts val="500"/>
+              </a:spcBef>
+              <a:spcAft>
+                <a:spcPts val="0"/>
+              </a:spcAft>
+            </a:pPr>
+            <a:r>
+              <a:rPr sz="1700" b="0" i="0">
                 <a:solidFill>
                   <a:srgbClr val="1A1A1A"/>
                 </a:solidFill>
                 <a:latin typeface="Arial"/>
               </a:rPr>
-              <a:t>The bullish intrinsic bias agrees with bullish trend sentiment in an uptrend, so Lim classifies it as a potential continuation (p. 211).</a:t>
-            </a:r>
-          </a:p>
-        </p:txBody>
-      </p:sp>
-      <p:sp>
-        <p:nvSpPr>
-          <p:cNvPr id="14" name="TextBox 13"/>
+              <a:t>Chapter 4 calls it bullish. In an uptrend, bullish biases agree: potential continuation (p. 211).</a:t>
+            </a:r>
+          </a:p>
+        </p:txBody>
+      </p:sp>
+      <p:sp>
+        <p:nvSpPr>
+          <p:cNvPr id="14" name="Rectangle 13"/>
+          <p:cNvSpPr/>
+          <p:nvPr/>
+        </p:nvSpPr>
+        <p:spPr>
+          <a:xfrm>
+            <a:off x="5669279" y="1207008"/>
+            <a:ext cx="5745175" cy="3087950"/>
+          </a:xfrm>
+          <a:prstGeom prst="rect">
+            <a:avLst/>
+          </a:prstGeom>
+          <a:solidFill>
+            <a:srgbClr val="FFFFFF"/>
+          </a:solidFill>
+          <a:ln w="12700">
+            <a:solidFill>
+              <a:srgbClr val="D7E0D9"/>
+            </a:solidFill>
+          </a:ln>
+          <a:effectLst/>
+        </p:spPr>
+        <p:txBody>
+          <a:bodyPr rtlCol="0" anchor="ctr"/>
+          <a:lstStyle/>
+          <a:p>
+            <a:pPr algn="ctr"/>
+          </a:p>
+        </p:txBody>
+      </p:sp>
+      <p:pic>
+        <p:nvPicPr>
+          <p:cNvPr id="15" name="Picture 14" descr="chart-s.png"/>
+          <p:cNvPicPr>
+            <a:picLocks noChangeAspect="1"/>
+          </p:cNvPicPr>
+          <p:nvPr/>
+        </p:nvPicPr>
+        <p:blipFill>
+          <a:blip r:embed="rId2"/>
+          <a:stretch>
+            <a:fillRect/>
+          </a:stretch>
+        </p:blipFill>
+        <p:spPr>
+          <a:xfrm>
+            <a:off x="5788151" y="1325880"/>
+            <a:ext cx="5507431" cy="2850206"/>
+          </a:xfrm>
+          <a:prstGeom prst="rect">
+            <a:avLst/>
+          </a:prstGeom>
+        </p:spPr>
+      </p:pic>
+      <p:sp>
+        <p:nvSpPr>
+          <p:cNvPr id="16" name="TextBox 15"/>
+          <p:cNvSpPr txBox="1"/>
+          <p:nvPr/>
+        </p:nvSpPr>
+        <p:spPr>
+          <a:xfrm>
+            <a:off x="5669279" y="4386398"/>
+            <a:ext cx="5745175" cy="274320"/>
+          </a:xfrm>
+          <a:prstGeom prst="rect">
+            <a:avLst/>
+          </a:prstGeom>
+          <a:noFill/>
+        </p:spPr>
+        <p:txBody>
+          <a:bodyPr wrap="square" anchor="t" lIns="0" rIns="0" tIns="0" bIns="0">
+            <a:spAutoFit/>
+          </a:bodyPr>
+          <a:lstStyle/>
+          <a:p>
+            <a:pPr algn="l">
+              <a:lnSpc>
+                <a:spcPct val="100000"/>
+              </a:lnSpc>
+              <a:spcBef>
+                <a:spcPts val="0"/>
+              </a:spcBef>
+              <a:spcAft>
+                <a:spcPts val="0"/>
+              </a:spcAft>
+            </a:pPr>
+            <a:r>
+              <a:rPr sz="900" b="0" i="0">
+                <a:solidFill>
+                  <a:srgbClr val="818181"/>
+                </a:solidFill>
+                <a:latin typeface="Arial"/>
+              </a:rPr>
+              <a:t>Chart S - FIN1209 teaching chart, drawn for this course. Illustrative data, not a real instrument.</a:t>
+            </a:r>
+          </a:p>
+        </p:txBody>
+      </p:sp>
+      <p:sp>
+        <p:nvSpPr>
+          <p:cNvPr id="17" name="TextBox 16"/>
           <p:cNvSpPr txBox="1"/>
           <p:nvPr/>
         </p:nvSpPr>
@@ -12876,7 +14134,7 @@
                 </a:solidFill>
                 <a:latin typeface="Arial"/>
               </a:rPr>
-              <a:t>A price bar is a compact record of opening, highest, lowest, and closing prices. This chapter teaches how to read that record as price action.</a:t>
+              <a:t>A price bar is a compact record of opening, highest, lowest, and closing prices. This chapter teaches how to read that four-price record.</a:t>
             </a:r>
           </a:p>
           <a:p>
@@ -21775,7 +23033,7 @@
         <p:spPr>
           <a:xfrm>
             <a:off x="777240" y="1965960"/>
-            <a:ext cx="5303520" cy="3108960"/>
+            <a:ext cx="5669280" cy="3108960"/>
           </a:xfrm>
           <a:prstGeom prst="rect">
             <a:avLst/>
@@ -21800,13 +23058,13 @@
               </a:spcAft>
             </a:pPr>
             <a:r>
-              <a:rPr sz="1600" b="0" i="0">
+              <a:rPr sz="1800" b="0" i="0">
                 <a:solidFill>
                   <a:srgbClr val="1A1A1A"/>
                 </a:solidFill>
                 <a:latin typeface="Arial"/>
               </a:rPr>
-              <a:t>First recall Chapter 3's OHLC. Lim writes, "A standard price bar comprises an open (O), high (H), low (L), and close (C) price" (p. 209).</a:t>
+              <a:t>Lim writes, "A standard price bar comprises an open (O), high (H), low (L), and close (C) price" (p. 209).</a:t>
             </a:r>
           </a:p>
           <a:p>
@@ -21822,13 +23080,13 @@
               </a:spcAft>
             </a:pPr>
             <a:r>
-              <a:rPr sz="1600" b="0" i="0">
+              <a:rPr sz="1800" b="0" i="0">
                 <a:solidFill>
                   <a:srgbClr val="1A1A1A"/>
                 </a:solidFill>
                 <a:latin typeface="Arial"/>
               </a:rPr>
-              <a:t>Lim defines range as the absolute high-to-low distance, |H - L| (p. 209). Ours, invented: O 50.00, H 52.40, L 49.60, C 51.10; range = PHP 2.80.</a:t>
+              <a:t>Lim defines range as |H - L| (p. 209). Ours, invented: O 50.00, H 52.40, L 49.60, C 51.10; range = Philippine pesos (PHP) 2.80.</a:t>
             </a:r>
           </a:p>
           <a:p>
@@ -21844,31 +23102,13 @@
               </a:spcAft>
             </a:pPr>
             <a:r>
-              <a:rPr sz="1600" b="0" i="0">
+              <a:rPr sz="1800" b="0" i="0">
                 <a:solidFill>
                   <a:srgbClr val="1A1A1A"/>
                 </a:solidFill>
                 <a:latin typeface="Arial"/>
               </a:rPr>
-              <a:t>Meaning/action: read these four retained prices before interpreting a pattern. The figure marks the close </a:t>
-            </a:r>
-            <a:r>
-              <a:rPr sz="1600" b="1" i="0">
-                <a:solidFill>
-                  <a:srgbClr val="7B3FA0"/>
-                </a:solidFill>
-                <a:latin typeface="Arial"/>
-              </a:rPr>
-              <a:t>(4)</a:t>
-            </a:r>
-            <a:r>
-              <a:rPr sz="1600" b="0" i="0">
-                <a:solidFill>
-                  <a:srgbClr val="1A1A1A"/>
-                </a:solidFill>
-                <a:latin typeface="Arial"/>
-              </a:rPr>
-              <a:t>.</a:t>
+              <a:t>Action: read these four prices before a pattern. Figure 7.1 marks the close (4).</a:t>
             </a:r>
           </a:p>
         </p:txBody>
@@ -21882,7 +23122,7 @@
         <p:spPr>
           <a:xfrm>
             <a:off x="777240" y="4965192"/>
-            <a:ext cx="82296" cy="664464"/>
+            <a:ext cx="82296" cy="725424"/>
           </a:xfrm>
           <a:prstGeom prst="rect">
             <a:avLst/>
@@ -21912,7 +23152,7 @@
         <p:spPr>
           <a:xfrm>
             <a:off x="1069848" y="5001768"/>
-            <a:ext cx="5010912" cy="664464"/>
+            <a:ext cx="5376672" cy="725424"/>
           </a:xfrm>
           <a:prstGeom prst="rect">
             <a:avLst/>
@@ -21937,7 +23177,7 @@
               </a:spcAft>
             </a:pPr>
             <a:r>
-              <a:rPr sz="1700" b="1" i="0">
+              <a:rPr sz="1900" b="1" i="0">
                 <a:solidFill>
                   <a:srgbClr val="1A1A1A"/>
                 </a:solidFill>
@@ -21956,8 +23196,8 @@
         </p:nvSpPr>
         <p:spPr>
           <a:xfrm>
-            <a:off x="6400799" y="1810512"/>
-            <a:ext cx="5013655" cy="3683222"/>
+            <a:off x="6766559" y="1810512"/>
+            <a:ext cx="4647894" cy="3419352"/>
           </a:xfrm>
           <a:prstGeom prst="rect">
             <a:avLst/>
@@ -21988,8 +23228,8 @@
         </p:nvSpPr>
         <p:spPr>
           <a:xfrm>
-            <a:off x="6519671" y="1929384"/>
-            <a:ext cx="4775911" cy="3445478"/>
+            <a:off x="6885431" y="1929384"/>
+            <a:ext cx="4410151" cy="3181608"/>
           </a:xfrm>
           <a:prstGeom prst="rect">
             <a:avLst/>
@@ -22020,8 +23260,8 @@
         </p:nvSpPr>
         <p:spPr>
           <a:xfrm>
-            <a:off x="6519671" y="1929384"/>
-            <a:ext cx="4775911" cy="50800"/>
+            <a:off x="6885431" y="1929384"/>
+            <a:ext cx="4410151" cy="50800"/>
           </a:xfrm>
           <a:prstGeom prst="rect">
             <a:avLst/>
@@ -22050,8 +23290,8 @@
         </p:nvSpPr>
         <p:spPr>
           <a:xfrm>
-            <a:off x="6793991" y="2203703"/>
-            <a:ext cx="4227271" cy="2988278"/>
+            <a:off x="7159751" y="2203703"/>
+            <a:ext cx="3861511" cy="2724408"/>
           </a:xfrm>
           <a:prstGeom prst="rect">
             <a:avLst/>
@@ -22117,8 +23357,8 @@
         </p:nvSpPr>
         <p:spPr>
           <a:xfrm>
-            <a:off x="9480736" y="3238665"/>
-            <a:ext cx="334313" cy="275638"/>
+            <a:off x="9619725" y="3138395"/>
+            <a:ext cx="308710" cy="254528"/>
           </a:xfrm>
           <a:prstGeom prst="ellipse">
             <a:avLst/>
@@ -22146,8 +23386,8 @@
         </p:nvSpPr>
         <p:spPr>
           <a:xfrm>
-            <a:off x="9480736" y="2618479"/>
-            <a:ext cx="334313" cy="275638"/>
+            <a:off x="9619725" y="2565705"/>
+            <a:ext cx="308710" cy="254528"/>
           </a:xfrm>
           <a:prstGeom prst="ellipse">
             <a:avLst/>
@@ -22175,8 +23415,8 @@
         </p:nvSpPr>
         <p:spPr>
           <a:xfrm>
-            <a:off x="9480736" y="4272309"/>
-            <a:ext cx="334313" cy="275638"/>
+            <a:off x="9619725" y="4092878"/>
+            <a:ext cx="308710" cy="254528"/>
           </a:xfrm>
           <a:prstGeom prst="ellipse">
             <a:avLst/>
@@ -22204,8 +23444,8 @@
         </p:nvSpPr>
         <p:spPr>
           <a:xfrm>
-            <a:off x="9815050" y="3479849"/>
-            <a:ext cx="334313" cy="275638"/>
+            <a:off x="9928436" y="3361108"/>
+            <a:ext cx="308710" cy="254528"/>
           </a:xfrm>
           <a:prstGeom prst="ellipse">
             <a:avLst/>
@@ -22233,7 +23473,7 @@
         </p:nvSpPr>
         <p:spPr>
           <a:xfrm>
-            <a:off x="9104781" y="3101505"/>
+            <a:off x="9262058" y="3001235"/>
             <a:ext cx="274320" cy="274320"/>
           </a:xfrm>
           <a:prstGeom prst="ellipse">
@@ -22284,7 +23524,7 @@
         </p:nvSpPr>
         <p:spPr>
           <a:xfrm>
-            <a:off x="10012204" y="2309045"/>
+            <a:off x="10099986" y="2269465"/>
             <a:ext cx="274320" cy="274320"/>
           </a:xfrm>
           <a:prstGeom prst="ellipse">
@@ -22335,7 +23575,7 @@
         </p:nvSpPr>
         <p:spPr>
           <a:xfrm>
-            <a:off x="10012204" y="4617516"/>
+            <a:off x="10099986" y="4401143"/>
             <a:ext cx="274320" cy="274320"/>
           </a:xfrm>
           <a:prstGeom prst="ellipse">
@@ -22386,7 +23626,7 @@
         </p:nvSpPr>
         <p:spPr>
           <a:xfrm>
-            <a:off x="10346518" y="3618327"/>
+            <a:off x="10408697" y="3478476"/>
             <a:ext cx="274320" cy="274320"/>
           </a:xfrm>
           <a:prstGeom prst="ellipse">
@@ -22437,8 +23677,8 @@
         </p:nvSpPr>
         <p:spPr>
           <a:xfrm>
-            <a:off x="6400799" y="5585174"/>
-            <a:ext cx="5013655" cy="274320"/>
+            <a:off x="6766559" y="5321304"/>
+            <a:ext cx="4647894" cy="274320"/>
           </a:xfrm>
           <a:prstGeom prst="rect">
             <a:avLst/>
@@ -22726,7 +23966,7 @@
         <p:spPr>
           <a:xfrm>
             <a:off x="777240" y="1965960"/>
-            <a:ext cx="4663440" cy="3108960"/>
+            <a:ext cx="5303520" cy="3108960"/>
           </a:xfrm>
           <a:prstGeom prst="rect">
             <a:avLst/>
@@ -22751,13 +23991,13 @@
               </a:spcAft>
             </a:pPr>
             <a:r>
-              <a:rPr sz="1500" b="0" i="0">
+              <a:rPr sz="2000" b="0" i="0">
                 <a:solidFill>
                   <a:srgbClr val="1A1A1A"/>
                 </a:solidFill>
                 <a:latin typeface="Arial"/>
               </a:rPr>
-              <a:t>Now trace the five invented trades that the book's Figure 7.1 filters into one bar: 50.00, 50.80, 49.60, 52.40, and 51.10 Philippine pesos.</a:t>
+              <a:t>Now trace Figure 7.1's five invented trades: 50.00, 50.80, 49.60, 52.40, and 51.10 Philippine pesos.</a:t>
             </a:r>
           </a:p>
           <a:p>
@@ -22773,16 +24013,16 @@
               </a:spcAft>
             </a:pPr>
             <a:r>
-              <a:rPr sz="1500" b="0" i="0">
+              <a:rPr sz="2000" b="0" i="0">
                 <a:solidFill>
                   <a:srgbClr val="1A1A1A"/>
                 </a:solidFill>
                 <a:latin typeface="Arial"/>
               </a:rPr>
-              <a:t>The first trade becomes O 50.00 </a:t>
-            </a:r>
-            <a:r>
-              <a:rPr sz="1500" b="1" i="0">
+              <a:t>First becomes O 50.00 </a:t>
+            </a:r>
+            <a:r>
+              <a:rPr sz="2000" b="1" i="0">
                 <a:solidFill>
                   <a:srgbClr val="E09B00"/>
                 </a:solidFill>
@@ -22791,16 +24031,16 @@
               <a:t>(1)</a:t>
             </a:r>
             <a:r>
-              <a:rPr sz="1500" b="0" i="0">
+              <a:rPr sz="2000" b="0" i="0">
                 <a:solidFill>
                   <a:srgbClr val="1A1A1A"/>
                 </a:solidFill>
                 <a:latin typeface="Arial"/>
               </a:rPr>
-              <a:t>. The highest trade becomes H 52.40 </a:t>
-            </a:r>
-            <a:r>
-              <a:rPr sz="1500" b="1" i="0">
+              <a:t>; highest H 52.40 </a:t>
+            </a:r>
+            <a:r>
+              <a:rPr sz="2000" b="1" i="0">
                 <a:solidFill>
                   <a:srgbClr val="C62828"/>
                 </a:solidFill>
@@ -22809,16 +24049,16 @@
               <a:t>(2)</a:t>
             </a:r>
             <a:r>
-              <a:rPr sz="1500" b="0" i="0">
+              <a:rPr sz="2000" b="0" i="0">
                 <a:solidFill>
                   <a:srgbClr val="1A1A1A"/>
                 </a:solidFill>
                 <a:latin typeface="Arial"/>
               </a:rPr>
-              <a:t>, and the last trade becomes C 51.10 </a:t>
-            </a:r>
-            <a:r>
-              <a:rPr sz="1500" b="1" i="0">
+              <a:t>; last C 51.10 </a:t>
+            </a:r>
+            <a:r>
+              <a:rPr sz="2000" b="1" i="0">
                 <a:solidFill>
                   <a:srgbClr val="1F5FAD"/>
                 </a:solidFill>
@@ -22827,7 +24067,7 @@
               <a:t>(3)</a:t>
             </a:r>
             <a:r>
-              <a:rPr sz="1500" b="0" i="0">
+              <a:rPr sz="2000" b="0" i="0">
                 <a:solidFill>
                   <a:srgbClr val="1A1A1A"/>
                 </a:solidFill>
@@ -22849,16 +24089,16 @@
               </a:spcAft>
             </a:pPr>
             <a:r>
-              <a:rPr sz="1500" b="0" i="0">
+              <a:rPr sz="2000" b="0" i="0">
                 <a:solidFill>
                   <a:srgbClr val="1A1A1A"/>
                 </a:solidFill>
                 <a:latin typeface="Arial"/>
               </a:rPr>
-              <a:t>The lowest trade, 49.60, supplies L </a:t>
-            </a:r>
-            <a:r>
-              <a:rPr sz="1500" b="1" i="0">
+              <a:t>Lowest 49.60 supplies L </a:t>
+            </a:r>
+            <a:r>
+              <a:rPr sz="2000" b="1" i="0">
                 <a:solidFill>
                   <a:srgbClr val="7B3FA0"/>
                 </a:solidFill>
@@ -22867,13 +24107,13 @@
               <a:t>(4)</a:t>
             </a:r>
             <a:r>
-              <a:rPr sz="1500" b="0" i="0">
+              <a:rPr sz="2000" b="0" i="0">
                 <a:solidFill>
                   <a:srgbClr val="1A1A1A"/>
                 </a:solidFill>
                 <a:latin typeface="Arial"/>
               </a:rPr>
-              <a:t>. Meaning/action: keep first, highest, lowest, and last; do not keep every trade.</a:t>
+              <a:t>. Keep first, highest, lowest, and last.</a:t>
             </a:r>
           </a:p>
         </p:txBody>
@@ -22886,8 +24126,8 @@
         </p:nvSpPr>
         <p:spPr>
           <a:xfrm>
-            <a:off x="777240" y="4821174"/>
-            <a:ext cx="82296" cy="633984"/>
+            <a:off x="777240" y="4901183"/>
+            <a:ext cx="82296" cy="786384"/>
           </a:xfrm>
           <a:prstGeom prst="rect">
             <a:avLst/>
@@ -22916,8 +24156,8 @@
         </p:nvSpPr>
         <p:spPr>
           <a:xfrm>
-            <a:off x="1069848" y="4857750"/>
-            <a:ext cx="4370832" cy="633984"/>
+            <a:off x="1069848" y="4937759"/>
+            <a:ext cx="5010912" cy="786384"/>
           </a:xfrm>
           <a:prstGeom prst="rect">
             <a:avLst/>
@@ -22942,7 +24182,7 @@
               </a:spcAft>
             </a:pPr>
             <a:r>
-              <a:rPr sz="1600" b="1" i="0">
+              <a:rPr sz="2100" b="1" i="0">
                 <a:solidFill>
                   <a:srgbClr val="1A1A1A"/>
                 </a:solidFill>
@@ -22961,7 +24201,7 @@
         </p:nvSpPr>
         <p:spPr>
           <a:xfrm>
-            <a:off x="6991189" y="1810512"/>
+            <a:off x="7311229" y="1810512"/>
             <a:ext cx="3192795" cy="3749039"/>
           </a:xfrm>
           <a:prstGeom prst="rect">
@@ -22993,7 +24233,7 @@
         </p:nvSpPr>
         <p:spPr>
           <a:xfrm>
-            <a:off x="7110061" y="1929384"/>
+            <a:off x="7430101" y="1929384"/>
             <a:ext cx="2955051" cy="3511296"/>
           </a:xfrm>
           <a:prstGeom prst="rect">
@@ -23025,7 +24265,7 @@
         </p:nvSpPr>
         <p:spPr>
           <a:xfrm>
-            <a:off x="7110061" y="1929384"/>
+            <a:off x="7430101" y="1929384"/>
             <a:ext cx="2955051" cy="50800"/>
           </a:xfrm>
           <a:prstGeom prst="rect">
@@ -23055,7 +24295,7 @@
         </p:nvSpPr>
         <p:spPr>
           <a:xfrm>
-            <a:off x="7384381" y="2203703"/>
+            <a:off x="7704421" y="2203703"/>
             <a:ext cx="2406411" cy="3054096"/>
           </a:xfrm>
           <a:prstGeom prst="rect">
@@ -23122,7 +24362,7 @@
         </p:nvSpPr>
         <p:spPr>
           <a:xfrm>
-            <a:off x="7789723" y="3193450"/>
+            <a:off x="8109763" y="3193450"/>
             <a:ext cx="295505" cy="421355"/>
           </a:xfrm>
           <a:prstGeom prst="ellipse">
@@ -23151,7 +24391,7 @@
         </p:nvSpPr>
         <p:spPr>
           <a:xfrm>
-            <a:off x="8232981" y="2456078"/>
+            <a:off x="8553021" y="2456078"/>
             <a:ext cx="295505" cy="456468"/>
           </a:xfrm>
           <a:prstGeom prst="ellipse">
@@ -23180,7 +24420,7 @@
         </p:nvSpPr>
         <p:spPr>
           <a:xfrm>
-            <a:off x="8587587" y="3404128"/>
+            <a:off x="8907627" y="3404128"/>
             <a:ext cx="295505" cy="456468"/>
           </a:xfrm>
           <a:prstGeom prst="ellipse">
@@ -23209,7 +24449,7 @@
         </p:nvSpPr>
         <p:spPr>
           <a:xfrm>
-            <a:off x="8469385" y="4317065"/>
+            <a:off x="8789425" y="4317065"/>
             <a:ext cx="295505" cy="421355"/>
           </a:xfrm>
           <a:prstGeom prst="ellipse">
@@ -23238,7 +24478,7 @@
         </p:nvSpPr>
         <p:spPr>
           <a:xfrm>
-            <a:off x="7504811" y="3477646"/>
+            <a:off x="7824851" y="3477646"/>
             <a:ext cx="274320" cy="274320"/>
           </a:xfrm>
           <a:prstGeom prst="ellipse">
@@ -23289,7 +24529,7 @@
         </p:nvSpPr>
         <p:spPr>
           <a:xfrm>
-            <a:off x="8539079" y="2108240"/>
+            <a:off x="8859119" y="2108240"/>
             <a:ext cx="274320" cy="274320"/>
           </a:xfrm>
           <a:prstGeom prst="ellipse">
@@ -23340,7 +24580,7 @@
         </p:nvSpPr>
         <p:spPr>
           <a:xfrm>
-            <a:off x="8893685" y="3828775"/>
+            <a:off x="9213725" y="3828775"/>
             <a:ext cx="274320" cy="274320"/>
           </a:xfrm>
           <a:prstGeom prst="ellipse">
@@ -23391,7 +24631,7 @@
         </p:nvSpPr>
         <p:spPr>
           <a:xfrm>
-            <a:off x="8745932" y="4741712"/>
+            <a:off x="9065972" y="4741712"/>
             <a:ext cx="274320" cy="274320"/>
           </a:xfrm>
           <a:prstGeom prst="ellipse">
@@ -23442,8 +24682,8 @@
         </p:nvSpPr>
         <p:spPr>
           <a:xfrm>
-            <a:off x="5760719" y="5650991"/>
-            <a:ext cx="5653735" cy="274320"/>
+            <a:off x="6400799" y="5650991"/>
+            <a:ext cx="5013655" cy="274320"/>
           </a:xfrm>
           <a:prstGeom prst="rect">
             <a:avLst/>
@@ -23468,7 +24708,7 @@
               </a:spcAft>
             </a:pPr>
             <a:r>
-              <a:rPr sz="1200" b="0" i="0">
+              <a:rPr sz="1100" b="0" i="0">
                 <a:solidFill>
                   <a:srgbClr val="818181"/>
                 </a:solidFill>
@@ -23731,7 +24971,7 @@
         <p:spPr>
           <a:xfrm>
             <a:off x="777240" y="1965960"/>
-            <a:ext cx="4572000" cy="3108960"/>
+            <a:ext cx="5303520" cy="3108960"/>
           </a:xfrm>
           <a:prstGeom prst="rect">
             <a:avLst/>
@@ -23756,13 +24996,13 @@
               </a:spcAft>
             </a:pPr>
             <a:r>
-              <a:rPr sz="1500" b="0" i="0">
+              <a:rPr sz="1800" b="0" i="0">
                 <a:solidFill>
                   <a:srgbClr val="1A1A1A"/>
                 </a:solidFill>
                 <a:latin typeface="Arial"/>
               </a:rPr>
-              <a:t>Now extend the same rule to three invented five-minute bars. Their first open is 50.00, highest high 50.90, lowest low 49.40, and last close 50.30.</a:t>
+              <a:t>Now extend the same rule to three invented five-minute bars: first O 50.00, highest H 50.90, lowest L 49.40, last C 50.30.</a:t>
             </a:r>
           </a:p>
           <a:p>
@@ -23778,16 +25018,16 @@
               </a:spcAft>
             </a:pPr>
             <a:r>
-              <a:rPr sz="1500" b="0" i="0">
+              <a:rPr sz="1800" b="0" i="0">
                 <a:solidFill>
                   <a:srgbClr val="1A1A1A"/>
                 </a:solidFill>
                 <a:latin typeface="Arial"/>
               </a:rPr>
-              <a:t>Figure 7.2 keeps first O </a:t>
-            </a:r>
-            <a:r>
-              <a:rPr sz="1500" b="1" i="0">
+              <a:t>Figure 7.2 keeps O </a:t>
+            </a:r>
+            <a:r>
+              <a:rPr sz="1800" b="1" i="0">
                 <a:solidFill>
                   <a:srgbClr val="E09B00"/>
                 </a:solidFill>
@@ -23796,16 +25036,16 @@
               <a:t>(1)</a:t>
             </a:r>
             <a:r>
-              <a:rPr sz="1500" b="0" i="0">
+              <a:rPr sz="1800" b="0" i="0">
                 <a:solidFill>
                   <a:srgbClr val="1A1A1A"/>
                 </a:solidFill>
                 <a:latin typeface="Arial"/>
               </a:rPr>
-              <a:t>, highest H </a:t>
-            </a:r>
-            <a:r>
-              <a:rPr sz="1500" b="1" i="0">
+              <a:t>, H </a:t>
+            </a:r>
+            <a:r>
+              <a:rPr sz="1800" b="1" i="0">
                 <a:solidFill>
                   <a:srgbClr val="C62828"/>
                 </a:solidFill>
@@ -23814,16 +25054,16 @@
               <a:t>(2)</a:t>
             </a:r>
             <a:r>
-              <a:rPr sz="1500" b="0" i="0">
+              <a:rPr sz="1800" b="0" i="0">
                 <a:solidFill>
                   <a:srgbClr val="1A1A1A"/>
                 </a:solidFill>
                 <a:latin typeface="Arial"/>
               </a:rPr>
-              <a:t>, lowest L </a:t>
-            </a:r>
-            <a:r>
-              <a:rPr sz="1500" b="1" i="0">
+              <a:t>, L </a:t>
+            </a:r>
+            <a:r>
+              <a:rPr sz="1800" b="1" i="0">
                 <a:solidFill>
                   <a:srgbClr val="1F5FAD"/>
                 </a:solidFill>
@@ -23832,16 +25072,16 @@
               <a:t>(3)</a:t>
             </a:r>
             <a:r>
-              <a:rPr sz="1500" b="0" i="0">
+              <a:rPr sz="1800" b="0" i="0">
                 <a:solidFill>
                   <a:srgbClr val="1A1A1A"/>
                 </a:solidFill>
                 <a:latin typeface="Arial"/>
               </a:rPr>
-              <a:t>, and last C </a:t>
-            </a:r>
-            <a:r>
-              <a:rPr sz="1500" b="1" i="0">
+              <a:t>, and C </a:t>
+            </a:r>
+            <a:r>
+              <a:rPr sz="1800" b="1" i="0">
                 <a:solidFill>
                   <a:srgbClr val="7B3FA0"/>
                 </a:solidFill>
@@ -23850,7 +25090,7 @@
               <a:t>(4)</a:t>
             </a:r>
             <a:r>
-              <a:rPr sz="1500" b="0" i="0">
+              <a:rPr sz="1800" b="0" i="0">
                 <a:solidFill>
                   <a:srgbClr val="1A1A1A"/>
                 </a:solidFill>
@@ -23872,13 +25112,13 @@
               </a:spcAft>
             </a:pPr>
             <a:r>
-              <a:rPr sz="1500" b="0" i="0">
+              <a:rPr sz="1800" b="0" i="0">
                 <a:solidFill>
                   <a:srgbClr val="1A1A1A"/>
                 </a:solidFill>
                 <a:latin typeface="Arial"/>
               </a:rPr>
-              <a:t>Meaning/action: a higher-timeframe bar preserves first, extreme, and last values. It does not average intermediate opens or closes.</a:t>
+              <a:t>Action: a higher-timeframe bar preserves first, extreme, and last values; it does not average intermediate opens or closes.</a:t>
             </a:r>
           </a:p>
         </p:txBody>
@@ -23891,8 +25131,8 @@
         </p:nvSpPr>
         <p:spPr>
           <a:xfrm>
-            <a:off x="777240" y="5061204"/>
-            <a:ext cx="82296" cy="633984"/>
+            <a:off x="777240" y="4965192"/>
+            <a:ext cx="82296" cy="725424"/>
           </a:xfrm>
           <a:prstGeom prst="rect">
             <a:avLst/>
@@ -23921,8 +25161,8 @@
         </p:nvSpPr>
         <p:spPr>
           <a:xfrm>
-            <a:off x="1069848" y="5097780"/>
-            <a:ext cx="4279392" cy="633984"/>
+            <a:off x="1069848" y="5001768"/>
+            <a:ext cx="5010912" cy="725424"/>
           </a:xfrm>
           <a:prstGeom prst="rect">
             <a:avLst/>
@@ -23947,7 +25187,7 @@
               </a:spcAft>
             </a:pPr>
             <a:r>
-              <a:rPr sz="1600" b="1" i="0">
+              <a:rPr sz="1900" b="1" i="0">
                 <a:solidFill>
                   <a:srgbClr val="1A1A1A"/>
                 </a:solidFill>
@@ -23966,7 +25206,7 @@
         </p:nvSpPr>
         <p:spPr>
           <a:xfrm>
-            <a:off x="6750226" y="1810512"/>
+            <a:off x="7115986" y="1810512"/>
             <a:ext cx="3583281" cy="3749039"/>
           </a:xfrm>
           <a:prstGeom prst="rect">
@@ -23998,7 +25238,7 @@
         </p:nvSpPr>
         <p:spPr>
           <a:xfrm>
-            <a:off x="6869098" y="1929384"/>
+            <a:off x="7234858" y="1929384"/>
             <a:ext cx="3345537" cy="3511296"/>
           </a:xfrm>
           <a:prstGeom prst="rect">
@@ -24030,7 +25270,7 @@
         </p:nvSpPr>
         <p:spPr>
           <a:xfrm>
-            <a:off x="6869098" y="1929384"/>
+            <a:off x="7234858" y="1929384"/>
             <a:ext cx="3345537" cy="50800"/>
           </a:xfrm>
           <a:prstGeom prst="rect">
@@ -24060,7 +25300,7 @@
         </p:nvSpPr>
         <p:spPr>
           <a:xfrm>
-            <a:off x="7143418" y="2203703"/>
+            <a:off x="7509178" y="2203703"/>
             <a:ext cx="2796897" cy="3054096"/>
           </a:xfrm>
           <a:prstGeom prst="rect">
@@ -24127,7 +25367,7 @@
         </p:nvSpPr>
         <p:spPr>
           <a:xfrm>
-            <a:off x="8809510" y="3193450"/>
+            <a:off x="9175270" y="3193450"/>
             <a:ext cx="468375" cy="351129"/>
           </a:xfrm>
           <a:prstGeom prst="ellipse">
@@ -24156,7 +25396,7 @@
         </p:nvSpPr>
         <p:spPr>
           <a:xfrm>
-            <a:off x="8809510" y="2456078"/>
+            <a:off x="9175270" y="2456078"/>
             <a:ext cx="468375" cy="351129"/>
           </a:xfrm>
           <a:prstGeom prst="ellipse">
@@ -24185,7 +25425,7 @@
         </p:nvSpPr>
         <p:spPr>
           <a:xfrm>
-            <a:off x="8809510" y="4949098"/>
+            <a:off x="9175270" y="4949098"/>
             <a:ext cx="468375" cy="351129"/>
           </a:xfrm>
           <a:prstGeom prst="ellipse">
@@ -24214,7 +25454,7 @@
         </p:nvSpPr>
         <p:spPr>
           <a:xfrm>
-            <a:off x="8809510" y="4001048"/>
+            <a:off x="9175270" y="4001048"/>
             <a:ext cx="468375" cy="386242"/>
           </a:xfrm>
           <a:prstGeom prst="ellipse">
@@ -24243,7 +25483,7 @@
         </p:nvSpPr>
         <p:spPr>
           <a:xfrm>
-            <a:off x="8552245" y="3175345"/>
+            <a:off x="8918005" y="3175345"/>
             <a:ext cx="246888" cy="246888"/>
           </a:xfrm>
           <a:prstGeom prst="ellipse">
@@ -24294,7 +25534,7 @@
         </p:nvSpPr>
         <p:spPr>
           <a:xfrm>
-            <a:off x="9689727" y="2157069"/>
+            <a:off x="10055487" y="2157069"/>
             <a:ext cx="246888" cy="246888"/>
           </a:xfrm>
           <a:prstGeom prst="ellipse">
@@ -24345,7 +25585,7 @@
         </p:nvSpPr>
         <p:spPr>
           <a:xfrm>
-            <a:off x="9689727" y="5247010"/>
+            <a:off x="10055487" y="5247010"/>
             <a:ext cx="246888" cy="246888"/>
           </a:xfrm>
           <a:prstGeom prst="ellipse">
@@ -24396,7 +25636,7 @@
         </p:nvSpPr>
         <p:spPr>
           <a:xfrm>
-            <a:off x="8552245" y="3982943"/>
+            <a:off x="8918005" y="3982943"/>
             <a:ext cx="246888" cy="246888"/>
           </a:xfrm>
           <a:prstGeom prst="ellipse">
@@ -24447,8 +25687,8 @@
         </p:nvSpPr>
         <p:spPr>
           <a:xfrm>
-            <a:off x="5669279" y="5650991"/>
-            <a:ext cx="5745175" cy="274320"/>
+            <a:off x="6400799" y="5650991"/>
+            <a:ext cx="5013655" cy="274320"/>
           </a:xfrm>
           <a:prstGeom prst="rect">
             <a:avLst/>
@@ -24473,7 +25713,7 @@
               </a:spcAft>
             </a:pPr>
             <a:r>
-              <a:rPr sz="1200" b="0" i="0">
+              <a:rPr sz="1100" b="0" i="0">
                 <a:solidFill>
                   <a:srgbClr val="818181"/>
                 </a:solidFill>
@@ -24736,7 +25976,7 @@
         <p:spPr>
           <a:xfrm>
             <a:off x="777240" y="1965960"/>
-            <a:ext cx="4617720" cy="3108960"/>
+            <a:ext cx="5303520" cy="3108960"/>
           </a:xfrm>
           <a:prstGeom prst="rect">
             <a:avLst/>
@@ -24761,13 +26001,13 @@
               </a:spcAft>
             </a:pPr>
             <a:r>
-              <a:rPr sz="1600" b="0" i="0">
+              <a:rPr sz="1700" b="0" i="0">
                 <a:solidFill>
                   <a:srgbClr val="1A1A1A"/>
                 </a:solidFill>
                 <a:latin typeface="Arial"/>
               </a:rPr>
-              <a:t>The book next shows a series of five-minute intervals before it classifies any formation (Lim, p. 210).</a:t>
+              <a:t>The book next shows five-minute intervals before it classifies a formation (Lim, p. 210).</a:t>
             </a:r>
           </a:p>
           <a:p>
@@ -24783,7 +26023,7 @@
               </a:spcAft>
             </a:pPr>
             <a:r>
-              <a:rPr sz="1600" b="0" i="0">
+              <a:rPr sz="1700" b="0" i="0">
                 <a:solidFill>
                   <a:srgbClr val="1A1A1A"/>
                 </a:solidFill>
@@ -24792,7 +26032,7 @@
               <a:t>Gold </a:t>
             </a:r>
             <a:r>
-              <a:rPr sz="1600" b="1" i="0">
+              <a:rPr sz="1700" b="1" i="0">
                 <a:solidFill>
                   <a:srgbClr val="E09B00"/>
                 </a:solidFill>
@@ -24801,7 +26041,7 @@
               <a:t>(1)</a:t>
             </a:r>
             <a:r>
-              <a:rPr sz="1600" b="0" i="0">
+              <a:rPr sz="1700" b="0" i="0">
                 <a:solidFill>
                   <a:srgbClr val="1A1A1A"/>
                 </a:solidFill>
@@ -24810,7 +26050,7 @@
               <a:t> marks the first interval, red </a:t>
             </a:r>
             <a:r>
-              <a:rPr sz="1600" b="1" i="0">
+              <a:rPr sz="1700" b="1" i="0">
                 <a:solidFill>
                   <a:srgbClr val="C62828"/>
                 </a:solidFill>
@@ -24819,16 +26059,16 @@
               <a:t>(2)</a:t>
             </a:r>
             <a:r>
-              <a:rPr sz="1600" b="0" i="0">
+              <a:rPr sz="1700" b="0" i="0">
                 <a:solidFill>
                   <a:srgbClr val="1A1A1A"/>
                 </a:solidFill>
                 <a:latin typeface="Arial"/>
               </a:rPr>
-              <a:t> a later price sequence, and blue </a:t>
-            </a:r>
-            <a:r>
-              <a:rPr sz="1600" b="1" i="0">
+              <a:t> a later sequence, and blue </a:t>
+            </a:r>
+            <a:r>
+              <a:rPr sz="1700" b="1" i="0">
                 <a:solidFill>
                   <a:srgbClr val="1F5FAD"/>
                 </a:solidFill>
@@ -24837,13 +26077,13 @@
               <a:t>(3)</a:t>
             </a:r>
             <a:r>
-              <a:rPr sz="1600" b="0" i="0">
+              <a:rPr sz="1700" b="0" i="0">
                 <a:solidFill>
                   <a:srgbClr val="1A1A1A"/>
                 </a:solidFill>
                 <a:latin typeface="Arial"/>
               </a:rPr>
-              <a:t> the OHLC bars made from those intervals.</a:t>
+              <a:t> the OHLC bar below one interval.</a:t>
             </a:r>
           </a:p>
           <a:p>
@@ -24859,13 +26099,13 @@
               </a:spcAft>
             </a:pPr>
             <a:r>
-              <a:rPr sz="1600" b="0" i="0">
+              <a:rPr sz="1700" b="0" i="0">
                 <a:solidFill>
                   <a:srgbClr val="1A1A1A"/>
                 </a:solidFill>
                 <a:latin typeface="Arial"/>
               </a:rPr>
-              <a:t>Meaning/action: read each interval first; only then count bars, identify intrinsic sentiment, and ask continuation or reversal.</a:t>
+              <a:t>Action: read each interval first; then count bars, identify intrinsic sentiment, and ask continuation or reversal.</a:t>
             </a:r>
           </a:p>
         </p:txBody>
@@ -24878,8 +26118,8 @@
         </p:nvSpPr>
         <p:spPr>
           <a:xfrm>
-            <a:off x="777240" y="4965192"/>
-            <a:ext cx="82296" cy="664464"/>
+            <a:off x="777240" y="4837176"/>
+            <a:ext cx="82296" cy="694944"/>
           </a:xfrm>
           <a:prstGeom prst="rect">
             <a:avLst/>
@@ -24908,8 +26148,8 @@
         </p:nvSpPr>
         <p:spPr>
           <a:xfrm>
-            <a:off x="1069848" y="5001768"/>
-            <a:ext cx="4325112" cy="664464"/>
+            <a:off x="1069848" y="4873752"/>
+            <a:ext cx="5010912" cy="694944"/>
           </a:xfrm>
           <a:prstGeom prst="rect">
             <a:avLst/>
@@ -24934,7 +26174,7 @@
               </a:spcAft>
             </a:pPr>
             <a:r>
-              <a:rPr sz="1700" b="1" i="0">
+              <a:rPr sz="1800" b="1" i="0">
                 <a:solidFill>
                   <a:srgbClr val="1A1A1A"/>
                 </a:solidFill>
@@ -24953,8 +26193,8 @@
         </p:nvSpPr>
         <p:spPr>
           <a:xfrm>
-            <a:off x="5714999" y="1810512"/>
-            <a:ext cx="5699455" cy="3442679"/>
+            <a:off x="6400799" y="1810512"/>
+            <a:ext cx="5013655" cy="3040251"/>
           </a:xfrm>
           <a:prstGeom prst="rect">
             <a:avLst/>
@@ -24985,8 +26225,8 @@
         </p:nvSpPr>
         <p:spPr>
           <a:xfrm>
-            <a:off x="5833871" y="1929384"/>
-            <a:ext cx="5461711" cy="3204935"/>
+            <a:off x="6519671" y="1929384"/>
+            <a:ext cx="4775911" cy="2802507"/>
           </a:xfrm>
           <a:prstGeom prst="rect">
             <a:avLst/>
@@ -25017,8 +26257,8 @@
         </p:nvSpPr>
         <p:spPr>
           <a:xfrm>
-            <a:off x="5833871" y="1929384"/>
-            <a:ext cx="5461711" cy="50800"/>
+            <a:off x="6519671" y="1929384"/>
+            <a:ext cx="4775911" cy="50800"/>
           </a:xfrm>
           <a:prstGeom prst="rect">
             <a:avLst/>
@@ -25047,8 +26287,8 @@
         </p:nvSpPr>
         <p:spPr>
           <a:xfrm>
-            <a:off x="6108191" y="2203703"/>
-            <a:ext cx="4913071" cy="2747735"/>
+            <a:off x="6793991" y="2203703"/>
+            <a:ext cx="4227271" cy="2345307"/>
           </a:xfrm>
           <a:prstGeom prst="rect">
             <a:avLst/>
@@ -25114,8 +26354,8 @@
         </p:nvSpPr>
         <p:spPr>
           <a:xfrm>
-            <a:off x="6025031" y="2826765"/>
-            <a:ext cx="382319" cy="480740"/>
+            <a:off x="6686828" y="2714086"/>
+            <a:ext cx="334313" cy="420376"/>
           </a:xfrm>
           <a:prstGeom prst="ellipse">
             <a:avLst/>
@@ -25143,8 +26383,8 @@
         </p:nvSpPr>
         <p:spPr>
           <a:xfrm>
-            <a:off x="8892430" y="2890864"/>
-            <a:ext cx="382319" cy="480740"/>
+            <a:off x="9194182" y="2770136"/>
+            <a:ext cx="334313" cy="420376"/>
           </a:xfrm>
           <a:prstGeom prst="ellipse">
             <a:avLst/>
@@ -25172,8 +26412,8 @@
         </p:nvSpPr>
         <p:spPr>
           <a:xfrm>
-            <a:off x="8947047" y="4044641"/>
-            <a:ext cx="382319" cy="448690"/>
+            <a:off x="9241941" y="3779038"/>
+            <a:ext cx="334313" cy="392351"/>
           </a:xfrm>
           <a:prstGeom prst="ellipse">
             <a:avLst/>
@@ -25201,7 +26441,7 @@
         </p:nvSpPr>
         <p:spPr>
           <a:xfrm>
-            <a:off x="5815090" y="2538503"/>
+            <a:off x="6487174" y="2445944"/>
             <a:ext cx="256032" cy="256032"/>
           </a:xfrm>
           <a:prstGeom prst="ellipse">
@@ -25252,7 +26492,7 @@
         </p:nvSpPr>
         <p:spPr>
           <a:xfrm>
-            <a:off x="9365202" y="2602601"/>
+            <a:off x="9591516" y="2501994"/>
             <a:ext cx="256032" cy="256032"/>
           </a:xfrm>
           <a:prstGeom prst="ellipse">
@@ -25303,7 +26543,7 @@
         </p:nvSpPr>
         <p:spPr>
           <a:xfrm>
-            <a:off x="9419819" y="4493513"/>
+            <a:off x="9639275" y="4155474"/>
             <a:ext cx="256032" cy="256032"/>
           </a:xfrm>
           <a:prstGeom prst="ellipse">
@@ -25354,8 +26594,8 @@
         </p:nvSpPr>
         <p:spPr>
           <a:xfrm>
-            <a:off x="5714999" y="5344631"/>
-            <a:ext cx="5699455" cy="274320"/>
+            <a:off x="6400799" y="4942203"/>
+            <a:ext cx="5013655" cy="274320"/>
           </a:xfrm>
           <a:prstGeom prst="rect">
             <a:avLst/>
@@ -25380,7 +26620,7 @@
               </a:spcAft>
             </a:pPr>
             <a:r>
-              <a:rPr sz="1200" b="0" i="0">
+              <a:rPr sz="1100" b="0" i="0">
                 <a:solidFill>
                   <a:srgbClr val="818181"/>
                 </a:solidFill>

</xml_diff>

<commit_message>
Fix Chapter 7 third reader findings
</commit_message>
<xml_diff>
--- a/chapter-07/FIN1209-Chapter-07.pptx
+++ b/chapter-07/FIN1209-Chapter-07.pptx
@@ -6545,7 +6545,7 @@
                 </a:solidFill>
                 <a:latin typeface="Arial"/>
               </a:rPr>
-              <a:t>. Prices rise into the pair </a:t>
+              <a:t>. The rising upper price sequence beside the pair is bullish trend context </a:t>
             </a:r>
             <a:r>
               <a:rPr sz="1700" b="1" i="0">
@@ -6563,7 +6563,7 @@
                 </a:solidFill>
                 <a:latin typeface="Arial"/>
               </a:rPr>
-              <a:t>, so bullish trend and bearish formation disagree.</a:t>
+              <a:t>.</a:t>
             </a:r>
           </a:p>
           <a:p>
@@ -11826,7 +11826,7 @@
                 </a:solidFill>
                 <a:latin typeface="Arial"/>
               </a:rPr>
-              <a:t>With the three questions in place, define the sentiments that decide the expectation.</a:t>
+              <a:t>With the three questions in place, define trend sentiment: bullish in an uptrend, bearish in a downtrend. Intrinsic sentiment is a formation's own bullish or bearish bias (Lim, p. 211).</a:t>
             </a:r>
           </a:p>
           <a:p>
@@ -11848,7 +11848,7 @@
                 </a:solidFill>
                 <a:latin typeface="Arial"/>
               </a:rPr>
-              <a:t>Trend sentiment is bullish in an uptrend and bearish in a downtrend. Intrinsic sentiment is the formation's own bullish or bearish bias (Lim, p. 211).</a:t>
+              <a:t>Chapter 4 defines an inverted head and shoulders as bullish; in an uptrend, bullish biases agree.</a:t>
             </a:r>
           </a:p>
           <a:p>
@@ -11870,29 +11870,7 @@
                 </a:solidFill>
                 <a:latin typeface="Arial"/>
               </a:rPr>
-              <a:t>Ours, invented: an uptrend rises 4.0% over four bars; a bullish formation rises 2.0% over two bars. Both are bullish and agree.</a:t>
-            </a:r>
-          </a:p>
-          <a:p>
-            <a:pPr algn="l">
-              <a:lnSpc>
-                <a:spcPct val="118000"/>
-              </a:lnSpc>
-              <a:spcBef>
-                <a:spcPts val="0"/>
-              </a:spcBef>
-              <a:spcAft>
-                <a:spcPts val="1300"/>
-              </a:spcAft>
-            </a:pPr>
-            <a:r>
-              <a:rPr sz="2100" b="0" i="0">
-                <a:solidFill>
-                  <a:srgbClr val="1A1A1A"/>
-                </a:solidFill>
-                <a:latin typeface="Arial"/>
-              </a:rPr>
-              <a:t>Meaning/action: compare both before calling continuation or reversal.</a:t>
+              <a:t>Four invented trend/form cells: +4.0%/+2.0% and -4.0%/-2.0% continue; +4.0%/-2.0% and -4.0%/+2.0% are potential reversals.</a:t>
             </a:r>
           </a:p>
         </p:txBody>
@@ -11905,7 +11883,7 @@
         </p:nvSpPr>
         <p:spPr>
           <a:xfrm>
-            <a:off x="777240" y="5211318"/>
+            <a:off x="777240" y="5028437"/>
             <a:ext cx="82296" cy="467614"/>
           </a:xfrm>
           <a:prstGeom prst="rect">
@@ -11935,7 +11913,7 @@
         </p:nvSpPr>
         <p:spPr>
           <a:xfrm>
-            <a:off x="1069848" y="5247894"/>
+            <a:off x="1069848" y="5065013"/>
             <a:ext cx="10344607" cy="467614"/>
           </a:xfrm>
           <a:prstGeom prst="rect">
@@ -26065,7 +26043,7 @@
                 </a:solidFill>
                 <a:latin typeface="Arial"/>
               </a:rPr>
-              <a:t> a later sequence, and blue </a:t>
+              <a:t> a later interval, and blue </a:t>
             </a:r>
             <a:r>
               <a:rPr sz="1700" b="1" i="0">

</xml_diff>

<commit_message>
Define trend sentiment before use
</commit_message>
<xml_diff>
--- a/chapter-07/FIN1209-Chapter-07.pptx
+++ b/chapter-07/FIN1209-Chapter-07.pptx
@@ -6080,7 +6080,7 @@
                 </a:solidFill>
                 <a:latin typeface="Arial"/>
               </a:rPr>
-              <a:t>Finally ask whether intrinsic sentiment agrees with trend sentiment. Agreement is continuation; disagreement is reversal (Lim, p. 211).</a:t>
+              <a:t>Trend sentiment is bullish in an uptrend and bearish in a downtrend (Lim, p. 211).</a:t>
             </a:r>
           </a:p>
           <a:p>
@@ -6102,7 +6102,7 @@
                 </a:solidFill>
                 <a:latin typeface="Arial"/>
               </a:rPr>
-              <a:t>Ours, invented: bearish intrinsic sentiment in an uptrend disagrees, so it is a potential reversal; bullish intrinsic sentiment agrees, so it is a potential continuation.</a:t>
+              <a:t>Compare intrinsic sentiment: agreement suggests continuation; disagreement suggests potential reversal (p. 211).</a:t>
             </a:r>
           </a:p>
           <a:p>
@@ -6124,7 +6124,7 @@
                 </a:solidFill>
                 <a:latin typeface="Arial"/>
               </a:rPr>
-              <a:t>Meaning/action: these are directional expectations, not certainties. Part 2 makes the agreement rule explicit.</a:t>
+              <a:t>Ours: bearish formation plus uptrend means potential reversal; bullish plus uptrend means potential continuation, not certainty.</a:t>
             </a:r>
           </a:p>
         </p:txBody>
@@ -6137,7 +6137,7 @@
         </p:nvSpPr>
         <p:spPr>
           <a:xfrm>
-            <a:off x="777240" y="5028437"/>
+            <a:off x="777240" y="4713731"/>
             <a:ext cx="82296" cy="467614"/>
           </a:xfrm>
           <a:prstGeom prst="rect">
@@ -6167,7 +6167,7 @@
         </p:nvSpPr>
         <p:spPr>
           <a:xfrm>
-            <a:off x="1069848" y="5065013"/>
+            <a:off x="1069848" y="4750307"/>
             <a:ext cx="10344607" cy="467614"/>
           </a:xfrm>
           <a:prstGeom prst="rect">

</xml_diff>

<commit_message>
Improve sentiment table and worked read
</commit_message>
<xml_diff>
--- a/chapter-07/FIN1209-Chapter-07.pptx
+++ b/chapter-07/FIN1209-Chapter-07.pptx
@@ -6673,8 +6673,8 @@
         </p:nvSpPr>
         <p:spPr>
           <a:xfrm>
-            <a:off x="7636449" y="1810512"/>
-            <a:ext cx="2313755" cy="3749039"/>
+            <a:off x="6173571" y="1810512"/>
+            <a:ext cx="5239512" cy="3749039"/>
           </a:xfrm>
           <a:prstGeom prst="rect">
             <a:avLst/>
@@ -6697,38 +6697,30 @@
           </a:p>
         </p:txBody>
       </p:sp>
-      <p:sp>
-        <p:nvSpPr>
-          <p:cNvPr id="11" name="Rectangle 10"/>
-          <p:cNvSpPr/>
-          <p:nvPr/>
-        </p:nvSpPr>
-        <p:spPr>
-          <a:xfrm>
-            <a:off x="7755321" y="1929384"/>
-            <a:ext cx="2076011" cy="3511296"/>
-          </a:xfrm>
-          <a:prstGeom prst="rect">
-            <a:avLst/>
-          </a:prstGeom>
-          <a:solidFill>
-            <a:srgbClr val="FFFFFF"/>
-          </a:solidFill>
-          <a:ln w="12700">
-            <a:solidFill>
-              <a:srgbClr val="D7E0D9"/>
-            </a:solidFill>
-          </a:ln>
-          <a:effectLst/>
-        </p:spPr>
-        <p:txBody>
-          <a:bodyPr rtlCol="0" anchor="ctr"/>
-          <a:lstStyle/>
-          <a:p>
-            <a:pPr algn="ctr"/>
-          </a:p>
-        </p:txBody>
-      </p:sp>
+      <p:pic>
+        <p:nvPicPr>
+          <p:cNvPr id="11" name="Picture 10" descr="chart-u.png"/>
+          <p:cNvPicPr>
+            <a:picLocks noChangeAspect="1"/>
+          </p:cNvPicPr>
+          <p:nvPr/>
+        </p:nvPicPr>
+        <p:blipFill>
+          <a:blip r:embed="rId2"/>
+          <a:stretch>
+            <a:fillRect/>
+          </a:stretch>
+        </p:blipFill>
+        <p:spPr>
+          <a:xfrm>
+            <a:off x="6292443" y="1929384"/>
+            <a:ext cx="5001768" cy="3511296"/>
+          </a:xfrm>
+          <a:prstGeom prst="rect">
+            <a:avLst/>
+          </a:prstGeom>
+        </p:spPr>
+      </p:pic>
       <p:sp>
         <p:nvSpPr>
           <p:cNvPr id="12" name="Rectangle 11"/>
@@ -6737,105 +6729,8 @@
         </p:nvSpPr>
         <p:spPr>
           <a:xfrm>
-            <a:off x="7755321" y="1929384"/>
-            <a:ext cx="2076011" cy="50800"/>
-          </a:xfrm>
-          <a:prstGeom prst="rect">
-            <a:avLst/>
-          </a:prstGeom>
-          <a:solidFill>
-            <a:srgbClr val="F2A900"/>
-          </a:solidFill>
-          <a:ln>
-            <a:noFill/>
-          </a:ln>
-          <a:effectLst/>
-        </p:spPr>
-        <p:txBody>
-          <a:bodyPr rtlCol="0" anchor="ctr"/>
-          <a:lstStyle/>
-          <a:p>
-            <a:pPr algn="ctr"/>
-          </a:p>
-        </p:txBody>
-      </p:sp>
-      <p:sp>
-        <p:nvSpPr>
-          <p:cNvPr id="13" name="TextBox 12"/>
-          <p:cNvSpPr txBox="1"/>
-          <p:nvPr/>
-        </p:nvSpPr>
-        <p:spPr>
-          <a:xfrm>
-            <a:off x="8029641" y="2203703"/>
-            <a:ext cx="1527371" cy="3054096"/>
-          </a:xfrm>
-          <a:prstGeom prst="rect">
-            <a:avLst/>
-          </a:prstGeom>
-          <a:noFill/>
-        </p:spPr>
-        <p:txBody>
-          <a:bodyPr wrap="square" anchor="t" lIns="0" rIns="0" tIns="0" bIns="0">
-            <a:spAutoFit/>
-          </a:bodyPr>
-          <a:lstStyle/>
-          <a:p>
-            <a:pPr algn="l">
-              <a:lnSpc>
-                <a:spcPct val="100000"/>
-              </a:lnSpc>
-              <a:spcBef>
-                <a:spcPts val="0"/>
-              </a:spcBef>
-              <a:spcAft>
-                <a:spcPts val="400"/>
-              </a:spcAft>
-            </a:pPr>
-            <a:r>
-              <a:rPr sz="1100" b="1" i="0">
-                <a:solidFill>
-                  <a:srgbClr val="818181"/>
-                </a:solidFill>
-                <a:latin typeface="Arial"/>
-              </a:rPr>
-              <a:t>FIGURE 7.3</a:t>
-            </a:r>
-          </a:p>
-          <a:p>
-            <a:pPr algn="l">
-              <a:lnSpc>
-                <a:spcPct val="115000"/>
-              </a:lnSpc>
-              <a:spcBef>
-                <a:spcPts val="0"/>
-              </a:spcBef>
-              <a:spcAft>
-                <a:spcPts val="0"/>
-              </a:spcAft>
-            </a:pPr>
-            <a:r>
-              <a:rPr sz="1500" b="0" i="0">
-                <a:solidFill>
-                  <a:srgbClr val="1A1A1A"/>
-                </a:solidFill>
-                <a:latin typeface="Palatino"/>
-              </a:rPr>
-              <a:t>Figure 7.3 crop showing the two counted OHLC bars, the second bar's location, and the rising price context used in the worked read.</a:t>
-            </a:r>
-          </a:p>
-        </p:txBody>
-      </p:sp>
-      <p:sp>
-        <p:nvSpPr>
-          <p:cNvPr id="14" name="Rectangle 13"/>
-          <p:cNvSpPr/>
-          <p:nvPr/>
-        </p:nvSpPr>
-        <p:spPr>
-          <a:xfrm>
-            <a:off x="8170524" y="3825483"/>
-            <a:ext cx="1017245" cy="1474744"/>
+            <a:off x="8443203" y="2631643"/>
+            <a:ext cx="2400848" cy="2036551"/>
           </a:xfrm>
           <a:prstGeom prst="rect">
             <a:avLst/>
@@ -6857,14 +6752,14 @@
       </p:sp>
       <p:sp>
         <p:nvSpPr>
-          <p:cNvPr id="15" name="Oval 14"/>
-          <p:cNvSpPr/>
-          <p:nvPr/>
-        </p:nvSpPr>
-        <p:spPr>
-          <a:xfrm>
-            <a:off x="8814087" y="4036161"/>
-            <a:ext cx="352921" cy="1193840"/>
+          <p:cNvPr id="13" name="Oval 12"/>
+          <p:cNvSpPr/>
+          <p:nvPr/>
+        </p:nvSpPr>
+        <p:spPr>
+          <a:xfrm>
+            <a:off x="10093787" y="2912546"/>
+            <a:ext cx="700247" cy="1825873"/>
           </a:xfrm>
           <a:prstGeom prst="ellipse">
             <a:avLst/>
@@ -6886,14 +6781,14 @@
       </p:sp>
       <p:sp>
         <p:nvSpPr>
-          <p:cNvPr id="16" name="Oval 15"/>
-          <p:cNvSpPr/>
-          <p:nvPr/>
-        </p:nvSpPr>
-        <p:spPr>
-          <a:xfrm>
-            <a:off x="8897128" y="2210287"/>
-            <a:ext cx="519002" cy="1228953"/>
+          <p:cNvPr id="14" name="Oval 13"/>
+          <p:cNvSpPr/>
+          <p:nvPr/>
+        </p:nvSpPr>
+        <p:spPr>
+          <a:xfrm>
+            <a:off x="6792620" y="2807208"/>
+            <a:ext cx="2600919" cy="1860986"/>
           </a:xfrm>
           <a:prstGeom prst="ellipse">
             <a:avLst/>
@@ -6915,13 +6810,13 @@
       </p:sp>
       <p:sp>
         <p:nvSpPr>
-          <p:cNvPr id="17" name="Oval 16"/>
-          <p:cNvSpPr/>
-          <p:nvPr/>
-        </p:nvSpPr>
-        <p:spPr>
-          <a:xfrm>
-            <a:off x="7876427" y="3627241"/>
+          <p:cNvPr id="15" name="Oval 14"/>
+          <p:cNvSpPr/>
+          <p:nvPr/>
+        </p:nvSpPr>
+        <p:spPr>
+          <a:xfrm>
+            <a:off x="8065099" y="2292949"/>
             <a:ext cx="256032" cy="256032"/>
           </a:xfrm>
           <a:prstGeom prst="ellipse">
@@ -6966,13 +6861,13 @@
       </p:sp>
       <p:sp>
         <p:nvSpPr>
-          <p:cNvPr id="18" name="Oval 17"/>
-          <p:cNvSpPr/>
-          <p:nvPr/>
-        </p:nvSpPr>
-        <p:spPr>
-          <a:xfrm>
-            <a:off x="9122034" y="3837919"/>
+          <p:cNvPr id="16" name="Oval 15"/>
+          <p:cNvSpPr/>
+          <p:nvPr/>
+        </p:nvSpPr>
+        <p:spPr>
+          <a:xfrm>
+            <a:off x="10866089" y="2679192"/>
             <a:ext cx="256032" cy="256032"/>
           </a:xfrm>
           <a:prstGeom prst="ellipse">
@@ -7017,13 +6912,13 @@
       </p:sp>
       <p:sp>
         <p:nvSpPr>
-          <p:cNvPr id="19" name="Oval 18"/>
-          <p:cNvSpPr/>
-          <p:nvPr/>
-        </p:nvSpPr>
-        <p:spPr>
-          <a:xfrm>
-            <a:off x="9371155" y="1976932"/>
+          <p:cNvPr id="17" name="Oval 16"/>
+          <p:cNvSpPr/>
+          <p:nvPr/>
+        </p:nvSpPr>
+        <p:spPr>
+          <a:xfrm>
+            <a:off x="6514551" y="2398288"/>
             <a:ext cx="256032" cy="256032"/>
           </a:xfrm>
           <a:prstGeom prst="ellipse">
@@ -7068,7 +6963,7 @@
       </p:sp>
       <p:sp>
         <p:nvSpPr>
-          <p:cNvPr id="20" name="TextBox 19"/>
+          <p:cNvPr id="18" name="TextBox 17"/>
           <p:cNvSpPr txBox="1"/>
           <p:nvPr/>
         </p:nvSpPr>
@@ -7100,20 +6995,20 @@
               </a:spcAft>
             </a:pPr>
             <a:r>
-              <a:rPr sz="1200" b="0" i="0">
+              <a:rPr sz="900" b="0" i="0">
                 <a:solidFill>
                   <a:srgbClr val="818181"/>
                 </a:solidFill>
                 <a:latin typeface="Arial"/>
               </a:rPr>
-              <a:t>Figure 7.3 - Lim, The Handbook of Technical Analysis (Wiley, 2016)</a:t>
-            </a:r>
-          </a:p>
-        </p:txBody>
-      </p:sp>
-      <p:sp>
-        <p:nvSpPr>
-          <p:cNvPr id="21" name="TextBox 20"/>
+              <a:t>Chart U - FIN1209 teaching chart, drawn for this course. Illustrative data, not a real instrument.</a:t>
+            </a:r>
+          </a:p>
+        </p:txBody>
+      </p:sp>
+      <p:sp>
+        <p:nvSpPr>
+          <p:cNvPr id="19" name="TextBox 18"/>
           <p:cNvSpPr txBox="1"/>
           <p:nvPr/>
         </p:nvSpPr>
@@ -7151,7 +7046,7 @@
                 </a:solidFill>
                 <a:latin typeface="Arial"/>
               </a:rPr>
-              <a:t>Lim (2016), pp. 210 to 211, Figure 7.3. The PHP values and classification are ours, invented to show the sequence.</a:t>
+              <a:t>FIN1209 teaching chart U. All PHP values, marks and labels are ours, invented.</a:t>
             </a:r>
           </a:p>
         </p:txBody>
@@ -11870,7 +11765,7 @@
                 </a:solidFill>
                 <a:latin typeface="Arial"/>
               </a:rPr>
-              <a:t>Four invented trend/form cells: +4.0%/+2.0% and -4.0%/-2.0% continue; +4.0%/-2.0% and -4.0%/+2.0% are potential reversals.</a:t>
+              <a:t>Four invented cells: uptrend plus bullish formation and downtrend plus bearish formation are continuation; the mixed pairs are potential reversals.</a:t>
             </a:r>
           </a:p>
         </p:txBody>
@@ -12227,13 +12122,13 @@
               </a:spcAft>
             </a:pPr>
             <a:r>
-              <a:rPr sz="2000" b="0" i="0">
+              <a:rPr sz="1800" b="0" i="0">
                 <a:solidFill>
                   <a:srgbClr val="1A1A1A"/>
                 </a:solidFill>
                 <a:latin typeface="Arial"/>
               </a:rPr>
-              <a:t>Now apply four invented cases: +4.0% trend/+2.0% formation and -4.0%/-2.0% agree, so both continue.</a:t>
+              <a:t>Read the rows first: an uptrend has bullish trend sentiment; a downtrend has bearish trend sentiment. Columns show bullish or bearish formation.</a:t>
             </a:r>
           </a:p>
           <a:p>
@@ -12249,13 +12144,13 @@
               </a:spcAft>
             </a:pPr>
             <a:r>
-              <a:rPr sz="2000" b="0" i="0">
+              <a:rPr sz="1800" b="0" i="0">
                 <a:solidFill>
                   <a:srgbClr val="1A1A1A"/>
                 </a:solidFill>
                 <a:latin typeface="Arial"/>
               </a:rPr>
-              <a:t>+4.0%/-2.0% disagrees, so potential reversal; -4.0%/+2.0% also disagrees, so potential reversal.</a:t>
+              <a:t>The two agreement cells are continuation; the two mixed cells are potential reversal.</a:t>
             </a:r>
           </a:p>
           <a:p>
@@ -12271,7 +12166,7 @@
               </a:spcAft>
             </a:pPr>
             <a:r>
-              <a:rPr sz="2000" b="0" i="0">
+              <a:rPr sz="1800" b="0" i="0">
                 <a:solidFill>
                   <a:srgbClr val="1A1A1A"/>
                 </a:solidFill>
@@ -12290,8 +12185,8 @@
         </p:nvSpPr>
         <p:spPr>
           <a:xfrm>
-            <a:off x="5669279" y="1810512"/>
-            <a:ext cx="5745175" cy="3087950"/>
+            <a:off x="5670651" y="1810512"/>
+            <a:ext cx="5742432" cy="3749039"/>
           </a:xfrm>
           <a:prstGeom prst="rect">
             <a:avLst/>
@@ -12330,8 +12225,8 @@
         </p:blipFill>
         <p:spPr>
           <a:xfrm>
-            <a:off x="5788151" y="1929384"/>
-            <a:ext cx="5507431" cy="2850206"/>
+            <a:off x="5789523" y="1929384"/>
+            <a:ext cx="5504688" cy="3511296"/>
           </a:xfrm>
           <a:prstGeom prst="rect">
             <a:avLst/>
@@ -12346,7 +12241,7 @@
         </p:nvSpPr>
         <p:spPr>
           <a:xfrm>
-            <a:off x="5669279" y="4989902"/>
+            <a:off x="5669279" y="5650991"/>
             <a:ext cx="5745175" cy="274320"/>
           </a:xfrm>
           <a:prstGeom prst="rect">
@@ -13071,7 +12966,7 @@
         <p:spPr>
           <a:xfrm>
             <a:off x="5669279" y="1207008"/>
-            <a:ext cx="5745175" cy="3087950"/>
+            <a:ext cx="5745175" cy="3750789"/>
           </a:xfrm>
           <a:prstGeom prst="rect">
             <a:avLst/>
@@ -13111,7 +13006,7 @@
         <p:spPr>
           <a:xfrm>
             <a:off x="5788151" y="1325880"/>
-            <a:ext cx="5507431" cy="2850206"/>
+            <a:ext cx="5507431" cy="3513045"/>
           </a:xfrm>
           <a:prstGeom prst="rect">
             <a:avLst/>
@@ -13126,7 +13021,7 @@
         </p:nvSpPr>
         <p:spPr>
           <a:xfrm>
-            <a:off x="5669279" y="4386398"/>
+            <a:off x="5669279" y="5049237"/>
             <a:ext cx="5745175" cy="274320"/>
           </a:xfrm>
           <a:prstGeom prst="rect">
@@ -13737,7 +13632,7 @@
         <p:spPr>
           <a:xfrm>
             <a:off x="5669279" y="1207008"/>
-            <a:ext cx="5745175" cy="3087950"/>
+            <a:ext cx="5745175" cy="3750789"/>
           </a:xfrm>
           <a:prstGeom prst="rect">
             <a:avLst/>
@@ -13777,7 +13672,7 @@
         <p:spPr>
           <a:xfrm>
             <a:off x="5788151" y="1325880"/>
-            <a:ext cx="5507431" cy="2850206"/>
+            <a:ext cx="5507431" cy="3513045"/>
           </a:xfrm>
           <a:prstGeom prst="rect">
             <a:avLst/>
@@ -13792,7 +13687,7 @@
         </p:nvSpPr>
         <p:spPr>
           <a:xfrm>
-            <a:off x="5669279" y="4386398"/>
+            <a:off x="5669279" y="5049237"/>
             <a:ext cx="5745175" cy="274320"/>
           </a:xfrm>
           <a:prstGeom prst="rect">

</xml_diff>

<commit_message>
Tighten Chapter 7 chart marks
</commit_message>
<xml_diff>
--- a/chapter-07/FIN1209-Chapter-07.pptx
+++ b/chapter-07/FIN1209-Chapter-07.pptx
@@ -6729,8 +6729,8 @@
         </p:nvSpPr>
         <p:spPr>
           <a:xfrm>
-            <a:off x="8443203" y="2631643"/>
-            <a:ext cx="2400848" cy="2036551"/>
+            <a:off x="9243486" y="2561417"/>
+            <a:ext cx="1150406" cy="2106777"/>
           </a:xfrm>
           <a:prstGeom prst="rect">
             <a:avLst/>
@@ -6758,8 +6758,8 @@
         </p:nvSpPr>
         <p:spPr>
           <a:xfrm>
-            <a:off x="10093787" y="2912546"/>
-            <a:ext cx="700247" cy="1825873"/>
+            <a:off x="9993751" y="2842320"/>
+            <a:ext cx="300106" cy="280903"/>
           </a:xfrm>
           <a:prstGeom prst="ellipse">
             <a:avLst/>
@@ -6779,35 +6779,28 @@
           </a:p>
         </p:txBody>
       </p:sp>
-      <p:sp>
-        <p:nvSpPr>
-          <p:cNvPr id="14" name="Oval 13"/>
-          <p:cNvSpPr/>
-          <p:nvPr/>
-        </p:nvSpPr>
-        <p:spPr>
-          <a:xfrm>
-            <a:off x="6792620" y="2807208"/>
-            <a:ext cx="2600919" cy="1860986"/>
-          </a:xfrm>
-          <a:prstGeom prst="ellipse">
-            <a:avLst/>
-          </a:prstGeom>
-          <a:noFill/>
+      <p:cxnSp>
+        <p:nvCxnSpPr>
+          <p:cNvPr id="14" name="Connector 13"/>
+          <p:cNvCxnSpPr/>
+          <p:nvPr/>
+        </p:nvCxnSpPr>
+        <p:spPr>
+          <a:xfrm flipV="1">
+            <a:off x="7642920" y="3404128"/>
+            <a:ext cx="1450513" cy="807598"/>
+          </a:xfrm>
+          <a:prstGeom prst="line">
+            <a:avLst/>
+          </a:prstGeom>
           <a:ln w="44450">
             <a:solidFill>
               <a:srgbClr val="1F5FAD"/>
             </a:solidFill>
-          </a:ln>
-        </p:spPr>
-        <p:txBody>
-          <a:bodyPr rtlCol="0" anchor="ctr"/>
-          <a:lstStyle/>
-          <a:p>
-            <a:pPr algn="ctr"/>
-          </a:p>
-        </p:txBody>
-      </p:sp>
+            <a:tailEnd type="triangle" w="med" len="med"/>
+          </a:ln>
+        </p:spPr>
+      </p:cxnSp>
       <p:sp>
         <p:nvSpPr>
           <p:cNvPr id="15" name="Oval 14"/>
@@ -6816,8 +6809,8 @@
         </p:nvSpPr>
         <p:spPr>
           <a:xfrm>
-            <a:off x="8065099" y="2292949"/>
-            <a:ext cx="256032" cy="256032"/>
+            <a:off x="8992849" y="2355494"/>
+            <a:ext cx="201168" cy="201168"/>
           </a:xfrm>
           <a:prstGeom prst="ellipse">
             <a:avLst/>
@@ -6867,8 +6860,8 @@
         </p:nvSpPr>
         <p:spPr>
           <a:xfrm>
-            <a:off x="10866089" y="2679192"/>
-            <a:ext cx="256032" cy="256032"/>
+            <a:off x="10402488" y="2680655"/>
+            <a:ext cx="182880" cy="182880"/>
           </a:xfrm>
           <a:prstGeom prst="ellipse">
             <a:avLst/>
@@ -6918,8 +6911,8 @@
         </p:nvSpPr>
         <p:spPr>
           <a:xfrm>
-            <a:off x="6514551" y="2398288"/>
-            <a:ext cx="256032" cy="256032"/>
+            <a:off x="9202064" y="3172236"/>
+            <a:ext cx="182880" cy="182880"/>
           </a:xfrm>
           <a:prstGeom prst="ellipse">
             <a:avLst/>
@@ -13632,7 +13625,7 @@
         <p:spPr>
           <a:xfrm>
             <a:off x="5669279" y="1207008"/>
-            <a:ext cx="5745175" cy="3750789"/>
+            <a:ext cx="5745175" cy="3754306"/>
           </a:xfrm>
           <a:prstGeom prst="rect">
             <a:avLst/>
@@ -13665,6 +13658,7 @@
         </p:nvPicPr>
         <p:blipFill>
           <a:blip r:embed="rId2"/>
+          <a:srcRect l="50" r="50"/>
           <a:stretch>
             <a:fillRect/>
           </a:stretch>
@@ -13672,7 +13666,7 @@
         <p:spPr>
           <a:xfrm>
             <a:off x="5788151" y="1325880"/>
-            <a:ext cx="5507431" cy="3513045"/>
+            <a:ext cx="5507431" cy="3516562"/>
           </a:xfrm>
           <a:prstGeom prst="rect">
             <a:avLst/>
@@ -13687,7 +13681,7 @@
         </p:nvSpPr>
         <p:spPr>
           <a:xfrm>
-            <a:off x="5669279" y="5049237"/>
+            <a:off x="5669279" y="5052754"/>
             <a:ext cx="5745175" cy="274320"/>
           </a:xfrm>
           <a:prstGeom prst="rect">

</xml_diff>

<commit_message>
Fix final Chapter 7 chart marks
</commit_message>
<xml_diff>
--- a/chapter-07/FIN1209-Chapter-07.pptx
+++ b/chapter-07/FIN1209-Chapter-07.pptx
@@ -6729,8 +6729,8 @@
         </p:nvSpPr>
         <p:spPr>
           <a:xfrm>
-            <a:off x="9243486" y="2561417"/>
-            <a:ext cx="1150406" cy="2106777"/>
+            <a:off x="9293504" y="2315626"/>
+            <a:ext cx="1150406" cy="667146"/>
           </a:xfrm>
           <a:prstGeom prst="rect">
             <a:avLst/>
@@ -6758,8 +6758,8 @@
         </p:nvSpPr>
         <p:spPr>
           <a:xfrm>
-            <a:off x="9993751" y="2842320"/>
-            <a:ext cx="300106" cy="280903"/>
+            <a:off x="9993751" y="2736982"/>
+            <a:ext cx="300106" cy="245790"/>
           </a:xfrm>
           <a:prstGeom prst="ellipse">
             <a:avLst/>
@@ -6809,8 +6809,8 @@
         </p:nvSpPr>
         <p:spPr>
           <a:xfrm>
-            <a:off x="8992849" y="2355494"/>
-            <a:ext cx="201168" cy="201168"/>
+            <a:off x="9001993" y="2399751"/>
+            <a:ext cx="182880" cy="182880"/>
           </a:xfrm>
           <a:prstGeom prst="ellipse">
             <a:avLst/>
@@ -6860,8 +6860,8 @@
         </p:nvSpPr>
         <p:spPr>
           <a:xfrm>
-            <a:off x="10402488" y="2680655"/>
-            <a:ext cx="182880" cy="182880"/>
+            <a:off x="10411632" y="2654686"/>
+            <a:ext cx="164592" cy="164592"/>
           </a:xfrm>
           <a:prstGeom prst="ellipse">
             <a:avLst/>

</xml_diff>

<commit_message>
Improve Chapter 7 chart projection readability
</commit_message>
<xml_diff>
--- a/chapter-07/FIN1209-Chapter-07.pptx
+++ b/chapter-07/FIN1209-Chapter-07.pptx
@@ -17114,7 +17114,7 @@
                 </a:solidFill>
                 <a:latin typeface="Palatino"/>
               </a:rPr>
-              <a:t>Bearish key reversal: the numbers first</a:t>
+              <a:t>Bearish key reversal: numbers first</a:t>
             </a:r>
           </a:p>
         </p:txBody>
@@ -17203,7 +17203,7 @@
         <p:spPr>
           <a:xfrm>
             <a:off x="777240" y="1965960"/>
-            <a:ext cx="5943600" cy="3108960"/>
+            <a:ext cx="3657600" cy="3108960"/>
           </a:xfrm>
           <a:prstGeom prst="rect">
             <a:avLst/>
@@ -17228,13 +17228,13 @@
               </a:spcAft>
             </a:pPr>
             <a:r>
-              <a:rPr sz="1700" b="0" i="0">
+              <a:rPr sz="1600" b="0" i="0">
                 <a:solidFill>
                   <a:srgbClr val="1A1A1A"/>
                 </a:solidFill>
                 <a:latin typeface="Arial"/>
               </a:rPr>
-              <a:t>With the agreement rule in place, now read a named reversal bar in five steps.</a:t>
+              <a:t>Read the prior high and close first.</a:t>
             </a:r>
           </a:p>
           <a:p>
@@ -17250,13 +17250,31 @@
               </a:spcAft>
             </a:pPr>
             <a:r>
-              <a:rPr sz="1700" b="0" i="0">
+              <a:rPr sz="1600" b="0" i="0">
                 <a:solidFill>
                   <a:srgbClr val="1A1A1A"/>
                 </a:solidFill>
                 <a:latin typeface="Arial"/>
               </a:rPr>
-              <a:t>Step 1. Prior bar: open 50.80, high 52.00, low 50.60, close 51.10.</a:t>
+              <a:t>1. Open 52.30 above prior high 52.00 </a:t>
+            </a:r>
+            <a:r>
+              <a:rPr sz="1600" b="1" i="0">
+                <a:solidFill>
+                  <a:srgbClr val="E09B00"/>
+                </a:solidFill>
+                <a:latin typeface="Arial"/>
+              </a:rPr>
+              <a:t>(1)</a:t>
+            </a:r>
+            <a:r>
+              <a:rPr sz="1600" b="0" i="0">
+                <a:solidFill>
+                  <a:srgbClr val="1A1A1A"/>
+                </a:solidFill>
+                <a:latin typeface="Arial"/>
+              </a:rPr>
+              <a:t>.</a:t>
             </a:r>
           </a:p>
           <a:p>
@@ -17272,30 +17290,48 @@
               </a:spcAft>
             </a:pPr>
             <a:r>
-              <a:rPr sz="1700" b="0" i="0">
+              <a:rPr sz="1600" b="0" i="0">
                 <a:solidFill>
                   <a:srgbClr val="1A1A1A"/>
                 </a:solidFill>
                 <a:latin typeface="Arial"/>
               </a:rPr>
-              <a:t>Step 2. It opens at 52.30 above prior high 52.00 </a:t>
-            </a:r>
-            <a:r>
-              <a:rPr sz="1700" b="1" i="0">
-                <a:solidFill>
-                  <a:srgbClr val="E09B00"/>
-                </a:solidFill>
-                <a:latin typeface="Arial"/>
-              </a:rPr>
-              <a:t>(1)</a:t>
-            </a:r>
-            <a:r>
-              <a:rPr sz="1700" b="0" i="0">
+              <a:t>2. New high 53.20 </a:t>
+            </a:r>
+            <a:r>
+              <a:rPr sz="1600" b="1" i="0">
+                <a:solidFill>
+                  <a:srgbClr val="C62828"/>
+                </a:solidFill>
+                <a:latin typeface="Arial"/>
+              </a:rPr>
+              <a:t>(2)</a:t>
+            </a:r>
+            <a:r>
+              <a:rPr sz="1600" b="0" i="0">
                 <a:solidFill>
                   <a:srgbClr val="1A1A1A"/>
                 </a:solidFill>
                 <a:latin typeface="Arial"/>
               </a:rPr>
+              <a:t>. 3. Close 50.80 below prior close 51.10 </a:t>
+            </a:r>
+            <a:r>
+              <a:rPr sz="1600" b="1" i="0">
+                <a:solidFill>
+                  <a:srgbClr val="1F5FAD"/>
+                </a:solidFill>
+                <a:latin typeface="Arial"/>
+              </a:rPr>
+              <a:t>(3)</a:t>
+            </a:r>
+            <a:r>
+              <a:rPr sz="1600" b="0" i="0">
+                <a:solidFill>
+                  <a:srgbClr val="1A1A1A"/>
+                </a:solidFill>
+                <a:latin typeface="Arial"/>
+              </a:rPr>
               <a:t>.</a:t>
             </a:r>
           </a:p>
@@ -17312,25 +17348,25 @@
               </a:spcAft>
             </a:pPr>
             <a:r>
-              <a:rPr sz="1700" b="0" i="0">
+              <a:rPr sz="1600" b="0" i="0">
                 <a:solidFill>
                   <a:srgbClr val="1A1A1A"/>
                 </a:solidFill>
                 <a:latin typeface="Arial"/>
               </a:rPr>
-              <a:t>Step 3. It makes a new high of 53.20 </a:t>
-            </a:r>
-            <a:r>
-              <a:rPr sz="1700" b="1" i="0">
-                <a:solidFill>
-                  <a:srgbClr val="C62828"/>
-                </a:solidFill>
-                <a:latin typeface="Arial"/>
-              </a:rPr>
-              <a:t>(2)</a:t>
-            </a:r>
-            <a:r>
-              <a:rPr sz="1700" b="0" i="0">
+              <a:t>4. Volume 4.2m versus 2.0m </a:t>
+            </a:r>
+            <a:r>
+              <a:rPr sz="1600" b="1" i="0">
+                <a:solidFill>
+                  <a:srgbClr val="7B3FA0"/>
+                </a:solidFill>
+                <a:latin typeface="Arial"/>
+              </a:rPr>
+              <a:t>(4)</a:t>
+            </a:r>
+            <a:r>
+              <a:rPr sz="1600" b="0" i="0">
                 <a:solidFill>
                   <a:srgbClr val="1A1A1A"/>
                 </a:solidFill>
@@ -17352,71 +17388,13 @@
               </a:spcAft>
             </a:pPr>
             <a:r>
-              <a:rPr sz="1700" b="0" i="0">
+              <a:rPr sz="1600" b="0" i="0">
                 <a:solidFill>
                   <a:srgbClr val="1A1A1A"/>
                 </a:solidFill>
                 <a:latin typeface="Arial"/>
               </a:rPr>
-              <a:t>Step 4. It closes at 50.80 below prior close 51.10 </a:t>
-            </a:r>
-            <a:r>
-              <a:rPr sz="1700" b="1" i="0">
-                <a:solidFill>
-                  <a:srgbClr val="1F5FAD"/>
-                </a:solidFill>
-                <a:latin typeface="Arial"/>
-              </a:rPr>
-              <a:t>(3)</a:t>
-            </a:r>
-            <a:r>
-              <a:rPr sz="1700" b="0" i="0">
-                <a:solidFill>
-                  <a:srgbClr val="1A1A1A"/>
-                </a:solidFill>
-                <a:latin typeface="Arial"/>
-              </a:rPr>
-              <a:t>.</a:t>
-            </a:r>
-          </a:p>
-          <a:p>
-            <a:pPr algn="l">
-              <a:lnSpc>
-                <a:spcPct val="105000"/>
-              </a:lnSpc>
-              <a:spcBef>
-                <a:spcPts val="0"/>
-              </a:spcBef>
-              <a:spcAft>
-                <a:spcPts val="1100"/>
-              </a:spcAft>
-            </a:pPr>
-            <a:r>
-              <a:rPr sz="1700" b="0" i="0">
-                <a:solidFill>
-                  <a:srgbClr val="1A1A1A"/>
-                </a:solidFill>
-                <a:latin typeface="Arial"/>
-              </a:rPr>
-              <a:t>Step 5. Volume is 4.2 million versus 2.0 million </a:t>
-            </a:r>
-            <a:r>
-              <a:rPr sz="1700" b="1" i="0">
-                <a:solidFill>
-                  <a:srgbClr val="7B3FA0"/>
-                </a:solidFill>
-                <a:latin typeface="Arial"/>
-              </a:rPr>
-              <a:t>(4)</a:t>
-            </a:r>
-            <a:r>
-              <a:rPr sz="1700" b="0" i="0">
-                <a:solidFill>
-                  <a:srgbClr val="1A1A1A"/>
-                </a:solidFill>
-                <a:latin typeface="Arial"/>
-              </a:rPr>
-              <a:t>. That is a bearish key reversal (Lim, p. 218).</a:t>
+              <a:t>Meaning/action: bearish key reversal, a potential warning (Lim, p. 218).</a:t>
             </a:r>
           </a:p>
         </p:txBody>
@@ -17429,8 +17407,8 @@
         </p:nvSpPr>
         <p:spPr>
           <a:xfrm>
-            <a:off x="7040879" y="1810512"/>
-            <a:ext cx="4373575" cy="2169811"/>
+            <a:off x="4754879" y="1810512"/>
+            <a:ext cx="6751014" cy="3280439"/>
           </a:xfrm>
           <a:prstGeom prst="rect">
             <a:avLst/>
@@ -17469,8 +17447,8 @@
         </p:blipFill>
         <p:spPr>
           <a:xfrm>
-            <a:off x="7159751" y="1929384"/>
-            <a:ext cx="4135831" cy="1932067"/>
+            <a:off x="4873751" y="1929384"/>
+            <a:ext cx="6513270" cy="3042695"/>
           </a:xfrm>
           <a:prstGeom prst="rect">
             <a:avLst/>
@@ -17485,8 +17463,8 @@
         </p:nvSpPr>
         <p:spPr>
           <a:xfrm>
-            <a:off x="9806683" y="2489683"/>
-            <a:ext cx="206791" cy="96603"/>
+            <a:off x="9042245" y="2811765"/>
+            <a:ext cx="325663" cy="152134"/>
           </a:xfrm>
           <a:prstGeom prst="ellipse">
             <a:avLst/>
@@ -17514,8 +17492,8 @@
         </p:nvSpPr>
         <p:spPr>
           <a:xfrm>
-            <a:off x="9806683" y="2277156"/>
-            <a:ext cx="206791" cy="96603"/>
+            <a:off x="9042245" y="2477069"/>
+            <a:ext cx="325663" cy="152134"/>
           </a:xfrm>
           <a:prstGeom prst="ellipse">
             <a:avLst/>
@@ -17543,8 +17521,8 @@
         </p:nvSpPr>
         <p:spPr>
           <a:xfrm>
-            <a:off x="9806683" y="2934058"/>
-            <a:ext cx="206791" cy="96603"/>
+            <a:off x="9042245" y="3511585"/>
+            <a:ext cx="325663" cy="152134"/>
           </a:xfrm>
           <a:prstGeom prst="ellipse">
             <a:avLst/>
@@ -17572,8 +17550,8 @@
         </p:nvSpPr>
         <p:spPr>
           <a:xfrm>
-            <a:off x="9806683" y="3436396"/>
-            <a:ext cx="248149" cy="115924"/>
+            <a:off x="9042245" y="4302686"/>
+            <a:ext cx="390796" cy="182561"/>
           </a:xfrm>
           <a:prstGeom prst="ellipse">
             <a:avLst/>
@@ -17601,7 +17579,7 @@
         </p:nvSpPr>
         <p:spPr>
           <a:xfrm>
-            <a:off x="9154936" y="2430838"/>
+            <a:off x="8105204" y="2808452"/>
             <a:ext cx="310896" cy="310896"/>
           </a:xfrm>
           <a:prstGeom prst="ellipse">
@@ -17652,7 +17630,7 @@
         </p:nvSpPr>
         <p:spPr>
           <a:xfrm>
-            <a:off x="10188893" y="2025104"/>
+            <a:off x="9733522" y="2169486"/>
             <a:ext cx="310896" cy="310896"/>
           </a:xfrm>
           <a:prstGeom prst="ellipse">
@@ -17703,7 +17681,7 @@
         </p:nvSpPr>
         <p:spPr>
           <a:xfrm>
-            <a:off x="10188893" y="2971817"/>
+            <a:off x="9733522" y="3660407"/>
             <a:ext cx="310896" cy="310896"/>
           </a:xfrm>
           <a:prstGeom prst="ellipse">
@@ -17754,7 +17732,7 @@
         </p:nvSpPr>
         <p:spPr>
           <a:xfrm>
-            <a:off x="10322112" y="3483298"/>
+            <a:off x="9938064" y="4460652"/>
             <a:ext cx="292608" cy="292608"/>
           </a:xfrm>
           <a:prstGeom prst="ellipse">
@@ -17805,8 +17783,8 @@
         </p:nvSpPr>
         <p:spPr>
           <a:xfrm>
-            <a:off x="7040879" y="4071763"/>
-            <a:ext cx="4373575" cy="274320"/>
+            <a:off x="4754879" y="5182391"/>
+            <a:ext cx="6751014" cy="274320"/>
           </a:xfrm>
           <a:prstGeom prst="rect">
             <a:avLst/>
@@ -17831,7 +17809,7 @@
               </a:spcAft>
             </a:pPr>
             <a:r>
-              <a:rPr sz="900" b="0" i="0">
+              <a:rPr sz="1000" b="0" i="0">
                 <a:solidFill>
                   <a:srgbClr val="818181"/>
                 </a:solidFill>
@@ -28265,7 +28243,7 @@
                 </a:solidFill>
                 <a:latin typeface="Palatino"/>
               </a:rPr>
-              <a:t>Two-day reversal: read the two closes</a:t>
+              <a:t>Two-day reversal: read the closes</a:t>
             </a:r>
           </a:p>
         </p:txBody>
@@ -28354,7 +28332,7 @@
         <p:spPr>
           <a:xfrm>
             <a:off x="777240" y="1965960"/>
-            <a:ext cx="6949440" cy="3108960"/>
+            <a:ext cx="3657600" cy="3108960"/>
           </a:xfrm>
           <a:prstGeom prst="rect">
             <a:avLst/>
@@ -28379,13 +28357,49 @@
               </a:spcAft>
             </a:pPr>
             <a:r>
-              <a:rPr sz="1700" b="0" i="0">
+              <a:rPr sz="2000" b="0" i="0">
                 <a:solidFill>
                   <a:srgbClr val="1A1A1A"/>
                 </a:solidFill>
                 <a:latin typeface="Arial"/>
               </a:rPr>
-              <a:t>Now move from one-bar to a two-day pattern: read the first close near its high and the second near its low.</a:t>
+              <a:t>First close near high </a:t>
+            </a:r>
+            <a:r>
+              <a:rPr sz="2000" b="1" i="0">
+                <a:solidFill>
+                  <a:srgbClr val="E09B00"/>
+                </a:solidFill>
+                <a:latin typeface="Arial"/>
+              </a:rPr>
+              <a:t>(1)</a:t>
+            </a:r>
+            <a:r>
+              <a:rPr sz="2000" b="0" i="0">
+                <a:solidFill>
+                  <a:srgbClr val="1A1A1A"/>
+                </a:solidFill>
+                <a:latin typeface="Arial"/>
+              </a:rPr>
+              <a:t>; second near low </a:t>
+            </a:r>
+            <a:r>
+              <a:rPr sz="2000" b="1" i="0">
+                <a:solidFill>
+                  <a:srgbClr val="C62828"/>
+                </a:solidFill>
+                <a:latin typeface="Arial"/>
+              </a:rPr>
+              <a:t>(2)</a:t>
+            </a:r>
+            <a:r>
+              <a:rPr sz="2000" b="0" i="0">
+                <a:solidFill>
+                  <a:srgbClr val="1A1A1A"/>
+                </a:solidFill>
+                <a:latin typeface="Arial"/>
+              </a:rPr>
+              <a:t>.</a:t>
             </a:r>
           </a:p>
           <a:p>
@@ -28401,93 +28415,35 @@
               </a:spcAft>
             </a:pPr>
             <a:r>
-              <a:rPr sz="1700" b="0" i="0">
+              <a:rPr sz="2000" b="0" i="0">
                 <a:solidFill>
                   <a:srgbClr val="1A1A1A"/>
                 </a:solidFill>
                 <a:latin typeface="Arial"/>
               </a:rPr>
-              <a:t>Ours: bar 1 ranges PHP 49.70 to 52.20 and closes PHP 51.80 near its high </a:t>
-            </a:r>
-            <a:r>
-              <a:rPr sz="1700" b="1" i="0">
-                <a:solidFill>
-                  <a:srgbClr val="E09B00"/>
-                </a:solidFill>
-                <a:latin typeface="Arial"/>
-              </a:rPr>
-              <a:t>(1)</a:t>
-            </a:r>
-            <a:r>
-              <a:rPr sz="1700" b="0" i="0">
+              <a:t>Ours: PHP 51.80, then PHP 49.60; the second range is wider.</a:t>
+            </a:r>
+          </a:p>
+          <a:p>
+            <a:pPr algn="l">
+              <a:lnSpc>
+                <a:spcPct val="105000"/>
+              </a:lnSpc>
+              <a:spcBef>
+                <a:spcPts val="0"/>
+              </a:spcBef>
+              <a:spcAft>
+                <a:spcPts val="1100"/>
+              </a:spcAft>
+            </a:pPr>
+            <a:r>
+              <a:rPr sz="2000" b="0" i="0">
                 <a:solidFill>
                   <a:srgbClr val="1A1A1A"/>
                 </a:solidFill>
                 <a:latin typeface="Arial"/>
               </a:rPr>
-              <a:t>.</a:t>
-            </a:r>
-          </a:p>
-          <a:p>
-            <a:pPr algn="l">
-              <a:lnSpc>
-                <a:spcPct val="105000"/>
-              </a:lnSpc>
-              <a:spcBef>
-                <a:spcPts val="0"/>
-              </a:spcBef>
-              <a:spcAft>
-                <a:spcPts val="1100"/>
-              </a:spcAft>
-            </a:pPr>
-            <a:r>
-              <a:rPr sz="1700" b="0" i="0">
-                <a:solidFill>
-                  <a:srgbClr val="1A1A1A"/>
-                </a:solidFill>
-                <a:latin typeface="Arial"/>
-              </a:rPr>
-              <a:t>Bar 2 ranges PHP 49.00 to 52.00 and closes PHP 49.60 near its low </a:t>
-            </a:r>
-            <a:r>
-              <a:rPr sz="1700" b="1" i="0">
-                <a:solidFill>
-                  <a:srgbClr val="C62828"/>
-                </a:solidFill>
-                <a:latin typeface="Arial"/>
-              </a:rPr>
-              <a:t>(2)</a:t>
-            </a:r>
-            <a:r>
-              <a:rPr sz="1700" b="0" i="0">
-                <a:solidFill>
-                  <a:srgbClr val="1A1A1A"/>
-                </a:solidFill>
-                <a:latin typeface="Arial"/>
-              </a:rPr>
-              <a:t>. Its range is wider, which Lim prefers.</a:t>
-            </a:r>
-          </a:p>
-          <a:p>
-            <a:pPr algn="l">
-              <a:lnSpc>
-                <a:spcPct val="105000"/>
-              </a:lnSpc>
-              <a:spcBef>
-                <a:spcPts val="0"/>
-              </a:spcBef>
-              <a:spcAft>
-                <a:spcPts val="1100"/>
-              </a:spcAft>
-            </a:pPr>
-            <a:r>
-              <a:rPr sz="1700" b="0" i="0">
-                <a:solidFill>
-                  <a:srgbClr val="1A1A1A"/>
-                </a:solidFill>
-                <a:latin typeface="Arial"/>
-              </a:rPr>
-              <a:t>The two-bar close sequence warns of a bearish reversal; the later decline is not guaranteed.</a:t>
+              <a:t>Meaning/action: potential bearish reversal, not a guarantee.</a:t>
             </a:r>
           </a:p>
         </p:txBody>
@@ -28500,83 +28456,8 @@
         </p:nvSpPr>
         <p:spPr>
           <a:xfrm>
-            <a:off x="777240" y="5001768"/>
-            <a:ext cx="82296" cy="694944"/>
-          </a:xfrm>
-          <a:prstGeom prst="rect">
-            <a:avLst/>
-          </a:prstGeom>
-          <a:solidFill>
-            <a:srgbClr val="F2A900"/>
-          </a:solidFill>
-          <a:ln>
-            <a:noFill/>
-          </a:ln>
-          <a:effectLst/>
-        </p:spPr>
-        <p:txBody>
-          <a:bodyPr rtlCol="0" anchor="ctr"/>
-          <a:lstStyle/>
-          <a:p>
-            <a:pPr algn="ctr"/>
-          </a:p>
-        </p:txBody>
-      </p:sp>
-      <p:sp>
-        <p:nvSpPr>
-          <p:cNvPr id="9" name="TextBox 8"/>
-          <p:cNvSpPr txBox="1"/>
-          <p:nvPr/>
-        </p:nvSpPr>
-        <p:spPr>
-          <a:xfrm>
-            <a:off x="1069848" y="5038344"/>
-            <a:ext cx="6656832" cy="694944"/>
-          </a:xfrm>
-          <a:prstGeom prst="rect">
-            <a:avLst/>
-          </a:prstGeom>
-          <a:noFill/>
-        </p:spPr>
-        <p:txBody>
-          <a:bodyPr wrap="square" anchor="t" lIns="0" rIns="0" tIns="0" bIns="0">
-            <a:spAutoFit/>
-          </a:bodyPr>
-          <a:lstStyle/>
-          <a:p>
-            <a:pPr algn="l">
-              <a:lnSpc>
-                <a:spcPct val="100000"/>
-              </a:lnSpc>
-              <a:spcBef>
-                <a:spcPts val="0"/>
-              </a:spcBef>
-              <a:spcAft>
-                <a:spcPts val="0"/>
-              </a:spcAft>
-            </a:pPr>
-            <a:r>
-              <a:rPr sz="1800" b="1" i="0">
-                <a:solidFill>
-                  <a:srgbClr val="1A1A1A"/>
-                </a:solidFill>
-                <a:latin typeface="Arial"/>
-              </a:rPr>
-              <a:t>The pattern is defined by the two closing positions; wider ranges are a preference, not a requirement.</a:t>
-            </a:r>
-          </a:p>
-        </p:txBody>
-      </p:sp>
-      <p:sp>
-        <p:nvSpPr>
-          <p:cNvPr id="10" name="Rectangle 9"/>
-          <p:cNvSpPr/>
-          <p:nvPr/>
-        </p:nvSpPr>
-        <p:spPr>
-          <a:xfrm>
-            <a:off x="8046719" y="1810512"/>
-            <a:ext cx="3367734" cy="1699929"/>
+            <a:off x="4754879" y="1810512"/>
+            <a:ext cx="6751014" cy="3280439"/>
           </a:xfrm>
           <a:prstGeom prst="rect">
             <a:avLst/>
@@ -28601,7 +28482,7 @@
       </p:sp>
       <p:pic>
         <p:nvPicPr>
-          <p:cNvPr id="11" name="Picture 10" descr="chart-ra.png"/>
+          <p:cNvPr id="9" name="Picture 8" descr="chart-ra.png"/>
           <p:cNvPicPr>
             <a:picLocks noChangeAspect="1"/>
           </p:cNvPicPr>
@@ -28615,8 +28496,8 @@
         </p:blipFill>
         <p:spPr>
           <a:xfrm>
-            <a:off x="8165592" y="1929384"/>
-            <a:ext cx="3129990" cy="1462185"/>
+            <a:off x="4873751" y="1929384"/>
+            <a:ext cx="6513270" cy="3042695"/>
           </a:xfrm>
           <a:prstGeom prst="rect">
             <a:avLst/>
@@ -28625,14 +28506,14 @@
       </p:pic>
       <p:sp>
         <p:nvSpPr>
-          <p:cNvPr id="12" name="Oval 11"/>
-          <p:cNvSpPr/>
-          <p:nvPr/>
-        </p:nvSpPr>
-        <p:spPr>
-          <a:xfrm>
-            <a:off x="9010689" y="2338795"/>
-            <a:ext cx="219099" cy="116974"/>
+          <p:cNvPr id="10" name="Oval 9"/>
+          <p:cNvSpPr/>
+          <p:nvPr/>
+        </p:nvSpPr>
+        <p:spPr>
+          <a:xfrm>
+            <a:off x="6632335" y="2781338"/>
+            <a:ext cx="455928" cy="243415"/>
           </a:xfrm>
           <a:prstGeom prst="ellipse">
             <a:avLst/>
@@ -28654,14 +28535,14 @@
       </p:sp>
       <p:sp>
         <p:nvSpPr>
-          <p:cNvPr id="13" name="Oval 12"/>
-          <p:cNvSpPr/>
-          <p:nvPr/>
-        </p:nvSpPr>
-        <p:spPr>
-          <a:xfrm>
-            <a:off x="10168786" y="2748207"/>
-            <a:ext cx="250399" cy="131596"/>
+          <p:cNvPr id="11" name="Oval 10"/>
+          <p:cNvSpPr/>
+          <p:nvPr/>
+        </p:nvSpPr>
+        <p:spPr>
+          <a:xfrm>
+            <a:off x="9042245" y="3633293"/>
+            <a:ext cx="521061" cy="273842"/>
           </a:xfrm>
           <a:prstGeom prst="ellipse">
             <a:avLst/>
@@ -28683,13 +28564,13 @@
       </p:sp>
       <p:sp>
         <p:nvSpPr>
-          <p:cNvPr id="14" name="Oval 13"/>
-          <p:cNvSpPr/>
-          <p:nvPr/>
-        </p:nvSpPr>
-        <p:spPr>
-          <a:xfrm>
-            <a:off x="8739890" y="2136764"/>
+          <p:cNvPr id="12" name="Oval 11"/>
+          <p:cNvSpPr/>
+          <p:nvPr/>
+        </p:nvSpPr>
+        <p:spPr>
+          <a:xfrm>
+            <a:off x="6192371" y="2484477"/>
             <a:ext cx="228600" cy="228600"/>
           </a:xfrm>
           <a:prstGeom prst="ellipse">
@@ -28734,13 +28615,13 @@
       </p:sp>
       <p:sp>
         <p:nvSpPr>
-          <p:cNvPr id="15" name="Oval 14"/>
-          <p:cNvSpPr/>
-          <p:nvPr/>
-        </p:nvSpPr>
-        <p:spPr>
-          <a:xfrm>
-            <a:off x="10555284" y="2575420"/>
+          <p:cNvPr id="13" name="Oval 12"/>
+          <p:cNvSpPr/>
+          <p:nvPr/>
+        </p:nvSpPr>
+        <p:spPr>
+          <a:xfrm>
+            <a:off x="9970068" y="3397285"/>
             <a:ext cx="228600" cy="228600"/>
           </a:xfrm>
           <a:prstGeom prst="ellipse">
@@ -28785,14 +28666,14 @@
       </p:sp>
       <p:sp>
         <p:nvSpPr>
-          <p:cNvPr id="16" name="TextBox 15"/>
+          <p:cNvPr id="14" name="TextBox 13"/>
           <p:cNvSpPr txBox="1"/>
           <p:nvPr/>
         </p:nvSpPr>
         <p:spPr>
           <a:xfrm>
-            <a:off x="8046719" y="3601881"/>
-            <a:ext cx="3367734" cy="274320"/>
+            <a:off x="4754879" y="5182391"/>
+            <a:ext cx="6751014" cy="274320"/>
           </a:xfrm>
           <a:prstGeom prst="rect">
             <a:avLst/>
@@ -28817,7 +28698,7 @@
               </a:spcAft>
             </a:pPr>
             <a:r>
-              <a:rPr sz="900" b="0" i="0">
+              <a:rPr sz="1000" b="0" i="0">
                 <a:solidFill>
                   <a:srgbClr val="818181"/>
                 </a:solidFill>
@@ -28830,7 +28711,7 @@
       </p:sp>
       <p:sp>
         <p:nvSpPr>
-          <p:cNvPr id="17" name="TextBox 16"/>
+          <p:cNvPr id="15" name="TextBox 14"/>
           <p:cNvSpPr txBox="1"/>
           <p:nvPr/>
         </p:nvSpPr>
@@ -29862,7 +29743,7 @@
                 </a:solidFill>
                 <a:latin typeface="Palatino"/>
               </a:rPr>
-              <a:t>Bullish three-bar reversal: volume around the middle</a:t>
+              <a:t>Bullish three-bar reversal: volume</a:t>
             </a:r>
           </a:p>
         </p:txBody>
@@ -29951,7 +29832,7 @@
         <p:spPr>
           <a:xfrm>
             <a:off x="777240" y="1965960"/>
-            <a:ext cx="6400800" cy="3108960"/>
+            <a:ext cx="3657600" cy="3108960"/>
           </a:xfrm>
           <a:prstGeom prst="rect">
             <a:avLst/>
@@ -29976,13 +29857,67 @@
               </a:spcAft>
             </a:pPr>
             <a:r>
-              <a:rPr sz="1900" b="0" i="0">
+              <a:rPr sz="2000" b="0" i="0">
                 <a:solidFill>
                   <a:srgbClr val="1A1A1A"/>
                 </a:solidFill>
                 <a:latin typeface="Arial"/>
               </a:rPr>
-              <a:t>Three bars add a middle bar whose volume matters.</a:t>
+              <a:t>Read volume: strong </a:t>
+            </a:r>
+            <a:r>
+              <a:rPr sz="2000" b="1" i="0">
+                <a:solidFill>
+                  <a:srgbClr val="E09B00"/>
+                </a:solidFill>
+                <a:latin typeface="Arial"/>
+              </a:rPr>
+              <a:t>(1)</a:t>
+            </a:r>
+            <a:r>
+              <a:rPr sz="2000" b="0" i="0">
+                <a:solidFill>
+                  <a:srgbClr val="1A1A1A"/>
+                </a:solidFill>
+                <a:latin typeface="Arial"/>
+              </a:rPr>
+              <a:t>, quiet </a:t>
+            </a:r>
+            <a:r>
+              <a:rPr sz="2000" b="1" i="0">
+                <a:solidFill>
+                  <a:srgbClr val="C62828"/>
+                </a:solidFill>
+                <a:latin typeface="Arial"/>
+              </a:rPr>
+              <a:t>(2)</a:t>
+            </a:r>
+            <a:r>
+              <a:rPr sz="2000" b="0" i="0">
+                <a:solidFill>
+                  <a:srgbClr val="1A1A1A"/>
+                </a:solidFill>
+                <a:latin typeface="Arial"/>
+              </a:rPr>
+              <a:t>, strong </a:t>
+            </a:r>
+            <a:r>
+              <a:rPr sz="2000" b="1" i="0">
+                <a:solidFill>
+                  <a:srgbClr val="1F5FAD"/>
+                </a:solidFill>
+                <a:latin typeface="Arial"/>
+              </a:rPr>
+              <a:t>(3)</a:t>
+            </a:r>
+            <a:r>
+              <a:rPr sz="2000" b="0" i="0">
+                <a:solidFill>
+                  <a:srgbClr val="1A1A1A"/>
+                </a:solidFill>
+                <a:latin typeface="Arial"/>
+              </a:rPr>
+              <a:t>.</a:t>
             </a:r>
           </a:p>
           <a:p>
@@ -29998,111 +29933,35 @@
               </a:spcAft>
             </a:pPr>
             <a:r>
-              <a:rPr sz="1900" b="0" i="0">
+              <a:rPr sz="2000" b="0" i="0">
                 <a:solidFill>
                   <a:srgbClr val="1A1A1A"/>
                 </a:solidFill>
                 <a:latin typeface="Arial"/>
               </a:rPr>
-              <a:t>First bar ranges PHP 41.00 to 44.00. Volume: 4.0 million </a:t>
-            </a:r>
-            <a:r>
-              <a:rPr sz="1900" b="1" i="0">
-                <a:solidFill>
-                  <a:srgbClr val="E09B00"/>
-                </a:solidFill>
-                <a:latin typeface="Arial"/>
-              </a:rPr>
-              <a:t>(1)</a:t>
-            </a:r>
-            <a:r>
-              <a:rPr sz="1900" b="0" i="0">
+              <a:t>Ours: 4.0m, 0.6m, then 4.2m shares.</a:t>
+            </a:r>
+          </a:p>
+          <a:p>
+            <a:pPr algn="l">
+              <a:lnSpc>
+                <a:spcPct val="105000"/>
+              </a:lnSpc>
+              <a:spcBef>
+                <a:spcPts val="0"/>
+              </a:spcBef>
+              <a:spcAft>
+                <a:spcPts val="1100"/>
+              </a:spcAft>
+            </a:pPr>
+            <a:r>
+              <a:rPr sz="2000" b="0" i="0">
                 <a:solidFill>
                   <a:srgbClr val="1A1A1A"/>
                 </a:solidFill>
                 <a:latin typeface="Arial"/>
               </a:rPr>
-              <a:t>.</a:t>
-            </a:r>
-          </a:p>
-          <a:p>
-            <a:pPr algn="l">
-              <a:lnSpc>
-                <a:spcPct val="105000"/>
-              </a:lnSpc>
-              <a:spcBef>
-                <a:spcPts val="0"/>
-              </a:spcBef>
-              <a:spcAft>
-                <a:spcPts val="1100"/>
-              </a:spcAft>
-            </a:pPr>
-            <a:r>
-              <a:rPr sz="1900" b="0" i="0">
-                <a:solidFill>
-                  <a:srgbClr val="1A1A1A"/>
-                </a:solidFill>
-                <a:latin typeface="Arial"/>
-              </a:rPr>
-              <a:t>Middle ranges PHP 43.20 to 44.10. Volume: 0.6 million </a:t>
-            </a:r>
-            <a:r>
-              <a:rPr sz="1900" b="1" i="0">
-                <a:solidFill>
-                  <a:srgbClr val="C62828"/>
-                </a:solidFill>
-                <a:latin typeface="Arial"/>
-              </a:rPr>
-              <a:t>(2)</a:t>
-            </a:r>
-            <a:r>
-              <a:rPr sz="1900" b="0" i="0">
-                <a:solidFill>
-                  <a:srgbClr val="1A1A1A"/>
-                </a:solidFill>
-                <a:latin typeface="Arial"/>
-              </a:rPr>
-              <a:t>. Third closes PHP 46.50. Volume: 4.2 million </a:t>
-            </a:r>
-            <a:r>
-              <a:rPr sz="1900" b="1" i="0">
-                <a:solidFill>
-                  <a:srgbClr val="1F5FAD"/>
-                </a:solidFill>
-                <a:latin typeface="Arial"/>
-              </a:rPr>
-              <a:t>(3)</a:t>
-            </a:r>
-            <a:r>
-              <a:rPr sz="1900" b="0" i="0">
-                <a:solidFill>
-                  <a:srgbClr val="1A1A1A"/>
-                </a:solidFill>
-                <a:latin typeface="Arial"/>
-              </a:rPr>
-              <a:t>.</a:t>
-            </a:r>
-          </a:p>
-          <a:p>
-            <a:pPr algn="l">
-              <a:lnSpc>
-                <a:spcPct val="105000"/>
-              </a:lnSpc>
-              <a:spcBef>
-                <a:spcPts val="0"/>
-              </a:spcBef>
-              <a:spcAft>
-                <a:spcPts val="1100"/>
-              </a:spcAft>
-            </a:pPr>
-            <a:r>
-              <a:rPr sz="1900" b="0" i="0">
-                <a:solidFill>
-                  <a:srgbClr val="1A1A1A"/>
-                </a:solidFill>
-                <a:latin typeface="Arial"/>
-              </a:rPr>
-              <a:t>The quiet middle is below average and shows uncertainty inside a potential bullish reversal.</a:t>
+              <a:t>Meaning/action: a quiet middle shows uncertainty, not a guarantee.</a:t>
             </a:r>
           </a:p>
         </p:txBody>
@@ -30115,83 +29974,8 @@
         </p:nvSpPr>
         <p:spPr>
           <a:xfrm>
-            <a:off x="777240" y="4953762"/>
-            <a:ext cx="82296" cy="755904"/>
-          </a:xfrm>
-          <a:prstGeom prst="rect">
-            <a:avLst/>
-          </a:prstGeom>
-          <a:solidFill>
-            <a:srgbClr val="F2A900"/>
-          </a:solidFill>
-          <a:ln>
-            <a:noFill/>
-          </a:ln>
-          <a:effectLst/>
-        </p:spPr>
-        <p:txBody>
-          <a:bodyPr rtlCol="0" anchor="ctr"/>
-          <a:lstStyle/>
-          <a:p>
-            <a:pPr algn="ctr"/>
-          </a:p>
-        </p:txBody>
-      </p:sp>
-      <p:sp>
-        <p:nvSpPr>
-          <p:cNvPr id="9" name="TextBox 8"/>
-          <p:cNvSpPr txBox="1"/>
-          <p:nvPr/>
-        </p:nvSpPr>
-        <p:spPr>
-          <a:xfrm>
-            <a:off x="1069848" y="4990338"/>
-            <a:ext cx="6108192" cy="755904"/>
-          </a:xfrm>
-          <a:prstGeom prst="rect">
-            <a:avLst/>
-          </a:prstGeom>
-          <a:noFill/>
-        </p:spPr>
-        <p:txBody>
-          <a:bodyPr wrap="square" anchor="t" lIns="0" rIns="0" tIns="0" bIns="0">
-            <a:spAutoFit/>
-          </a:bodyPr>
-          <a:lstStyle/>
-          <a:p>
-            <a:pPr algn="l">
-              <a:lnSpc>
-                <a:spcPct val="100000"/>
-              </a:lnSpc>
-              <a:spcBef>
-                <a:spcPts val="0"/>
-              </a:spcBef>
-              <a:spcAft>
-                <a:spcPts val="0"/>
-              </a:spcAft>
-            </a:pPr>
-            <a:r>
-              <a:rPr sz="2000" b="1" i="0">
-                <a:solidFill>
-                  <a:srgbClr val="1A1A1A"/>
-                </a:solidFill>
-                <a:latin typeface="Arial"/>
-              </a:rPr>
-              <a:t>Strong outer volumes and a quiet middle are a clue, not a guarantee.</a:t>
-            </a:r>
-          </a:p>
-        </p:txBody>
-      </p:sp>
-      <p:sp>
-        <p:nvSpPr>
-          <p:cNvPr id="10" name="Rectangle 9"/>
-          <p:cNvSpPr/>
-          <p:nvPr/>
-        </p:nvSpPr>
-        <p:spPr>
-          <a:xfrm>
-            <a:off x="7498079" y="1810512"/>
-            <a:ext cx="3916374" cy="1956228"/>
+            <a:off x="4754879" y="1810512"/>
+            <a:ext cx="6751014" cy="3280439"/>
           </a:xfrm>
           <a:prstGeom prst="rect">
             <a:avLst/>
@@ -30216,7 +30000,7 @@
       </p:sp>
       <p:pic>
         <p:nvPicPr>
-          <p:cNvPr id="11" name="Picture 10" descr="chart-rb.png"/>
+          <p:cNvPr id="9" name="Picture 8" descr="chart-rb.png"/>
           <p:cNvPicPr>
             <a:picLocks noChangeAspect="1"/>
           </p:cNvPicPr>
@@ -30230,8 +30014,8 @@
         </p:blipFill>
         <p:spPr>
           <a:xfrm>
-            <a:off x="7616951" y="1929384"/>
-            <a:ext cx="3678631" cy="1718484"/>
+            <a:off x="4873751" y="1929384"/>
+            <a:ext cx="6513270" cy="3042695"/>
           </a:xfrm>
           <a:prstGeom prst="rect">
             <a:avLst/>
@@ -30240,14 +30024,14 @@
       </p:pic>
       <p:sp>
         <p:nvSpPr>
-          <p:cNvPr id="12" name="Oval 11"/>
-          <p:cNvSpPr/>
-          <p:nvPr/>
-        </p:nvSpPr>
-        <p:spPr>
-          <a:xfrm>
-            <a:off x="8426250" y="3218247"/>
-            <a:ext cx="257504" cy="154663"/>
+          <p:cNvPr id="10" name="Oval 9"/>
+          <p:cNvSpPr/>
+          <p:nvPr/>
+        </p:nvSpPr>
+        <p:spPr>
+          <a:xfrm>
+            <a:off x="6306671" y="4211405"/>
+            <a:ext cx="455928" cy="273842"/>
           </a:xfrm>
           <a:prstGeom prst="ellipse">
             <a:avLst/>
@@ -30269,14 +30053,14 @@
       </p:sp>
       <p:sp>
         <p:nvSpPr>
-          <p:cNvPr id="13" name="Oval 12"/>
-          <p:cNvSpPr/>
-          <p:nvPr/>
-        </p:nvSpPr>
-        <p:spPr>
-          <a:xfrm>
-            <a:off x="9345908" y="3218247"/>
-            <a:ext cx="257504" cy="154663"/>
+          <p:cNvPr id="11" name="Oval 10"/>
+          <p:cNvSpPr/>
+          <p:nvPr/>
+        </p:nvSpPr>
+        <p:spPr>
+          <a:xfrm>
+            <a:off x="7934989" y="4211405"/>
+            <a:ext cx="455928" cy="273842"/>
           </a:xfrm>
           <a:prstGeom prst="ellipse">
             <a:avLst/>
@@ -30298,14 +30082,14 @@
       </p:sp>
       <p:sp>
         <p:nvSpPr>
-          <p:cNvPr id="14" name="Oval 13"/>
-          <p:cNvSpPr/>
-          <p:nvPr/>
-        </p:nvSpPr>
-        <p:spPr>
-          <a:xfrm>
-            <a:off x="10302352" y="3218247"/>
-            <a:ext cx="257504" cy="154663"/>
+          <p:cNvPr id="12" name="Oval 11"/>
+          <p:cNvSpPr/>
+          <p:nvPr/>
+        </p:nvSpPr>
+        <p:spPr>
+          <a:xfrm>
+            <a:off x="9628439" y="4211405"/>
+            <a:ext cx="455928" cy="273842"/>
           </a:xfrm>
           <a:prstGeom prst="ellipse">
             <a:avLst/>
@@ -30327,13 +30111,13 @@
       </p:sp>
       <p:sp>
         <p:nvSpPr>
-          <p:cNvPr id="15" name="Oval 14"/>
-          <p:cNvSpPr/>
-          <p:nvPr/>
-        </p:nvSpPr>
-        <p:spPr>
-          <a:xfrm>
-            <a:off x="8160443" y="2976875"/>
+          <p:cNvPr id="13" name="Oval 12"/>
+          <p:cNvSpPr/>
+          <p:nvPr/>
+        </p:nvSpPr>
+        <p:spPr>
+          <a:xfrm>
+            <a:off x="5955825" y="3903823"/>
             <a:ext cx="310896" cy="310896"/>
           </a:xfrm>
           <a:prstGeom prst="ellipse">
@@ -30378,13 +30162,13 @@
       </p:sp>
       <p:sp>
         <p:nvSpPr>
-          <p:cNvPr id="16" name="Oval 15"/>
-          <p:cNvSpPr/>
-          <p:nvPr/>
-        </p:nvSpPr>
-        <p:spPr>
-          <a:xfrm>
-            <a:off x="9006529" y="2976875"/>
+          <p:cNvPr id="14" name="Oval 13"/>
+          <p:cNvSpPr/>
+          <p:nvPr/>
+        </p:nvSpPr>
+        <p:spPr>
+          <a:xfrm>
+            <a:off x="7453877" y="3903823"/>
             <a:ext cx="310896" cy="310896"/>
           </a:xfrm>
           <a:prstGeom prst="ellipse">
@@ -30429,13 +30213,13 @@
       </p:sp>
       <p:sp>
         <p:nvSpPr>
-          <p:cNvPr id="17" name="Oval 16"/>
-          <p:cNvSpPr/>
-          <p:nvPr/>
-        </p:nvSpPr>
-        <p:spPr>
-          <a:xfrm>
-            <a:off x="10625126" y="2976875"/>
+          <p:cNvPr id="15" name="Oval 14"/>
+          <p:cNvSpPr/>
+          <p:nvPr/>
+        </p:nvSpPr>
+        <p:spPr>
+          <a:xfrm>
+            <a:off x="10319717" y="3903823"/>
             <a:ext cx="310896" cy="310896"/>
           </a:xfrm>
           <a:prstGeom prst="ellipse">
@@ -30480,14 +30264,14 @@
       </p:sp>
       <p:sp>
         <p:nvSpPr>
-          <p:cNvPr id="18" name="TextBox 17"/>
+          <p:cNvPr id="16" name="TextBox 15"/>
           <p:cNvSpPr txBox="1"/>
           <p:nvPr/>
         </p:nvSpPr>
         <p:spPr>
           <a:xfrm>
-            <a:off x="7498079" y="3858180"/>
-            <a:ext cx="3916374" cy="274320"/>
+            <a:off x="4754879" y="5182391"/>
+            <a:ext cx="6751014" cy="274320"/>
           </a:xfrm>
           <a:prstGeom prst="rect">
             <a:avLst/>
@@ -30512,7 +30296,7 @@
               </a:spcAft>
             </a:pPr>
             <a:r>
-              <a:rPr sz="900" b="0" i="0">
+              <a:rPr sz="1000" b="0" i="0">
                 <a:solidFill>
                   <a:srgbClr val="818181"/>
                 </a:solidFill>
@@ -30525,7 +30309,7 @@
       </p:sp>
       <p:sp>
         <p:nvSpPr>
-          <p:cNvPr id="19" name="TextBox 18"/>
+          <p:cNvPr id="17" name="TextBox 16"/>
           <p:cNvSpPr txBox="1"/>
           <p:nvPr/>
         </p:nvSpPr>
@@ -38240,7 +38024,7 @@
                 </a:solidFill>
                 <a:latin typeface="Palatino"/>
               </a:rPr>
-              <a:t>Island reversal: two gaps isolate the bars</a:t>
+              <a:t>Island reversal: two gaps</a:t>
             </a:r>
           </a:p>
         </p:txBody>
@@ -38329,7 +38113,7 @@
         <p:spPr>
           <a:xfrm>
             <a:off x="777240" y="1965960"/>
-            <a:ext cx="6309360" cy="3108960"/>
+            <a:ext cx="3657600" cy="3108960"/>
           </a:xfrm>
           <a:prstGeom prst="rect">
             <a:avLst/>
@@ -38354,13 +38138,67 @@
               </a:spcAft>
             </a:pPr>
             <a:r>
-              <a:rPr sz="1700" b="0" i="0">
+              <a:rPr sz="2000" b="0" i="0">
                 <a:solidFill>
                   <a:srgbClr val="1A1A1A"/>
                 </a:solidFill>
                 <a:latin typeface="Arial"/>
               </a:rPr>
-              <a:t>Next, gaps can separate several bars from the surrounding trend into an island reversal.</a:t>
+              <a:t>Read the gap up </a:t>
+            </a:r>
+            <a:r>
+              <a:rPr sz="2000" b="1" i="0">
+                <a:solidFill>
+                  <a:srgbClr val="E09B00"/>
+                </a:solidFill>
+                <a:latin typeface="Arial"/>
+              </a:rPr>
+              <a:t>(1)</a:t>
+            </a:r>
+            <a:r>
+              <a:rPr sz="2000" b="0" i="0">
+                <a:solidFill>
+                  <a:srgbClr val="1A1A1A"/>
+                </a:solidFill>
+                <a:latin typeface="Arial"/>
+              </a:rPr>
+              <a:t>, isolated bars </a:t>
+            </a:r>
+            <a:r>
+              <a:rPr sz="2000" b="1" i="0">
+                <a:solidFill>
+                  <a:srgbClr val="C62828"/>
+                </a:solidFill>
+                <a:latin typeface="Arial"/>
+              </a:rPr>
+              <a:t>(2)</a:t>
+            </a:r>
+            <a:r>
+              <a:rPr sz="2000" b="0" i="0">
+                <a:solidFill>
+                  <a:srgbClr val="1A1A1A"/>
+                </a:solidFill>
+                <a:latin typeface="Arial"/>
+              </a:rPr>
+              <a:t>, then gap down </a:t>
+            </a:r>
+            <a:r>
+              <a:rPr sz="2000" b="1" i="0">
+                <a:solidFill>
+                  <a:srgbClr val="1F5FAD"/>
+                </a:solidFill>
+                <a:latin typeface="Arial"/>
+              </a:rPr>
+              <a:t>(3)</a:t>
+            </a:r>
+            <a:r>
+              <a:rPr sz="2000" b="0" i="0">
+                <a:solidFill>
+                  <a:srgbClr val="1A1A1A"/>
+                </a:solidFill>
+                <a:latin typeface="Arial"/>
+              </a:rPr>
+              <a:t>.</a:t>
             </a:r>
           </a:p>
           <a:p>
@@ -38376,111 +38214,35 @@
               </a:spcAft>
             </a:pPr>
             <a:r>
-              <a:rPr sz="1700" b="0" i="0">
+              <a:rPr sz="2000" b="0" i="0">
                 <a:solidFill>
                   <a:srgbClr val="1A1A1A"/>
                 </a:solidFill>
                 <a:latin typeface="Arial"/>
               </a:rPr>
-              <a:t>Ours: price gaps up from PHP 50.00 to an open of PHP 50.80 </a:t>
-            </a:r>
-            <a:r>
-              <a:rPr sz="1700" b="1" i="0">
-                <a:solidFill>
-                  <a:srgbClr val="E09B00"/>
-                </a:solidFill>
-                <a:latin typeface="Arial"/>
-              </a:rPr>
-              <a:t>(1)</a:t>
-            </a:r>
-            <a:r>
-              <a:rPr sz="1700" b="0" i="0">
+              <a:t>Ours: PHP 50.00 to 50.80, then PHP 49.40.</a:t>
+            </a:r>
+          </a:p>
+          <a:p>
+            <a:pPr algn="l">
+              <a:lnSpc>
+                <a:spcPct val="105000"/>
+              </a:lnSpc>
+              <a:spcBef>
+                <a:spcPts val="0"/>
+              </a:spcBef>
+              <a:spcAft>
+                <a:spcPts val="1100"/>
+              </a:spcAft>
+            </a:pPr>
+            <a:r>
+              <a:rPr sz="2000" b="0" i="0">
                 <a:solidFill>
                   <a:srgbClr val="1A1A1A"/>
                 </a:solidFill>
                 <a:latin typeface="Arial"/>
               </a:rPr>
-              <a:t>. Two bars sit alone </a:t>
-            </a:r>
-            <a:r>
-              <a:rPr sz="1700" b="1" i="0">
-                <a:solidFill>
-                  <a:srgbClr val="C62828"/>
-                </a:solidFill>
-                <a:latin typeface="Arial"/>
-              </a:rPr>
-              <a:t>(2)</a:t>
-            </a:r>
-            <a:r>
-              <a:rPr sz="1700" b="0" i="0">
-                <a:solidFill>
-                  <a:srgbClr val="1A1A1A"/>
-                </a:solidFill>
-                <a:latin typeface="Arial"/>
-              </a:rPr>
-              <a:t>.</a:t>
-            </a:r>
-          </a:p>
-          <a:p>
-            <a:pPr algn="l">
-              <a:lnSpc>
-                <a:spcPct val="105000"/>
-              </a:lnSpc>
-              <a:spcBef>
-                <a:spcPts val="0"/>
-              </a:spcBef>
-              <a:spcAft>
-                <a:spcPts val="1100"/>
-              </a:spcAft>
-            </a:pPr>
-            <a:r>
-              <a:rPr sz="1700" b="0" i="0">
-                <a:solidFill>
-                  <a:srgbClr val="1A1A1A"/>
-                </a:solidFill>
-                <a:latin typeface="Arial"/>
-              </a:rPr>
-              <a:t>It later gaps down to PHP 49.40 </a:t>
-            </a:r>
-            <a:r>
-              <a:rPr sz="1700" b="1" i="0">
-                <a:solidFill>
-                  <a:srgbClr val="1F5FAD"/>
-                </a:solidFill>
-                <a:latin typeface="Arial"/>
-              </a:rPr>
-              <a:t>(3)</a:t>
-            </a:r>
-            <a:r>
-              <a:rPr sz="1700" b="0" i="0">
-                <a:solidFill>
-                  <a:srgbClr val="1A1A1A"/>
-                </a:solidFill>
-                <a:latin typeface="Arial"/>
-              </a:rPr>
-              <a:t>. The gaps isolate the formation from surrounding bars.</a:t>
-            </a:r>
-          </a:p>
-          <a:p>
-            <a:pPr algn="l">
-              <a:lnSpc>
-                <a:spcPct val="105000"/>
-              </a:lnSpc>
-              <a:spcBef>
-                <a:spcPts val="0"/>
-              </a:spcBef>
-              <a:spcAft>
-                <a:spcPts val="1100"/>
-              </a:spcAft>
-            </a:pPr>
-            <a:r>
-              <a:rPr sz="1700" b="0" i="0">
-                <a:solidFill>
-                  <a:srgbClr val="1A1A1A"/>
-                </a:solidFill>
-                <a:latin typeface="Arial"/>
-              </a:rPr>
-              <a:t>Gap keeps Chapter 3's meaning in ‘Gaps’. The book shows an overbought stochastic label but gives no method here.</a:t>
+              <a:t>Meaning/action: two gaps isolate a potential reversal warning.</a:t>
             </a:r>
           </a:p>
         </p:txBody>
@@ -38493,83 +38255,8 @@
         </p:nvSpPr>
         <p:spPr>
           <a:xfrm>
-            <a:off x="777240" y="5001768"/>
-            <a:ext cx="82296" cy="694944"/>
-          </a:xfrm>
-          <a:prstGeom prst="rect">
-            <a:avLst/>
-          </a:prstGeom>
-          <a:solidFill>
-            <a:srgbClr val="F2A900"/>
-          </a:solidFill>
-          <a:ln>
-            <a:noFill/>
-          </a:ln>
-          <a:effectLst/>
-        </p:spPr>
-        <p:txBody>
-          <a:bodyPr rtlCol="0" anchor="ctr"/>
-          <a:lstStyle/>
-          <a:p>
-            <a:pPr algn="ctr"/>
-          </a:p>
-        </p:txBody>
-      </p:sp>
-      <p:sp>
-        <p:nvSpPr>
-          <p:cNvPr id="9" name="TextBox 8"/>
-          <p:cNvSpPr txBox="1"/>
-          <p:nvPr/>
-        </p:nvSpPr>
-        <p:spPr>
-          <a:xfrm>
-            <a:off x="1069848" y="5038344"/>
-            <a:ext cx="6016752" cy="694944"/>
-          </a:xfrm>
-          <a:prstGeom prst="rect">
-            <a:avLst/>
-          </a:prstGeom>
-          <a:noFill/>
-        </p:spPr>
-        <p:txBody>
-          <a:bodyPr wrap="square" anchor="t" lIns="0" rIns="0" tIns="0" bIns="0">
-            <a:spAutoFit/>
-          </a:bodyPr>
-          <a:lstStyle/>
-          <a:p>
-            <a:pPr algn="l">
-              <a:lnSpc>
-                <a:spcPct val="100000"/>
-              </a:lnSpc>
-              <a:spcBef>
-                <a:spcPts val="0"/>
-              </a:spcBef>
-              <a:spcAft>
-                <a:spcPts val="0"/>
-              </a:spcAft>
-            </a:pPr>
-            <a:r>
-              <a:rPr sz="1800" b="1" i="0">
-                <a:solidFill>
-                  <a:srgbClr val="1A1A1A"/>
-                </a:solidFill>
-                <a:latin typeface="Arial"/>
-              </a:rPr>
-              <a:t>Island means isolation by a gap up and a gap down, not merely several bars at a turning point.</a:t>
-            </a:r>
-          </a:p>
-        </p:txBody>
-      </p:sp>
-      <p:sp>
-        <p:nvSpPr>
-          <p:cNvPr id="10" name="Rectangle 9"/>
-          <p:cNvSpPr/>
-          <p:nvPr/>
-        </p:nvSpPr>
-        <p:spPr>
-          <a:xfrm>
-            <a:off x="7406640" y="1810512"/>
-            <a:ext cx="4007814" cy="1998945"/>
+            <a:off x="4754879" y="1810512"/>
+            <a:ext cx="6751014" cy="3280439"/>
           </a:xfrm>
           <a:prstGeom prst="rect">
             <a:avLst/>
@@ -38594,7 +38281,7 @@
       </p:sp>
       <p:pic>
         <p:nvPicPr>
-          <p:cNvPr id="11" name="Picture 10" descr="chart-rc.png"/>
+          <p:cNvPr id="9" name="Picture 8" descr="chart-rc.png"/>
           <p:cNvPicPr>
             <a:picLocks noChangeAspect="1"/>
           </p:cNvPicPr>
@@ -38608,8 +38295,8 @@
         </p:blipFill>
         <p:spPr>
           <a:xfrm>
-            <a:off x="7525512" y="1929384"/>
-            <a:ext cx="3770070" cy="1761201"/>
+            <a:off x="4873751" y="1929384"/>
+            <a:ext cx="6513270" cy="3042695"/>
           </a:xfrm>
           <a:prstGeom prst="rect">
             <a:avLst/>
@@ -38618,14 +38305,14 @@
       </p:pic>
       <p:sp>
         <p:nvSpPr>
-          <p:cNvPr id="12" name="Oval 11"/>
-          <p:cNvSpPr/>
-          <p:nvPr/>
-        </p:nvSpPr>
-        <p:spPr>
-          <a:xfrm>
-            <a:off x="8656533" y="2281624"/>
-            <a:ext cx="339306" cy="176120"/>
+          <p:cNvPr id="10" name="Oval 9"/>
+          <p:cNvSpPr/>
+          <p:nvPr/>
+        </p:nvSpPr>
+        <p:spPr>
+          <a:xfrm>
+            <a:off x="6827733" y="2537923"/>
+            <a:ext cx="586194" cy="304269"/>
           </a:xfrm>
           <a:prstGeom prst="ellipse">
             <a:avLst/>
@@ -38647,14 +38334,14 @@
       </p:sp>
       <p:sp>
         <p:nvSpPr>
-          <p:cNvPr id="13" name="Rectangle 12"/>
-          <p:cNvSpPr/>
-          <p:nvPr/>
-        </p:nvSpPr>
-        <p:spPr>
-          <a:xfrm>
-            <a:off x="9335146" y="2422520"/>
-            <a:ext cx="603211" cy="352240"/>
+          <p:cNvPr id="11" name="Rectangle 10"/>
+          <p:cNvSpPr/>
+          <p:nvPr/>
+        </p:nvSpPr>
+        <p:spPr>
+          <a:xfrm>
+            <a:off x="7348794" y="2598777"/>
+            <a:ext cx="1823715" cy="912808"/>
           </a:xfrm>
           <a:prstGeom prst="rect">
             <a:avLst/>
@@ -38676,14 +38363,14 @@
       </p:sp>
       <p:sp>
         <p:nvSpPr>
-          <p:cNvPr id="14" name="Oval 13"/>
-          <p:cNvSpPr/>
-          <p:nvPr/>
-        </p:nvSpPr>
-        <p:spPr>
-          <a:xfrm>
-            <a:off x="10164561" y="2281624"/>
-            <a:ext cx="377007" cy="176120"/>
+          <p:cNvPr id="12" name="Oval 11"/>
+          <p:cNvSpPr/>
+          <p:nvPr/>
+        </p:nvSpPr>
+        <p:spPr>
+          <a:xfrm>
+            <a:off x="9433041" y="2537923"/>
+            <a:ext cx="651327" cy="304269"/>
           </a:xfrm>
           <a:prstGeom prst="ellipse">
             <a:avLst/>
@@ -38705,13 +38392,13 @@
       </p:sp>
       <p:sp>
         <p:nvSpPr>
-          <p:cNvPr id="15" name="Oval 14"/>
-          <p:cNvSpPr/>
-          <p:nvPr/>
-        </p:nvSpPr>
-        <p:spPr>
-          <a:xfrm>
-            <a:off x="8312581" y="2038116"/>
+          <p:cNvPr id="13" name="Oval 12"/>
+          <p:cNvSpPr/>
+          <p:nvPr/>
+        </p:nvSpPr>
+        <p:spPr>
+          <a:xfrm>
+            <a:off x="6346621" y="2230340"/>
             <a:ext cx="310896" cy="310896"/>
           </a:xfrm>
           <a:prstGeom prst="ellipse">
@@ -38756,13 +38443,13 @@
       </p:sp>
       <p:sp>
         <p:nvSpPr>
-          <p:cNvPr id="16" name="Oval 15"/>
-          <p:cNvSpPr/>
-          <p:nvPr/>
-        </p:nvSpPr>
-        <p:spPr>
-          <a:xfrm>
-            <a:off x="9933712" y="2214236"/>
+          <p:cNvPr id="14" name="Oval 13"/>
+          <p:cNvSpPr/>
+          <p:nvPr/>
+        </p:nvSpPr>
+        <p:spPr>
+          <a:xfrm>
+            <a:off x="9277593" y="3416991"/>
             <a:ext cx="310896" cy="310896"/>
           </a:xfrm>
           <a:prstGeom prst="ellipse">
@@ -38807,13 +38494,13 @@
       </p:sp>
       <p:sp>
         <p:nvSpPr>
-          <p:cNvPr id="17" name="Oval 16"/>
-          <p:cNvSpPr/>
-          <p:nvPr/>
-        </p:nvSpPr>
-        <p:spPr>
-          <a:xfrm>
-            <a:off x="10612325" y="2038116"/>
+          <p:cNvPr id="15" name="Oval 14"/>
+          <p:cNvSpPr/>
+          <p:nvPr/>
+        </p:nvSpPr>
+        <p:spPr>
+          <a:xfrm>
+            <a:off x="10319717" y="2230340"/>
             <a:ext cx="310896" cy="310896"/>
           </a:xfrm>
           <a:prstGeom prst="ellipse">
@@ -38858,14 +38545,14 @@
       </p:sp>
       <p:sp>
         <p:nvSpPr>
-          <p:cNvPr id="18" name="TextBox 17"/>
+          <p:cNvPr id="16" name="TextBox 15"/>
           <p:cNvSpPr txBox="1"/>
           <p:nvPr/>
         </p:nvSpPr>
         <p:spPr>
           <a:xfrm>
-            <a:off x="7406640" y="3900897"/>
-            <a:ext cx="4007814" cy="274320"/>
+            <a:off x="4754879" y="5182391"/>
+            <a:ext cx="6751014" cy="274320"/>
           </a:xfrm>
           <a:prstGeom prst="rect">
             <a:avLst/>
@@ -38890,7 +38577,7 @@
               </a:spcAft>
             </a:pPr>
             <a:r>
-              <a:rPr sz="900" b="0" i="0">
+              <a:rPr sz="1000" b="0" i="0">
                 <a:solidFill>
                   <a:srgbClr val="818181"/>
                 </a:solidFill>
@@ -38903,7 +38590,7 @@
       </p:sp>
       <p:sp>
         <p:nvSpPr>
-          <p:cNvPr id="19" name="TextBox 18"/>
+          <p:cNvPr id="17" name="TextBox 16"/>
           <p:cNvSpPr txBox="1"/>
           <p:nvPr/>
         </p:nvSpPr>

</xml_diff>

<commit_message>
Polish Chapter 7 chart mark labels
</commit_message>
<xml_diff>
--- a/chapter-07/FIN1209-Chapter-07.pptx
+++ b/chapter-07/FIN1209-Chapter-07.pptx
@@ -17630,7 +17630,7 @@
         </p:nvSpPr>
         <p:spPr>
           <a:xfrm>
-            <a:off x="9733522" y="2169486"/>
+            <a:off x="10449982" y="2321621"/>
             <a:ext cx="310896" cy="310896"/>
           </a:xfrm>
           <a:prstGeom prst="ellipse">
@@ -28570,7 +28570,7 @@
         </p:nvSpPr>
         <p:spPr>
           <a:xfrm>
-            <a:off x="6192371" y="2484477"/>
+            <a:off x="5541044" y="2667038"/>
             <a:ext cx="228600" cy="228600"/>
           </a:xfrm>
           <a:prstGeom prst="ellipse">
@@ -30117,7 +30117,7 @@
         </p:nvSpPr>
         <p:spPr>
           <a:xfrm>
-            <a:off x="5955825" y="3903823"/>
+            <a:off x="5630161" y="3447418"/>
             <a:ext cx="310896" cy="310896"/>
           </a:xfrm>
           <a:prstGeom prst="ellipse">
@@ -38341,7 +38341,7 @@
         <p:spPr>
           <a:xfrm>
             <a:off x="7348794" y="2598777"/>
-            <a:ext cx="1823715" cy="912808"/>
+            <a:ext cx="2475042" cy="912808"/>
           </a:xfrm>
           <a:prstGeom prst="rect">
             <a:avLst/>
@@ -38449,7 +38449,7 @@
         </p:nvSpPr>
         <p:spPr>
           <a:xfrm>
-            <a:off x="9277593" y="3416991"/>
+            <a:off x="9798655" y="3416991"/>
             <a:ext cx="310896" cy="310896"/>
           </a:xfrm>
           <a:prstGeom prst="ellipse">

</xml_diff>